<commit_message>
Run Gen5.3 bull momentum specialist baseline
</commit_message>
<xml_diff>
--- a/presentations/gen5_3_bull_momentum_specialist_plan.pptx
+++ b/presentations/gen5_3_bull_momentum_specialist_plan.pptx
@@ -2,21 +2,25 @@
 <file path=ppt/presentation.xml><?xml version="1.0" encoding="utf-8"?>
 <p:presentation xmlns:p="http://schemas.openxmlformats.org/presentationml/2006/main">
   <p:sldMasterIdLst>
-    <p:sldMasterId xmlns:r="http://schemas.openxmlformats.org/officeDocument/2006/relationships" id="2147483648" r:id="Rca08a83ccf4749f3"/>
+    <p:sldMasterId xmlns:r="http://schemas.openxmlformats.org/officeDocument/2006/relationships" id="2147483648" r:id="Rffc1a028262e4739"/>
   </p:sldMasterIdLst>
   <p:notesMasterIdLst>
-    <p:notesMasterId xmlns:r="http://schemas.openxmlformats.org/officeDocument/2006/relationships" r:id="R62331f5d41c146ac"/>
+    <p:notesMasterId xmlns:r="http://schemas.openxmlformats.org/officeDocument/2006/relationships" r:id="Re5715b932fd345ed"/>
   </p:notesMasterIdLst>
   <p:sldIdLst>
-    <p:sldId xmlns:r="http://schemas.openxmlformats.org/officeDocument/2006/relationships" id="256" r:id="R2a98d75fbd184a2f"/>
-    <p:sldId xmlns:r="http://schemas.openxmlformats.org/officeDocument/2006/relationships" id="257" r:id="Ra52276e0be264374"/>
-    <p:sldId xmlns:r="http://schemas.openxmlformats.org/officeDocument/2006/relationships" id="258" r:id="R1e068268f6ee4d33"/>
-    <p:sldId xmlns:r="http://schemas.openxmlformats.org/officeDocument/2006/relationships" id="259" r:id="R7fb047e1af7a4c5e"/>
-    <p:sldId xmlns:r="http://schemas.openxmlformats.org/officeDocument/2006/relationships" id="260" r:id="Rdc60a233dd744f91"/>
-    <p:sldId xmlns:r="http://schemas.openxmlformats.org/officeDocument/2006/relationships" id="261" r:id="Rcc85551454ba452c"/>
-    <p:sldId xmlns:r="http://schemas.openxmlformats.org/officeDocument/2006/relationships" id="262" r:id="Rc7614790dd2c467f"/>
-    <p:sldId xmlns:r="http://schemas.openxmlformats.org/officeDocument/2006/relationships" id="263" r:id="R06ae6ff0240649c8"/>
-    <p:sldId xmlns:r="http://schemas.openxmlformats.org/officeDocument/2006/relationships" id="264" r:id="R6a0115684f0e4740"/>
+    <p:sldId xmlns:r="http://schemas.openxmlformats.org/officeDocument/2006/relationships" id="256" r:id="Rf1bb3d7fb46c447c"/>
+    <p:sldId xmlns:r="http://schemas.openxmlformats.org/officeDocument/2006/relationships" id="257" r:id="R88a8ef7417ba4719"/>
+    <p:sldId xmlns:r="http://schemas.openxmlformats.org/officeDocument/2006/relationships" id="258" r:id="R6f6780d49d6f4419"/>
+    <p:sldId xmlns:r="http://schemas.openxmlformats.org/officeDocument/2006/relationships" id="259" r:id="R93af5d5a86d24e96"/>
+    <p:sldId xmlns:r="http://schemas.openxmlformats.org/officeDocument/2006/relationships" id="260" r:id="R684b6c2954884bc8"/>
+    <p:sldId xmlns:r="http://schemas.openxmlformats.org/officeDocument/2006/relationships" id="261" r:id="R8a05b78f19694027"/>
+    <p:sldId xmlns:r="http://schemas.openxmlformats.org/officeDocument/2006/relationships" id="262" r:id="R8073d5dd73ab41b8"/>
+    <p:sldId xmlns:r="http://schemas.openxmlformats.org/officeDocument/2006/relationships" id="263" r:id="R1491b24603014c2b"/>
+    <p:sldId xmlns:r="http://schemas.openxmlformats.org/officeDocument/2006/relationships" id="264" r:id="R16b1a4373991483b"/>
+    <p:sldId xmlns:r="http://schemas.openxmlformats.org/officeDocument/2006/relationships" id="265" r:id="Ra7d3c940f4d6418d"/>
+    <p:sldId xmlns:r="http://schemas.openxmlformats.org/officeDocument/2006/relationships" id="266" r:id="R319079a09bab4c78"/>
+    <p:sldId xmlns:r="http://schemas.openxmlformats.org/officeDocument/2006/relationships" id="267" r:id="R14ac2b761943420d"/>
+    <p:sldId xmlns:r="http://schemas.openxmlformats.org/officeDocument/2006/relationships" id="268" r:id="R38acd66fbbad4d66"/>
   </p:sldIdLst>
   <p:sldSz cx="12192000" cy="6858000"/>
   <p:notesSz cx="6858000" cy="9144000"/>
@@ -571,6 +575,270 @@
 </p:notes>
 </file>
 
+<file path=ppt/notesSlides/notesSlide10.xml><?xml version="1.0" encoding="utf-8"?>
+<p:notes xmlns:p="http://schemas.openxmlformats.org/presentationml/2006/main">
+  <p:cSld>
+    <p:spTree>
+      <p:nvGrpSpPr>
+        <p:cNvPr id="1" name=""/>
+        <p:cNvGrpSpPr/>
+        <p:nvPr/>
+      </p:nvGrpSpPr>
+      <p:grpSpPr>
+        <a:xfrm xmlns:a="http://schemas.openxmlformats.org/drawingml/2006/main"/>
+      </p:grpSpPr>
+      <p:sp>
+        <p:nvSpPr>
+          <p:cNvPr id="2" name="Slide Image Placeholder 1"/>
+          <p:cNvSpPr>
+            <a:spLocks xmlns:a="http://schemas.openxmlformats.org/drawingml/2006/main" noGrp="1"/>
+          </p:cNvSpPr>
+          <p:nvPr>
+            <p:ph type="sldImg" idx="0"/>
+          </p:nvPr>
+        </p:nvSpPr>
+        <p:spPr/>
+      </p:sp>
+      <p:sp>
+        <p:nvSpPr>
+          <p:cNvPr id="3" name="Notes Placeholder 2"/>
+          <p:cNvSpPr>
+            <a:spLocks xmlns:a="http://schemas.openxmlformats.org/drawingml/2006/main" noGrp="1"/>
+          </p:cNvSpPr>
+          <p:nvPr>
+            <p:ph type="body" idx="1"/>
+          </p:nvPr>
+        </p:nvSpPr>
+        <p:spPr/>
+        <p:txBody>
+          <a:bodyPr xmlns:a="http://schemas.openxmlformats.org/drawingml/2006/main"/>
+          <a:lstStyle xmlns:a="http://schemas.openxmlformats.org/drawingml/2006/main"/>
+          <a:p xmlns:a="http://schemas.openxmlformats.org/drawingml/2006/main"/>
+        </p:txBody>
+      </p:sp>
+      <p:sp>
+        <p:nvSpPr>
+          <p:cNvPr id="4" name="Slide Number Placeholder 3"/>
+          <p:cNvSpPr>
+            <a:spLocks xmlns:a="http://schemas.openxmlformats.org/drawingml/2006/main" noGrp="1"/>
+          </p:cNvSpPr>
+          <p:nvPr>
+            <p:ph type="sldNum" idx="5"/>
+          </p:nvPr>
+        </p:nvSpPr>
+        <p:spPr/>
+        <p:txBody>
+          <a:bodyPr xmlns:a="http://schemas.openxmlformats.org/drawingml/2006/main"/>
+          <a:lstStyle xmlns:a="http://schemas.openxmlformats.org/drawingml/2006/main"/>
+          <a:p xmlns:a="http://schemas.openxmlformats.org/drawingml/2006/main"/>
+        </p:txBody>
+      </p:sp>
+    </p:spTree>
+  </p:cSld>
+  <p:clrMapOvr>
+    <a:masterClrMapping xmlns:a="http://schemas.openxmlformats.org/drawingml/2006/main"/>
+  </p:clrMapOvr>
+</p:notes>
+</file>
+
+<file path=ppt/notesSlides/notesSlide11.xml><?xml version="1.0" encoding="utf-8"?>
+<p:notes xmlns:p="http://schemas.openxmlformats.org/presentationml/2006/main">
+  <p:cSld>
+    <p:spTree>
+      <p:nvGrpSpPr>
+        <p:cNvPr id="1" name=""/>
+        <p:cNvGrpSpPr/>
+        <p:nvPr/>
+      </p:nvGrpSpPr>
+      <p:grpSpPr>
+        <a:xfrm xmlns:a="http://schemas.openxmlformats.org/drawingml/2006/main"/>
+      </p:grpSpPr>
+      <p:sp>
+        <p:nvSpPr>
+          <p:cNvPr id="2" name="Slide Image Placeholder 1"/>
+          <p:cNvSpPr>
+            <a:spLocks xmlns:a="http://schemas.openxmlformats.org/drawingml/2006/main" noGrp="1"/>
+          </p:cNvSpPr>
+          <p:nvPr>
+            <p:ph type="sldImg" idx="0"/>
+          </p:nvPr>
+        </p:nvSpPr>
+        <p:spPr/>
+      </p:sp>
+      <p:sp>
+        <p:nvSpPr>
+          <p:cNvPr id="3" name="Notes Placeholder 2"/>
+          <p:cNvSpPr>
+            <a:spLocks xmlns:a="http://schemas.openxmlformats.org/drawingml/2006/main" noGrp="1"/>
+          </p:cNvSpPr>
+          <p:nvPr>
+            <p:ph type="body" idx="1"/>
+          </p:nvPr>
+        </p:nvSpPr>
+        <p:spPr/>
+        <p:txBody>
+          <a:bodyPr xmlns:a="http://schemas.openxmlformats.org/drawingml/2006/main"/>
+          <a:lstStyle xmlns:a="http://schemas.openxmlformats.org/drawingml/2006/main"/>
+          <a:p xmlns:a="http://schemas.openxmlformats.org/drawingml/2006/main"/>
+        </p:txBody>
+      </p:sp>
+      <p:sp>
+        <p:nvSpPr>
+          <p:cNvPr id="4" name="Slide Number Placeholder 3"/>
+          <p:cNvSpPr>
+            <a:spLocks xmlns:a="http://schemas.openxmlformats.org/drawingml/2006/main" noGrp="1"/>
+          </p:cNvSpPr>
+          <p:nvPr>
+            <p:ph type="sldNum" idx="5"/>
+          </p:nvPr>
+        </p:nvSpPr>
+        <p:spPr/>
+        <p:txBody>
+          <a:bodyPr xmlns:a="http://schemas.openxmlformats.org/drawingml/2006/main"/>
+          <a:lstStyle xmlns:a="http://schemas.openxmlformats.org/drawingml/2006/main"/>
+          <a:p xmlns:a="http://schemas.openxmlformats.org/drawingml/2006/main"/>
+        </p:txBody>
+      </p:sp>
+    </p:spTree>
+  </p:cSld>
+  <p:clrMapOvr>
+    <a:masterClrMapping xmlns:a="http://schemas.openxmlformats.org/drawingml/2006/main"/>
+  </p:clrMapOvr>
+</p:notes>
+</file>
+
+<file path=ppt/notesSlides/notesSlide12.xml><?xml version="1.0" encoding="utf-8"?>
+<p:notes xmlns:p="http://schemas.openxmlformats.org/presentationml/2006/main">
+  <p:cSld>
+    <p:spTree>
+      <p:nvGrpSpPr>
+        <p:cNvPr id="1" name=""/>
+        <p:cNvGrpSpPr/>
+        <p:nvPr/>
+      </p:nvGrpSpPr>
+      <p:grpSpPr>
+        <a:xfrm xmlns:a="http://schemas.openxmlformats.org/drawingml/2006/main"/>
+      </p:grpSpPr>
+      <p:sp>
+        <p:nvSpPr>
+          <p:cNvPr id="2" name="Slide Image Placeholder 1"/>
+          <p:cNvSpPr>
+            <a:spLocks xmlns:a="http://schemas.openxmlformats.org/drawingml/2006/main" noGrp="1"/>
+          </p:cNvSpPr>
+          <p:nvPr>
+            <p:ph type="sldImg" idx="0"/>
+          </p:nvPr>
+        </p:nvSpPr>
+        <p:spPr/>
+      </p:sp>
+      <p:sp>
+        <p:nvSpPr>
+          <p:cNvPr id="3" name="Notes Placeholder 2"/>
+          <p:cNvSpPr>
+            <a:spLocks xmlns:a="http://schemas.openxmlformats.org/drawingml/2006/main" noGrp="1"/>
+          </p:cNvSpPr>
+          <p:nvPr>
+            <p:ph type="body" idx="1"/>
+          </p:nvPr>
+        </p:nvSpPr>
+        <p:spPr/>
+        <p:txBody>
+          <a:bodyPr xmlns:a="http://schemas.openxmlformats.org/drawingml/2006/main"/>
+          <a:lstStyle xmlns:a="http://schemas.openxmlformats.org/drawingml/2006/main"/>
+          <a:p xmlns:a="http://schemas.openxmlformats.org/drawingml/2006/main"/>
+        </p:txBody>
+      </p:sp>
+      <p:sp>
+        <p:nvSpPr>
+          <p:cNvPr id="4" name="Slide Number Placeholder 3"/>
+          <p:cNvSpPr>
+            <a:spLocks xmlns:a="http://schemas.openxmlformats.org/drawingml/2006/main" noGrp="1"/>
+          </p:cNvSpPr>
+          <p:nvPr>
+            <p:ph type="sldNum" idx="5"/>
+          </p:nvPr>
+        </p:nvSpPr>
+        <p:spPr/>
+        <p:txBody>
+          <a:bodyPr xmlns:a="http://schemas.openxmlformats.org/drawingml/2006/main"/>
+          <a:lstStyle xmlns:a="http://schemas.openxmlformats.org/drawingml/2006/main"/>
+          <a:p xmlns:a="http://schemas.openxmlformats.org/drawingml/2006/main"/>
+        </p:txBody>
+      </p:sp>
+    </p:spTree>
+  </p:cSld>
+  <p:clrMapOvr>
+    <a:masterClrMapping xmlns:a="http://schemas.openxmlformats.org/drawingml/2006/main"/>
+  </p:clrMapOvr>
+</p:notes>
+</file>
+
+<file path=ppt/notesSlides/notesSlide13.xml><?xml version="1.0" encoding="utf-8"?>
+<p:notes xmlns:p="http://schemas.openxmlformats.org/presentationml/2006/main">
+  <p:cSld>
+    <p:spTree>
+      <p:nvGrpSpPr>
+        <p:cNvPr id="1" name=""/>
+        <p:cNvGrpSpPr/>
+        <p:nvPr/>
+      </p:nvGrpSpPr>
+      <p:grpSpPr>
+        <a:xfrm xmlns:a="http://schemas.openxmlformats.org/drawingml/2006/main"/>
+      </p:grpSpPr>
+      <p:sp>
+        <p:nvSpPr>
+          <p:cNvPr id="2" name="Slide Image Placeholder 1"/>
+          <p:cNvSpPr>
+            <a:spLocks xmlns:a="http://schemas.openxmlformats.org/drawingml/2006/main" noGrp="1"/>
+          </p:cNvSpPr>
+          <p:nvPr>
+            <p:ph type="sldImg" idx="0"/>
+          </p:nvPr>
+        </p:nvSpPr>
+        <p:spPr/>
+      </p:sp>
+      <p:sp>
+        <p:nvSpPr>
+          <p:cNvPr id="3" name="Notes Placeholder 2"/>
+          <p:cNvSpPr>
+            <a:spLocks xmlns:a="http://schemas.openxmlformats.org/drawingml/2006/main" noGrp="1"/>
+          </p:cNvSpPr>
+          <p:nvPr>
+            <p:ph type="body" idx="1"/>
+          </p:nvPr>
+        </p:nvSpPr>
+        <p:spPr/>
+        <p:txBody>
+          <a:bodyPr xmlns:a="http://schemas.openxmlformats.org/drawingml/2006/main"/>
+          <a:lstStyle xmlns:a="http://schemas.openxmlformats.org/drawingml/2006/main"/>
+          <a:p xmlns:a="http://schemas.openxmlformats.org/drawingml/2006/main"/>
+        </p:txBody>
+      </p:sp>
+      <p:sp>
+        <p:nvSpPr>
+          <p:cNvPr id="4" name="Slide Number Placeholder 3"/>
+          <p:cNvSpPr>
+            <a:spLocks xmlns:a="http://schemas.openxmlformats.org/drawingml/2006/main" noGrp="1"/>
+          </p:cNvSpPr>
+          <p:nvPr>
+            <p:ph type="sldNum" idx="5"/>
+          </p:nvPr>
+        </p:nvSpPr>
+        <p:spPr/>
+        <p:txBody>
+          <a:bodyPr xmlns:a="http://schemas.openxmlformats.org/drawingml/2006/main"/>
+          <a:lstStyle xmlns:a="http://schemas.openxmlformats.org/drawingml/2006/main"/>
+          <a:p xmlns:a="http://schemas.openxmlformats.org/drawingml/2006/main"/>
+        </p:txBody>
+      </p:sp>
+    </p:spTree>
+  </p:cSld>
+  <p:clrMapOvr>
+    <a:masterClrMapping xmlns:a="http://schemas.openxmlformats.org/drawingml/2006/main"/>
+  </p:clrMapOvr>
+</p:notes>
+</file>
+
 <file path=ppt/notesSlides/notesSlide2.xml><?xml version="1.0" encoding="utf-8"?>
 <p:notes xmlns:p="http://schemas.openxmlformats.org/presentationml/2006/main">
   <p:cSld>
@@ -1137,7 +1405,7 @@
   </p:cSld>
   <p:clrMap bg1="lt1" tx1="dk1" bg2="lt2" tx2="dk2" accent1="accent1" accent2="accent2" accent3="accent3" accent4="accent4" accent5="accent5" accent6="accent6" hlink="hlink" folHlink="folHlink"/>
   <p:sldLayoutIdLst>
-    <p:sldLayoutId xmlns:r="http://schemas.openxmlformats.org/officeDocument/2006/relationships" id="2147483649" r:id="R08e151bbc53a4263"/>
+    <p:sldLayoutId xmlns:r="http://schemas.openxmlformats.org/officeDocument/2006/relationships" id="2147483649" r:id="R240ed903c0b34d75"/>
   </p:sldLayoutIdLst>
   <p:txStyles>
     <p:titleStyle>
@@ -1688,7 +1956,7 @@
           <p:cNvPr id="1" name="">
             <a:extLst xmlns:a="http://schemas.openxmlformats.org/drawingml/2006/main">
               <a:ext uri="{FF2B5EF4-FFF2-40B4-BE49-F238E27FC236}">
-                <a16:creationId xmlns:a16="http://schemas.microsoft.com/office/drawing/2014/main" id="{62ACC6C8-FC0D-458B-92C3-472017CACC41}"/>
+                <a16:creationId xmlns:a16="http://schemas.microsoft.com/office/drawing/2014/main" id="{2BFEAC4A-957D-4A47-95DB-6A56AC60EAAF}"/>
               </a:ext>
             </a:extLst>
           </p:cNvPr>
@@ -1738,7 +2006,7 @@
           <p:cNvPr id="2" name="">
             <a:extLst xmlns:a="http://schemas.openxmlformats.org/drawingml/2006/main">
               <a:ext uri="{FF2B5EF4-FFF2-40B4-BE49-F238E27FC236}">
-                <a16:creationId xmlns:a16="http://schemas.microsoft.com/office/drawing/2014/main" id="{EE579332-4178-4F0D-8EED-9D17FFD020EC}"/>
+                <a16:creationId xmlns:a16="http://schemas.microsoft.com/office/drawing/2014/main" id="{92F76554-9CF5-46F4-B0B1-F6945E83BBFE}"/>
               </a:ext>
             </a:extLst>
           </p:cNvPr>
@@ -1788,7 +2056,7 @@
           <p:cNvPr id="3" name="">
             <a:extLst xmlns:a="http://schemas.openxmlformats.org/drawingml/2006/main">
               <a:ext uri="{FF2B5EF4-FFF2-40B4-BE49-F238E27FC236}">
-                <a16:creationId xmlns:a16="http://schemas.microsoft.com/office/drawing/2014/main" id="{C515E8B0-34C7-4E9A-AD99-A89D440B3B6D}"/>
+                <a16:creationId xmlns:a16="http://schemas.microsoft.com/office/drawing/2014/main" id="{ED232ACF-A13F-4192-9AD8-C30CE7E378EC}"/>
               </a:ext>
             </a:extLst>
           </p:cNvPr>
@@ -1838,7 +2106,7 @@
           <p:cNvPr id="4" name="">
             <a:extLst xmlns:a="http://schemas.openxmlformats.org/drawingml/2006/main">
               <a:ext uri="{FF2B5EF4-FFF2-40B4-BE49-F238E27FC236}">
-                <a16:creationId xmlns:a16="http://schemas.microsoft.com/office/drawing/2014/main" id="{3C36ADAA-6B90-4C42-A9D3-93AAA6A32C41}"/>
+                <a16:creationId xmlns:a16="http://schemas.microsoft.com/office/drawing/2014/main" id="{B2B9F2DA-D573-4559-9FFF-47C11C7D0AA4}"/>
               </a:ext>
             </a:extLst>
           </p:cNvPr>
@@ -1873,7 +2141,7 @@
           <p:cNvPr id="5" name="">
             <a:extLst xmlns:a="http://schemas.openxmlformats.org/drawingml/2006/main">
               <a:ext uri="{FF2B5EF4-FFF2-40B4-BE49-F238E27FC236}">
-                <a16:creationId xmlns:a16="http://schemas.microsoft.com/office/drawing/2014/main" id="{85160087-AF58-4F08-BF09-E77CC83F0463}"/>
+                <a16:creationId xmlns:a16="http://schemas.microsoft.com/office/drawing/2014/main" id="{376A605F-C51F-4C6C-B7F6-97CD7934731B}"/>
               </a:ext>
             </a:extLst>
           </p:cNvPr>
@@ -1923,7 +2191,7 @@
           <p:cNvPr id="6" name="">
             <a:extLst xmlns:a="http://schemas.openxmlformats.org/drawingml/2006/main">
               <a:ext uri="{FF2B5EF4-FFF2-40B4-BE49-F238E27FC236}">
-                <a16:creationId xmlns:a16="http://schemas.microsoft.com/office/drawing/2014/main" id="{1A7551BC-743D-4BA3-81E8-C072F31E82C1}"/>
+                <a16:creationId xmlns:a16="http://schemas.microsoft.com/office/drawing/2014/main" id="{3FD3B4CB-0407-4782-8CAE-FDFCF65373BD}"/>
               </a:ext>
             </a:extLst>
           </p:cNvPr>
@@ -1973,7 +2241,7 @@
           <p:cNvPr id="7" name="">
             <a:extLst xmlns:a="http://schemas.openxmlformats.org/drawingml/2006/main">
               <a:ext uri="{FF2B5EF4-FFF2-40B4-BE49-F238E27FC236}">
-                <a16:creationId xmlns:a16="http://schemas.microsoft.com/office/drawing/2014/main" id="{87DBAD15-A19A-4F86-9CBD-F3CBFE8A1254}"/>
+                <a16:creationId xmlns:a16="http://schemas.microsoft.com/office/drawing/2014/main" id="{A3BAA75E-F23C-4F30-B972-C2A1265B5C1B}"/>
               </a:ext>
             </a:extLst>
           </p:cNvPr>
@@ -2021,7 +2289,2688 @@
     </p:spTree>
     <p:extLst>
       <p:ext uri="{BB962C8B-B14F-4D97-AF65-F5344CB8AC3E}">
-        <p14:creationId xmlns:p14="http://schemas.microsoft.com/office/powerpoint/2010/main" val="987875923"/>
+        <p14:creationId xmlns:p14="http://schemas.microsoft.com/office/powerpoint/2010/main" val="563850745"/>
+      </p:ext>
+    </p:extLst>
+  </p:cSld>
+</p:sld>
+</file>
+
+<file path=ppt/slides/slide10.xml><?xml version="1.0" encoding="utf-8"?>
+<p:sld xmlns:p="http://schemas.openxmlformats.org/presentationml/2006/main">
+  <p:cSld>
+    <p:bg>
+      <p:bgPr>
+        <a:solidFill xmlns:a="http://schemas.openxmlformats.org/drawingml/2006/main">
+          <a:srgbClr val="FFFFFF"/>
+        </a:solidFill>
+      </p:bgPr>
+    </p:bg>
+    <p:spTree>
+      <p:nvGrpSpPr>
+        <p:cNvPr id="1" name=""/>
+        <p:cNvGrpSpPr/>
+        <p:nvPr/>
+      </p:nvGrpSpPr>
+      <p:grpSpPr>
+        <a:xfrm xmlns:a="http://schemas.openxmlformats.org/drawingml/2006/main"/>
+      </p:grpSpPr>
+      <p:sp>
+        <p:nvSpPr>
+          <p:cNvPr id="1" name="">
+            <a:extLst xmlns:a="http://schemas.openxmlformats.org/drawingml/2006/main">
+              <a:ext uri="{FF2B5EF4-FFF2-40B4-BE49-F238E27FC236}">
+                <a16:creationId xmlns:a16="http://schemas.microsoft.com/office/drawing/2014/main" id="{23FC7A45-F790-4641-956E-1021CB3C1B51}"/>
+              </a:ext>
+            </a:extLst>
+          </p:cNvPr>
+          <p:cNvSpPr>
+            <a:spLocks xmlns:a="http://schemas.openxmlformats.org/drawingml/2006/main" noGrp="1"/>
+          </p:cNvSpPr>
+          <p:nvPr/>
+        </p:nvSpPr>
+        <p:spPr>
+          <a:xfrm xmlns:a="http://schemas.openxmlformats.org/drawingml/2006/main">
+            <a:off x="609600" y="304800"/>
+            <a:ext cx="5334000" cy="209550"/>
+          </a:xfrm>
+          <a:prstGeom xmlns:a="http://schemas.openxmlformats.org/drawingml/2006/main" prst="rect">
+            <a:avLst/>
+          </a:prstGeom>
+          <a:noFill xmlns:a="http://schemas.openxmlformats.org/drawingml/2006/main"/>
+          <a:ln xmlns:a="http://schemas.openxmlformats.org/drawingml/2006/main" w="0">
+            <a:noFill/>
+            <a:prstDash val="solid"/>
+          </a:ln>
+        </p:spPr>
+        <p:txBody>
+          <a:bodyPr xmlns:a="http://schemas.openxmlformats.org/drawingml/2006/main"/>
+          <a:lstStyle xmlns:a="http://schemas.openxmlformats.org/drawingml/2006/main"/>
+          <a:p xmlns:a="http://schemas.openxmlformats.org/drawingml/2006/main">
+            <a:pPr>
+              <a:defRPr sz="975" b="1">
+                <a:solidFill>
+                  <a:srgbClr val="2563EB"/>
+                </a:solidFill>
+              </a:defRPr>
+            </a:pPr>
+            <a:r>
+              <a:rPr sz="975" b="1">
+                <a:solidFill>
+                  <a:srgbClr val="2563EB"/>
+                </a:solidFill>
+              </a:rPr>
+              <a:t>GEN5.3 PCA RESEARCH PIVOT</a:t>
+            </a:r>
+          </a:p>
+        </p:txBody>
+      </p:sp>
+      <p:sp>
+        <p:nvSpPr>
+          <p:cNvPr id="2" name="">
+            <a:extLst xmlns:a="http://schemas.openxmlformats.org/drawingml/2006/main">
+              <a:ext uri="{FF2B5EF4-FFF2-40B4-BE49-F238E27FC236}">
+                <a16:creationId xmlns:a16="http://schemas.microsoft.com/office/drawing/2014/main" id="{29A9BC32-4796-4D97-AE25-5A65F73F16C3}"/>
+              </a:ext>
+            </a:extLst>
+          </p:cNvPr>
+          <p:cNvSpPr>
+            <a:spLocks xmlns:a="http://schemas.openxmlformats.org/drawingml/2006/main" noGrp="1"/>
+          </p:cNvSpPr>
+          <p:nvPr/>
+        </p:nvSpPr>
+        <p:spPr>
+          <a:xfrm xmlns:a="http://schemas.openxmlformats.org/drawingml/2006/main">
+            <a:off x="609600" y="647700"/>
+            <a:ext cx="9334500" cy="876300"/>
+          </a:xfrm>
+          <a:prstGeom xmlns:a="http://schemas.openxmlformats.org/drawingml/2006/main" prst="rect">
+            <a:avLst/>
+          </a:prstGeom>
+          <a:noFill xmlns:a="http://schemas.openxmlformats.org/drawingml/2006/main"/>
+          <a:ln xmlns:a="http://schemas.openxmlformats.org/drawingml/2006/main" w="0">
+            <a:noFill/>
+            <a:prstDash val="solid"/>
+          </a:ln>
+        </p:spPr>
+        <p:txBody>
+          <a:bodyPr xmlns:a="http://schemas.openxmlformats.org/drawingml/2006/main"/>
+          <a:lstStyle xmlns:a="http://schemas.openxmlformats.org/drawingml/2006/main"/>
+          <a:p xmlns:a="http://schemas.openxmlformats.org/drawingml/2006/main">
+            <a:pPr>
+              <a:defRPr sz="2775" b="1">
+                <a:solidFill>
+                  <a:srgbClr val="111827"/>
+                </a:solidFill>
+              </a:defRPr>
+            </a:pPr>
+            <a:r>
+              <a:rPr sz="2775" b="1">
+                <a:solidFill>
+                  <a:srgbClr val="111827"/>
+                </a:solidFill>
+              </a:rPr>
+              <a:t>The first baseline gives us a clean, bounded answer</a:t>
+            </a:r>
+          </a:p>
+        </p:txBody>
+      </p:sp>
+      <p:sp>
+        <p:nvSpPr>
+          <p:cNvPr id="3" name="">
+            <a:extLst xmlns:a="http://schemas.openxmlformats.org/drawingml/2006/main">
+              <a:ext uri="{FF2B5EF4-FFF2-40B4-BE49-F238E27FC236}">
+                <a16:creationId xmlns:a16="http://schemas.microsoft.com/office/drawing/2014/main" id="{E24DE787-D63A-4D71-8268-0A833CBE4F2B}"/>
+              </a:ext>
+            </a:extLst>
+          </p:cNvPr>
+          <p:cNvSpPr>
+            <a:spLocks xmlns:a="http://schemas.openxmlformats.org/drawingml/2006/main" noGrp="1"/>
+          </p:cNvSpPr>
+          <p:nvPr/>
+        </p:nvSpPr>
+        <p:spPr>
+          <a:xfrm xmlns:a="http://schemas.openxmlformats.org/drawingml/2006/main">
+            <a:off x="609600" y="1485900"/>
+            <a:ext cx="10572750" cy="9525"/>
+          </a:xfrm>
+          <a:prstGeom xmlns:a="http://schemas.openxmlformats.org/drawingml/2006/main" prst="rect">
+            <a:avLst/>
+          </a:prstGeom>
+          <a:solidFill xmlns:a="http://schemas.openxmlformats.org/drawingml/2006/main">
+            <a:srgbClr val="CBD3DD"/>
+          </a:solidFill>
+          <a:ln xmlns:a="http://schemas.openxmlformats.org/drawingml/2006/main" w="0">
+            <a:solidFill>
+              <a:srgbClr val="CBD3DD"/>
+            </a:solidFill>
+            <a:prstDash val="solid"/>
+          </a:ln>
+        </p:spPr>
+      </p:sp>
+      <p:sp>
+        <p:nvSpPr>
+          <p:cNvPr id="4" name="">
+            <a:extLst xmlns:a="http://schemas.openxmlformats.org/drawingml/2006/main">
+              <a:ext uri="{FF2B5EF4-FFF2-40B4-BE49-F238E27FC236}">
+                <a16:creationId xmlns:a16="http://schemas.microsoft.com/office/drawing/2014/main" id="{88341BA6-A0C7-4389-A348-0EDE8444AF55}"/>
+              </a:ext>
+            </a:extLst>
+          </p:cNvPr>
+          <p:cNvSpPr>
+            <a:spLocks xmlns:a="http://schemas.openxmlformats.org/drawingml/2006/main" noGrp="1"/>
+          </p:cNvSpPr>
+          <p:nvPr/>
+        </p:nvSpPr>
+        <p:spPr>
+          <a:xfrm xmlns:a="http://schemas.openxmlformats.org/drawingml/2006/main">
+            <a:off x="704850" y="1943100"/>
+            <a:ext cx="4953000" cy="3333750"/>
+          </a:xfrm>
+          <a:prstGeom xmlns:a="http://schemas.openxmlformats.org/drawingml/2006/main" prst="roundRect">
+            <a:avLst>
+              <a:gd name="adj" fmla="val 2286"/>
+            </a:avLst>
+          </a:prstGeom>
+          <a:solidFill xmlns:a="http://schemas.openxmlformats.org/drawingml/2006/main">
+            <a:srgbClr val="EFF6FF"/>
+          </a:solidFill>
+          <a:ln xmlns:a="http://schemas.openxmlformats.org/drawingml/2006/main" w="9525">
+            <a:solidFill>
+              <a:srgbClr val="BFDBFE"/>
+            </a:solidFill>
+            <a:prstDash val="solid"/>
+          </a:ln>
+        </p:spPr>
+      </p:sp>
+      <p:sp>
+        <p:nvSpPr>
+          <p:cNvPr id="5" name="">
+            <a:extLst xmlns:a="http://schemas.openxmlformats.org/drawingml/2006/main">
+              <a:ext uri="{FF2B5EF4-FFF2-40B4-BE49-F238E27FC236}">
+                <a16:creationId xmlns:a16="http://schemas.microsoft.com/office/drawing/2014/main" id="{946ECB9C-7386-4FAC-8147-EE10B7234CF0}"/>
+              </a:ext>
+            </a:extLst>
+          </p:cNvPr>
+          <p:cNvSpPr>
+            <a:spLocks xmlns:a="http://schemas.openxmlformats.org/drawingml/2006/main" noGrp="1"/>
+          </p:cNvSpPr>
+          <p:nvPr/>
+        </p:nvSpPr>
+        <p:spPr>
+          <a:xfrm xmlns:a="http://schemas.openxmlformats.org/drawingml/2006/main">
+            <a:off x="1028700" y="2247900"/>
+            <a:ext cx="3429000" cy="304800"/>
+          </a:xfrm>
+          <a:prstGeom xmlns:a="http://schemas.openxmlformats.org/drawingml/2006/main" prst="rect">
+            <a:avLst/>
+          </a:prstGeom>
+          <a:noFill xmlns:a="http://schemas.openxmlformats.org/drawingml/2006/main"/>
+          <a:ln xmlns:a="http://schemas.openxmlformats.org/drawingml/2006/main" w="0">
+            <a:noFill/>
+            <a:prstDash val="solid"/>
+          </a:ln>
+        </p:spPr>
+        <p:txBody>
+          <a:bodyPr xmlns:a="http://schemas.openxmlformats.org/drawingml/2006/main"/>
+          <a:lstStyle xmlns:a="http://schemas.openxmlformats.org/drawingml/2006/main"/>
+          <a:p xmlns:a="http://schemas.openxmlformats.org/drawingml/2006/main">
+            <a:pPr>
+              <a:defRPr sz="2025" b="1">
+                <a:solidFill>
+                  <a:srgbClr val="2563EB"/>
+                </a:solidFill>
+              </a:defRPr>
+            </a:pPr>
+            <a:r>
+              <a:rPr sz="2025" b="1">
+                <a:solidFill>
+                  <a:srgbClr val="2563EB"/>
+                </a:solidFill>
+              </a:rPr>
+              <a:t>What we tested</a:t>
+            </a:r>
+          </a:p>
+        </p:txBody>
+      </p:sp>
+      <p:sp>
+        <p:nvSpPr>
+          <p:cNvPr id="6" name="">
+            <a:extLst xmlns:a="http://schemas.openxmlformats.org/drawingml/2006/main">
+              <a:ext uri="{FF2B5EF4-FFF2-40B4-BE49-F238E27FC236}">
+                <a16:creationId xmlns:a16="http://schemas.microsoft.com/office/drawing/2014/main" id="{C48F1386-E841-49EF-A08F-F88963D64767}"/>
+              </a:ext>
+            </a:extLst>
+          </p:cNvPr>
+          <p:cNvSpPr>
+            <a:spLocks xmlns:a="http://schemas.openxmlformats.org/drawingml/2006/main" noGrp="1"/>
+          </p:cNvSpPr>
+          <p:nvPr/>
+        </p:nvSpPr>
+        <p:spPr>
+          <a:xfrm xmlns:a="http://schemas.openxmlformats.org/drawingml/2006/main">
+            <a:off x="1047750" y="2924175"/>
+            <a:ext cx="76200" cy="76200"/>
+          </a:xfrm>
+          <a:prstGeom xmlns:a="http://schemas.openxmlformats.org/drawingml/2006/main" prst="ellipse">
+            <a:avLst/>
+          </a:prstGeom>
+          <a:solidFill xmlns:a="http://schemas.openxmlformats.org/drawingml/2006/main">
+            <a:srgbClr val="2563EB"/>
+          </a:solidFill>
+          <a:ln xmlns:a="http://schemas.openxmlformats.org/drawingml/2006/main" w="0">
+            <a:noFill/>
+            <a:prstDash val="solid"/>
+          </a:ln>
+        </p:spPr>
+      </p:sp>
+      <p:sp>
+        <p:nvSpPr>
+          <p:cNvPr id="7" name="">
+            <a:extLst xmlns:a="http://schemas.openxmlformats.org/drawingml/2006/main">
+              <a:ext uri="{FF2B5EF4-FFF2-40B4-BE49-F238E27FC236}">
+                <a16:creationId xmlns:a16="http://schemas.microsoft.com/office/drawing/2014/main" id="{CEF94EC5-F88D-419C-8787-27A92ECAA2B2}"/>
+              </a:ext>
+            </a:extLst>
+          </p:cNvPr>
+          <p:cNvSpPr>
+            <a:spLocks xmlns:a="http://schemas.openxmlformats.org/drawingml/2006/main" noGrp="1"/>
+          </p:cNvSpPr>
+          <p:nvPr/>
+        </p:nvSpPr>
+        <p:spPr>
+          <a:xfrm xmlns:a="http://schemas.openxmlformats.org/drawingml/2006/main">
+            <a:off x="1257300" y="2838450"/>
+            <a:ext cx="3695700" cy="361950"/>
+          </a:xfrm>
+          <a:prstGeom xmlns:a="http://schemas.openxmlformats.org/drawingml/2006/main" prst="rect">
+            <a:avLst/>
+          </a:prstGeom>
+          <a:noFill xmlns:a="http://schemas.openxmlformats.org/drawingml/2006/main"/>
+          <a:ln xmlns:a="http://schemas.openxmlformats.org/drawingml/2006/main" w="0">
+            <a:noFill/>
+            <a:prstDash val="solid"/>
+          </a:ln>
+        </p:spPr>
+        <p:txBody>
+          <a:bodyPr xmlns:a="http://schemas.openxmlformats.org/drawingml/2006/main"/>
+          <a:lstStyle xmlns:a="http://schemas.openxmlformats.org/drawingml/2006/main"/>
+          <a:p xmlns:a="http://schemas.openxmlformats.org/drawingml/2006/main">
+            <a:pPr>
+              <a:defRPr sz="1350" b="0">
+                <a:solidFill>
+                  <a:srgbClr val="111827"/>
+                </a:solidFill>
+              </a:defRPr>
+            </a:pPr>
+            <a:r>
+              <a:rPr sz="1350" b="0">
+                <a:solidFill>
+                  <a:srgbClr val="111827"/>
+                </a:solidFill>
+              </a:rPr>
+              <a:t>High-beta basket: AMD, NVDA, TSLA, AAPL, MSTR</a:t>
+            </a:r>
+          </a:p>
+        </p:txBody>
+      </p:sp>
+      <p:sp>
+        <p:nvSpPr>
+          <p:cNvPr id="8" name="">
+            <a:extLst xmlns:a="http://schemas.openxmlformats.org/drawingml/2006/main">
+              <a:ext uri="{FF2B5EF4-FFF2-40B4-BE49-F238E27FC236}">
+                <a16:creationId xmlns:a16="http://schemas.microsoft.com/office/drawing/2014/main" id="{D3ABC21C-1006-4A43-B782-46DF7D13F5E6}"/>
+              </a:ext>
+            </a:extLst>
+          </p:cNvPr>
+          <p:cNvSpPr>
+            <a:spLocks xmlns:a="http://schemas.openxmlformats.org/drawingml/2006/main" noGrp="1"/>
+          </p:cNvSpPr>
+          <p:nvPr/>
+        </p:nvSpPr>
+        <p:spPr>
+          <a:xfrm xmlns:a="http://schemas.openxmlformats.org/drawingml/2006/main">
+            <a:off x="1047750" y="3248025"/>
+            <a:ext cx="76200" cy="76200"/>
+          </a:xfrm>
+          <a:prstGeom xmlns:a="http://schemas.openxmlformats.org/drawingml/2006/main" prst="ellipse">
+            <a:avLst/>
+          </a:prstGeom>
+          <a:solidFill xmlns:a="http://schemas.openxmlformats.org/drawingml/2006/main">
+            <a:srgbClr val="2563EB"/>
+          </a:solidFill>
+          <a:ln xmlns:a="http://schemas.openxmlformats.org/drawingml/2006/main" w="0">
+            <a:noFill/>
+            <a:prstDash val="solid"/>
+          </a:ln>
+        </p:spPr>
+      </p:sp>
+      <p:sp>
+        <p:nvSpPr>
+          <p:cNvPr id="9" name="">
+            <a:extLst xmlns:a="http://schemas.openxmlformats.org/drawingml/2006/main">
+              <a:ext uri="{FF2B5EF4-FFF2-40B4-BE49-F238E27FC236}">
+                <a16:creationId xmlns:a16="http://schemas.microsoft.com/office/drawing/2014/main" id="{226EE91E-4877-4D4A-A319-37CFDBA3F934}"/>
+              </a:ext>
+            </a:extLst>
+          </p:cNvPr>
+          <p:cNvSpPr>
+            <a:spLocks xmlns:a="http://schemas.openxmlformats.org/drawingml/2006/main" noGrp="1"/>
+          </p:cNvSpPr>
+          <p:nvPr/>
+        </p:nvSpPr>
+        <p:spPr>
+          <a:xfrm xmlns:a="http://schemas.openxmlformats.org/drawingml/2006/main">
+            <a:off x="1257300" y="3162300"/>
+            <a:ext cx="3695700" cy="361950"/>
+          </a:xfrm>
+          <a:prstGeom xmlns:a="http://schemas.openxmlformats.org/drawingml/2006/main" prst="rect">
+            <a:avLst/>
+          </a:prstGeom>
+          <a:noFill xmlns:a="http://schemas.openxmlformats.org/drawingml/2006/main"/>
+          <a:ln xmlns:a="http://schemas.openxmlformats.org/drawingml/2006/main" w="0">
+            <a:noFill/>
+            <a:prstDash val="solid"/>
+          </a:ln>
+        </p:spPr>
+        <p:txBody>
+          <a:bodyPr xmlns:a="http://schemas.openxmlformats.org/drawingml/2006/main"/>
+          <a:lstStyle xmlns:a="http://schemas.openxmlformats.org/drawingml/2006/main"/>
+          <a:p xmlns:a="http://schemas.openxmlformats.org/drawingml/2006/main">
+            <a:pPr>
+              <a:defRPr sz="1350" b="0">
+                <a:solidFill>
+                  <a:srgbClr val="111827"/>
+                </a:solidFill>
+              </a:defRPr>
+            </a:pPr>
+            <a:r>
+              <a:rPr sz="1350" b="0">
+                <a:solidFill>
+                  <a:srgbClr val="111827"/>
+                </a:solidFill>
+              </a:rPr>
+              <a:t>Context: basket + SPY/QQQ/IWM/SMH/TLT/GLD</a:t>
+            </a:r>
+          </a:p>
+        </p:txBody>
+      </p:sp>
+      <p:sp>
+        <p:nvSpPr>
+          <p:cNvPr id="10" name="">
+            <a:extLst xmlns:a="http://schemas.openxmlformats.org/drawingml/2006/main">
+              <a:ext uri="{FF2B5EF4-FFF2-40B4-BE49-F238E27FC236}">
+                <a16:creationId xmlns:a16="http://schemas.microsoft.com/office/drawing/2014/main" id="{AB940544-8A0A-4C1A-A2D3-56112916A610}"/>
+              </a:ext>
+            </a:extLst>
+          </p:cNvPr>
+          <p:cNvSpPr>
+            <a:spLocks xmlns:a="http://schemas.openxmlformats.org/drawingml/2006/main" noGrp="1"/>
+          </p:cNvSpPr>
+          <p:nvPr/>
+        </p:nvSpPr>
+        <p:spPr>
+          <a:xfrm xmlns:a="http://schemas.openxmlformats.org/drawingml/2006/main">
+            <a:off x="1047750" y="3571875"/>
+            <a:ext cx="76200" cy="76200"/>
+          </a:xfrm>
+          <a:prstGeom xmlns:a="http://schemas.openxmlformats.org/drawingml/2006/main" prst="ellipse">
+            <a:avLst/>
+          </a:prstGeom>
+          <a:solidFill xmlns:a="http://schemas.openxmlformats.org/drawingml/2006/main">
+            <a:srgbClr val="2563EB"/>
+          </a:solidFill>
+          <a:ln xmlns:a="http://schemas.openxmlformats.org/drawingml/2006/main" w="0">
+            <a:noFill/>
+            <a:prstDash val="solid"/>
+          </a:ln>
+        </p:spPr>
+      </p:sp>
+      <p:sp>
+        <p:nvSpPr>
+          <p:cNvPr id="11" name="">
+            <a:extLst xmlns:a="http://schemas.openxmlformats.org/drawingml/2006/main">
+              <a:ext uri="{FF2B5EF4-FFF2-40B4-BE49-F238E27FC236}">
+                <a16:creationId xmlns:a16="http://schemas.microsoft.com/office/drawing/2014/main" id="{86CA11B9-23ED-4EA7-A27E-52D9F1B4D7B0}"/>
+              </a:ext>
+            </a:extLst>
+          </p:cNvPr>
+          <p:cNvSpPr>
+            <a:spLocks xmlns:a="http://schemas.openxmlformats.org/drawingml/2006/main" noGrp="1"/>
+          </p:cNvSpPr>
+          <p:nvPr/>
+        </p:nvSpPr>
+        <p:spPr>
+          <a:xfrm xmlns:a="http://schemas.openxmlformats.org/drawingml/2006/main">
+            <a:off x="1257300" y="3486150"/>
+            <a:ext cx="3695700" cy="361950"/>
+          </a:xfrm>
+          <a:prstGeom xmlns:a="http://schemas.openxmlformats.org/drawingml/2006/main" prst="rect">
+            <a:avLst/>
+          </a:prstGeom>
+          <a:noFill xmlns:a="http://schemas.openxmlformats.org/drawingml/2006/main"/>
+          <a:ln xmlns:a="http://schemas.openxmlformats.org/drawingml/2006/main" w="0">
+            <a:noFill/>
+            <a:prstDash val="solid"/>
+          </a:ln>
+        </p:spPr>
+        <p:txBody>
+          <a:bodyPr xmlns:a="http://schemas.openxmlformats.org/drawingml/2006/main"/>
+          <a:lstStyle xmlns:a="http://schemas.openxmlformats.org/drawingml/2006/main"/>
+          <a:p xmlns:a="http://schemas.openxmlformats.org/drawingml/2006/main">
+            <a:pPr>
+              <a:defRPr sz="1350" b="0">
+                <a:solidFill>
+                  <a:srgbClr val="111827"/>
+                </a:solidFill>
+              </a:defRPr>
+            </a:pPr>
+            <a:r>
+              <a:rPr sz="1350" b="0">
+                <a:solidFill>
+                  <a:srgbClr val="111827"/>
+                </a:solidFill>
+              </a:rPr>
+              <a:t>PCA: behavioral-pool, 3x3 quantile states</a:t>
+            </a:r>
+          </a:p>
+        </p:txBody>
+      </p:sp>
+      <p:sp>
+        <p:nvSpPr>
+          <p:cNvPr id="12" name="">
+            <a:extLst xmlns:a="http://schemas.openxmlformats.org/drawingml/2006/main">
+              <a:ext uri="{FF2B5EF4-FFF2-40B4-BE49-F238E27FC236}">
+                <a16:creationId xmlns:a16="http://schemas.microsoft.com/office/drawing/2014/main" id="{618126D9-1435-48C4-99F2-63BC7F47CB9D}"/>
+              </a:ext>
+            </a:extLst>
+          </p:cNvPr>
+          <p:cNvSpPr>
+            <a:spLocks xmlns:a="http://schemas.openxmlformats.org/drawingml/2006/main" noGrp="1"/>
+          </p:cNvSpPr>
+          <p:nvPr/>
+        </p:nvSpPr>
+        <p:spPr>
+          <a:xfrm xmlns:a="http://schemas.openxmlformats.org/drawingml/2006/main">
+            <a:off x="1047750" y="3895725"/>
+            <a:ext cx="76200" cy="76200"/>
+          </a:xfrm>
+          <a:prstGeom xmlns:a="http://schemas.openxmlformats.org/drawingml/2006/main" prst="ellipse">
+            <a:avLst/>
+          </a:prstGeom>
+          <a:solidFill xmlns:a="http://schemas.openxmlformats.org/drawingml/2006/main">
+            <a:srgbClr val="2563EB"/>
+          </a:solidFill>
+          <a:ln xmlns:a="http://schemas.openxmlformats.org/drawingml/2006/main" w="0">
+            <a:noFill/>
+            <a:prstDash val="solid"/>
+          </a:ln>
+        </p:spPr>
+      </p:sp>
+      <p:sp>
+        <p:nvSpPr>
+          <p:cNvPr id="13" name="">
+            <a:extLst xmlns:a="http://schemas.openxmlformats.org/drawingml/2006/main">
+              <a:ext uri="{FF2B5EF4-FFF2-40B4-BE49-F238E27FC236}">
+                <a16:creationId xmlns:a16="http://schemas.microsoft.com/office/drawing/2014/main" id="{3AEBBC96-9B67-4488-8414-423F59D7463D}"/>
+              </a:ext>
+            </a:extLst>
+          </p:cNvPr>
+          <p:cNvSpPr>
+            <a:spLocks xmlns:a="http://schemas.openxmlformats.org/drawingml/2006/main" noGrp="1"/>
+          </p:cNvSpPr>
+          <p:nvPr/>
+        </p:nvSpPr>
+        <p:spPr>
+          <a:xfrm xmlns:a="http://schemas.openxmlformats.org/drawingml/2006/main">
+            <a:off x="1257300" y="3810000"/>
+            <a:ext cx="3695700" cy="361950"/>
+          </a:xfrm>
+          <a:prstGeom xmlns:a="http://schemas.openxmlformats.org/drawingml/2006/main" prst="rect">
+            <a:avLst/>
+          </a:prstGeom>
+          <a:noFill xmlns:a="http://schemas.openxmlformats.org/drawingml/2006/main"/>
+          <a:ln xmlns:a="http://schemas.openxmlformats.org/drawingml/2006/main" w="0">
+            <a:noFill/>
+            <a:prstDash val="solid"/>
+          </a:ln>
+        </p:spPr>
+        <p:txBody>
+          <a:bodyPr xmlns:a="http://schemas.openxmlformats.org/drawingml/2006/main"/>
+          <a:lstStyle xmlns:a="http://schemas.openxmlformats.org/drawingml/2006/main"/>
+          <a:p xmlns:a="http://schemas.openxmlformats.org/drawingml/2006/main">
+            <a:pPr>
+              <a:defRPr sz="1350" b="0">
+                <a:solidFill>
+                  <a:srgbClr val="111827"/>
+                </a:solidFill>
+              </a:defRPr>
+            </a:pPr>
+            <a:r>
+              <a:rPr sz="1350" b="0">
+                <a:solidFill>
+                  <a:srgbClr val="111827"/>
+                </a:solidFill>
+              </a:rPr>
+              <a:t>Policy: pooled-family asset-variant</a:t>
+            </a:r>
+          </a:p>
+        </p:txBody>
+      </p:sp>
+      <p:sp>
+        <p:nvSpPr>
+          <p:cNvPr id="14" name="">
+            <a:extLst xmlns:a="http://schemas.openxmlformats.org/drawingml/2006/main">
+              <a:ext uri="{FF2B5EF4-FFF2-40B4-BE49-F238E27FC236}">
+                <a16:creationId xmlns:a16="http://schemas.microsoft.com/office/drawing/2014/main" id="{6F48D719-5AF5-42F6-8F17-11DA2E7ED6B8}"/>
+              </a:ext>
+            </a:extLst>
+          </p:cNvPr>
+          <p:cNvSpPr>
+            <a:spLocks xmlns:a="http://schemas.openxmlformats.org/drawingml/2006/main" noGrp="1"/>
+          </p:cNvSpPr>
+          <p:nvPr/>
+        </p:nvSpPr>
+        <p:spPr>
+          <a:xfrm xmlns:a="http://schemas.openxmlformats.org/drawingml/2006/main">
+            <a:off x="1047750" y="4219575"/>
+            <a:ext cx="76200" cy="76200"/>
+          </a:xfrm>
+          <a:prstGeom xmlns:a="http://schemas.openxmlformats.org/drawingml/2006/main" prst="ellipse">
+            <a:avLst/>
+          </a:prstGeom>
+          <a:solidFill xmlns:a="http://schemas.openxmlformats.org/drawingml/2006/main">
+            <a:srgbClr val="2563EB"/>
+          </a:solidFill>
+          <a:ln xmlns:a="http://schemas.openxmlformats.org/drawingml/2006/main" w="0">
+            <a:noFill/>
+            <a:prstDash val="solid"/>
+          </a:ln>
+        </p:spPr>
+      </p:sp>
+      <p:sp>
+        <p:nvSpPr>
+          <p:cNvPr id="15" name="">
+            <a:extLst xmlns:a="http://schemas.openxmlformats.org/drawingml/2006/main">
+              <a:ext uri="{FF2B5EF4-FFF2-40B4-BE49-F238E27FC236}">
+                <a16:creationId xmlns:a16="http://schemas.microsoft.com/office/drawing/2014/main" id="{6EF81309-8F0C-412D-8A67-C6DB5089B12E}"/>
+              </a:ext>
+            </a:extLst>
+          </p:cNvPr>
+          <p:cNvSpPr>
+            <a:spLocks xmlns:a="http://schemas.openxmlformats.org/drawingml/2006/main" noGrp="1"/>
+          </p:cNvSpPr>
+          <p:nvPr/>
+        </p:nvSpPr>
+        <p:spPr>
+          <a:xfrm xmlns:a="http://schemas.openxmlformats.org/drawingml/2006/main">
+            <a:off x="1257300" y="4133850"/>
+            <a:ext cx="3695700" cy="361950"/>
+          </a:xfrm>
+          <a:prstGeom xmlns:a="http://schemas.openxmlformats.org/drawingml/2006/main" prst="rect">
+            <a:avLst/>
+          </a:prstGeom>
+          <a:noFill xmlns:a="http://schemas.openxmlformats.org/drawingml/2006/main"/>
+          <a:ln xmlns:a="http://schemas.openxmlformats.org/drawingml/2006/main" w="0">
+            <a:noFill/>
+            <a:prstDash val="solid"/>
+          </a:ln>
+        </p:spPr>
+        <p:txBody>
+          <a:bodyPr xmlns:a="http://schemas.openxmlformats.org/drawingml/2006/main"/>
+          <a:lstStyle xmlns:a="http://schemas.openxmlformats.org/drawingml/2006/main"/>
+          <a:p xmlns:a="http://schemas.openxmlformats.org/drawingml/2006/main">
+            <a:pPr>
+              <a:defRPr sz="1350" b="0">
+                <a:solidFill>
+                  <a:srgbClr val="111827"/>
+                </a:solidFill>
+              </a:defRPr>
+            </a:pPr>
+            <a:r>
+              <a:rPr sz="1350" b="0">
+                <a:solidFill>
+                  <a:srgbClr val="111827"/>
+                </a:solidFill>
+              </a:rPr>
+              <a:t>Families: EMA, breakout, pullback, volatility breakout, no-trade</a:t>
+            </a:r>
+          </a:p>
+        </p:txBody>
+      </p:sp>
+      <p:sp>
+        <p:nvSpPr>
+          <p:cNvPr id="16" name="">
+            <a:extLst xmlns:a="http://schemas.openxmlformats.org/drawingml/2006/main">
+              <a:ext uri="{FF2B5EF4-FFF2-40B4-BE49-F238E27FC236}">
+                <a16:creationId xmlns:a16="http://schemas.microsoft.com/office/drawing/2014/main" id="{79B06206-3877-438C-B4D1-926C5A9916CA}"/>
+              </a:ext>
+            </a:extLst>
+          </p:cNvPr>
+          <p:cNvSpPr>
+            <a:spLocks xmlns:a="http://schemas.openxmlformats.org/drawingml/2006/main" noGrp="1"/>
+          </p:cNvSpPr>
+          <p:nvPr/>
+        </p:nvSpPr>
+        <p:spPr>
+          <a:xfrm xmlns:a="http://schemas.openxmlformats.org/drawingml/2006/main">
+            <a:off x="6496050" y="1943100"/>
+            <a:ext cx="4953000" cy="3333750"/>
+          </a:xfrm>
+          <a:prstGeom xmlns:a="http://schemas.openxmlformats.org/drawingml/2006/main" prst="roundRect">
+            <a:avLst>
+              <a:gd name="adj" fmla="val 2286"/>
+            </a:avLst>
+          </a:prstGeom>
+          <a:solidFill xmlns:a="http://schemas.openxmlformats.org/drawingml/2006/main">
+            <a:srgbClr val="F0FDF4"/>
+          </a:solidFill>
+          <a:ln xmlns:a="http://schemas.openxmlformats.org/drawingml/2006/main" w="9525">
+            <a:solidFill>
+              <a:srgbClr val="A7F3D0"/>
+            </a:solidFill>
+            <a:prstDash val="solid"/>
+          </a:ln>
+        </p:spPr>
+      </p:sp>
+      <p:sp>
+        <p:nvSpPr>
+          <p:cNvPr id="17" name="">
+            <a:extLst xmlns:a="http://schemas.openxmlformats.org/drawingml/2006/main">
+              <a:ext uri="{FF2B5EF4-FFF2-40B4-BE49-F238E27FC236}">
+                <a16:creationId xmlns:a16="http://schemas.microsoft.com/office/drawing/2014/main" id="{D4666629-F56D-4D53-AB7E-44ECB1F297AD}"/>
+              </a:ext>
+            </a:extLst>
+          </p:cNvPr>
+          <p:cNvSpPr>
+            <a:spLocks xmlns:a="http://schemas.openxmlformats.org/drawingml/2006/main" noGrp="1"/>
+          </p:cNvSpPr>
+          <p:nvPr/>
+        </p:nvSpPr>
+        <p:spPr>
+          <a:xfrm xmlns:a="http://schemas.openxmlformats.org/drawingml/2006/main">
+            <a:off x="6819900" y="2247900"/>
+            <a:ext cx="3429000" cy="304800"/>
+          </a:xfrm>
+          <a:prstGeom xmlns:a="http://schemas.openxmlformats.org/drawingml/2006/main" prst="rect">
+            <a:avLst/>
+          </a:prstGeom>
+          <a:noFill xmlns:a="http://schemas.openxmlformats.org/drawingml/2006/main"/>
+          <a:ln xmlns:a="http://schemas.openxmlformats.org/drawingml/2006/main" w="0">
+            <a:noFill/>
+            <a:prstDash val="solid"/>
+          </a:ln>
+        </p:spPr>
+        <p:txBody>
+          <a:bodyPr xmlns:a="http://schemas.openxmlformats.org/drawingml/2006/main"/>
+          <a:lstStyle xmlns:a="http://schemas.openxmlformats.org/drawingml/2006/main"/>
+          <a:p xmlns:a="http://schemas.openxmlformats.org/drawingml/2006/main">
+            <a:pPr>
+              <a:defRPr sz="2025" b="1">
+                <a:solidFill>
+                  <a:srgbClr val="177A55"/>
+                </a:solidFill>
+              </a:defRPr>
+            </a:pPr>
+            <a:r>
+              <a:rPr sz="2025" b="1">
+                <a:solidFill>
+                  <a:srgbClr val="177A55"/>
+                </a:solidFill>
+              </a:rPr>
+              <a:t>Why this matters</a:t>
+            </a:r>
+          </a:p>
+        </p:txBody>
+      </p:sp>
+      <p:sp>
+        <p:nvSpPr>
+          <p:cNvPr id="18" name="">
+            <a:extLst xmlns:a="http://schemas.openxmlformats.org/drawingml/2006/main">
+              <a:ext uri="{FF2B5EF4-FFF2-40B4-BE49-F238E27FC236}">
+                <a16:creationId xmlns:a16="http://schemas.microsoft.com/office/drawing/2014/main" id="{E20C6ADF-34D4-49F1-BCDF-3AFCDD95D209}"/>
+              </a:ext>
+            </a:extLst>
+          </p:cNvPr>
+          <p:cNvSpPr>
+            <a:spLocks xmlns:a="http://schemas.openxmlformats.org/drawingml/2006/main" noGrp="1"/>
+          </p:cNvSpPr>
+          <p:nvPr/>
+        </p:nvSpPr>
+        <p:spPr>
+          <a:xfrm xmlns:a="http://schemas.openxmlformats.org/drawingml/2006/main">
+            <a:off x="6838950" y="3000375"/>
+            <a:ext cx="76200" cy="76200"/>
+          </a:xfrm>
+          <a:prstGeom xmlns:a="http://schemas.openxmlformats.org/drawingml/2006/main" prst="ellipse">
+            <a:avLst/>
+          </a:prstGeom>
+          <a:solidFill xmlns:a="http://schemas.openxmlformats.org/drawingml/2006/main">
+            <a:srgbClr val="177A55"/>
+          </a:solidFill>
+          <a:ln xmlns:a="http://schemas.openxmlformats.org/drawingml/2006/main" w="0">
+            <a:noFill/>
+            <a:prstDash val="solid"/>
+          </a:ln>
+        </p:spPr>
+      </p:sp>
+      <p:sp>
+        <p:nvSpPr>
+          <p:cNvPr id="19" name="">
+            <a:extLst xmlns:a="http://schemas.openxmlformats.org/drawingml/2006/main">
+              <a:ext uri="{FF2B5EF4-FFF2-40B4-BE49-F238E27FC236}">
+                <a16:creationId xmlns:a16="http://schemas.microsoft.com/office/drawing/2014/main" id="{7CC1659A-0079-400B-9CDD-D13683EE02CA}"/>
+              </a:ext>
+            </a:extLst>
+          </p:cNvPr>
+          <p:cNvSpPr>
+            <a:spLocks xmlns:a="http://schemas.openxmlformats.org/drawingml/2006/main" noGrp="1"/>
+          </p:cNvSpPr>
+          <p:nvPr/>
+        </p:nvSpPr>
+        <p:spPr>
+          <a:xfrm xmlns:a="http://schemas.openxmlformats.org/drawingml/2006/main">
+            <a:off x="7048500" y="2914650"/>
+            <a:ext cx="3695700" cy="409575"/>
+          </a:xfrm>
+          <a:prstGeom xmlns:a="http://schemas.openxmlformats.org/drawingml/2006/main" prst="rect">
+            <a:avLst/>
+          </a:prstGeom>
+          <a:noFill xmlns:a="http://schemas.openxmlformats.org/drawingml/2006/main"/>
+          <a:ln xmlns:a="http://schemas.openxmlformats.org/drawingml/2006/main" w="0">
+            <a:noFill/>
+            <a:prstDash val="solid"/>
+          </a:ln>
+        </p:spPr>
+        <p:txBody>
+          <a:bodyPr xmlns:a="http://schemas.openxmlformats.org/drawingml/2006/main"/>
+          <a:lstStyle xmlns:a="http://schemas.openxmlformats.org/drawingml/2006/main"/>
+          <a:p xmlns:a="http://schemas.openxmlformats.org/drawingml/2006/main">
+            <a:pPr>
+              <a:defRPr sz="1350" b="0">
+                <a:solidFill>
+                  <a:srgbClr val="111827"/>
+                </a:solidFill>
+              </a:defRPr>
+            </a:pPr>
+            <a:r>
+              <a:rPr sz="1350" b="0">
+                <a:solidFill>
+                  <a:srgbClr val="111827"/>
+                </a:solidFill>
+              </a:rPr>
+              <a:t>It tests participation quality before adding basket curation</a:t>
+            </a:r>
+          </a:p>
+        </p:txBody>
+      </p:sp>
+      <p:sp>
+        <p:nvSpPr>
+          <p:cNvPr id="20" name="">
+            <a:extLst xmlns:a="http://schemas.openxmlformats.org/drawingml/2006/main">
+              <a:ext uri="{FF2B5EF4-FFF2-40B4-BE49-F238E27FC236}">
+                <a16:creationId xmlns:a16="http://schemas.microsoft.com/office/drawing/2014/main" id="{6F37CB97-20AC-400D-AF2D-3AB96B633B85}"/>
+              </a:ext>
+            </a:extLst>
+          </p:cNvPr>
+          <p:cNvSpPr>
+            <a:spLocks xmlns:a="http://schemas.openxmlformats.org/drawingml/2006/main" noGrp="1"/>
+          </p:cNvSpPr>
+          <p:nvPr/>
+        </p:nvSpPr>
+        <p:spPr>
+          <a:xfrm xmlns:a="http://schemas.openxmlformats.org/drawingml/2006/main">
+            <a:off x="6838950" y="3371850"/>
+            <a:ext cx="76200" cy="76200"/>
+          </a:xfrm>
+          <a:prstGeom xmlns:a="http://schemas.openxmlformats.org/drawingml/2006/main" prst="ellipse">
+            <a:avLst/>
+          </a:prstGeom>
+          <a:solidFill xmlns:a="http://schemas.openxmlformats.org/drawingml/2006/main">
+            <a:srgbClr val="177A55"/>
+          </a:solidFill>
+          <a:ln xmlns:a="http://schemas.openxmlformats.org/drawingml/2006/main" w="0">
+            <a:noFill/>
+            <a:prstDash val="solid"/>
+          </a:ln>
+        </p:spPr>
+      </p:sp>
+      <p:sp>
+        <p:nvSpPr>
+          <p:cNvPr id="21" name="">
+            <a:extLst xmlns:a="http://schemas.openxmlformats.org/drawingml/2006/main">
+              <a:ext uri="{FF2B5EF4-FFF2-40B4-BE49-F238E27FC236}">
+                <a16:creationId xmlns:a16="http://schemas.microsoft.com/office/drawing/2014/main" id="{16BF09B5-2693-4564-B5CF-03A4D31DE5B2}"/>
+              </a:ext>
+            </a:extLst>
+          </p:cNvPr>
+          <p:cNvSpPr>
+            <a:spLocks xmlns:a="http://schemas.openxmlformats.org/drawingml/2006/main" noGrp="1"/>
+          </p:cNvSpPr>
+          <p:nvPr/>
+        </p:nvSpPr>
+        <p:spPr>
+          <a:xfrm xmlns:a="http://schemas.openxmlformats.org/drawingml/2006/main">
+            <a:off x="7048500" y="3286125"/>
+            <a:ext cx="3695700" cy="409575"/>
+          </a:xfrm>
+          <a:prstGeom xmlns:a="http://schemas.openxmlformats.org/drawingml/2006/main" prst="rect">
+            <a:avLst/>
+          </a:prstGeom>
+          <a:noFill xmlns:a="http://schemas.openxmlformats.org/drawingml/2006/main"/>
+          <a:ln xmlns:a="http://schemas.openxmlformats.org/drawingml/2006/main" w="0">
+            <a:noFill/>
+            <a:prstDash val="solid"/>
+          </a:ln>
+        </p:spPr>
+        <p:txBody>
+          <a:bodyPr xmlns:a="http://schemas.openxmlformats.org/drawingml/2006/main"/>
+          <a:lstStyle xmlns:a="http://schemas.openxmlformats.org/drawingml/2006/main"/>
+          <a:p xmlns:a="http://schemas.openxmlformats.org/drawingml/2006/main">
+            <a:pPr>
+              <a:defRPr sz="1350" b="0">
+                <a:solidFill>
+                  <a:srgbClr val="111827"/>
+                </a:solidFill>
+              </a:defRPr>
+            </a:pPr>
+            <a:r>
+              <a:rPr sz="1350" b="0">
+                <a:solidFill>
+                  <a:srgbClr val="111827"/>
+                </a:solidFill>
+              </a:rPr>
+              <a:t>It keeps mean reversion and SMA out of the first specialist baseline</a:t>
+            </a:r>
+          </a:p>
+        </p:txBody>
+      </p:sp>
+      <p:sp>
+        <p:nvSpPr>
+          <p:cNvPr id="22" name="">
+            <a:extLst xmlns:a="http://schemas.openxmlformats.org/drawingml/2006/main">
+              <a:ext uri="{FF2B5EF4-FFF2-40B4-BE49-F238E27FC236}">
+                <a16:creationId xmlns:a16="http://schemas.microsoft.com/office/drawing/2014/main" id="{B92E38F8-E3EA-44F9-96D0-EE718C4C21F0}"/>
+              </a:ext>
+            </a:extLst>
+          </p:cNvPr>
+          <p:cNvSpPr>
+            <a:spLocks xmlns:a="http://schemas.openxmlformats.org/drawingml/2006/main" noGrp="1"/>
+          </p:cNvSpPr>
+          <p:nvPr/>
+        </p:nvSpPr>
+        <p:spPr>
+          <a:xfrm xmlns:a="http://schemas.openxmlformats.org/drawingml/2006/main">
+            <a:off x="6838950" y="3743325"/>
+            <a:ext cx="76200" cy="76200"/>
+          </a:xfrm>
+          <a:prstGeom xmlns:a="http://schemas.openxmlformats.org/drawingml/2006/main" prst="ellipse">
+            <a:avLst/>
+          </a:prstGeom>
+          <a:solidFill xmlns:a="http://schemas.openxmlformats.org/drawingml/2006/main">
+            <a:srgbClr val="177A55"/>
+          </a:solidFill>
+          <a:ln xmlns:a="http://schemas.openxmlformats.org/drawingml/2006/main" w="0">
+            <a:noFill/>
+            <a:prstDash val="solid"/>
+          </a:ln>
+        </p:spPr>
+      </p:sp>
+      <p:sp>
+        <p:nvSpPr>
+          <p:cNvPr id="23" name="">
+            <a:extLst xmlns:a="http://schemas.openxmlformats.org/drawingml/2006/main">
+              <a:ext uri="{FF2B5EF4-FFF2-40B4-BE49-F238E27FC236}">
+                <a16:creationId xmlns:a16="http://schemas.microsoft.com/office/drawing/2014/main" id="{E15FA4CF-E644-41F2-8418-05E4495488F2}"/>
+              </a:ext>
+            </a:extLst>
+          </p:cNvPr>
+          <p:cNvSpPr>
+            <a:spLocks xmlns:a="http://schemas.openxmlformats.org/drawingml/2006/main" noGrp="1"/>
+          </p:cNvSpPr>
+          <p:nvPr/>
+        </p:nvSpPr>
+        <p:spPr>
+          <a:xfrm xmlns:a="http://schemas.openxmlformats.org/drawingml/2006/main">
+            <a:off x="7048500" y="3657600"/>
+            <a:ext cx="3695700" cy="409575"/>
+          </a:xfrm>
+          <a:prstGeom xmlns:a="http://schemas.openxmlformats.org/drawingml/2006/main" prst="rect">
+            <a:avLst/>
+          </a:prstGeom>
+          <a:noFill xmlns:a="http://schemas.openxmlformats.org/drawingml/2006/main"/>
+          <a:ln xmlns:a="http://schemas.openxmlformats.org/drawingml/2006/main" w="0">
+            <a:noFill/>
+            <a:prstDash val="solid"/>
+          </a:ln>
+        </p:spPr>
+        <p:txBody>
+          <a:bodyPr xmlns:a="http://schemas.openxmlformats.org/drawingml/2006/main"/>
+          <a:lstStyle xmlns:a="http://schemas.openxmlformats.org/drawingml/2006/main"/>
+          <a:p xmlns:a="http://schemas.openxmlformats.org/drawingml/2006/main">
+            <a:pPr>
+              <a:defRPr sz="1350" b="0">
+                <a:solidFill>
+                  <a:srgbClr val="111827"/>
+                </a:solidFill>
+              </a:defRPr>
+            </a:pPr>
+            <a:r>
+              <a:rPr sz="1350" b="0">
+                <a:solidFill>
+                  <a:srgbClr val="111827"/>
+                </a:solidFill>
+              </a:rPr>
+              <a:t>It judges the system against the hard comparator: holding the exact basket</a:t>
+            </a:r>
+          </a:p>
+        </p:txBody>
+      </p:sp>
+      <p:sp>
+        <p:nvSpPr>
+          <p:cNvPr id="24" name="">
+            <a:extLst xmlns:a="http://schemas.openxmlformats.org/drawingml/2006/main">
+              <a:ext uri="{FF2B5EF4-FFF2-40B4-BE49-F238E27FC236}">
+                <a16:creationId xmlns:a16="http://schemas.microsoft.com/office/drawing/2014/main" id="{977B37E7-8306-433D-B7C3-5E95DCFA8B8F}"/>
+              </a:ext>
+            </a:extLst>
+          </p:cNvPr>
+          <p:cNvSpPr>
+            <a:spLocks xmlns:a="http://schemas.openxmlformats.org/drawingml/2006/main" noGrp="1"/>
+          </p:cNvSpPr>
+          <p:nvPr/>
+        </p:nvSpPr>
+        <p:spPr>
+          <a:xfrm xmlns:a="http://schemas.openxmlformats.org/drawingml/2006/main">
+            <a:off x="6838950" y="4114800"/>
+            <a:ext cx="76200" cy="76200"/>
+          </a:xfrm>
+          <a:prstGeom xmlns:a="http://schemas.openxmlformats.org/drawingml/2006/main" prst="ellipse">
+            <a:avLst/>
+          </a:prstGeom>
+          <a:solidFill xmlns:a="http://schemas.openxmlformats.org/drawingml/2006/main">
+            <a:srgbClr val="177A55"/>
+          </a:solidFill>
+          <a:ln xmlns:a="http://schemas.openxmlformats.org/drawingml/2006/main" w="0">
+            <a:noFill/>
+            <a:prstDash val="solid"/>
+          </a:ln>
+        </p:spPr>
+      </p:sp>
+      <p:sp>
+        <p:nvSpPr>
+          <p:cNvPr id="25" name="">
+            <a:extLst xmlns:a="http://schemas.openxmlformats.org/drawingml/2006/main">
+              <a:ext uri="{FF2B5EF4-FFF2-40B4-BE49-F238E27FC236}">
+                <a16:creationId xmlns:a16="http://schemas.microsoft.com/office/drawing/2014/main" id="{6C877C2E-399A-4358-91A6-A325F9805CE5}"/>
+              </a:ext>
+            </a:extLst>
+          </p:cNvPr>
+          <p:cNvSpPr>
+            <a:spLocks xmlns:a="http://schemas.openxmlformats.org/drawingml/2006/main" noGrp="1"/>
+          </p:cNvSpPr>
+          <p:nvPr/>
+        </p:nvSpPr>
+        <p:spPr>
+          <a:xfrm xmlns:a="http://schemas.openxmlformats.org/drawingml/2006/main">
+            <a:off x="7048500" y="4029075"/>
+            <a:ext cx="3695700" cy="409575"/>
+          </a:xfrm>
+          <a:prstGeom xmlns:a="http://schemas.openxmlformats.org/drawingml/2006/main" prst="rect">
+            <a:avLst/>
+          </a:prstGeom>
+          <a:noFill xmlns:a="http://schemas.openxmlformats.org/drawingml/2006/main"/>
+          <a:ln xmlns:a="http://schemas.openxmlformats.org/drawingml/2006/main" w="0">
+            <a:noFill/>
+            <a:prstDash val="solid"/>
+          </a:ln>
+        </p:spPr>
+        <p:txBody>
+          <a:bodyPr xmlns:a="http://schemas.openxmlformats.org/drawingml/2006/main"/>
+          <a:lstStyle xmlns:a="http://schemas.openxmlformats.org/drawingml/2006/main"/>
+          <a:p xmlns:a="http://schemas.openxmlformats.org/drawingml/2006/main">
+            <a:pPr>
+              <a:defRPr sz="1350" b="0">
+                <a:solidFill>
+                  <a:srgbClr val="111827"/>
+                </a:solidFill>
+              </a:defRPr>
+            </a:pPr>
+            <a:r>
+              <a:rPr sz="1350" b="0">
+                <a:solidFill>
+                  <a:srgbClr val="111827"/>
+                </a:solidFill>
+              </a:rPr>
+              <a:t>It separates upside capture from drawdown avoidance</a:t>
+            </a:r>
+          </a:p>
+        </p:txBody>
+      </p:sp>
+    </p:spTree>
+    <p:extLst>
+      <p:ext uri="{BB962C8B-B14F-4D97-AF65-F5344CB8AC3E}">
+        <p14:creationId xmlns:p14="http://schemas.microsoft.com/office/powerpoint/2010/main" val="1282990229"/>
+      </p:ext>
+    </p:extLst>
+  </p:cSld>
+</p:sld>
+</file>
+
+<file path=ppt/slides/slide11.xml><?xml version="1.0" encoding="utf-8"?>
+<p:sld xmlns:p="http://schemas.openxmlformats.org/presentationml/2006/main">
+  <p:cSld>
+    <p:bg>
+      <p:bgPr>
+        <a:solidFill xmlns:a="http://schemas.openxmlformats.org/drawingml/2006/main">
+          <a:srgbClr val="FFFFFF"/>
+        </a:solidFill>
+      </p:bgPr>
+    </p:bg>
+    <p:spTree>
+      <p:nvGrpSpPr>
+        <p:cNvPr id="1" name=""/>
+        <p:cNvGrpSpPr/>
+        <p:nvPr/>
+      </p:nvGrpSpPr>
+      <p:grpSpPr>
+        <a:xfrm xmlns:a="http://schemas.openxmlformats.org/drawingml/2006/main"/>
+      </p:grpSpPr>
+      <p:sp>
+        <p:nvSpPr>
+          <p:cNvPr id="1" name="">
+            <a:extLst xmlns:a="http://schemas.openxmlformats.org/drawingml/2006/main">
+              <a:ext uri="{FF2B5EF4-FFF2-40B4-BE49-F238E27FC236}">
+                <a16:creationId xmlns:a16="http://schemas.microsoft.com/office/drawing/2014/main" id="{70CD79F7-CC52-4B5B-9E87-16A329432F58}"/>
+              </a:ext>
+            </a:extLst>
+          </p:cNvPr>
+          <p:cNvSpPr>
+            <a:spLocks xmlns:a="http://schemas.openxmlformats.org/drawingml/2006/main" noGrp="1"/>
+          </p:cNvSpPr>
+          <p:nvPr/>
+        </p:nvSpPr>
+        <p:spPr>
+          <a:xfrm xmlns:a="http://schemas.openxmlformats.org/drawingml/2006/main">
+            <a:off x="609600" y="304800"/>
+            <a:ext cx="5334000" cy="209550"/>
+          </a:xfrm>
+          <a:prstGeom xmlns:a="http://schemas.openxmlformats.org/drawingml/2006/main" prst="rect">
+            <a:avLst/>
+          </a:prstGeom>
+          <a:noFill xmlns:a="http://schemas.openxmlformats.org/drawingml/2006/main"/>
+          <a:ln xmlns:a="http://schemas.openxmlformats.org/drawingml/2006/main" w="0">
+            <a:noFill/>
+            <a:prstDash val="solid"/>
+          </a:ln>
+        </p:spPr>
+        <p:txBody>
+          <a:bodyPr xmlns:a="http://schemas.openxmlformats.org/drawingml/2006/main"/>
+          <a:lstStyle xmlns:a="http://schemas.openxmlformats.org/drawingml/2006/main"/>
+          <a:p xmlns:a="http://schemas.openxmlformats.org/drawingml/2006/main">
+            <a:pPr>
+              <a:defRPr sz="975" b="1">
+                <a:solidFill>
+                  <a:srgbClr val="2563EB"/>
+                </a:solidFill>
+              </a:defRPr>
+            </a:pPr>
+            <a:r>
+              <a:rPr sz="975" b="1">
+                <a:solidFill>
+                  <a:srgbClr val="2563EB"/>
+                </a:solidFill>
+              </a:rPr>
+              <a:t>GEN5.3 PCA RESEARCH PIVOT</a:t>
+            </a:r>
+          </a:p>
+        </p:txBody>
+      </p:sp>
+      <p:sp>
+        <p:nvSpPr>
+          <p:cNvPr id="2" name="">
+            <a:extLst xmlns:a="http://schemas.openxmlformats.org/drawingml/2006/main">
+              <a:ext uri="{FF2B5EF4-FFF2-40B4-BE49-F238E27FC236}">
+                <a16:creationId xmlns:a16="http://schemas.microsoft.com/office/drawing/2014/main" id="{84C4786C-A965-468D-98B5-1E1DC94F5841}"/>
+              </a:ext>
+            </a:extLst>
+          </p:cNvPr>
+          <p:cNvSpPr>
+            <a:spLocks xmlns:a="http://schemas.openxmlformats.org/drawingml/2006/main" noGrp="1"/>
+          </p:cNvSpPr>
+          <p:nvPr/>
+        </p:nvSpPr>
+        <p:spPr>
+          <a:xfrm xmlns:a="http://schemas.openxmlformats.org/drawingml/2006/main">
+            <a:off x="609600" y="647700"/>
+            <a:ext cx="9334500" cy="876300"/>
+          </a:xfrm>
+          <a:prstGeom xmlns:a="http://schemas.openxmlformats.org/drawingml/2006/main" prst="rect">
+            <a:avLst/>
+          </a:prstGeom>
+          <a:noFill xmlns:a="http://schemas.openxmlformats.org/drawingml/2006/main"/>
+          <a:ln xmlns:a="http://schemas.openxmlformats.org/drawingml/2006/main" w="0">
+            <a:noFill/>
+            <a:prstDash val="solid"/>
+          </a:ln>
+        </p:spPr>
+        <p:txBody>
+          <a:bodyPr xmlns:a="http://schemas.openxmlformats.org/drawingml/2006/main"/>
+          <a:lstStyle xmlns:a="http://schemas.openxmlformats.org/drawingml/2006/main"/>
+          <a:p xmlns:a="http://schemas.openxmlformats.org/drawingml/2006/main">
+            <a:pPr>
+              <a:defRPr sz="2775" b="1">
+                <a:solidFill>
+                  <a:srgbClr val="111827"/>
+                </a:solidFill>
+              </a:defRPr>
+            </a:pPr>
+            <a:r>
+              <a:rPr sz="2775" b="1">
+                <a:solidFill>
+                  <a:srgbClr val="111827"/>
+                </a:solidFill>
+              </a:rPr>
+              <a:t>The baseline protected capital in stress but still undercaptured the rebound</a:t>
+            </a:r>
+          </a:p>
+        </p:txBody>
+      </p:sp>
+      <p:sp>
+        <p:nvSpPr>
+          <p:cNvPr id="3" name="">
+            <a:extLst xmlns:a="http://schemas.openxmlformats.org/drawingml/2006/main">
+              <a:ext uri="{FF2B5EF4-FFF2-40B4-BE49-F238E27FC236}">
+                <a16:creationId xmlns:a16="http://schemas.microsoft.com/office/drawing/2014/main" id="{14F1C752-0696-46AC-A71B-53B41F53F791}"/>
+              </a:ext>
+            </a:extLst>
+          </p:cNvPr>
+          <p:cNvSpPr>
+            <a:spLocks xmlns:a="http://schemas.openxmlformats.org/drawingml/2006/main" noGrp="1"/>
+          </p:cNvSpPr>
+          <p:nvPr/>
+        </p:nvSpPr>
+        <p:spPr>
+          <a:xfrm xmlns:a="http://schemas.openxmlformats.org/drawingml/2006/main">
+            <a:off x="609600" y="1485900"/>
+            <a:ext cx="10572750" cy="9525"/>
+          </a:xfrm>
+          <a:prstGeom xmlns:a="http://schemas.openxmlformats.org/drawingml/2006/main" prst="rect">
+            <a:avLst/>
+          </a:prstGeom>
+          <a:solidFill xmlns:a="http://schemas.openxmlformats.org/drawingml/2006/main">
+            <a:srgbClr val="CBD3DD"/>
+          </a:solidFill>
+          <a:ln xmlns:a="http://schemas.openxmlformats.org/drawingml/2006/main" w="0">
+            <a:solidFill>
+              <a:srgbClr val="CBD3DD"/>
+            </a:solidFill>
+            <a:prstDash val="solid"/>
+          </a:ln>
+        </p:spPr>
+      </p:sp>
+      <p:sp>
+        <p:nvSpPr>
+          <p:cNvPr id="4" name="">
+            <a:extLst xmlns:a="http://schemas.openxmlformats.org/drawingml/2006/main">
+              <a:ext uri="{FF2B5EF4-FFF2-40B4-BE49-F238E27FC236}">
+                <a16:creationId xmlns:a16="http://schemas.microsoft.com/office/drawing/2014/main" id="{68EE189A-3DFF-4A5E-B1DE-9358766A46DA}"/>
+              </a:ext>
+            </a:extLst>
+          </p:cNvPr>
+          <p:cNvSpPr>
+            <a:spLocks xmlns:a="http://schemas.openxmlformats.org/drawingml/2006/main" noGrp="1"/>
+          </p:cNvSpPr>
+          <p:nvPr/>
+        </p:nvSpPr>
+        <p:spPr>
+          <a:xfrm xmlns:a="http://schemas.openxmlformats.org/drawingml/2006/main">
+            <a:off x="685800" y="2000250"/>
+            <a:ext cx="2571750" cy="1333500"/>
+          </a:xfrm>
+          <a:prstGeom xmlns:a="http://schemas.openxmlformats.org/drawingml/2006/main" prst="roundRect">
+            <a:avLst>
+              <a:gd name="adj" fmla="val 5714"/>
+            </a:avLst>
+          </a:prstGeom>
+          <a:solidFill xmlns:a="http://schemas.openxmlformats.org/drawingml/2006/main">
+            <a:srgbClr val="FFF1F2"/>
+          </a:solidFill>
+          <a:ln xmlns:a="http://schemas.openxmlformats.org/drawingml/2006/main" w="9525">
+            <a:solidFill>
+              <a:srgbClr val="FDA4AF"/>
+            </a:solidFill>
+            <a:prstDash val="solid"/>
+          </a:ln>
+        </p:spPr>
+      </p:sp>
+      <p:sp>
+        <p:nvSpPr>
+          <p:cNvPr id="5" name="">
+            <a:extLst xmlns:a="http://schemas.openxmlformats.org/drawingml/2006/main">
+              <a:ext uri="{FF2B5EF4-FFF2-40B4-BE49-F238E27FC236}">
+                <a16:creationId xmlns:a16="http://schemas.microsoft.com/office/drawing/2014/main" id="{5D4838EE-EB96-4EEC-832C-583C99B959FF}"/>
+              </a:ext>
+            </a:extLst>
+          </p:cNvPr>
+          <p:cNvSpPr>
+            <a:spLocks xmlns:a="http://schemas.openxmlformats.org/drawingml/2006/main" noGrp="1"/>
+          </p:cNvSpPr>
+          <p:nvPr/>
+        </p:nvSpPr>
+        <p:spPr>
+          <a:xfrm xmlns:a="http://schemas.openxmlformats.org/drawingml/2006/main">
+            <a:off x="914400" y="2266950"/>
+            <a:ext cx="2000250" cy="438150"/>
+          </a:xfrm>
+          <a:prstGeom xmlns:a="http://schemas.openxmlformats.org/drawingml/2006/main" prst="rect">
+            <a:avLst/>
+          </a:prstGeom>
+          <a:noFill xmlns:a="http://schemas.openxmlformats.org/drawingml/2006/main"/>
+          <a:ln xmlns:a="http://schemas.openxmlformats.org/drawingml/2006/main" w="0">
+            <a:noFill/>
+            <a:prstDash val="solid"/>
+          </a:ln>
+        </p:spPr>
+        <p:txBody>
+          <a:bodyPr xmlns:a="http://schemas.openxmlformats.org/drawingml/2006/main"/>
+          <a:lstStyle xmlns:a="http://schemas.openxmlformats.org/drawingml/2006/main"/>
+          <a:p xmlns:a="http://schemas.openxmlformats.org/drawingml/2006/main">
+            <a:pPr algn="ctr">
+              <a:defRPr sz="2550" b="1">
+                <a:solidFill>
+                  <a:srgbClr val="D1495B"/>
+                </a:solidFill>
+              </a:defRPr>
+            </a:pPr>
+            <a:r>
+              <a:rPr sz="2550" b="1">
+                <a:solidFill>
+                  <a:srgbClr val="D1495B"/>
+                </a:solidFill>
+              </a:rPr>
+              <a:t>-31.9 pp</a:t>
+            </a:r>
+          </a:p>
+        </p:txBody>
+      </p:sp>
+      <p:sp>
+        <p:nvSpPr>
+          <p:cNvPr id="6" name="">
+            <a:extLst xmlns:a="http://schemas.openxmlformats.org/drawingml/2006/main">
+              <a:ext uri="{FF2B5EF4-FFF2-40B4-BE49-F238E27FC236}">
+                <a16:creationId xmlns:a16="http://schemas.microsoft.com/office/drawing/2014/main" id="{C41DBB9B-A087-47E9-B5A0-840B923BE7AE}"/>
+              </a:ext>
+            </a:extLst>
+          </p:cNvPr>
+          <p:cNvSpPr>
+            <a:spLocks xmlns:a="http://schemas.openxmlformats.org/drawingml/2006/main" noGrp="1"/>
+          </p:cNvSpPr>
+          <p:nvPr/>
+        </p:nvSpPr>
+        <p:spPr>
+          <a:xfrm xmlns:a="http://schemas.openxmlformats.org/drawingml/2006/main">
+            <a:off x="933450" y="2800350"/>
+            <a:ext cx="2000250" cy="361950"/>
+          </a:xfrm>
+          <a:prstGeom xmlns:a="http://schemas.openxmlformats.org/drawingml/2006/main" prst="rect">
+            <a:avLst/>
+          </a:prstGeom>
+          <a:noFill xmlns:a="http://schemas.openxmlformats.org/drawingml/2006/main"/>
+          <a:ln xmlns:a="http://schemas.openxmlformats.org/drawingml/2006/main" w="0">
+            <a:noFill/>
+            <a:prstDash val="solid"/>
+          </a:ln>
+        </p:spPr>
+        <p:txBody>
+          <a:bodyPr xmlns:a="http://schemas.openxmlformats.org/drawingml/2006/main"/>
+          <a:lstStyle xmlns:a="http://schemas.openxmlformats.org/drawingml/2006/main"/>
+          <a:p xmlns:a="http://schemas.openxmlformats.org/drawingml/2006/main">
+            <a:pPr algn="ctr">
+              <a:defRPr sz="1200" b="0">
+                <a:solidFill>
+                  <a:srgbClr val="5B6472"/>
+                </a:solidFill>
+              </a:defRPr>
+            </a:pPr>
+            <a:r>
+              <a:rPr sz="1200" b="0">
+                <a:solidFill>
+                  <a:srgbClr val="5B6472"/>
+                </a:solidFill>
+              </a:rPr>
+              <a:t>Continuation alpha vs hold in 2020Q3</a:t>
+            </a:r>
+          </a:p>
+        </p:txBody>
+      </p:sp>
+      <p:sp>
+        <p:nvSpPr>
+          <p:cNvPr id="7" name="">
+            <a:extLst xmlns:a="http://schemas.openxmlformats.org/drawingml/2006/main">
+              <a:ext uri="{FF2B5EF4-FFF2-40B4-BE49-F238E27FC236}">
+                <a16:creationId xmlns:a16="http://schemas.microsoft.com/office/drawing/2014/main" id="{97F24DF0-767F-4E4F-ABF6-110329071EF9}"/>
+              </a:ext>
+            </a:extLst>
+          </p:cNvPr>
+          <p:cNvSpPr>
+            <a:spLocks xmlns:a="http://schemas.openxmlformats.org/drawingml/2006/main" noGrp="1"/>
+          </p:cNvSpPr>
+          <p:nvPr/>
+        </p:nvSpPr>
+        <p:spPr>
+          <a:xfrm xmlns:a="http://schemas.openxmlformats.org/drawingml/2006/main">
+            <a:off x="685800" y="3714750"/>
+            <a:ext cx="2571750" cy="1333500"/>
+          </a:xfrm>
+          <a:prstGeom xmlns:a="http://schemas.openxmlformats.org/drawingml/2006/main" prst="roundRect">
+            <a:avLst>
+              <a:gd name="adj" fmla="val 5714"/>
+            </a:avLst>
+          </a:prstGeom>
+          <a:solidFill xmlns:a="http://schemas.openxmlformats.org/drawingml/2006/main">
+            <a:srgbClr val="ECFDF5"/>
+          </a:solidFill>
+          <a:ln xmlns:a="http://schemas.openxmlformats.org/drawingml/2006/main" w="9525">
+            <a:solidFill>
+              <a:srgbClr val="A7F3D0"/>
+            </a:solidFill>
+            <a:prstDash val="solid"/>
+          </a:ln>
+        </p:spPr>
+      </p:sp>
+      <p:sp>
+        <p:nvSpPr>
+          <p:cNvPr id="8" name="">
+            <a:extLst xmlns:a="http://schemas.openxmlformats.org/drawingml/2006/main">
+              <a:ext uri="{FF2B5EF4-FFF2-40B4-BE49-F238E27FC236}">
+                <a16:creationId xmlns:a16="http://schemas.microsoft.com/office/drawing/2014/main" id="{6AC8CE07-F207-43E9-B447-C4675B480F28}"/>
+              </a:ext>
+            </a:extLst>
+          </p:cNvPr>
+          <p:cNvSpPr>
+            <a:spLocks xmlns:a="http://schemas.openxmlformats.org/drawingml/2006/main" noGrp="1"/>
+          </p:cNvSpPr>
+          <p:nvPr/>
+        </p:nvSpPr>
+        <p:spPr>
+          <a:xfrm xmlns:a="http://schemas.openxmlformats.org/drawingml/2006/main">
+            <a:off x="914400" y="3981450"/>
+            <a:ext cx="2000250" cy="438150"/>
+          </a:xfrm>
+          <a:prstGeom xmlns:a="http://schemas.openxmlformats.org/drawingml/2006/main" prst="rect">
+            <a:avLst/>
+          </a:prstGeom>
+          <a:noFill xmlns:a="http://schemas.openxmlformats.org/drawingml/2006/main"/>
+          <a:ln xmlns:a="http://schemas.openxmlformats.org/drawingml/2006/main" w="0">
+            <a:noFill/>
+            <a:prstDash val="solid"/>
+          </a:ln>
+        </p:spPr>
+        <p:txBody>
+          <a:bodyPr xmlns:a="http://schemas.openxmlformats.org/drawingml/2006/main"/>
+          <a:lstStyle xmlns:a="http://schemas.openxmlformats.org/drawingml/2006/main"/>
+          <a:p xmlns:a="http://schemas.openxmlformats.org/drawingml/2006/main">
+            <a:pPr algn="ctr">
+              <a:defRPr sz="2550" b="1">
+                <a:solidFill>
+                  <a:srgbClr val="177A55"/>
+                </a:solidFill>
+              </a:defRPr>
+            </a:pPr>
+            <a:r>
+              <a:rPr sz="2550" b="1">
+                <a:solidFill>
+                  <a:srgbClr val="177A55"/>
+                </a:solidFill>
+              </a:rPr>
+              <a:t>+12.2 pp</a:t>
+            </a:r>
+          </a:p>
+        </p:txBody>
+      </p:sp>
+      <p:sp>
+        <p:nvSpPr>
+          <p:cNvPr id="9" name="">
+            <a:extLst xmlns:a="http://schemas.openxmlformats.org/drawingml/2006/main">
+              <a:ext uri="{FF2B5EF4-FFF2-40B4-BE49-F238E27FC236}">
+                <a16:creationId xmlns:a16="http://schemas.microsoft.com/office/drawing/2014/main" id="{49A7CF44-E324-476F-B66F-A92273B710CC}"/>
+              </a:ext>
+            </a:extLst>
+          </p:cNvPr>
+          <p:cNvSpPr>
+            <a:spLocks xmlns:a="http://schemas.openxmlformats.org/drawingml/2006/main" noGrp="1"/>
+          </p:cNvSpPr>
+          <p:nvPr/>
+        </p:nvSpPr>
+        <p:spPr>
+          <a:xfrm xmlns:a="http://schemas.openxmlformats.org/drawingml/2006/main">
+            <a:off x="933450" y="4514850"/>
+            <a:ext cx="2000250" cy="361950"/>
+          </a:xfrm>
+          <a:prstGeom xmlns:a="http://schemas.openxmlformats.org/drawingml/2006/main" prst="rect">
+            <a:avLst/>
+          </a:prstGeom>
+          <a:noFill xmlns:a="http://schemas.openxmlformats.org/drawingml/2006/main"/>
+          <a:ln xmlns:a="http://schemas.openxmlformats.org/drawingml/2006/main" w="0">
+            <a:noFill/>
+            <a:prstDash val="solid"/>
+          </a:ln>
+        </p:spPr>
+        <p:txBody>
+          <a:bodyPr xmlns:a="http://schemas.openxmlformats.org/drawingml/2006/main"/>
+          <a:lstStyle xmlns:a="http://schemas.openxmlformats.org/drawingml/2006/main"/>
+          <a:p xmlns:a="http://schemas.openxmlformats.org/drawingml/2006/main">
+            <a:pPr algn="ctr">
+              <a:defRPr sz="1200" b="0">
+                <a:solidFill>
+                  <a:srgbClr val="5B6472"/>
+                </a:solidFill>
+              </a:defRPr>
+            </a:pPr>
+            <a:r>
+              <a:rPr sz="1200" b="0">
+                <a:solidFill>
+                  <a:srgbClr val="5B6472"/>
+                </a:solidFill>
+              </a:rPr>
+              <a:t>Continuation alpha vs hold in 2022Q1</a:t>
+            </a:r>
+          </a:p>
+        </p:txBody>
+      </p:sp>
+      <p:sp>
+        <p:nvSpPr>
+          <p:cNvPr id="10" name="">
+            <a:extLst xmlns:a="http://schemas.openxmlformats.org/drawingml/2006/main">
+              <a:ext uri="{FF2B5EF4-FFF2-40B4-BE49-F238E27FC236}">
+                <a16:creationId xmlns:a16="http://schemas.microsoft.com/office/drawing/2014/main" id="{E50BBEF9-5B1D-4F04-862D-80266BD1D07F}"/>
+              </a:ext>
+            </a:extLst>
+          </p:cNvPr>
+          <p:cNvSpPr>
+            <a:spLocks xmlns:a="http://schemas.openxmlformats.org/drawingml/2006/main" noGrp="1"/>
+          </p:cNvSpPr>
+          <p:nvPr/>
+        </p:nvSpPr>
+        <p:spPr>
+          <a:xfrm xmlns:a="http://schemas.openxmlformats.org/drawingml/2006/main">
+            <a:off x="3562350" y="2000250"/>
+            <a:ext cx="2571750" cy="1333500"/>
+          </a:xfrm>
+          <a:prstGeom xmlns:a="http://schemas.openxmlformats.org/drawingml/2006/main" prst="roundRect">
+            <a:avLst>
+              <a:gd name="adj" fmla="val 5714"/>
+            </a:avLst>
+          </a:prstGeom>
+          <a:solidFill xmlns:a="http://schemas.openxmlformats.org/drawingml/2006/main">
+            <a:srgbClr val="F8FAFC"/>
+          </a:solidFill>
+          <a:ln xmlns:a="http://schemas.openxmlformats.org/drawingml/2006/main" w="9525">
+            <a:solidFill>
+              <a:srgbClr val="CBD5E1"/>
+            </a:solidFill>
+            <a:prstDash val="solid"/>
+          </a:ln>
+        </p:spPr>
+      </p:sp>
+      <p:sp>
+        <p:nvSpPr>
+          <p:cNvPr id="11" name="">
+            <a:extLst xmlns:a="http://schemas.openxmlformats.org/drawingml/2006/main">
+              <a:ext uri="{FF2B5EF4-FFF2-40B4-BE49-F238E27FC236}">
+                <a16:creationId xmlns:a16="http://schemas.microsoft.com/office/drawing/2014/main" id="{62F08763-2A0D-4849-9048-B4E69D45C0A8}"/>
+              </a:ext>
+            </a:extLst>
+          </p:cNvPr>
+          <p:cNvSpPr>
+            <a:spLocks xmlns:a="http://schemas.openxmlformats.org/drawingml/2006/main" noGrp="1"/>
+          </p:cNvSpPr>
+          <p:nvPr/>
+        </p:nvSpPr>
+        <p:spPr>
+          <a:xfrm xmlns:a="http://schemas.openxmlformats.org/drawingml/2006/main">
+            <a:off x="3790950" y="2266950"/>
+            <a:ext cx="2000250" cy="438150"/>
+          </a:xfrm>
+          <a:prstGeom xmlns:a="http://schemas.openxmlformats.org/drawingml/2006/main" prst="rect">
+            <a:avLst/>
+          </a:prstGeom>
+          <a:noFill xmlns:a="http://schemas.openxmlformats.org/drawingml/2006/main"/>
+          <a:ln xmlns:a="http://schemas.openxmlformats.org/drawingml/2006/main" w="0">
+            <a:noFill/>
+            <a:prstDash val="solid"/>
+          </a:ln>
+        </p:spPr>
+        <p:txBody>
+          <a:bodyPr xmlns:a="http://schemas.openxmlformats.org/drawingml/2006/main"/>
+          <a:lstStyle xmlns:a="http://schemas.openxmlformats.org/drawingml/2006/main"/>
+          <a:p xmlns:a="http://schemas.openxmlformats.org/drawingml/2006/main">
+            <a:pPr algn="ctr">
+              <a:defRPr sz="2550" b="1">
+                <a:solidFill>
+                  <a:srgbClr val="0F9F8F"/>
+                </a:solidFill>
+              </a:defRPr>
+            </a:pPr>
+            <a:r>
+              <a:rPr sz="2550" b="1">
+                <a:solidFill>
+                  <a:srgbClr val="0F9F8F"/>
+                </a:solidFill>
+              </a:rPr>
+              <a:t>57.2%</a:t>
+            </a:r>
+          </a:p>
+        </p:txBody>
+      </p:sp>
+      <p:sp>
+        <p:nvSpPr>
+          <p:cNvPr id="12" name="">
+            <a:extLst xmlns:a="http://schemas.openxmlformats.org/drawingml/2006/main">
+              <a:ext uri="{FF2B5EF4-FFF2-40B4-BE49-F238E27FC236}">
+                <a16:creationId xmlns:a16="http://schemas.microsoft.com/office/drawing/2014/main" id="{DDD8C620-B4FD-4BE9-996B-09E6C1796601}"/>
+              </a:ext>
+            </a:extLst>
+          </p:cNvPr>
+          <p:cNvSpPr>
+            <a:spLocks xmlns:a="http://schemas.openxmlformats.org/drawingml/2006/main" noGrp="1"/>
+          </p:cNvSpPr>
+          <p:nvPr/>
+        </p:nvSpPr>
+        <p:spPr>
+          <a:xfrm xmlns:a="http://schemas.openxmlformats.org/drawingml/2006/main">
+            <a:off x="3810000" y="2800350"/>
+            <a:ext cx="2000250" cy="361950"/>
+          </a:xfrm>
+          <a:prstGeom xmlns:a="http://schemas.openxmlformats.org/drawingml/2006/main" prst="rect">
+            <a:avLst/>
+          </a:prstGeom>
+          <a:noFill xmlns:a="http://schemas.openxmlformats.org/drawingml/2006/main"/>
+          <a:ln xmlns:a="http://schemas.openxmlformats.org/drawingml/2006/main" w="0">
+            <a:noFill/>
+            <a:prstDash val="solid"/>
+          </a:ln>
+        </p:spPr>
+        <p:txBody>
+          <a:bodyPr xmlns:a="http://schemas.openxmlformats.org/drawingml/2006/main"/>
+          <a:lstStyle xmlns:a="http://schemas.openxmlformats.org/drawingml/2006/main"/>
+          <a:p xmlns:a="http://schemas.openxmlformats.org/drawingml/2006/main">
+            <a:pPr algn="ctr">
+              <a:defRPr sz="1200" b="0">
+                <a:solidFill>
+                  <a:srgbClr val="5B6472"/>
+                </a:solidFill>
+              </a:defRPr>
+            </a:pPr>
+            <a:r>
+              <a:rPr sz="1200" b="0">
+                <a:solidFill>
+                  <a:srgbClr val="5B6472"/>
+                </a:solidFill>
+              </a:rPr>
+              <a:t>Continuation exposure in 2020Q3</a:t>
+            </a:r>
+          </a:p>
+        </p:txBody>
+      </p:sp>
+      <p:sp>
+        <p:nvSpPr>
+          <p:cNvPr id="13" name="">
+            <a:extLst xmlns:a="http://schemas.openxmlformats.org/drawingml/2006/main">
+              <a:ext uri="{FF2B5EF4-FFF2-40B4-BE49-F238E27FC236}">
+                <a16:creationId xmlns:a16="http://schemas.microsoft.com/office/drawing/2014/main" id="{315AA798-8273-420D-953D-0C81C2AC7EB6}"/>
+              </a:ext>
+            </a:extLst>
+          </p:cNvPr>
+          <p:cNvSpPr>
+            <a:spLocks xmlns:a="http://schemas.openxmlformats.org/drawingml/2006/main" noGrp="1"/>
+          </p:cNvSpPr>
+          <p:nvPr/>
+        </p:nvSpPr>
+        <p:spPr>
+          <a:xfrm xmlns:a="http://schemas.openxmlformats.org/drawingml/2006/main">
+            <a:off x="3562350" y="3714750"/>
+            <a:ext cx="2571750" cy="1333500"/>
+          </a:xfrm>
+          <a:prstGeom xmlns:a="http://schemas.openxmlformats.org/drawingml/2006/main" prst="roundRect">
+            <a:avLst>
+              <a:gd name="adj" fmla="val 5714"/>
+            </a:avLst>
+          </a:prstGeom>
+          <a:solidFill xmlns:a="http://schemas.openxmlformats.org/drawingml/2006/main">
+            <a:srgbClr val="F8FAFC"/>
+          </a:solidFill>
+          <a:ln xmlns:a="http://schemas.openxmlformats.org/drawingml/2006/main" w="9525">
+            <a:solidFill>
+              <a:srgbClr val="CBD5E1"/>
+            </a:solidFill>
+            <a:prstDash val="solid"/>
+          </a:ln>
+        </p:spPr>
+      </p:sp>
+      <p:sp>
+        <p:nvSpPr>
+          <p:cNvPr id="14" name="">
+            <a:extLst xmlns:a="http://schemas.openxmlformats.org/drawingml/2006/main">
+              <a:ext uri="{FF2B5EF4-FFF2-40B4-BE49-F238E27FC236}">
+                <a16:creationId xmlns:a16="http://schemas.microsoft.com/office/drawing/2014/main" id="{EBBE8E46-A404-4138-A0C0-323D2D4C38B5}"/>
+              </a:ext>
+            </a:extLst>
+          </p:cNvPr>
+          <p:cNvSpPr>
+            <a:spLocks xmlns:a="http://schemas.openxmlformats.org/drawingml/2006/main" noGrp="1"/>
+          </p:cNvSpPr>
+          <p:nvPr/>
+        </p:nvSpPr>
+        <p:spPr>
+          <a:xfrm xmlns:a="http://schemas.openxmlformats.org/drawingml/2006/main">
+            <a:off x="3790950" y="3981450"/>
+            <a:ext cx="2000250" cy="438150"/>
+          </a:xfrm>
+          <a:prstGeom xmlns:a="http://schemas.openxmlformats.org/drawingml/2006/main" prst="rect">
+            <a:avLst/>
+          </a:prstGeom>
+          <a:noFill xmlns:a="http://schemas.openxmlformats.org/drawingml/2006/main"/>
+          <a:ln xmlns:a="http://schemas.openxmlformats.org/drawingml/2006/main" w="0">
+            <a:noFill/>
+            <a:prstDash val="solid"/>
+          </a:ln>
+        </p:spPr>
+        <p:txBody>
+          <a:bodyPr xmlns:a="http://schemas.openxmlformats.org/drawingml/2006/main"/>
+          <a:lstStyle xmlns:a="http://schemas.openxmlformats.org/drawingml/2006/main"/>
+          <a:p xmlns:a="http://schemas.openxmlformats.org/drawingml/2006/main">
+            <a:pPr algn="ctr">
+              <a:defRPr sz="2550" b="1">
+                <a:solidFill>
+                  <a:srgbClr val="0F9F8F"/>
+                </a:solidFill>
+              </a:defRPr>
+            </a:pPr>
+            <a:r>
+              <a:rPr sz="2550" b="1">
+                <a:solidFill>
+                  <a:srgbClr val="0F9F8F"/>
+                </a:solidFill>
+              </a:rPr>
+              <a:t>12.6%</a:t>
+            </a:r>
+          </a:p>
+        </p:txBody>
+      </p:sp>
+      <p:sp>
+        <p:nvSpPr>
+          <p:cNvPr id="15" name="">
+            <a:extLst xmlns:a="http://schemas.openxmlformats.org/drawingml/2006/main">
+              <a:ext uri="{FF2B5EF4-FFF2-40B4-BE49-F238E27FC236}">
+                <a16:creationId xmlns:a16="http://schemas.microsoft.com/office/drawing/2014/main" id="{96F826CE-F39B-4959-BD8C-4B72E8A4DDBC}"/>
+              </a:ext>
+            </a:extLst>
+          </p:cNvPr>
+          <p:cNvSpPr>
+            <a:spLocks xmlns:a="http://schemas.openxmlformats.org/drawingml/2006/main" noGrp="1"/>
+          </p:cNvSpPr>
+          <p:nvPr/>
+        </p:nvSpPr>
+        <p:spPr>
+          <a:xfrm xmlns:a="http://schemas.openxmlformats.org/drawingml/2006/main">
+            <a:off x="3810000" y="4514850"/>
+            <a:ext cx="2000250" cy="361950"/>
+          </a:xfrm>
+          <a:prstGeom xmlns:a="http://schemas.openxmlformats.org/drawingml/2006/main" prst="rect">
+            <a:avLst/>
+          </a:prstGeom>
+          <a:noFill xmlns:a="http://schemas.openxmlformats.org/drawingml/2006/main"/>
+          <a:ln xmlns:a="http://schemas.openxmlformats.org/drawingml/2006/main" w="0">
+            <a:noFill/>
+            <a:prstDash val="solid"/>
+          </a:ln>
+        </p:spPr>
+        <p:txBody>
+          <a:bodyPr xmlns:a="http://schemas.openxmlformats.org/drawingml/2006/main"/>
+          <a:lstStyle xmlns:a="http://schemas.openxmlformats.org/drawingml/2006/main"/>
+          <a:p xmlns:a="http://schemas.openxmlformats.org/drawingml/2006/main">
+            <a:pPr algn="ctr">
+              <a:defRPr sz="1200" b="0">
+                <a:solidFill>
+                  <a:srgbClr val="5B6472"/>
+                </a:solidFill>
+              </a:defRPr>
+            </a:pPr>
+            <a:r>
+              <a:rPr sz="1200" b="0">
+                <a:solidFill>
+                  <a:srgbClr val="5B6472"/>
+                </a:solidFill>
+              </a:rPr>
+              <a:t>Continuation exposure in 2022Q1</a:t>
+            </a:r>
+          </a:p>
+        </p:txBody>
+      </p:sp>
+      <p:pic>
+        <p:nvPicPr>
+          <p:cNvPr id="33" name=""/>
+          <p:cNvPicPr>
+            <a:picLocks xmlns:a="http://schemas.openxmlformats.org/drawingml/2006/main" noChangeAspect="1"/>
+          </p:cNvPicPr>
+          <p:nvPr/>
+        </p:nvPicPr>
+        <p:blipFill>
+          <a:blip xmlns:r="http://schemas.openxmlformats.org/officeDocument/2006/relationships" xmlns:a="http://schemas.openxmlformats.org/drawingml/2006/main" r:embed="R278f100491ba4b25"/>
+          <a:stretch xmlns:a="http://schemas.openxmlformats.org/drawingml/2006/main"/>
+        </p:blipFill>
+        <p:spPr>
+          <a:xfrm xmlns:a="http://schemas.openxmlformats.org/drawingml/2006/main">
+            <a:off x="7091570" y="1809750"/>
+            <a:ext cx="3571461" cy="3733800"/>
+          </a:xfrm>
+          <a:prstGeom xmlns:a="http://schemas.openxmlformats.org/drawingml/2006/main" prst="rect">
+            <a:avLst/>
+          </a:prstGeom>
+        </p:spPr>
+      </p:pic>
+      <p:sp>
+        <p:nvSpPr>
+          <p:cNvPr id="17" name="">
+            <a:extLst xmlns:a="http://schemas.openxmlformats.org/drawingml/2006/main">
+              <a:ext uri="{FF2B5EF4-FFF2-40B4-BE49-F238E27FC236}">
+                <a16:creationId xmlns:a16="http://schemas.microsoft.com/office/drawing/2014/main" id="{B6220455-213F-4FC2-A029-0A0A975BCF7D}"/>
+              </a:ext>
+            </a:extLst>
+          </p:cNvPr>
+          <p:cNvSpPr>
+            <a:spLocks xmlns:a="http://schemas.openxmlformats.org/drawingml/2006/main" noGrp="1"/>
+          </p:cNvSpPr>
+          <p:nvPr/>
+        </p:nvSpPr>
+        <p:spPr>
+          <a:xfrm xmlns:a="http://schemas.openxmlformats.org/drawingml/2006/main">
+            <a:off x="1085850" y="5676900"/>
+            <a:ext cx="9810750" cy="419100"/>
+          </a:xfrm>
+          <a:prstGeom xmlns:a="http://schemas.openxmlformats.org/drawingml/2006/main" prst="rect">
+            <a:avLst/>
+          </a:prstGeom>
+          <a:noFill xmlns:a="http://schemas.openxmlformats.org/drawingml/2006/main"/>
+          <a:ln xmlns:a="http://schemas.openxmlformats.org/drawingml/2006/main" w="0">
+            <a:noFill/>
+            <a:prstDash val="solid"/>
+          </a:ln>
+        </p:spPr>
+        <p:txBody>
+          <a:bodyPr xmlns:a="http://schemas.openxmlformats.org/drawingml/2006/main"/>
+          <a:lstStyle xmlns:a="http://schemas.openxmlformats.org/drawingml/2006/main"/>
+          <a:p xmlns:a="http://schemas.openxmlformats.org/drawingml/2006/main">
+            <a:pPr algn="ctr">
+              <a:defRPr sz="1650" b="1">
+                <a:solidFill>
+                  <a:srgbClr val="111827"/>
+                </a:solidFill>
+              </a:defRPr>
+            </a:pPr>
+            <a:r>
+              <a:rPr sz="1650" b="1">
+                <a:solidFill>
+                  <a:srgbClr val="111827"/>
+                </a:solidFill>
+              </a:rPr>
+              <a:t>Aggregate mean alpha was -13.5 pp for fresh and -9.8 pp for continuation. This is not a victory lap; it is a sharper diagnosis.</a:t>
+            </a:r>
+          </a:p>
+        </p:txBody>
+      </p:sp>
+    </p:spTree>
+    <p:extLst>
+      <p:ext uri="{BB962C8B-B14F-4D97-AF65-F5344CB8AC3E}">
+        <p14:creationId xmlns:p14="http://schemas.microsoft.com/office/powerpoint/2010/main" val="1358957094"/>
+      </p:ext>
+    </p:extLst>
+  </p:cSld>
+</p:sld>
+</file>
+
+<file path=ppt/slides/slide12.xml><?xml version="1.0" encoding="utf-8"?>
+<p:sld xmlns:p="http://schemas.openxmlformats.org/presentationml/2006/main">
+  <p:cSld>
+    <p:bg>
+      <p:bgPr>
+        <a:solidFill xmlns:a="http://schemas.openxmlformats.org/drawingml/2006/main">
+          <a:srgbClr val="FFFFFF"/>
+        </a:solidFill>
+      </p:bgPr>
+    </p:bg>
+    <p:spTree>
+      <p:nvGrpSpPr>
+        <p:cNvPr id="1" name=""/>
+        <p:cNvGrpSpPr/>
+        <p:nvPr/>
+      </p:nvGrpSpPr>
+      <p:grpSpPr>
+        <a:xfrm xmlns:a="http://schemas.openxmlformats.org/drawingml/2006/main"/>
+      </p:grpSpPr>
+      <p:sp>
+        <p:nvSpPr>
+          <p:cNvPr id="1" name="">
+            <a:extLst xmlns:a="http://schemas.openxmlformats.org/drawingml/2006/main">
+              <a:ext uri="{FF2B5EF4-FFF2-40B4-BE49-F238E27FC236}">
+                <a16:creationId xmlns:a16="http://schemas.microsoft.com/office/drawing/2014/main" id="{509C3F20-768F-423E-9B77-847C66881538}"/>
+              </a:ext>
+            </a:extLst>
+          </p:cNvPr>
+          <p:cNvSpPr>
+            <a:spLocks xmlns:a="http://schemas.openxmlformats.org/drawingml/2006/main" noGrp="1"/>
+          </p:cNvSpPr>
+          <p:nvPr/>
+        </p:nvSpPr>
+        <p:spPr>
+          <a:xfrm xmlns:a="http://schemas.openxmlformats.org/drawingml/2006/main">
+            <a:off x="609600" y="304800"/>
+            <a:ext cx="5334000" cy="209550"/>
+          </a:xfrm>
+          <a:prstGeom xmlns:a="http://schemas.openxmlformats.org/drawingml/2006/main" prst="rect">
+            <a:avLst/>
+          </a:prstGeom>
+          <a:noFill xmlns:a="http://schemas.openxmlformats.org/drawingml/2006/main"/>
+          <a:ln xmlns:a="http://schemas.openxmlformats.org/drawingml/2006/main" w="0">
+            <a:noFill/>
+            <a:prstDash val="solid"/>
+          </a:ln>
+        </p:spPr>
+        <p:txBody>
+          <a:bodyPr xmlns:a="http://schemas.openxmlformats.org/drawingml/2006/main"/>
+          <a:lstStyle xmlns:a="http://schemas.openxmlformats.org/drawingml/2006/main"/>
+          <a:p xmlns:a="http://schemas.openxmlformats.org/drawingml/2006/main">
+            <a:pPr>
+              <a:defRPr sz="975" b="1">
+                <a:solidFill>
+                  <a:srgbClr val="2563EB"/>
+                </a:solidFill>
+              </a:defRPr>
+            </a:pPr>
+            <a:r>
+              <a:rPr sz="975" b="1">
+                <a:solidFill>
+                  <a:srgbClr val="2563EB"/>
+                </a:solidFill>
+              </a:rPr>
+              <a:t>GEN5.3 PCA RESEARCH PIVOT</a:t>
+            </a:r>
+          </a:p>
+        </p:txBody>
+      </p:sp>
+      <p:sp>
+        <p:nvSpPr>
+          <p:cNvPr id="2" name="">
+            <a:extLst xmlns:a="http://schemas.openxmlformats.org/drawingml/2006/main">
+              <a:ext uri="{FF2B5EF4-FFF2-40B4-BE49-F238E27FC236}">
+                <a16:creationId xmlns:a16="http://schemas.microsoft.com/office/drawing/2014/main" id="{2D13A5C7-EB63-489A-9AFC-4F47C39D9345}"/>
+              </a:ext>
+            </a:extLst>
+          </p:cNvPr>
+          <p:cNvSpPr>
+            <a:spLocks xmlns:a="http://schemas.openxmlformats.org/drawingml/2006/main" noGrp="1"/>
+          </p:cNvSpPr>
+          <p:nvPr/>
+        </p:nvSpPr>
+        <p:spPr>
+          <a:xfrm xmlns:a="http://schemas.openxmlformats.org/drawingml/2006/main">
+            <a:off x="609600" y="647700"/>
+            <a:ext cx="9334500" cy="876300"/>
+          </a:xfrm>
+          <a:prstGeom xmlns:a="http://schemas.openxmlformats.org/drawingml/2006/main" prst="rect">
+            <a:avLst/>
+          </a:prstGeom>
+          <a:noFill xmlns:a="http://schemas.openxmlformats.org/drawingml/2006/main"/>
+          <a:ln xmlns:a="http://schemas.openxmlformats.org/drawingml/2006/main" w="0">
+            <a:noFill/>
+            <a:prstDash val="solid"/>
+          </a:ln>
+        </p:spPr>
+        <p:txBody>
+          <a:bodyPr xmlns:a="http://schemas.openxmlformats.org/drawingml/2006/main"/>
+          <a:lstStyle xmlns:a="http://schemas.openxmlformats.org/drawingml/2006/main"/>
+          <a:p xmlns:a="http://schemas.openxmlformats.org/drawingml/2006/main">
+            <a:pPr>
+              <a:defRPr sz="2775" b="1">
+                <a:solidFill>
+                  <a:srgbClr val="111827"/>
+                </a:solidFill>
+              </a:defRPr>
+            </a:pPr>
+            <a:r>
+              <a:rPr sz="2775" b="1">
+                <a:solidFill>
+                  <a:srgbClr val="111827"/>
+                </a:solidFill>
+              </a:rPr>
+              <a:t>The audit points to participation timing, not just strategy availability</a:t>
+            </a:r>
+          </a:p>
+        </p:txBody>
+      </p:sp>
+      <p:sp>
+        <p:nvSpPr>
+          <p:cNvPr id="3" name="">
+            <a:extLst xmlns:a="http://schemas.openxmlformats.org/drawingml/2006/main">
+              <a:ext uri="{FF2B5EF4-FFF2-40B4-BE49-F238E27FC236}">
+                <a16:creationId xmlns:a16="http://schemas.microsoft.com/office/drawing/2014/main" id="{F6FF025A-78A2-42A2-8D0B-FB7AA17B2A2A}"/>
+              </a:ext>
+            </a:extLst>
+          </p:cNvPr>
+          <p:cNvSpPr>
+            <a:spLocks xmlns:a="http://schemas.openxmlformats.org/drawingml/2006/main" noGrp="1"/>
+          </p:cNvSpPr>
+          <p:nvPr/>
+        </p:nvSpPr>
+        <p:spPr>
+          <a:xfrm xmlns:a="http://schemas.openxmlformats.org/drawingml/2006/main">
+            <a:off x="609600" y="1485900"/>
+            <a:ext cx="10572750" cy="9525"/>
+          </a:xfrm>
+          <a:prstGeom xmlns:a="http://schemas.openxmlformats.org/drawingml/2006/main" prst="rect">
+            <a:avLst/>
+          </a:prstGeom>
+          <a:solidFill xmlns:a="http://schemas.openxmlformats.org/drawingml/2006/main">
+            <a:srgbClr val="CBD3DD"/>
+          </a:solidFill>
+          <a:ln xmlns:a="http://schemas.openxmlformats.org/drawingml/2006/main" w="0">
+            <a:solidFill>
+              <a:srgbClr val="CBD3DD"/>
+            </a:solidFill>
+            <a:prstDash val="solid"/>
+          </a:ln>
+        </p:spPr>
+      </p:sp>
+      <p:pic>
+        <p:nvPicPr>
+          <p:cNvPr id="10" name=""/>
+          <p:cNvPicPr>
+            <a:picLocks xmlns:a="http://schemas.openxmlformats.org/drawingml/2006/main" noChangeAspect="1"/>
+          </p:cNvPicPr>
+          <p:nvPr/>
+        </p:nvPicPr>
+        <p:blipFill>
+          <a:blip xmlns:r="http://schemas.openxmlformats.org/officeDocument/2006/relationships" xmlns:a="http://schemas.openxmlformats.org/drawingml/2006/main" r:embed="R79cdf432fdbc4868"/>
+          <a:stretch xmlns:a="http://schemas.openxmlformats.org/drawingml/2006/main"/>
+        </p:blipFill>
+        <p:spPr>
+          <a:xfrm xmlns:a="http://schemas.openxmlformats.org/drawingml/2006/main">
+            <a:off x="698256" y="1809750"/>
+            <a:ext cx="5671038" cy="4095750"/>
+          </a:xfrm>
+          <a:prstGeom xmlns:a="http://schemas.openxmlformats.org/drawingml/2006/main" prst="rect">
+            <a:avLst/>
+          </a:prstGeom>
+        </p:spPr>
+      </p:pic>
+      <p:pic>
+        <p:nvPicPr>
+          <p:cNvPr id="11" name=""/>
+          <p:cNvPicPr>
+            <a:picLocks xmlns:a="http://schemas.openxmlformats.org/drawingml/2006/main" noChangeAspect="1"/>
+          </p:cNvPicPr>
+          <p:nvPr/>
+        </p:nvPicPr>
+        <p:blipFill>
+          <a:blip xmlns:r="http://schemas.openxmlformats.org/officeDocument/2006/relationships" xmlns:a="http://schemas.openxmlformats.org/drawingml/2006/main" r:embed="R62952b35a6db4f65"/>
+          <a:stretch xmlns:a="http://schemas.openxmlformats.org/drawingml/2006/main"/>
+        </p:blipFill>
+        <p:spPr>
+          <a:xfrm xmlns:a="http://schemas.openxmlformats.org/drawingml/2006/main">
+            <a:off x="6877050" y="1929179"/>
+            <a:ext cx="4762500" cy="3113942"/>
+          </a:xfrm>
+          <a:prstGeom xmlns:a="http://schemas.openxmlformats.org/drawingml/2006/main" prst="rect">
+            <a:avLst/>
+          </a:prstGeom>
+        </p:spPr>
+      </p:pic>
+      <p:sp>
+        <p:nvSpPr>
+          <p:cNvPr id="6" name="">
+            <a:extLst xmlns:a="http://schemas.openxmlformats.org/drawingml/2006/main">
+              <a:ext uri="{FF2B5EF4-FFF2-40B4-BE49-F238E27FC236}">
+                <a16:creationId xmlns:a16="http://schemas.microsoft.com/office/drawing/2014/main" id="{C4AA4F32-5D3E-48CE-BE03-D089C827E0A2}"/>
+              </a:ext>
+            </a:extLst>
+          </p:cNvPr>
+          <p:cNvSpPr>
+            <a:spLocks xmlns:a="http://schemas.openxmlformats.org/drawingml/2006/main" noGrp="1"/>
+          </p:cNvSpPr>
+          <p:nvPr/>
+        </p:nvSpPr>
+        <p:spPr>
+          <a:xfrm xmlns:a="http://schemas.openxmlformats.org/drawingml/2006/main">
+            <a:off x="7067550" y="5276850"/>
+            <a:ext cx="4191000" cy="819150"/>
+          </a:xfrm>
+          <a:prstGeom xmlns:a="http://schemas.openxmlformats.org/drawingml/2006/main" prst="rect">
+            <a:avLst/>
+          </a:prstGeom>
+          <a:noFill xmlns:a="http://schemas.openxmlformats.org/drawingml/2006/main"/>
+          <a:ln xmlns:a="http://schemas.openxmlformats.org/drawingml/2006/main" w="0">
+            <a:noFill/>
+            <a:prstDash val="solid"/>
+          </a:ln>
+        </p:spPr>
+        <p:txBody>
+          <a:bodyPr xmlns:a="http://schemas.openxmlformats.org/drawingml/2006/main"/>
+          <a:lstStyle xmlns:a="http://schemas.openxmlformats.org/drawingml/2006/main"/>
+          <a:p xmlns:a="http://schemas.openxmlformats.org/drawingml/2006/main">
+            <a:pPr>
+              <a:defRPr sz="1350" b="0">
+                <a:solidFill>
+                  <a:srgbClr val="5B6472"/>
+                </a:solidFill>
+              </a:defRPr>
+            </a:pPr>
+            <a:r>
+              <a:rPr sz="1350" b="0">
+                <a:solidFill>
+                  <a:srgbClr val="5B6472"/>
+                </a:solidFill>
+              </a:rPr>
+              <a:t>The state/family map selected plenty of momentum candidates, so the first failure mode is not that no-trade swallowed the whole system. The problem is more specific: exposure still arrived too late or too lightly in the rebound while drawdown avoidance worked better in the stress window.</a:t>
+            </a:r>
+          </a:p>
+        </p:txBody>
+      </p:sp>
+    </p:spTree>
+    <p:extLst>
+      <p:ext uri="{BB962C8B-B14F-4D97-AF65-F5344CB8AC3E}">
+        <p14:creationId xmlns:p14="http://schemas.microsoft.com/office/powerpoint/2010/main" val="766357857"/>
+      </p:ext>
+    </p:extLst>
+  </p:cSld>
+</p:sld>
+</file>
+
+<file path=ppt/slides/slide13.xml><?xml version="1.0" encoding="utf-8"?>
+<p:sld xmlns:p="http://schemas.openxmlformats.org/presentationml/2006/main">
+  <p:cSld>
+    <p:bg>
+      <p:bgPr>
+        <a:solidFill xmlns:a="http://schemas.openxmlformats.org/drawingml/2006/main">
+          <a:srgbClr val="FFFFFF"/>
+        </a:solidFill>
+      </p:bgPr>
+    </p:bg>
+    <p:spTree>
+      <p:nvGrpSpPr>
+        <p:cNvPr id="1" name=""/>
+        <p:cNvGrpSpPr/>
+        <p:nvPr/>
+      </p:nvGrpSpPr>
+      <p:grpSpPr>
+        <a:xfrm xmlns:a="http://schemas.openxmlformats.org/drawingml/2006/main"/>
+      </p:grpSpPr>
+      <p:sp>
+        <p:nvSpPr>
+          <p:cNvPr id="1" name="">
+            <a:extLst xmlns:a="http://schemas.openxmlformats.org/drawingml/2006/main">
+              <a:ext uri="{FF2B5EF4-FFF2-40B4-BE49-F238E27FC236}">
+                <a16:creationId xmlns:a16="http://schemas.microsoft.com/office/drawing/2014/main" id="{3A32EB45-078B-4261-8835-BB19AD1FEBA3}"/>
+              </a:ext>
+            </a:extLst>
+          </p:cNvPr>
+          <p:cNvSpPr>
+            <a:spLocks xmlns:a="http://schemas.openxmlformats.org/drawingml/2006/main" noGrp="1"/>
+          </p:cNvSpPr>
+          <p:nvPr/>
+        </p:nvSpPr>
+        <p:spPr>
+          <a:xfrm xmlns:a="http://schemas.openxmlformats.org/drawingml/2006/main">
+            <a:off x="609600" y="304800"/>
+            <a:ext cx="5334000" cy="209550"/>
+          </a:xfrm>
+          <a:prstGeom xmlns:a="http://schemas.openxmlformats.org/drawingml/2006/main" prst="rect">
+            <a:avLst/>
+          </a:prstGeom>
+          <a:noFill xmlns:a="http://schemas.openxmlformats.org/drawingml/2006/main"/>
+          <a:ln xmlns:a="http://schemas.openxmlformats.org/drawingml/2006/main" w="0">
+            <a:noFill/>
+            <a:prstDash val="solid"/>
+          </a:ln>
+        </p:spPr>
+        <p:txBody>
+          <a:bodyPr xmlns:a="http://schemas.openxmlformats.org/drawingml/2006/main"/>
+          <a:lstStyle xmlns:a="http://schemas.openxmlformats.org/drawingml/2006/main"/>
+          <a:p xmlns:a="http://schemas.openxmlformats.org/drawingml/2006/main">
+            <a:pPr>
+              <a:defRPr sz="975" b="1">
+                <a:solidFill>
+                  <a:srgbClr val="2563EB"/>
+                </a:solidFill>
+              </a:defRPr>
+            </a:pPr>
+            <a:r>
+              <a:rPr sz="975" b="1">
+                <a:solidFill>
+                  <a:srgbClr val="2563EB"/>
+                </a:solidFill>
+              </a:rPr>
+              <a:t>GEN5.3 PCA RESEARCH PIVOT</a:t>
+            </a:r>
+          </a:p>
+        </p:txBody>
+      </p:sp>
+      <p:sp>
+        <p:nvSpPr>
+          <p:cNvPr id="2" name="">
+            <a:extLst xmlns:a="http://schemas.openxmlformats.org/drawingml/2006/main">
+              <a:ext uri="{FF2B5EF4-FFF2-40B4-BE49-F238E27FC236}">
+                <a16:creationId xmlns:a16="http://schemas.microsoft.com/office/drawing/2014/main" id="{1E237E4E-DC9D-4D4B-A15C-37818A57564F}"/>
+              </a:ext>
+            </a:extLst>
+          </p:cNvPr>
+          <p:cNvSpPr>
+            <a:spLocks xmlns:a="http://schemas.openxmlformats.org/drawingml/2006/main" noGrp="1"/>
+          </p:cNvSpPr>
+          <p:nvPr/>
+        </p:nvSpPr>
+        <p:spPr>
+          <a:xfrm xmlns:a="http://schemas.openxmlformats.org/drawingml/2006/main">
+            <a:off x="609600" y="647700"/>
+            <a:ext cx="9334500" cy="876300"/>
+          </a:xfrm>
+          <a:prstGeom xmlns:a="http://schemas.openxmlformats.org/drawingml/2006/main" prst="rect">
+            <a:avLst/>
+          </a:prstGeom>
+          <a:noFill xmlns:a="http://schemas.openxmlformats.org/drawingml/2006/main"/>
+          <a:ln xmlns:a="http://schemas.openxmlformats.org/drawingml/2006/main" w="0">
+            <a:noFill/>
+            <a:prstDash val="solid"/>
+          </a:ln>
+        </p:spPr>
+        <p:txBody>
+          <a:bodyPr xmlns:a="http://schemas.openxmlformats.org/drawingml/2006/main"/>
+          <a:lstStyle xmlns:a="http://schemas.openxmlformats.org/drawingml/2006/main"/>
+          <a:p xmlns:a="http://schemas.openxmlformats.org/drawingml/2006/main">
+            <a:pPr>
+              <a:defRPr sz="2775" b="1">
+                <a:solidFill>
+                  <a:srgbClr val="111827"/>
+                </a:solidFill>
+              </a:defRPr>
+            </a:pPr>
+            <a:r>
+              <a:rPr sz="2775" b="1">
+                <a:solidFill>
+                  <a:srgbClr val="111827"/>
+                </a:solidFill>
+              </a:rPr>
+              <a:t>Next Gen5.3 slice: diagnose why bullish participation is still late</a:t>
+            </a:r>
+          </a:p>
+        </p:txBody>
+      </p:sp>
+      <p:sp>
+        <p:nvSpPr>
+          <p:cNvPr id="3" name="">
+            <a:extLst xmlns:a="http://schemas.openxmlformats.org/drawingml/2006/main">
+              <a:ext uri="{FF2B5EF4-FFF2-40B4-BE49-F238E27FC236}">
+                <a16:creationId xmlns:a16="http://schemas.microsoft.com/office/drawing/2014/main" id="{AFC7B80E-D94E-41C7-A38A-5530914D5ABD}"/>
+              </a:ext>
+            </a:extLst>
+          </p:cNvPr>
+          <p:cNvSpPr>
+            <a:spLocks xmlns:a="http://schemas.openxmlformats.org/drawingml/2006/main" noGrp="1"/>
+          </p:cNvSpPr>
+          <p:nvPr/>
+        </p:nvSpPr>
+        <p:spPr>
+          <a:xfrm xmlns:a="http://schemas.openxmlformats.org/drawingml/2006/main">
+            <a:off x="609600" y="1485900"/>
+            <a:ext cx="10572750" cy="9525"/>
+          </a:xfrm>
+          <a:prstGeom xmlns:a="http://schemas.openxmlformats.org/drawingml/2006/main" prst="rect">
+            <a:avLst/>
+          </a:prstGeom>
+          <a:solidFill xmlns:a="http://schemas.openxmlformats.org/drawingml/2006/main">
+            <a:srgbClr val="CBD3DD"/>
+          </a:solidFill>
+          <a:ln xmlns:a="http://schemas.openxmlformats.org/drawingml/2006/main" w="0">
+            <a:solidFill>
+              <a:srgbClr val="CBD3DD"/>
+            </a:solidFill>
+            <a:prstDash val="solid"/>
+          </a:ln>
+        </p:spPr>
+      </p:sp>
+      <p:sp>
+        <p:nvSpPr>
+          <p:cNvPr id="4" name="">
+            <a:extLst xmlns:a="http://schemas.openxmlformats.org/drawingml/2006/main">
+              <a:ext uri="{FF2B5EF4-FFF2-40B4-BE49-F238E27FC236}">
+                <a16:creationId xmlns:a16="http://schemas.microsoft.com/office/drawing/2014/main" id="{A8D9F19F-1B92-46A0-BCC1-5C44691BFE29}"/>
+              </a:ext>
+            </a:extLst>
+          </p:cNvPr>
+          <p:cNvSpPr>
+            <a:spLocks xmlns:a="http://schemas.openxmlformats.org/drawingml/2006/main" noGrp="1"/>
+          </p:cNvSpPr>
+          <p:nvPr/>
+        </p:nvSpPr>
+        <p:spPr>
+          <a:xfrm xmlns:a="http://schemas.openxmlformats.org/drawingml/2006/main">
+            <a:off x="781050" y="2038350"/>
+            <a:ext cx="10382250" cy="3143250"/>
+          </a:xfrm>
+          <a:prstGeom xmlns:a="http://schemas.openxmlformats.org/drawingml/2006/main" prst="roundRect">
+            <a:avLst>
+              <a:gd name="adj" fmla="val 2424"/>
+            </a:avLst>
+          </a:prstGeom>
+          <a:solidFill xmlns:a="http://schemas.openxmlformats.org/drawingml/2006/main">
+            <a:srgbClr val="F8FAFC"/>
+          </a:solidFill>
+          <a:ln xmlns:a="http://schemas.openxmlformats.org/drawingml/2006/main" w="9525">
+            <a:solidFill>
+              <a:srgbClr val="D7DEE8"/>
+            </a:solidFill>
+            <a:prstDash val="solid"/>
+          </a:ln>
+        </p:spPr>
+      </p:sp>
+      <p:sp>
+        <p:nvSpPr>
+          <p:cNvPr id="5" name="">
+            <a:extLst xmlns:a="http://schemas.openxmlformats.org/drawingml/2006/main">
+              <a:ext uri="{FF2B5EF4-FFF2-40B4-BE49-F238E27FC236}">
+                <a16:creationId xmlns:a16="http://schemas.microsoft.com/office/drawing/2014/main" id="{CE98FB16-782F-4777-BBDE-1BFA4DFBC24D}"/>
+              </a:ext>
+            </a:extLst>
+          </p:cNvPr>
+          <p:cNvSpPr>
+            <a:spLocks xmlns:a="http://schemas.openxmlformats.org/drawingml/2006/main" noGrp="1"/>
+          </p:cNvSpPr>
+          <p:nvPr/>
+        </p:nvSpPr>
+        <p:spPr>
+          <a:xfrm xmlns:a="http://schemas.openxmlformats.org/drawingml/2006/main">
+            <a:off x="1143000" y="2362200"/>
+            <a:ext cx="4095750" cy="323850"/>
+          </a:xfrm>
+          <a:prstGeom xmlns:a="http://schemas.openxmlformats.org/drawingml/2006/main" prst="rect">
+            <a:avLst/>
+          </a:prstGeom>
+          <a:noFill xmlns:a="http://schemas.openxmlformats.org/drawingml/2006/main"/>
+          <a:ln xmlns:a="http://schemas.openxmlformats.org/drawingml/2006/main" w="0">
+            <a:noFill/>
+            <a:prstDash val="solid"/>
+          </a:ln>
+        </p:spPr>
+        <p:txBody>
+          <a:bodyPr xmlns:a="http://schemas.openxmlformats.org/drawingml/2006/main"/>
+          <a:lstStyle xmlns:a="http://schemas.openxmlformats.org/drawingml/2006/main"/>
+          <a:p xmlns:a="http://schemas.openxmlformats.org/drawingml/2006/main">
+            <a:pPr>
+              <a:defRPr sz="2025" b="1">
+                <a:solidFill>
+                  <a:srgbClr val="111827"/>
+                </a:solidFill>
+              </a:defRPr>
+            </a:pPr>
+            <a:r>
+              <a:rPr sz="2025" b="1">
+                <a:solidFill>
+                  <a:srgbClr val="111827"/>
+                </a:solidFill>
+              </a:rPr>
+              <a:t>Recommended next question</a:t>
+            </a:r>
+          </a:p>
+        </p:txBody>
+      </p:sp>
+      <p:sp>
+        <p:nvSpPr>
+          <p:cNvPr id="6" name="">
+            <a:extLst xmlns:a="http://schemas.openxmlformats.org/drawingml/2006/main">
+              <a:ext uri="{FF2B5EF4-FFF2-40B4-BE49-F238E27FC236}">
+                <a16:creationId xmlns:a16="http://schemas.microsoft.com/office/drawing/2014/main" id="{338F9BD9-D933-4A2C-AC6A-0D194C2185C1}"/>
+              </a:ext>
+            </a:extLst>
+          </p:cNvPr>
+          <p:cNvSpPr>
+            <a:spLocks xmlns:a="http://schemas.openxmlformats.org/drawingml/2006/main" noGrp="1"/>
+          </p:cNvSpPr>
+          <p:nvPr/>
+        </p:nvSpPr>
+        <p:spPr>
+          <a:xfrm xmlns:a="http://schemas.openxmlformats.org/drawingml/2006/main">
+            <a:off x="1143000" y="2971800"/>
+            <a:ext cx="8953500" cy="742950"/>
+          </a:xfrm>
+          <a:prstGeom xmlns:a="http://schemas.openxmlformats.org/drawingml/2006/main" prst="rect">
+            <a:avLst/>
+          </a:prstGeom>
+          <a:noFill xmlns:a="http://schemas.openxmlformats.org/drawingml/2006/main"/>
+          <a:ln xmlns:a="http://schemas.openxmlformats.org/drawingml/2006/main" w="0">
+            <a:noFill/>
+            <a:prstDash val="solid"/>
+          </a:ln>
+        </p:spPr>
+        <p:txBody>
+          <a:bodyPr xmlns:a="http://schemas.openxmlformats.org/drawingml/2006/main"/>
+          <a:lstStyle xmlns:a="http://schemas.openxmlformats.org/drawingml/2006/main"/>
+          <a:p xmlns:a="http://schemas.openxmlformats.org/drawingml/2006/main">
+            <a:pPr>
+              <a:defRPr sz="1875" b="0">
+                <a:solidFill>
+                  <a:srgbClr val="111827"/>
+                </a:solidFill>
+              </a:defRPr>
+            </a:pPr>
+            <a:r>
+              <a:rPr sz="1875" b="0">
+                <a:solidFill>
+                  <a:srgbClr val="111827"/>
+                </a:solidFill>
+              </a:rPr>
+              <a:t>Do improved momentum-participation features make PCA states enter and stay long earlier during obvious high-beta upside without surrendering the 2022 drawdown protection?</a:t>
+            </a:r>
+          </a:p>
+        </p:txBody>
+      </p:sp>
+      <p:sp>
+        <p:nvSpPr>
+          <p:cNvPr id="7" name="">
+            <a:extLst xmlns:a="http://schemas.openxmlformats.org/drawingml/2006/main">
+              <a:ext uri="{FF2B5EF4-FFF2-40B4-BE49-F238E27FC236}">
+                <a16:creationId xmlns:a16="http://schemas.microsoft.com/office/drawing/2014/main" id="{B3F5F196-1666-49A7-BCD6-EC81AD2B63F7}"/>
+              </a:ext>
+            </a:extLst>
+          </p:cNvPr>
+          <p:cNvSpPr>
+            <a:spLocks xmlns:a="http://schemas.openxmlformats.org/drawingml/2006/main" noGrp="1"/>
+          </p:cNvSpPr>
+          <p:nvPr/>
+        </p:nvSpPr>
+        <p:spPr>
+          <a:xfrm xmlns:a="http://schemas.openxmlformats.org/drawingml/2006/main">
+            <a:off x="1181100" y="4181475"/>
+            <a:ext cx="76200" cy="76200"/>
+          </a:xfrm>
+          <a:prstGeom xmlns:a="http://schemas.openxmlformats.org/drawingml/2006/main" prst="ellipse">
+            <a:avLst/>
+          </a:prstGeom>
+          <a:solidFill xmlns:a="http://schemas.openxmlformats.org/drawingml/2006/main">
+            <a:srgbClr val="D97706"/>
+          </a:solidFill>
+          <a:ln xmlns:a="http://schemas.openxmlformats.org/drawingml/2006/main" w="0">
+            <a:noFill/>
+            <a:prstDash val="solid"/>
+          </a:ln>
+        </p:spPr>
+      </p:sp>
+      <p:sp>
+        <p:nvSpPr>
+          <p:cNvPr id="8" name="">
+            <a:extLst xmlns:a="http://schemas.openxmlformats.org/drawingml/2006/main">
+              <a:ext uri="{FF2B5EF4-FFF2-40B4-BE49-F238E27FC236}">
+                <a16:creationId xmlns:a16="http://schemas.microsoft.com/office/drawing/2014/main" id="{0D8FAC86-95B7-4BF9-91F0-0ECA9CB447E0}"/>
+              </a:ext>
+            </a:extLst>
+          </p:cNvPr>
+          <p:cNvSpPr>
+            <a:spLocks xmlns:a="http://schemas.openxmlformats.org/drawingml/2006/main" noGrp="1"/>
+          </p:cNvSpPr>
+          <p:nvPr/>
+        </p:nvSpPr>
+        <p:spPr>
+          <a:xfrm xmlns:a="http://schemas.openxmlformats.org/drawingml/2006/main">
+            <a:off x="1390650" y="4095750"/>
+            <a:ext cx="8743950" cy="342900"/>
+          </a:xfrm>
+          <a:prstGeom xmlns:a="http://schemas.openxmlformats.org/drawingml/2006/main" prst="rect">
+            <a:avLst/>
+          </a:prstGeom>
+          <a:noFill xmlns:a="http://schemas.openxmlformats.org/drawingml/2006/main"/>
+          <a:ln xmlns:a="http://schemas.openxmlformats.org/drawingml/2006/main" w="0">
+            <a:noFill/>
+            <a:prstDash val="solid"/>
+          </a:ln>
+        </p:spPr>
+        <p:txBody>
+          <a:bodyPr xmlns:a="http://schemas.openxmlformats.org/drawingml/2006/main"/>
+          <a:lstStyle xmlns:a="http://schemas.openxmlformats.org/drawingml/2006/main"/>
+          <a:p xmlns:a="http://schemas.openxmlformats.org/drawingml/2006/main">
+            <a:pPr>
+              <a:defRPr sz="1350" b="0">
+                <a:solidFill>
+                  <a:srgbClr val="111827"/>
+                </a:solidFill>
+              </a:defRPr>
+            </a:pPr>
+            <a:r>
+              <a:rPr sz="1350" b="0">
+                <a:solidFill>
+                  <a:srgbClr val="111827"/>
+                </a:solidFill>
+              </a:rPr>
+              <a:t>Keep the same basket, context, 3x3 PCA, pooled-family policy, and benchmark.</a:t>
+            </a:r>
+          </a:p>
+        </p:txBody>
+      </p:sp>
+      <p:sp>
+        <p:nvSpPr>
+          <p:cNvPr id="9" name="">
+            <a:extLst xmlns:a="http://schemas.openxmlformats.org/drawingml/2006/main">
+              <a:ext uri="{FF2B5EF4-FFF2-40B4-BE49-F238E27FC236}">
+                <a16:creationId xmlns:a16="http://schemas.microsoft.com/office/drawing/2014/main" id="{1FA72D4A-C5A1-4A50-AF2D-A8DE6D0C144F}"/>
+              </a:ext>
+            </a:extLst>
+          </p:cNvPr>
+          <p:cNvSpPr>
+            <a:spLocks xmlns:a="http://schemas.openxmlformats.org/drawingml/2006/main" noGrp="1"/>
+          </p:cNvSpPr>
+          <p:nvPr/>
+        </p:nvSpPr>
+        <p:spPr>
+          <a:xfrm xmlns:a="http://schemas.openxmlformats.org/drawingml/2006/main">
+            <a:off x="1181100" y="4486275"/>
+            <a:ext cx="76200" cy="76200"/>
+          </a:xfrm>
+          <a:prstGeom xmlns:a="http://schemas.openxmlformats.org/drawingml/2006/main" prst="ellipse">
+            <a:avLst/>
+          </a:prstGeom>
+          <a:solidFill xmlns:a="http://schemas.openxmlformats.org/drawingml/2006/main">
+            <a:srgbClr val="D97706"/>
+          </a:solidFill>
+          <a:ln xmlns:a="http://schemas.openxmlformats.org/drawingml/2006/main" w="0">
+            <a:noFill/>
+            <a:prstDash val="solid"/>
+          </a:ln>
+        </p:spPr>
+      </p:sp>
+      <p:sp>
+        <p:nvSpPr>
+          <p:cNvPr id="10" name="">
+            <a:extLst xmlns:a="http://schemas.openxmlformats.org/drawingml/2006/main">
+              <a:ext uri="{FF2B5EF4-FFF2-40B4-BE49-F238E27FC236}">
+                <a16:creationId xmlns:a16="http://schemas.microsoft.com/office/drawing/2014/main" id="{91FDB32A-5FF4-4F4A-BF49-5D777F7159A3}"/>
+              </a:ext>
+            </a:extLst>
+          </p:cNvPr>
+          <p:cNvSpPr>
+            <a:spLocks xmlns:a="http://schemas.openxmlformats.org/drawingml/2006/main" noGrp="1"/>
+          </p:cNvSpPr>
+          <p:nvPr/>
+        </p:nvSpPr>
+        <p:spPr>
+          <a:xfrm xmlns:a="http://schemas.openxmlformats.org/drawingml/2006/main">
+            <a:off x="1390650" y="4400550"/>
+            <a:ext cx="8743950" cy="342900"/>
+          </a:xfrm>
+          <a:prstGeom xmlns:a="http://schemas.openxmlformats.org/drawingml/2006/main" prst="rect">
+            <a:avLst/>
+          </a:prstGeom>
+          <a:noFill xmlns:a="http://schemas.openxmlformats.org/drawingml/2006/main"/>
+          <a:ln xmlns:a="http://schemas.openxmlformats.org/drawingml/2006/main" w="0">
+            <a:noFill/>
+            <a:prstDash val="solid"/>
+          </a:ln>
+        </p:spPr>
+        <p:txBody>
+          <a:bodyPr xmlns:a="http://schemas.openxmlformats.org/drawingml/2006/main"/>
+          <a:lstStyle xmlns:a="http://schemas.openxmlformats.org/drawingml/2006/main"/>
+          <a:p xmlns:a="http://schemas.openxmlformats.org/drawingml/2006/main">
+            <a:pPr>
+              <a:defRPr sz="1350" b="0">
+                <a:solidFill>
+                  <a:srgbClr val="111827"/>
+                </a:solidFill>
+              </a:defRPr>
+            </a:pPr>
+            <a:r>
+              <a:rPr sz="1350" b="0">
+                <a:solidFill>
+                  <a:srgbClr val="111827"/>
+                </a:solidFill>
+              </a:rPr>
+              <a:t>Add one compact feature-set challenger focused on trend slope, relative strength, and drawdown recovery.</a:t>
+            </a:r>
+          </a:p>
+        </p:txBody>
+      </p:sp>
+      <p:sp>
+        <p:nvSpPr>
+          <p:cNvPr id="11" name="">
+            <a:extLst xmlns:a="http://schemas.openxmlformats.org/drawingml/2006/main">
+              <a:ext uri="{FF2B5EF4-FFF2-40B4-BE49-F238E27FC236}">
+                <a16:creationId xmlns:a16="http://schemas.microsoft.com/office/drawing/2014/main" id="{A400D0AA-86EE-4B9A-B254-0571CF439806}"/>
+              </a:ext>
+            </a:extLst>
+          </p:cNvPr>
+          <p:cNvSpPr>
+            <a:spLocks xmlns:a="http://schemas.openxmlformats.org/drawingml/2006/main" noGrp="1"/>
+          </p:cNvSpPr>
+          <p:nvPr/>
+        </p:nvSpPr>
+        <p:spPr>
+          <a:xfrm xmlns:a="http://schemas.openxmlformats.org/drawingml/2006/main">
+            <a:off x="1181100" y="4791075"/>
+            <a:ext cx="76200" cy="76200"/>
+          </a:xfrm>
+          <a:prstGeom xmlns:a="http://schemas.openxmlformats.org/drawingml/2006/main" prst="ellipse">
+            <a:avLst/>
+          </a:prstGeom>
+          <a:solidFill xmlns:a="http://schemas.openxmlformats.org/drawingml/2006/main">
+            <a:srgbClr val="D97706"/>
+          </a:solidFill>
+          <a:ln xmlns:a="http://schemas.openxmlformats.org/drawingml/2006/main" w="0">
+            <a:noFill/>
+            <a:prstDash val="solid"/>
+          </a:ln>
+        </p:spPr>
+      </p:sp>
+      <p:sp>
+        <p:nvSpPr>
+          <p:cNvPr id="12" name="">
+            <a:extLst xmlns:a="http://schemas.openxmlformats.org/drawingml/2006/main">
+              <a:ext uri="{FF2B5EF4-FFF2-40B4-BE49-F238E27FC236}">
+                <a16:creationId xmlns:a16="http://schemas.microsoft.com/office/drawing/2014/main" id="{7DD09877-F53F-465F-98E0-F2F73361D395}"/>
+              </a:ext>
+            </a:extLst>
+          </p:cNvPr>
+          <p:cNvSpPr>
+            <a:spLocks xmlns:a="http://schemas.openxmlformats.org/drawingml/2006/main" noGrp="1"/>
+          </p:cNvSpPr>
+          <p:nvPr/>
+        </p:nvSpPr>
+        <p:spPr>
+          <a:xfrm xmlns:a="http://schemas.openxmlformats.org/drawingml/2006/main">
+            <a:off x="1390650" y="4705350"/>
+            <a:ext cx="8743950" cy="342900"/>
+          </a:xfrm>
+          <a:prstGeom xmlns:a="http://schemas.openxmlformats.org/drawingml/2006/main" prst="rect">
+            <a:avLst/>
+          </a:prstGeom>
+          <a:noFill xmlns:a="http://schemas.openxmlformats.org/drawingml/2006/main"/>
+          <a:ln xmlns:a="http://schemas.openxmlformats.org/drawingml/2006/main" w="0">
+            <a:noFill/>
+            <a:prstDash val="solid"/>
+          </a:ln>
+        </p:spPr>
+        <p:txBody>
+          <a:bodyPr xmlns:a="http://schemas.openxmlformats.org/drawingml/2006/main"/>
+          <a:lstStyle xmlns:a="http://schemas.openxmlformats.org/drawingml/2006/main"/>
+          <a:p xmlns:a="http://schemas.openxmlformats.org/drawingml/2006/main">
+            <a:pPr>
+              <a:defRPr sz="1350" b="0">
+                <a:solidFill>
+                  <a:srgbClr val="111827"/>
+                </a:solidFill>
+              </a:defRPr>
+            </a:pPr>
+            <a:r>
+              <a:rPr sz="1350" b="0">
+                <a:solidFill>
+                  <a:srgbClr val="111827"/>
+                </a:solidFill>
+              </a:rPr>
+              <a:t>Run 2020Q3 and 2022Q1 first; expand windows only if the behavior changes mechanically.</a:t>
+            </a:r>
+          </a:p>
+        </p:txBody>
+      </p:sp>
+      <p:sp>
+        <p:nvSpPr>
+          <p:cNvPr id="13" name="">
+            <a:extLst xmlns:a="http://schemas.openxmlformats.org/drawingml/2006/main">
+              <a:ext uri="{FF2B5EF4-FFF2-40B4-BE49-F238E27FC236}">
+                <a16:creationId xmlns:a16="http://schemas.microsoft.com/office/drawing/2014/main" id="{FADED8C5-8ECF-41C7-B5AA-37414E0C5A75}"/>
+              </a:ext>
+            </a:extLst>
+          </p:cNvPr>
+          <p:cNvSpPr>
+            <a:spLocks xmlns:a="http://schemas.openxmlformats.org/drawingml/2006/main" noGrp="1"/>
+          </p:cNvSpPr>
+          <p:nvPr/>
+        </p:nvSpPr>
+        <p:spPr>
+          <a:xfrm xmlns:a="http://schemas.openxmlformats.org/drawingml/2006/main">
+            <a:off x="1219200" y="5810250"/>
+            <a:ext cx="9620250" cy="400050"/>
+          </a:xfrm>
+          <a:prstGeom xmlns:a="http://schemas.openxmlformats.org/drawingml/2006/main" prst="rect">
+            <a:avLst/>
+          </a:prstGeom>
+          <a:noFill xmlns:a="http://schemas.openxmlformats.org/drawingml/2006/main"/>
+          <a:ln xmlns:a="http://schemas.openxmlformats.org/drawingml/2006/main" w="0">
+            <a:noFill/>
+            <a:prstDash val="solid"/>
+          </a:ln>
+        </p:spPr>
+        <p:txBody>
+          <a:bodyPr xmlns:a="http://schemas.openxmlformats.org/drawingml/2006/main"/>
+          <a:lstStyle xmlns:a="http://schemas.openxmlformats.org/drawingml/2006/main"/>
+          <a:p xmlns:a="http://schemas.openxmlformats.org/drawingml/2006/main">
+            <a:pPr algn="ctr">
+              <a:defRPr sz="1500" b="1">
+                <a:solidFill>
+                  <a:srgbClr val="111827"/>
+                </a:solidFill>
+              </a:defRPr>
+            </a:pPr>
+            <a:r>
+              <a:rPr sz="1500" b="1">
+                <a:solidFill>
+                  <a:srgbClr val="111827"/>
+                </a:solidFill>
+              </a:rPr>
+              <a:t>Compute note: full Gen4 daily-default breadth is expensive enough that feature engineering should start with compact grids, then confirm with full breadth after the mechanism is visible.</a:t>
+            </a:r>
+          </a:p>
+        </p:txBody>
+      </p:sp>
+    </p:spTree>
+    <p:extLst>
+      <p:ext uri="{BB962C8B-B14F-4D97-AF65-F5344CB8AC3E}">
+        <p14:creationId xmlns:p14="http://schemas.microsoft.com/office/powerpoint/2010/main" val="71963633"/>
       </p:ext>
     </p:extLst>
   </p:cSld>
@@ -2052,7 +5001,7 @@
           <p:cNvPr id="1" name="">
             <a:extLst xmlns:a="http://schemas.openxmlformats.org/drawingml/2006/main">
               <a:ext uri="{FF2B5EF4-FFF2-40B4-BE49-F238E27FC236}">
-                <a16:creationId xmlns:a16="http://schemas.microsoft.com/office/drawing/2014/main" id="{92A73E12-C761-4208-8A64-AFB697F1A462}"/>
+                <a16:creationId xmlns:a16="http://schemas.microsoft.com/office/drawing/2014/main" id="{56FF4BE9-853A-4D90-A041-E3F808DCD5BB}"/>
               </a:ext>
             </a:extLst>
           </p:cNvPr>
@@ -2102,7 +5051,7 @@
           <p:cNvPr id="2" name="">
             <a:extLst xmlns:a="http://schemas.openxmlformats.org/drawingml/2006/main">
               <a:ext uri="{FF2B5EF4-FFF2-40B4-BE49-F238E27FC236}">
-                <a16:creationId xmlns:a16="http://schemas.microsoft.com/office/drawing/2014/main" id="{09E3F0A1-6F84-42B9-A6CF-1249E5991638}"/>
+                <a16:creationId xmlns:a16="http://schemas.microsoft.com/office/drawing/2014/main" id="{50871AA7-C3BB-47BE-97AD-DC12E6757797}"/>
               </a:ext>
             </a:extLst>
           </p:cNvPr>
@@ -2152,7 +5101,7 @@
           <p:cNvPr id="3" name="">
             <a:extLst xmlns:a="http://schemas.openxmlformats.org/drawingml/2006/main">
               <a:ext uri="{FF2B5EF4-FFF2-40B4-BE49-F238E27FC236}">
-                <a16:creationId xmlns:a16="http://schemas.microsoft.com/office/drawing/2014/main" id="{3A00565A-88BA-4767-8267-57A4AE3DB678}"/>
+                <a16:creationId xmlns:a16="http://schemas.microsoft.com/office/drawing/2014/main" id="{C824441C-47DF-4A3B-AC0A-3894885AD635}"/>
               </a:ext>
             </a:extLst>
           </p:cNvPr>
@@ -2185,7 +5134,7 @@
           <p:cNvPr id="4" name="">
             <a:extLst xmlns:a="http://schemas.openxmlformats.org/drawingml/2006/main">
               <a:ext uri="{FF2B5EF4-FFF2-40B4-BE49-F238E27FC236}">
-                <a16:creationId xmlns:a16="http://schemas.microsoft.com/office/drawing/2014/main" id="{BE8B146B-6FCE-47F1-96B3-385224988DF4}"/>
+                <a16:creationId xmlns:a16="http://schemas.microsoft.com/office/drawing/2014/main" id="{D76A394C-50C7-471B-8C22-9BB1A25041B4}"/>
               </a:ext>
             </a:extLst>
           </p:cNvPr>
@@ -2220,7 +5169,7 @@
           <p:cNvPr id="5" name="">
             <a:extLst xmlns:a="http://schemas.openxmlformats.org/drawingml/2006/main">
               <a:ext uri="{FF2B5EF4-FFF2-40B4-BE49-F238E27FC236}">
-                <a16:creationId xmlns:a16="http://schemas.microsoft.com/office/drawing/2014/main" id="{3F4252CB-FB18-4175-84C1-A96839639291}"/>
+                <a16:creationId xmlns:a16="http://schemas.microsoft.com/office/drawing/2014/main" id="{608CFF40-39F5-4437-8BAE-B814631A1455}"/>
               </a:ext>
             </a:extLst>
           </p:cNvPr>
@@ -2270,7 +5219,7 @@
           <p:cNvPr id="6" name="">
             <a:extLst xmlns:a="http://schemas.openxmlformats.org/drawingml/2006/main">
               <a:ext uri="{FF2B5EF4-FFF2-40B4-BE49-F238E27FC236}">
-                <a16:creationId xmlns:a16="http://schemas.microsoft.com/office/drawing/2014/main" id="{EC9F182E-AF1B-45C7-A324-C8AB937DBCA1}"/>
+                <a16:creationId xmlns:a16="http://schemas.microsoft.com/office/drawing/2014/main" id="{3AD0750A-7CB9-41D9-8EBE-A8D10DFAFBD9}"/>
               </a:ext>
             </a:extLst>
           </p:cNvPr>
@@ -2301,7 +5250,7 @@
           <p:cNvPr id="7" name="">
             <a:extLst xmlns:a="http://schemas.openxmlformats.org/drawingml/2006/main">
               <a:ext uri="{FF2B5EF4-FFF2-40B4-BE49-F238E27FC236}">
-                <a16:creationId xmlns:a16="http://schemas.microsoft.com/office/drawing/2014/main" id="{DDE30F4C-F8B7-4B6A-BBDD-F5F9B6853A80}"/>
+                <a16:creationId xmlns:a16="http://schemas.microsoft.com/office/drawing/2014/main" id="{EE174954-FBEC-483B-B138-85AE35B0101A}"/>
               </a:ext>
             </a:extLst>
           </p:cNvPr>
@@ -2351,7 +5300,7 @@
           <p:cNvPr id="8" name="">
             <a:extLst xmlns:a="http://schemas.openxmlformats.org/drawingml/2006/main">
               <a:ext uri="{FF2B5EF4-FFF2-40B4-BE49-F238E27FC236}">
-                <a16:creationId xmlns:a16="http://schemas.microsoft.com/office/drawing/2014/main" id="{48EB970E-B6BF-4448-AD95-7D21898B20C1}"/>
+                <a16:creationId xmlns:a16="http://schemas.microsoft.com/office/drawing/2014/main" id="{457A7F49-5706-4F19-BC04-E3D740ECE589}"/>
               </a:ext>
             </a:extLst>
           </p:cNvPr>
@@ -2382,7 +5331,7 @@
           <p:cNvPr id="9" name="">
             <a:extLst xmlns:a="http://schemas.openxmlformats.org/drawingml/2006/main">
               <a:ext uri="{FF2B5EF4-FFF2-40B4-BE49-F238E27FC236}">
-                <a16:creationId xmlns:a16="http://schemas.microsoft.com/office/drawing/2014/main" id="{14474B6A-1FF1-48DF-BB21-1129EF0064E7}"/>
+                <a16:creationId xmlns:a16="http://schemas.microsoft.com/office/drawing/2014/main" id="{B6A857AC-5EA5-4446-A0A2-5ECCBB2732D4}"/>
               </a:ext>
             </a:extLst>
           </p:cNvPr>
@@ -2432,7 +5381,7 @@
           <p:cNvPr id="10" name="">
             <a:extLst xmlns:a="http://schemas.openxmlformats.org/drawingml/2006/main">
               <a:ext uri="{FF2B5EF4-FFF2-40B4-BE49-F238E27FC236}">
-                <a16:creationId xmlns:a16="http://schemas.microsoft.com/office/drawing/2014/main" id="{9F626EFD-6BF0-441E-9C43-79C93FF49D18}"/>
+                <a16:creationId xmlns:a16="http://schemas.microsoft.com/office/drawing/2014/main" id="{65F7332E-78CF-4343-A53B-277E98DDDD9A}"/>
               </a:ext>
             </a:extLst>
           </p:cNvPr>
@@ -2463,7 +5412,7 @@
           <p:cNvPr id="11" name="">
             <a:extLst xmlns:a="http://schemas.openxmlformats.org/drawingml/2006/main">
               <a:ext uri="{FF2B5EF4-FFF2-40B4-BE49-F238E27FC236}">
-                <a16:creationId xmlns:a16="http://schemas.microsoft.com/office/drawing/2014/main" id="{CD29C328-02F2-4068-813F-E2454BB16C1B}"/>
+                <a16:creationId xmlns:a16="http://schemas.microsoft.com/office/drawing/2014/main" id="{0EBE3D20-2538-47DD-B072-F2823878FEA2}"/>
               </a:ext>
             </a:extLst>
           </p:cNvPr>
@@ -2513,7 +5462,7 @@
           <p:cNvPr id="12" name="">
             <a:extLst xmlns:a="http://schemas.openxmlformats.org/drawingml/2006/main">
               <a:ext uri="{FF2B5EF4-FFF2-40B4-BE49-F238E27FC236}">
-                <a16:creationId xmlns:a16="http://schemas.microsoft.com/office/drawing/2014/main" id="{15431394-429A-48B4-94E5-9E5C74926582}"/>
+                <a16:creationId xmlns:a16="http://schemas.microsoft.com/office/drawing/2014/main" id="{037E0167-547C-482F-B78E-A5EF1D1F4FEF}"/>
               </a:ext>
             </a:extLst>
           </p:cNvPr>
@@ -2544,7 +5493,7 @@
           <p:cNvPr id="13" name="">
             <a:extLst xmlns:a="http://schemas.openxmlformats.org/drawingml/2006/main">
               <a:ext uri="{FF2B5EF4-FFF2-40B4-BE49-F238E27FC236}">
-                <a16:creationId xmlns:a16="http://schemas.microsoft.com/office/drawing/2014/main" id="{8D400C4C-A4C3-419A-AD1C-DCF8FAA9E481}"/>
+                <a16:creationId xmlns:a16="http://schemas.microsoft.com/office/drawing/2014/main" id="{E0CCF127-389E-47ED-B0B2-617D692BA24D}"/>
               </a:ext>
             </a:extLst>
           </p:cNvPr>
@@ -2594,7 +5543,7 @@
           <p:cNvPr id="14" name="">
             <a:extLst xmlns:a="http://schemas.openxmlformats.org/drawingml/2006/main">
               <a:ext uri="{FF2B5EF4-FFF2-40B4-BE49-F238E27FC236}">
-                <a16:creationId xmlns:a16="http://schemas.microsoft.com/office/drawing/2014/main" id="{EA87E221-9BC4-4A08-BE2D-36F556944003}"/>
+                <a16:creationId xmlns:a16="http://schemas.microsoft.com/office/drawing/2014/main" id="{3E5793A2-C081-45B1-834A-9E5E8E5160BB}"/>
               </a:ext>
             </a:extLst>
           </p:cNvPr>
@@ -2625,7 +5574,7 @@
           <p:cNvPr id="15" name="">
             <a:extLst xmlns:a="http://schemas.openxmlformats.org/drawingml/2006/main">
               <a:ext uri="{FF2B5EF4-FFF2-40B4-BE49-F238E27FC236}">
-                <a16:creationId xmlns:a16="http://schemas.microsoft.com/office/drawing/2014/main" id="{721F31EC-49B2-496E-A01E-5EF68B6FBF6D}"/>
+                <a16:creationId xmlns:a16="http://schemas.microsoft.com/office/drawing/2014/main" id="{3FCA4997-78B9-46B7-A02C-264EB4FE7D83}"/>
               </a:ext>
             </a:extLst>
           </p:cNvPr>
@@ -2675,7 +5624,7 @@
           <p:cNvPr id="16" name="">
             <a:extLst xmlns:a="http://schemas.openxmlformats.org/drawingml/2006/main">
               <a:ext uri="{FF2B5EF4-FFF2-40B4-BE49-F238E27FC236}">
-                <a16:creationId xmlns:a16="http://schemas.microsoft.com/office/drawing/2014/main" id="{7654710D-F146-43B8-A44D-32FAE9501429}"/>
+                <a16:creationId xmlns:a16="http://schemas.microsoft.com/office/drawing/2014/main" id="{41E06B2A-C501-41BB-B677-F2FCDE45D13F}"/>
               </a:ext>
             </a:extLst>
           </p:cNvPr>
@@ -2710,7 +5659,7 @@
           <p:cNvPr id="17" name="">
             <a:extLst xmlns:a="http://schemas.openxmlformats.org/drawingml/2006/main">
               <a:ext uri="{FF2B5EF4-FFF2-40B4-BE49-F238E27FC236}">
-                <a16:creationId xmlns:a16="http://schemas.microsoft.com/office/drawing/2014/main" id="{A147732A-42D8-43F2-8166-3924962F7CC8}"/>
+                <a16:creationId xmlns:a16="http://schemas.microsoft.com/office/drawing/2014/main" id="{F20FF216-BA8B-4AC5-A13F-D0D6254D84FF}"/>
               </a:ext>
             </a:extLst>
           </p:cNvPr>
@@ -2760,7 +5709,7 @@
           <p:cNvPr id="18" name="">
             <a:extLst xmlns:a="http://schemas.openxmlformats.org/drawingml/2006/main">
               <a:ext uri="{FF2B5EF4-FFF2-40B4-BE49-F238E27FC236}">
-                <a16:creationId xmlns:a16="http://schemas.microsoft.com/office/drawing/2014/main" id="{0A7F3E51-2558-41D7-8D9F-E2D66D0AC8FF}"/>
+                <a16:creationId xmlns:a16="http://schemas.microsoft.com/office/drawing/2014/main" id="{AFF661A5-A840-4B6A-8BA7-638C73AA082C}"/>
               </a:ext>
             </a:extLst>
           </p:cNvPr>
@@ -2791,7 +5740,7 @@
           <p:cNvPr id="19" name="">
             <a:extLst xmlns:a="http://schemas.openxmlformats.org/drawingml/2006/main">
               <a:ext uri="{FF2B5EF4-FFF2-40B4-BE49-F238E27FC236}">
-                <a16:creationId xmlns:a16="http://schemas.microsoft.com/office/drawing/2014/main" id="{C34A3CB1-D27F-4459-923F-193520DFD66A}"/>
+                <a16:creationId xmlns:a16="http://schemas.microsoft.com/office/drawing/2014/main" id="{C05BBF29-7D38-4E93-93E9-3ADC9664037F}"/>
               </a:ext>
             </a:extLst>
           </p:cNvPr>
@@ -2841,7 +5790,7 @@
           <p:cNvPr id="20" name="">
             <a:extLst xmlns:a="http://schemas.openxmlformats.org/drawingml/2006/main">
               <a:ext uri="{FF2B5EF4-FFF2-40B4-BE49-F238E27FC236}">
-                <a16:creationId xmlns:a16="http://schemas.microsoft.com/office/drawing/2014/main" id="{BAEA1BED-1298-4DCE-83D5-4C26FB70D50B}"/>
+                <a16:creationId xmlns:a16="http://schemas.microsoft.com/office/drawing/2014/main" id="{9A00D305-4ED3-4D1B-8944-3C78885C40EF}"/>
               </a:ext>
             </a:extLst>
           </p:cNvPr>
@@ -2872,7 +5821,7 @@
           <p:cNvPr id="21" name="">
             <a:extLst xmlns:a="http://schemas.openxmlformats.org/drawingml/2006/main">
               <a:ext uri="{FF2B5EF4-FFF2-40B4-BE49-F238E27FC236}">
-                <a16:creationId xmlns:a16="http://schemas.microsoft.com/office/drawing/2014/main" id="{E147369E-6DBE-4C77-A56C-589211A9BDAF}"/>
+                <a16:creationId xmlns:a16="http://schemas.microsoft.com/office/drawing/2014/main" id="{BCCE2957-721F-4D22-A5FB-A802DD76829D}"/>
               </a:ext>
             </a:extLst>
           </p:cNvPr>
@@ -2922,7 +5871,7 @@
           <p:cNvPr id="22" name="">
             <a:extLst xmlns:a="http://schemas.openxmlformats.org/drawingml/2006/main">
               <a:ext uri="{FF2B5EF4-FFF2-40B4-BE49-F238E27FC236}">
-                <a16:creationId xmlns:a16="http://schemas.microsoft.com/office/drawing/2014/main" id="{96AB5E69-6CD1-460F-9784-537E95EE249D}"/>
+                <a16:creationId xmlns:a16="http://schemas.microsoft.com/office/drawing/2014/main" id="{51FFA570-664A-4441-8CFB-96881B24F52E}"/>
               </a:ext>
             </a:extLst>
           </p:cNvPr>
@@ -2953,7 +5902,7 @@
           <p:cNvPr id="23" name="">
             <a:extLst xmlns:a="http://schemas.openxmlformats.org/drawingml/2006/main">
               <a:ext uri="{FF2B5EF4-FFF2-40B4-BE49-F238E27FC236}">
-                <a16:creationId xmlns:a16="http://schemas.microsoft.com/office/drawing/2014/main" id="{037F47ED-9371-403B-92E3-6A96C2F2D8CF}"/>
+                <a16:creationId xmlns:a16="http://schemas.microsoft.com/office/drawing/2014/main" id="{65633EE2-0DFF-496C-A049-875D671FDBEB}"/>
               </a:ext>
             </a:extLst>
           </p:cNvPr>
@@ -3003,7 +5952,7 @@
           <p:cNvPr id="24" name="">
             <a:extLst xmlns:a="http://schemas.openxmlformats.org/drawingml/2006/main">
               <a:ext uri="{FF2B5EF4-FFF2-40B4-BE49-F238E27FC236}">
-                <a16:creationId xmlns:a16="http://schemas.microsoft.com/office/drawing/2014/main" id="{A82ED345-C7DB-44A1-811E-9AB7CEF0D011}"/>
+                <a16:creationId xmlns:a16="http://schemas.microsoft.com/office/drawing/2014/main" id="{15DA309B-B513-421F-8D24-38B1F029B44F}"/>
               </a:ext>
             </a:extLst>
           </p:cNvPr>
@@ -3034,7 +5983,7 @@
           <p:cNvPr id="25" name="">
             <a:extLst xmlns:a="http://schemas.openxmlformats.org/drawingml/2006/main">
               <a:ext uri="{FF2B5EF4-FFF2-40B4-BE49-F238E27FC236}">
-                <a16:creationId xmlns:a16="http://schemas.microsoft.com/office/drawing/2014/main" id="{C9A6E6C7-C9C1-49B4-9DF4-9862DB921963}"/>
+                <a16:creationId xmlns:a16="http://schemas.microsoft.com/office/drawing/2014/main" id="{717F9C7C-B1B2-43C9-8A0B-283A4F6F0802}"/>
               </a:ext>
             </a:extLst>
           </p:cNvPr>
@@ -3084,7 +6033,7 @@
           <p:cNvPr id="26" name="">
             <a:extLst xmlns:a="http://schemas.openxmlformats.org/drawingml/2006/main">
               <a:ext uri="{FF2B5EF4-FFF2-40B4-BE49-F238E27FC236}">
-                <a16:creationId xmlns:a16="http://schemas.microsoft.com/office/drawing/2014/main" id="{5F0CC7C2-CF07-46B6-BB19-46B21AA1AFF1}"/>
+                <a16:creationId xmlns:a16="http://schemas.microsoft.com/office/drawing/2014/main" id="{97BF6F11-E197-4588-953A-FA82B478A557}"/>
               </a:ext>
             </a:extLst>
           </p:cNvPr>
@@ -3132,7 +6081,7 @@
     </p:spTree>
     <p:extLst>
       <p:ext uri="{BB962C8B-B14F-4D97-AF65-F5344CB8AC3E}">
-        <p14:creationId xmlns:p14="http://schemas.microsoft.com/office/powerpoint/2010/main" val="88718730"/>
+        <p14:creationId xmlns:p14="http://schemas.microsoft.com/office/powerpoint/2010/main" val="138071836"/>
       </p:ext>
     </p:extLst>
   </p:cSld>
@@ -3163,7 +6112,7 @@
           <p:cNvPr id="1" name="">
             <a:extLst xmlns:a="http://schemas.openxmlformats.org/drawingml/2006/main">
               <a:ext uri="{FF2B5EF4-FFF2-40B4-BE49-F238E27FC236}">
-                <a16:creationId xmlns:a16="http://schemas.microsoft.com/office/drawing/2014/main" id="{113F643C-1317-424E-872C-9298236352A5}"/>
+                <a16:creationId xmlns:a16="http://schemas.microsoft.com/office/drawing/2014/main" id="{BF4DB844-203E-4B76-83AC-ABF7E1D7DD1F}"/>
               </a:ext>
             </a:extLst>
           </p:cNvPr>
@@ -3213,7 +6162,7 @@
           <p:cNvPr id="2" name="">
             <a:extLst xmlns:a="http://schemas.openxmlformats.org/drawingml/2006/main">
               <a:ext uri="{FF2B5EF4-FFF2-40B4-BE49-F238E27FC236}">
-                <a16:creationId xmlns:a16="http://schemas.microsoft.com/office/drawing/2014/main" id="{D0067FA3-510C-444C-99CF-595354A91792}"/>
+                <a16:creationId xmlns:a16="http://schemas.microsoft.com/office/drawing/2014/main" id="{F657AF1B-EE97-466D-8235-14881E0B5A7C}"/>
               </a:ext>
             </a:extLst>
           </p:cNvPr>
@@ -3263,7 +6212,7 @@
           <p:cNvPr id="3" name="">
             <a:extLst xmlns:a="http://schemas.openxmlformats.org/drawingml/2006/main">
               <a:ext uri="{FF2B5EF4-FFF2-40B4-BE49-F238E27FC236}">
-                <a16:creationId xmlns:a16="http://schemas.microsoft.com/office/drawing/2014/main" id="{3A3044CC-4330-42B5-B670-F0330F52657E}"/>
+                <a16:creationId xmlns:a16="http://schemas.microsoft.com/office/drawing/2014/main" id="{2C5CC106-91BA-4226-BFDA-3324D764B0A9}"/>
               </a:ext>
             </a:extLst>
           </p:cNvPr>
@@ -3296,7 +6245,7 @@
           <p:cNvPr id="4" name="">
             <a:extLst xmlns:a="http://schemas.openxmlformats.org/drawingml/2006/main">
               <a:ext uri="{FF2B5EF4-FFF2-40B4-BE49-F238E27FC236}">
-                <a16:creationId xmlns:a16="http://schemas.microsoft.com/office/drawing/2014/main" id="{60BC9219-EC69-42D1-8EE5-D8F73B7792C7}"/>
+                <a16:creationId xmlns:a16="http://schemas.microsoft.com/office/drawing/2014/main" id="{7BB18FA5-5856-4786-A876-9F78BF416430}"/>
               </a:ext>
             </a:extLst>
           </p:cNvPr>
@@ -3331,7 +6280,7 @@
           <p:cNvPr id="5" name="">
             <a:extLst xmlns:a="http://schemas.openxmlformats.org/drawingml/2006/main">
               <a:ext uri="{FF2B5EF4-FFF2-40B4-BE49-F238E27FC236}">
-                <a16:creationId xmlns:a16="http://schemas.microsoft.com/office/drawing/2014/main" id="{1D6EB0ED-A6FE-4983-9F26-52166E597EA6}"/>
+                <a16:creationId xmlns:a16="http://schemas.microsoft.com/office/drawing/2014/main" id="{642B28B0-2934-4492-A20C-5EF2575250BB}"/>
               </a:ext>
             </a:extLst>
           </p:cNvPr>
@@ -3381,7 +6330,7 @@
           <p:cNvPr id="6" name="">
             <a:extLst xmlns:a="http://schemas.openxmlformats.org/drawingml/2006/main">
               <a:ext uri="{FF2B5EF4-FFF2-40B4-BE49-F238E27FC236}">
-                <a16:creationId xmlns:a16="http://schemas.microsoft.com/office/drawing/2014/main" id="{52168A71-8274-4A0A-A3B4-728366C9EF19}"/>
+                <a16:creationId xmlns:a16="http://schemas.microsoft.com/office/drawing/2014/main" id="{1F451813-8BE4-47EB-91D4-75EC29674B67}"/>
               </a:ext>
             </a:extLst>
           </p:cNvPr>
@@ -3412,7 +6361,7 @@
           <p:cNvPr id="7" name="">
             <a:extLst xmlns:a="http://schemas.openxmlformats.org/drawingml/2006/main">
               <a:ext uri="{FF2B5EF4-FFF2-40B4-BE49-F238E27FC236}">
-                <a16:creationId xmlns:a16="http://schemas.microsoft.com/office/drawing/2014/main" id="{093EBA2D-BAFE-4D5A-90D7-FFE9DC51E11F}"/>
+                <a16:creationId xmlns:a16="http://schemas.microsoft.com/office/drawing/2014/main" id="{207D013A-30B6-489A-B37B-91F09E4D80A6}"/>
               </a:ext>
             </a:extLst>
           </p:cNvPr>
@@ -3447,7 +6396,7 @@
           <p:cNvPr id="8" name="">
             <a:extLst xmlns:a="http://schemas.openxmlformats.org/drawingml/2006/main">
               <a:ext uri="{FF2B5EF4-FFF2-40B4-BE49-F238E27FC236}">
-                <a16:creationId xmlns:a16="http://schemas.microsoft.com/office/drawing/2014/main" id="{5D00213C-275C-414B-94B9-C54230F33EF5}"/>
+                <a16:creationId xmlns:a16="http://schemas.microsoft.com/office/drawing/2014/main" id="{B9635D39-9F8C-4517-A239-A2E47C4A55CE}"/>
               </a:ext>
             </a:extLst>
           </p:cNvPr>
@@ -3497,7 +6446,7 @@
           <p:cNvPr id="9" name="">
             <a:extLst xmlns:a="http://schemas.openxmlformats.org/drawingml/2006/main">
               <a:ext uri="{FF2B5EF4-FFF2-40B4-BE49-F238E27FC236}">
-                <a16:creationId xmlns:a16="http://schemas.microsoft.com/office/drawing/2014/main" id="{1945C528-552F-4948-B8A1-FA5685739BE3}"/>
+                <a16:creationId xmlns:a16="http://schemas.microsoft.com/office/drawing/2014/main" id="{D7AF7FE6-F5B8-4B8F-8C4D-47A2BB986536}"/>
               </a:ext>
             </a:extLst>
           </p:cNvPr>
@@ -3528,7 +6477,7 @@
           <p:cNvPr id="10" name="">
             <a:extLst xmlns:a="http://schemas.openxmlformats.org/drawingml/2006/main">
               <a:ext uri="{FF2B5EF4-FFF2-40B4-BE49-F238E27FC236}">
-                <a16:creationId xmlns:a16="http://schemas.microsoft.com/office/drawing/2014/main" id="{3875C78D-FEB9-4A3E-892D-C2337C0A9E03}"/>
+                <a16:creationId xmlns:a16="http://schemas.microsoft.com/office/drawing/2014/main" id="{E67FF066-BF73-4D6D-861B-D7D9D8F052BA}"/>
               </a:ext>
             </a:extLst>
           </p:cNvPr>
@@ -3563,7 +6512,7 @@
           <p:cNvPr id="11" name="">
             <a:extLst xmlns:a="http://schemas.openxmlformats.org/drawingml/2006/main">
               <a:ext uri="{FF2B5EF4-FFF2-40B4-BE49-F238E27FC236}">
-                <a16:creationId xmlns:a16="http://schemas.microsoft.com/office/drawing/2014/main" id="{8C83008E-DC38-42B8-8A7E-BACAF37F9FEF}"/>
+                <a16:creationId xmlns:a16="http://schemas.microsoft.com/office/drawing/2014/main" id="{BE47F05B-960C-47AA-9ADF-8D066C83732C}"/>
               </a:ext>
             </a:extLst>
           </p:cNvPr>
@@ -3613,7 +6562,7 @@
           <p:cNvPr id="12" name="">
             <a:extLst xmlns:a="http://schemas.openxmlformats.org/drawingml/2006/main">
               <a:ext uri="{FF2B5EF4-FFF2-40B4-BE49-F238E27FC236}">
-                <a16:creationId xmlns:a16="http://schemas.microsoft.com/office/drawing/2014/main" id="{270A7B76-0F06-41BC-9E52-148F03EFB24B}"/>
+                <a16:creationId xmlns:a16="http://schemas.microsoft.com/office/drawing/2014/main" id="{F0460358-2E2C-44A0-9338-C2967EAAB0A4}"/>
               </a:ext>
             </a:extLst>
           </p:cNvPr>
@@ -3644,7 +6593,7 @@
           <p:cNvPr id="13" name="">
             <a:extLst xmlns:a="http://schemas.openxmlformats.org/drawingml/2006/main">
               <a:ext uri="{FF2B5EF4-FFF2-40B4-BE49-F238E27FC236}">
-                <a16:creationId xmlns:a16="http://schemas.microsoft.com/office/drawing/2014/main" id="{B90CBA53-68BF-47D0-B2BF-A0241C710949}"/>
+                <a16:creationId xmlns:a16="http://schemas.microsoft.com/office/drawing/2014/main" id="{1092F0FD-3477-40A5-9136-AB936622F2B7}"/>
               </a:ext>
             </a:extLst>
           </p:cNvPr>
@@ -3679,7 +6628,7 @@
           <p:cNvPr id="14" name="">
             <a:extLst xmlns:a="http://schemas.openxmlformats.org/drawingml/2006/main">
               <a:ext uri="{FF2B5EF4-FFF2-40B4-BE49-F238E27FC236}">
-                <a16:creationId xmlns:a16="http://schemas.microsoft.com/office/drawing/2014/main" id="{8482194B-E1DF-46B0-B830-80CFC81D19C2}"/>
+                <a16:creationId xmlns:a16="http://schemas.microsoft.com/office/drawing/2014/main" id="{AFD92E67-1725-44B3-810C-FBE6CAEF0F1B}"/>
               </a:ext>
             </a:extLst>
           </p:cNvPr>
@@ -3729,7 +6678,7 @@
           <p:cNvPr id="15" name="">
             <a:extLst xmlns:a="http://schemas.openxmlformats.org/drawingml/2006/main">
               <a:ext uri="{FF2B5EF4-FFF2-40B4-BE49-F238E27FC236}">
-                <a16:creationId xmlns:a16="http://schemas.microsoft.com/office/drawing/2014/main" id="{5D6B960D-CD88-4ECC-93B5-7514FD5E704D}"/>
+                <a16:creationId xmlns:a16="http://schemas.microsoft.com/office/drawing/2014/main" id="{A0654890-1D3B-43A3-91AC-51560F022E39}"/>
               </a:ext>
             </a:extLst>
           </p:cNvPr>
@@ -3764,7 +6713,7 @@
           <p:cNvPr id="16" name="">
             <a:extLst xmlns:a="http://schemas.openxmlformats.org/drawingml/2006/main">
               <a:ext uri="{FF2B5EF4-FFF2-40B4-BE49-F238E27FC236}">
-                <a16:creationId xmlns:a16="http://schemas.microsoft.com/office/drawing/2014/main" id="{EBD6F740-333A-4E80-B8E4-0E894F72DBF5}"/>
+                <a16:creationId xmlns:a16="http://schemas.microsoft.com/office/drawing/2014/main" id="{615048F9-EB4E-4077-92CD-ECE171728AAB}"/>
               </a:ext>
             </a:extLst>
           </p:cNvPr>
@@ -3814,7 +6763,7 @@
           <p:cNvPr id="17" name="">
             <a:extLst xmlns:a="http://schemas.openxmlformats.org/drawingml/2006/main">
               <a:ext uri="{FF2B5EF4-FFF2-40B4-BE49-F238E27FC236}">
-                <a16:creationId xmlns:a16="http://schemas.microsoft.com/office/drawing/2014/main" id="{A9739E00-EFF1-471A-AD29-CC644F8463D1}"/>
+                <a16:creationId xmlns:a16="http://schemas.microsoft.com/office/drawing/2014/main" id="{AD9AF367-4D20-436E-BC2C-CBC8F24DD3E5}"/>
               </a:ext>
             </a:extLst>
           </p:cNvPr>
@@ -3862,7 +6811,7 @@
     </p:spTree>
     <p:extLst>
       <p:ext uri="{BB962C8B-B14F-4D97-AF65-F5344CB8AC3E}">
-        <p14:creationId xmlns:p14="http://schemas.microsoft.com/office/powerpoint/2010/main" val="1991208593"/>
+        <p14:creationId xmlns:p14="http://schemas.microsoft.com/office/powerpoint/2010/main" val="2002627261"/>
       </p:ext>
     </p:extLst>
   </p:cSld>
@@ -3893,7 +6842,7 @@
           <p:cNvPr id="1" name="">
             <a:extLst xmlns:a="http://schemas.openxmlformats.org/drawingml/2006/main">
               <a:ext uri="{FF2B5EF4-FFF2-40B4-BE49-F238E27FC236}">
-                <a16:creationId xmlns:a16="http://schemas.microsoft.com/office/drawing/2014/main" id="{CF4EA7C2-683A-4106-A8A9-C85901CFF31B}"/>
+                <a16:creationId xmlns:a16="http://schemas.microsoft.com/office/drawing/2014/main" id="{CE5F6DBB-CC7D-4EBD-BB07-D6F9D329AB2E}"/>
               </a:ext>
             </a:extLst>
           </p:cNvPr>
@@ -3943,7 +6892,7 @@
           <p:cNvPr id="2" name="">
             <a:extLst xmlns:a="http://schemas.openxmlformats.org/drawingml/2006/main">
               <a:ext uri="{FF2B5EF4-FFF2-40B4-BE49-F238E27FC236}">
-                <a16:creationId xmlns:a16="http://schemas.microsoft.com/office/drawing/2014/main" id="{ECC2EE0F-8DAC-4049-B3B3-2311D3947B32}"/>
+                <a16:creationId xmlns:a16="http://schemas.microsoft.com/office/drawing/2014/main" id="{E5F98F62-C008-4FB2-AF3F-86DBBD2484CC}"/>
               </a:ext>
             </a:extLst>
           </p:cNvPr>
@@ -3993,7 +6942,7 @@
           <p:cNvPr id="3" name="">
             <a:extLst xmlns:a="http://schemas.openxmlformats.org/drawingml/2006/main">
               <a:ext uri="{FF2B5EF4-FFF2-40B4-BE49-F238E27FC236}">
-                <a16:creationId xmlns:a16="http://schemas.microsoft.com/office/drawing/2014/main" id="{71584582-EBC1-4F39-A984-500DA3436223}"/>
+                <a16:creationId xmlns:a16="http://schemas.microsoft.com/office/drawing/2014/main" id="{61093D7C-3021-4458-869D-820E63CA7550}"/>
               </a:ext>
             </a:extLst>
           </p:cNvPr>
@@ -4026,7 +6975,7 @@
           <p:cNvPr id="4" name="">
             <a:extLst xmlns:a="http://schemas.openxmlformats.org/drawingml/2006/main">
               <a:ext uri="{FF2B5EF4-FFF2-40B4-BE49-F238E27FC236}">
-                <a16:creationId xmlns:a16="http://schemas.microsoft.com/office/drawing/2014/main" id="{3AC7D129-BB05-422C-9A44-15B87DC1CAB9}"/>
+                <a16:creationId xmlns:a16="http://schemas.microsoft.com/office/drawing/2014/main" id="{AE96D7ED-87FC-43DC-B44D-B10033550293}"/>
               </a:ext>
             </a:extLst>
           </p:cNvPr>
@@ -4061,7 +7010,7 @@
           <p:cNvPr id="5" name="">
             <a:extLst xmlns:a="http://schemas.openxmlformats.org/drawingml/2006/main">
               <a:ext uri="{FF2B5EF4-FFF2-40B4-BE49-F238E27FC236}">
-                <a16:creationId xmlns:a16="http://schemas.microsoft.com/office/drawing/2014/main" id="{3DCA4A70-5F03-4F1A-B21A-8BE9AEB17E71}"/>
+                <a16:creationId xmlns:a16="http://schemas.microsoft.com/office/drawing/2014/main" id="{853B821C-60FA-434F-8BF2-95762B98A7F2}"/>
               </a:ext>
             </a:extLst>
           </p:cNvPr>
@@ -4096,7 +7045,7 @@
           <p:cNvPr id="6" name="">
             <a:extLst xmlns:a="http://schemas.openxmlformats.org/drawingml/2006/main">
               <a:ext uri="{FF2B5EF4-FFF2-40B4-BE49-F238E27FC236}">
-                <a16:creationId xmlns:a16="http://schemas.microsoft.com/office/drawing/2014/main" id="{89D62C55-69E8-4500-9A45-96F3CC59E269}"/>
+                <a16:creationId xmlns:a16="http://schemas.microsoft.com/office/drawing/2014/main" id="{A8A24997-3FDD-4164-AA8E-037211CB1AC1}"/>
               </a:ext>
             </a:extLst>
           </p:cNvPr>
@@ -4146,7 +7095,7 @@
           <p:cNvPr id="7" name="">
             <a:extLst xmlns:a="http://schemas.openxmlformats.org/drawingml/2006/main">
               <a:ext uri="{FF2B5EF4-FFF2-40B4-BE49-F238E27FC236}">
-                <a16:creationId xmlns:a16="http://schemas.microsoft.com/office/drawing/2014/main" id="{AACDD46C-6EBE-404C-8178-C887CE636FAA}"/>
+                <a16:creationId xmlns:a16="http://schemas.microsoft.com/office/drawing/2014/main" id="{E6C50622-B418-45EF-8803-5B302920C30D}"/>
               </a:ext>
             </a:extLst>
           </p:cNvPr>
@@ -4196,7 +7145,7 @@
           <p:cNvPr id="8" name="">
             <a:extLst xmlns:a="http://schemas.openxmlformats.org/drawingml/2006/main">
               <a:ext uri="{FF2B5EF4-FFF2-40B4-BE49-F238E27FC236}">
-                <a16:creationId xmlns:a16="http://schemas.microsoft.com/office/drawing/2014/main" id="{21A96731-294E-4627-B4CE-751D50A0AD4E}"/>
+                <a16:creationId xmlns:a16="http://schemas.microsoft.com/office/drawing/2014/main" id="{13AB00C2-7B08-42F7-AED8-7DC001D94F14}"/>
               </a:ext>
             </a:extLst>
           </p:cNvPr>
@@ -4227,7 +7176,7 @@
           <p:cNvPr id="9" name="">
             <a:extLst xmlns:a="http://schemas.openxmlformats.org/drawingml/2006/main">
               <a:ext uri="{FF2B5EF4-FFF2-40B4-BE49-F238E27FC236}">
-                <a16:creationId xmlns:a16="http://schemas.microsoft.com/office/drawing/2014/main" id="{8091DFBB-5A62-4136-97CB-CAC31EE0DADF}"/>
+                <a16:creationId xmlns:a16="http://schemas.microsoft.com/office/drawing/2014/main" id="{4658822D-511A-4F2A-A409-7FF15DC9227A}"/>
               </a:ext>
             </a:extLst>
           </p:cNvPr>
@@ -4277,7 +7226,7 @@
           <p:cNvPr id="10" name="">
             <a:extLst xmlns:a="http://schemas.openxmlformats.org/drawingml/2006/main">
               <a:ext uri="{FF2B5EF4-FFF2-40B4-BE49-F238E27FC236}">
-                <a16:creationId xmlns:a16="http://schemas.microsoft.com/office/drawing/2014/main" id="{B4A73292-7EFB-4686-85AC-F06A283D6363}"/>
+                <a16:creationId xmlns:a16="http://schemas.microsoft.com/office/drawing/2014/main" id="{DF441EA0-F8CE-4C7C-A62B-9AB7DF5FB977}"/>
               </a:ext>
             </a:extLst>
           </p:cNvPr>
@@ -4308,7 +7257,7 @@
           <p:cNvPr id="11" name="">
             <a:extLst xmlns:a="http://schemas.openxmlformats.org/drawingml/2006/main">
               <a:ext uri="{FF2B5EF4-FFF2-40B4-BE49-F238E27FC236}">
-                <a16:creationId xmlns:a16="http://schemas.microsoft.com/office/drawing/2014/main" id="{DC41979B-3A4C-40AE-AF83-D7D560F8B20E}"/>
+                <a16:creationId xmlns:a16="http://schemas.microsoft.com/office/drawing/2014/main" id="{A448222B-6AD0-4123-BA27-84902E663F56}"/>
               </a:ext>
             </a:extLst>
           </p:cNvPr>
@@ -4358,7 +7307,7 @@
           <p:cNvPr id="12" name="">
             <a:extLst xmlns:a="http://schemas.openxmlformats.org/drawingml/2006/main">
               <a:ext uri="{FF2B5EF4-FFF2-40B4-BE49-F238E27FC236}">
-                <a16:creationId xmlns:a16="http://schemas.microsoft.com/office/drawing/2014/main" id="{5E56CA24-85B9-42B7-A0BD-E7A62E1F2BD4}"/>
+                <a16:creationId xmlns:a16="http://schemas.microsoft.com/office/drawing/2014/main" id="{A4573205-E61D-49BD-9F21-B36235632CEE}"/>
               </a:ext>
             </a:extLst>
           </p:cNvPr>
@@ -4389,7 +7338,7 @@
           <p:cNvPr id="13" name="">
             <a:extLst xmlns:a="http://schemas.openxmlformats.org/drawingml/2006/main">
               <a:ext uri="{FF2B5EF4-FFF2-40B4-BE49-F238E27FC236}">
-                <a16:creationId xmlns:a16="http://schemas.microsoft.com/office/drawing/2014/main" id="{CD5429EF-79F6-4D45-875A-9CFF672D93FA}"/>
+                <a16:creationId xmlns:a16="http://schemas.microsoft.com/office/drawing/2014/main" id="{67AFEFA9-3421-4F34-A284-682E5C90A116}"/>
               </a:ext>
             </a:extLst>
           </p:cNvPr>
@@ -4439,7 +7388,7 @@
           <p:cNvPr id="14" name="">
             <a:extLst xmlns:a="http://schemas.openxmlformats.org/drawingml/2006/main">
               <a:ext uri="{FF2B5EF4-FFF2-40B4-BE49-F238E27FC236}">
-                <a16:creationId xmlns:a16="http://schemas.microsoft.com/office/drawing/2014/main" id="{0005C85E-EF50-49E7-B2A1-2FC00482F445}"/>
+                <a16:creationId xmlns:a16="http://schemas.microsoft.com/office/drawing/2014/main" id="{D7329E7A-5070-4C70-9144-E8AB1B07995B}"/>
               </a:ext>
             </a:extLst>
           </p:cNvPr>
@@ -4470,7 +7419,7 @@
           <p:cNvPr id="15" name="">
             <a:extLst xmlns:a="http://schemas.openxmlformats.org/drawingml/2006/main">
               <a:ext uri="{FF2B5EF4-FFF2-40B4-BE49-F238E27FC236}">
-                <a16:creationId xmlns:a16="http://schemas.microsoft.com/office/drawing/2014/main" id="{A1541F8C-E27C-4CDC-9768-AF9C85934A26}"/>
+                <a16:creationId xmlns:a16="http://schemas.microsoft.com/office/drawing/2014/main" id="{5A403A76-4BAC-407C-8E15-08F56F72A358}"/>
               </a:ext>
             </a:extLst>
           </p:cNvPr>
@@ -4520,7 +7469,7 @@
           <p:cNvPr id="16" name="">
             <a:extLst xmlns:a="http://schemas.openxmlformats.org/drawingml/2006/main">
               <a:ext uri="{FF2B5EF4-FFF2-40B4-BE49-F238E27FC236}">
-                <a16:creationId xmlns:a16="http://schemas.microsoft.com/office/drawing/2014/main" id="{14A0DF7F-A80F-46FE-96FB-2BDF85DF4627}"/>
+                <a16:creationId xmlns:a16="http://schemas.microsoft.com/office/drawing/2014/main" id="{EBDF9DF3-5E29-46C2-814E-A67B44E6604D}"/>
               </a:ext>
             </a:extLst>
           </p:cNvPr>
@@ -4551,7 +7500,7 @@
           <p:cNvPr id="17" name="">
             <a:extLst xmlns:a="http://schemas.openxmlformats.org/drawingml/2006/main">
               <a:ext uri="{FF2B5EF4-FFF2-40B4-BE49-F238E27FC236}">
-                <a16:creationId xmlns:a16="http://schemas.microsoft.com/office/drawing/2014/main" id="{95F82F0B-10A9-4454-AE89-04A0FA91A197}"/>
+                <a16:creationId xmlns:a16="http://schemas.microsoft.com/office/drawing/2014/main" id="{D9ED026A-4174-4406-9F8F-23102F79DD1F}"/>
               </a:ext>
             </a:extLst>
           </p:cNvPr>
@@ -4601,7 +7550,7 @@
           <p:cNvPr id="18" name="">
             <a:extLst xmlns:a="http://schemas.openxmlformats.org/drawingml/2006/main">
               <a:ext uri="{FF2B5EF4-FFF2-40B4-BE49-F238E27FC236}">
-                <a16:creationId xmlns:a16="http://schemas.microsoft.com/office/drawing/2014/main" id="{28E82B3C-63CB-433D-BB93-BC1FBAD2BF1B}"/>
+                <a16:creationId xmlns:a16="http://schemas.microsoft.com/office/drawing/2014/main" id="{5092516C-0586-45E5-9D88-A97853DAB758}"/>
               </a:ext>
             </a:extLst>
           </p:cNvPr>
@@ -4632,7 +7581,7 @@
           <p:cNvPr id="19" name="">
             <a:extLst xmlns:a="http://schemas.openxmlformats.org/drawingml/2006/main">
               <a:ext uri="{FF2B5EF4-FFF2-40B4-BE49-F238E27FC236}">
-                <a16:creationId xmlns:a16="http://schemas.microsoft.com/office/drawing/2014/main" id="{19A92C15-A4BA-436C-91B9-C8760A0C84BF}"/>
+                <a16:creationId xmlns:a16="http://schemas.microsoft.com/office/drawing/2014/main" id="{7B2C9635-1D94-4F5E-AA03-7F1A1295531F}"/>
               </a:ext>
             </a:extLst>
           </p:cNvPr>
@@ -4682,7 +7631,7 @@
           <p:cNvPr id="20" name="">
             <a:extLst xmlns:a="http://schemas.openxmlformats.org/drawingml/2006/main">
               <a:ext uri="{FF2B5EF4-FFF2-40B4-BE49-F238E27FC236}">
-                <a16:creationId xmlns:a16="http://schemas.microsoft.com/office/drawing/2014/main" id="{AD107892-C845-43B2-88E7-B482169B5372}"/>
+                <a16:creationId xmlns:a16="http://schemas.microsoft.com/office/drawing/2014/main" id="{392E08F9-CB24-45BC-802F-626AC9917505}"/>
               </a:ext>
             </a:extLst>
           </p:cNvPr>
@@ -4713,7 +7662,7 @@
           <p:cNvPr id="21" name="">
             <a:extLst xmlns:a="http://schemas.openxmlformats.org/drawingml/2006/main">
               <a:ext uri="{FF2B5EF4-FFF2-40B4-BE49-F238E27FC236}">
-                <a16:creationId xmlns:a16="http://schemas.microsoft.com/office/drawing/2014/main" id="{72B5519C-B13E-4FDB-9670-A8F529D5EB72}"/>
+                <a16:creationId xmlns:a16="http://schemas.microsoft.com/office/drawing/2014/main" id="{E440289E-6001-4106-86D5-EF4122F7B3C6}"/>
               </a:ext>
             </a:extLst>
           </p:cNvPr>
@@ -4763,7 +7712,7 @@
           <p:cNvPr id="22" name="">
             <a:extLst xmlns:a="http://schemas.openxmlformats.org/drawingml/2006/main">
               <a:ext uri="{FF2B5EF4-FFF2-40B4-BE49-F238E27FC236}">
-                <a16:creationId xmlns:a16="http://schemas.microsoft.com/office/drawing/2014/main" id="{3EF2ADE9-9822-4C8B-8CB2-0C6C7F15BDDD}"/>
+                <a16:creationId xmlns:a16="http://schemas.microsoft.com/office/drawing/2014/main" id="{624AAC33-05FA-474B-A984-920B8C39015F}"/>
               </a:ext>
             </a:extLst>
           </p:cNvPr>
@@ -4794,7 +7743,7 @@
           <p:cNvPr id="23" name="">
             <a:extLst xmlns:a="http://schemas.openxmlformats.org/drawingml/2006/main">
               <a:ext uri="{FF2B5EF4-FFF2-40B4-BE49-F238E27FC236}">
-                <a16:creationId xmlns:a16="http://schemas.microsoft.com/office/drawing/2014/main" id="{5FEB6B80-9100-434B-954B-C20EE88FD4AB}"/>
+                <a16:creationId xmlns:a16="http://schemas.microsoft.com/office/drawing/2014/main" id="{F11FA9B6-BAFF-4E61-97E0-F01A283E6866}"/>
               </a:ext>
             </a:extLst>
           </p:cNvPr>
@@ -4842,7 +7791,7 @@
     </p:spTree>
     <p:extLst>
       <p:ext uri="{BB962C8B-B14F-4D97-AF65-F5344CB8AC3E}">
-        <p14:creationId xmlns:p14="http://schemas.microsoft.com/office/powerpoint/2010/main" val="1652170530"/>
+        <p14:creationId xmlns:p14="http://schemas.microsoft.com/office/powerpoint/2010/main" val="1094014076"/>
       </p:ext>
     </p:extLst>
   </p:cSld>
@@ -4873,7 +7822,7 @@
           <p:cNvPr id="1" name="">
             <a:extLst xmlns:a="http://schemas.openxmlformats.org/drawingml/2006/main">
               <a:ext uri="{FF2B5EF4-FFF2-40B4-BE49-F238E27FC236}">
-                <a16:creationId xmlns:a16="http://schemas.microsoft.com/office/drawing/2014/main" id="{A40F26AD-CC0E-4F56-84B5-C3AEC6F33CEC}"/>
+                <a16:creationId xmlns:a16="http://schemas.microsoft.com/office/drawing/2014/main" id="{4957E6DF-8D33-48F0-BFD5-07A2B86B989D}"/>
               </a:ext>
             </a:extLst>
           </p:cNvPr>
@@ -4923,7 +7872,7 @@
           <p:cNvPr id="2" name="">
             <a:extLst xmlns:a="http://schemas.openxmlformats.org/drawingml/2006/main">
               <a:ext uri="{FF2B5EF4-FFF2-40B4-BE49-F238E27FC236}">
-                <a16:creationId xmlns:a16="http://schemas.microsoft.com/office/drawing/2014/main" id="{3EDD8F47-1FF8-45EC-A36C-60784049E0D1}"/>
+                <a16:creationId xmlns:a16="http://schemas.microsoft.com/office/drawing/2014/main" id="{F0823E1B-4541-469A-A946-29C0C8BC124A}"/>
               </a:ext>
             </a:extLst>
           </p:cNvPr>
@@ -4973,7 +7922,7 @@
           <p:cNvPr id="3" name="">
             <a:extLst xmlns:a="http://schemas.openxmlformats.org/drawingml/2006/main">
               <a:ext uri="{FF2B5EF4-FFF2-40B4-BE49-F238E27FC236}">
-                <a16:creationId xmlns:a16="http://schemas.microsoft.com/office/drawing/2014/main" id="{59EE1A05-53B2-4204-ABCA-AE68182DF189}"/>
+                <a16:creationId xmlns:a16="http://schemas.microsoft.com/office/drawing/2014/main" id="{25121B9D-0B0E-4783-BFBA-6390CE346164}"/>
               </a:ext>
             </a:extLst>
           </p:cNvPr>
@@ -5006,7 +7955,7 @@
           <p:cNvPr id="4" name="">
             <a:extLst xmlns:a="http://schemas.openxmlformats.org/drawingml/2006/main">
               <a:ext uri="{FF2B5EF4-FFF2-40B4-BE49-F238E27FC236}">
-                <a16:creationId xmlns:a16="http://schemas.microsoft.com/office/drawing/2014/main" id="{D94D5D2B-C39D-4EF5-AB92-B0E47769BE1C}"/>
+                <a16:creationId xmlns:a16="http://schemas.microsoft.com/office/drawing/2014/main" id="{554F84EB-DE9D-4180-9A77-9F795A621564}"/>
               </a:ext>
             </a:extLst>
           </p:cNvPr>
@@ -5041,7 +7990,7 @@
           <p:cNvPr id="5" name="">
             <a:extLst xmlns:a="http://schemas.openxmlformats.org/drawingml/2006/main">
               <a:ext uri="{FF2B5EF4-FFF2-40B4-BE49-F238E27FC236}">
-                <a16:creationId xmlns:a16="http://schemas.microsoft.com/office/drawing/2014/main" id="{7E6F220B-A0F7-44D5-9162-97FDE09C7683}"/>
+                <a16:creationId xmlns:a16="http://schemas.microsoft.com/office/drawing/2014/main" id="{D1310A29-0109-4B97-8D1C-B275B98E177B}"/>
               </a:ext>
             </a:extLst>
           </p:cNvPr>
@@ -5076,7 +8025,7 @@
           <p:cNvPr id="6" name="">
             <a:extLst xmlns:a="http://schemas.openxmlformats.org/drawingml/2006/main">
               <a:ext uri="{FF2B5EF4-FFF2-40B4-BE49-F238E27FC236}">
-                <a16:creationId xmlns:a16="http://schemas.microsoft.com/office/drawing/2014/main" id="{1DB184D0-6288-4DEF-996E-E6B4F2113813}"/>
+                <a16:creationId xmlns:a16="http://schemas.microsoft.com/office/drawing/2014/main" id="{E38230A1-5BA5-4702-A822-DDA122EAAB33}"/>
               </a:ext>
             </a:extLst>
           </p:cNvPr>
@@ -5111,7 +8060,7 @@
           <p:cNvPr id="7" name="">
             <a:extLst xmlns:a="http://schemas.openxmlformats.org/drawingml/2006/main">
               <a:ext uri="{FF2B5EF4-FFF2-40B4-BE49-F238E27FC236}">
-                <a16:creationId xmlns:a16="http://schemas.microsoft.com/office/drawing/2014/main" id="{DFA85068-F631-4A45-8842-BBD99DB9E039}"/>
+                <a16:creationId xmlns:a16="http://schemas.microsoft.com/office/drawing/2014/main" id="{F31348D2-EDE4-4EC3-B216-3F53FA0CD19E}"/>
               </a:ext>
             </a:extLst>
           </p:cNvPr>
@@ -5161,7 +8110,7 @@
           <p:cNvPr id="8" name="">
             <a:extLst xmlns:a="http://schemas.openxmlformats.org/drawingml/2006/main">
               <a:ext uri="{FF2B5EF4-FFF2-40B4-BE49-F238E27FC236}">
-                <a16:creationId xmlns:a16="http://schemas.microsoft.com/office/drawing/2014/main" id="{8641B10E-940F-4982-8297-27453084FF43}"/>
+                <a16:creationId xmlns:a16="http://schemas.microsoft.com/office/drawing/2014/main" id="{3C00BD6A-EEE3-432D-B9D2-59957176FF5E}"/>
               </a:ext>
             </a:extLst>
           </p:cNvPr>
@@ -5211,7 +8160,7 @@
           <p:cNvPr id="9" name="">
             <a:extLst xmlns:a="http://schemas.openxmlformats.org/drawingml/2006/main">
               <a:ext uri="{FF2B5EF4-FFF2-40B4-BE49-F238E27FC236}">
-                <a16:creationId xmlns:a16="http://schemas.microsoft.com/office/drawing/2014/main" id="{F7CB844F-F86E-43BF-8DAD-FCE69364E395}"/>
+                <a16:creationId xmlns:a16="http://schemas.microsoft.com/office/drawing/2014/main" id="{DE49B5CF-AA58-4B4A-9247-E6CB868B8EFC}"/>
               </a:ext>
             </a:extLst>
           </p:cNvPr>
@@ -5261,7 +8210,7 @@
           <p:cNvPr id="10" name="">
             <a:extLst xmlns:a="http://schemas.openxmlformats.org/drawingml/2006/main">
               <a:ext uri="{FF2B5EF4-FFF2-40B4-BE49-F238E27FC236}">
-                <a16:creationId xmlns:a16="http://schemas.microsoft.com/office/drawing/2014/main" id="{49A96E07-6F5C-4E75-9C87-6EA14A7C08FC}"/>
+                <a16:creationId xmlns:a16="http://schemas.microsoft.com/office/drawing/2014/main" id="{C849A663-6CAF-438F-8021-2908343EC0B9}"/>
               </a:ext>
             </a:extLst>
           </p:cNvPr>
@@ -5311,7 +8260,7 @@
           <p:cNvPr id="11" name="">
             <a:extLst xmlns:a="http://schemas.openxmlformats.org/drawingml/2006/main">
               <a:ext uri="{FF2B5EF4-FFF2-40B4-BE49-F238E27FC236}">
-                <a16:creationId xmlns:a16="http://schemas.microsoft.com/office/drawing/2014/main" id="{13872D7D-8D9E-47EA-AFA2-2A30AF86D2C2}"/>
+                <a16:creationId xmlns:a16="http://schemas.microsoft.com/office/drawing/2014/main" id="{FA6BAE1E-D37E-468E-8CAA-5FF9A7D1F73F}"/>
               </a:ext>
             </a:extLst>
           </p:cNvPr>
@@ -5361,7 +8310,7 @@
           <p:cNvPr id="12" name="">
             <a:extLst xmlns:a="http://schemas.openxmlformats.org/drawingml/2006/main">
               <a:ext uri="{FF2B5EF4-FFF2-40B4-BE49-F238E27FC236}">
-                <a16:creationId xmlns:a16="http://schemas.microsoft.com/office/drawing/2014/main" id="{7DBE6663-1CD9-4250-9C90-77FC3D30BE10}"/>
+                <a16:creationId xmlns:a16="http://schemas.microsoft.com/office/drawing/2014/main" id="{10E2EEA2-35B6-4345-8C7C-574EA0B41DFD}"/>
               </a:ext>
             </a:extLst>
           </p:cNvPr>
@@ -5411,7 +8360,7 @@
           <p:cNvPr id="13" name="">
             <a:extLst xmlns:a="http://schemas.openxmlformats.org/drawingml/2006/main">
               <a:ext uri="{FF2B5EF4-FFF2-40B4-BE49-F238E27FC236}">
-                <a16:creationId xmlns:a16="http://schemas.microsoft.com/office/drawing/2014/main" id="{31564C52-5664-4E35-9120-193A148851B4}"/>
+                <a16:creationId xmlns:a16="http://schemas.microsoft.com/office/drawing/2014/main" id="{32F08A7D-6002-4052-8683-7943D1C98359}"/>
               </a:ext>
             </a:extLst>
           </p:cNvPr>
@@ -5459,7 +8408,7 @@
     </p:spTree>
     <p:extLst>
       <p:ext uri="{BB962C8B-B14F-4D97-AF65-F5344CB8AC3E}">
-        <p14:creationId xmlns:p14="http://schemas.microsoft.com/office/powerpoint/2010/main" val="1136434094"/>
+        <p14:creationId xmlns:p14="http://schemas.microsoft.com/office/powerpoint/2010/main" val="1404789962"/>
       </p:ext>
     </p:extLst>
   </p:cSld>
@@ -5490,7 +8439,7 @@
           <p:cNvPr id="1" name="">
             <a:extLst xmlns:a="http://schemas.openxmlformats.org/drawingml/2006/main">
               <a:ext uri="{FF2B5EF4-FFF2-40B4-BE49-F238E27FC236}">
-                <a16:creationId xmlns:a16="http://schemas.microsoft.com/office/drawing/2014/main" id="{49D0E76B-962D-494C-9F04-9AFDB4EADEA5}"/>
+                <a16:creationId xmlns:a16="http://schemas.microsoft.com/office/drawing/2014/main" id="{B1F4F06C-685D-4FB0-A1F7-77EADF5397A2}"/>
               </a:ext>
             </a:extLst>
           </p:cNvPr>
@@ -5540,7 +8489,7 @@
           <p:cNvPr id="2" name="">
             <a:extLst xmlns:a="http://schemas.openxmlformats.org/drawingml/2006/main">
               <a:ext uri="{FF2B5EF4-FFF2-40B4-BE49-F238E27FC236}">
-                <a16:creationId xmlns:a16="http://schemas.microsoft.com/office/drawing/2014/main" id="{54F069F2-9B07-4ABE-9A71-26B871EE6B61}"/>
+                <a16:creationId xmlns:a16="http://schemas.microsoft.com/office/drawing/2014/main" id="{A6444397-8ED2-4192-81AF-FB1BC2C53825}"/>
               </a:ext>
             </a:extLst>
           </p:cNvPr>
@@ -5590,7 +8539,7 @@
           <p:cNvPr id="3" name="">
             <a:extLst xmlns:a="http://schemas.openxmlformats.org/drawingml/2006/main">
               <a:ext uri="{FF2B5EF4-FFF2-40B4-BE49-F238E27FC236}">
-                <a16:creationId xmlns:a16="http://schemas.microsoft.com/office/drawing/2014/main" id="{C74E3635-78B7-49AE-928E-46C7E15DBDAC}"/>
+                <a16:creationId xmlns:a16="http://schemas.microsoft.com/office/drawing/2014/main" id="{E8562D3F-9004-49CC-93EF-FC14EFD2E659}"/>
               </a:ext>
             </a:extLst>
           </p:cNvPr>
@@ -5623,7 +8572,7 @@
           <p:cNvPr id="4" name="">
             <a:extLst xmlns:a="http://schemas.openxmlformats.org/drawingml/2006/main">
               <a:ext uri="{FF2B5EF4-FFF2-40B4-BE49-F238E27FC236}">
-                <a16:creationId xmlns:a16="http://schemas.microsoft.com/office/drawing/2014/main" id="{92800960-8AEE-4848-A777-24BE5B0DCAE3}"/>
+                <a16:creationId xmlns:a16="http://schemas.microsoft.com/office/drawing/2014/main" id="{88C4C8D9-CBEE-4149-A7DA-F9EA53CD9A7D}"/>
               </a:ext>
             </a:extLst>
           </p:cNvPr>
@@ -5658,7 +8607,7 @@
           <p:cNvPr id="5" name="">
             <a:extLst xmlns:a="http://schemas.openxmlformats.org/drawingml/2006/main">
               <a:ext uri="{FF2B5EF4-FFF2-40B4-BE49-F238E27FC236}">
-                <a16:creationId xmlns:a16="http://schemas.microsoft.com/office/drawing/2014/main" id="{0E271B70-02CF-469B-8E95-9C1CDDEBBB4E}"/>
+                <a16:creationId xmlns:a16="http://schemas.microsoft.com/office/drawing/2014/main" id="{91B6BC0E-3A56-4921-85FD-F766A57817E0}"/>
               </a:ext>
             </a:extLst>
           </p:cNvPr>
@@ -5708,7 +8657,7 @@
           <p:cNvPr id="6" name="">
             <a:extLst xmlns:a="http://schemas.openxmlformats.org/drawingml/2006/main">
               <a:ext uri="{FF2B5EF4-FFF2-40B4-BE49-F238E27FC236}">
-                <a16:creationId xmlns:a16="http://schemas.microsoft.com/office/drawing/2014/main" id="{2FA083DB-99B4-4123-A1FC-8B0707263040}"/>
+                <a16:creationId xmlns:a16="http://schemas.microsoft.com/office/drawing/2014/main" id="{6D485949-F335-4448-8DF2-7A1C1895E7CF}"/>
               </a:ext>
             </a:extLst>
           </p:cNvPr>
@@ -5739,7 +8688,7 @@
           <p:cNvPr id="7" name="">
             <a:extLst xmlns:a="http://schemas.openxmlformats.org/drawingml/2006/main">
               <a:ext uri="{FF2B5EF4-FFF2-40B4-BE49-F238E27FC236}">
-                <a16:creationId xmlns:a16="http://schemas.microsoft.com/office/drawing/2014/main" id="{49CA97D9-EEBE-4F0B-8D18-D22F812103B3}"/>
+                <a16:creationId xmlns:a16="http://schemas.microsoft.com/office/drawing/2014/main" id="{80554F95-8511-4FC9-8B43-DB13C12F421A}"/>
               </a:ext>
             </a:extLst>
           </p:cNvPr>
@@ -5789,7 +8738,7 @@
           <p:cNvPr id="8" name="">
             <a:extLst xmlns:a="http://schemas.openxmlformats.org/drawingml/2006/main">
               <a:ext uri="{FF2B5EF4-FFF2-40B4-BE49-F238E27FC236}">
-                <a16:creationId xmlns:a16="http://schemas.microsoft.com/office/drawing/2014/main" id="{C895F8D8-5954-427A-AE71-4D8EDF151033}"/>
+                <a16:creationId xmlns:a16="http://schemas.microsoft.com/office/drawing/2014/main" id="{D272D281-7496-4142-8A75-842F52FCDB90}"/>
               </a:ext>
             </a:extLst>
           </p:cNvPr>
@@ -5820,7 +8769,7 @@
           <p:cNvPr id="9" name="">
             <a:extLst xmlns:a="http://schemas.openxmlformats.org/drawingml/2006/main">
               <a:ext uri="{FF2B5EF4-FFF2-40B4-BE49-F238E27FC236}">
-                <a16:creationId xmlns:a16="http://schemas.microsoft.com/office/drawing/2014/main" id="{984ECBF7-B8CF-4E58-9F6E-974C6C0D0143}"/>
+                <a16:creationId xmlns:a16="http://schemas.microsoft.com/office/drawing/2014/main" id="{14F19489-3C17-47C3-987B-13F433A28DDD}"/>
               </a:ext>
             </a:extLst>
           </p:cNvPr>
@@ -5870,7 +8819,7 @@
           <p:cNvPr id="10" name="">
             <a:extLst xmlns:a="http://schemas.openxmlformats.org/drawingml/2006/main">
               <a:ext uri="{FF2B5EF4-FFF2-40B4-BE49-F238E27FC236}">
-                <a16:creationId xmlns:a16="http://schemas.microsoft.com/office/drawing/2014/main" id="{BD28F50E-660B-44E6-B860-768662542540}"/>
+                <a16:creationId xmlns:a16="http://schemas.microsoft.com/office/drawing/2014/main" id="{D5980CA1-48DA-4A19-ADF3-1CEB47FE0ACC}"/>
               </a:ext>
             </a:extLst>
           </p:cNvPr>
@@ -5901,7 +8850,7 @@
           <p:cNvPr id="11" name="">
             <a:extLst xmlns:a="http://schemas.openxmlformats.org/drawingml/2006/main">
               <a:ext uri="{FF2B5EF4-FFF2-40B4-BE49-F238E27FC236}">
-                <a16:creationId xmlns:a16="http://schemas.microsoft.com/office/drawing/2014/main" id="{D7F804CC-C438-4E79-A4C7-CABE4D5811FC}"/>
+                <a16:creationId xmlns:a16="http://schemas.microsoft.com/office/drawing/2014/main" id="{EF03EFB7-D871-43AB-A38B-66F2D9603F0D}"/>
               </a:ext>
             </a:extLst>
           </p:cNvPr>
@@ -5951,7 +8900,7 @@
           <p:cNvPr id="12" name="">
             <a:extLst xmlns:a="http://schemas.openxmlformats.org/drawingml/2006/main">
               <a:ext uri="{FF2B5EF4-FFF2-40B4-BE49-F238E27FC236}">
-                <a16:creationId xmlns:a16="http://schemas.microsoft.com/office/drawing/2014/main" id="{2E6EC131-BFAA-407C-9CB3-4D03D80045FF}"/>
+                <a16:creationId xmlns:a16="http://schemas.microsoft.com/office/drawing/2014/main" id="{E87BE44E-CE9B-4CFA-BC12-0121E77024B1}"/>
               </a:ext>
             </a:extLst>
           </p:cNvPr>
@@ -5982,7 +8931,7 @@
           <p:cNvPr id="13" name="">
             <a:extLst xmlns:a="http://schemas.openxmlformats.org/drawingml/2006/main">
               <a:ext uri="{FF2B5EF4-FFF2-40B4-BE49-F238E27FC236}">
-                <a16:creationId xmlns:a16="http://schemas.microsoft.com/office/drawing/2014/main" id="{7FB8DB7E-594A-4BAF-977E-A0B095FBA13C}"/>
+                <a16:creationId xmlns:a16="http://schemas.microsoft.com/office/drawing/2014/main" id="{9B0988AF-C765-41B1-A38A-5C77F29F40AD}"/>
               </a:ext>
             </a:extLst>
           </p:cNvPr>
@@ -6032,7 +8981,7 @@
           <p:cNvPr id="14" name="">
             <a:extLst xmlns:a="http://schemas.openxmlformats.org/drawingml/2006/main">
               <a:ext uri="{FF2B5EF4-FFF2-40B4-BE49-F238E27FC236}">
-                <a16:creationId xmlns:a16="http://schemas.microsoft.com/office/drawing/2014/main" id="{0B5713AA-A00B-41FF-B230-FD631A3472CC}"/>
+                <a16:creationId xmlns:a16="http://schemas.microsoft.com/office/drawing/2014/main" id="{E0091A29-20C3-4098-97ED-B1C41F108921}"/>
               </a:ext>
             </a:extLst>
           </p:cNvPr>
@@ -6067,7 +9016,7 @@
           <p:cNvPr id="15" name="">
             <a:extLst xmlns:a="http://schemas.openxmlformats.org/drawingml/2006/main">
               <a:ext uri="{FF2B5EF4-FFF2-40B4-BE49-F238E27FC236}">
-                <a16:creationId xmlns:a16="http://schemas.microsoft.com/office/drawing/2014/main" id="{B6D6A035-EE9B-4F44-8E54-327BBE4BE9C0}"/>
+                <a16:creationId xmlns:a16="http://schemas.microsoft.com/office/drawing/2014/main" id="{D37B2C7D-2A68-45CC-95AC-DFAB12FD79A1}"/>
               </a:ext>
             </a:extLst>
           </p:cNvPr>
@@ -6117,7 +9066,7 @@
           <p:cNvPr id="16" name="">
             <a:extLst xmlns:a="http://schemas.openxmlformats.org/drawingml/2006/main">
               <a:ext uri="{FF2B5EF4-FFF2-40B4-BE49-F238E27FC236}">
-                <a16:creationId xmlns:a16="http://schemas.microsoft.com/office/drawing/2014/main" id="{BBE8485E-7A6B-466C-8BF2-1F985850CFB6}"/>
+                <a16:creationId xmlns:a16="http://schemas.microsoft.com/office/drawing/2014/main" id="{2546B165-BB8A-4DC0-8742-DD490817F4E9}"/>
               </a:ext>
             </a:extLst>
           </p:cNvPr>
@@ -6148,7 +9097,7 @@
           <p:cNvPr id="17" name="">
             <a:extLst xmlns:a="http://schemas.openxmlformats.org/drawingml/2006/main">
               <a:ext uri="{FF2B5EF4-FFF2-40B4-BE49-F238E27FC236}">
-                <a16:creationId xmlns:a16="http://schemas.microsoft.com/office/drawing/2014/main" id="{875DFC83-9D25-453F-9EBB-D8FB23023F93}"/>
+                <a16:creationId xmlns:a16="http://schemas.microsoft.com/office/drawing/2014/main" id="{A01493C1-0437-44E4-B728-561519AE8D18}"/>
               </a:ext>
             </a:extLst>
           </p:cNvPr>
@@ -6198,7 +9147,7 @@
           <p:cNvPr id="18" name="">
             <a:extLst xmlns:a="http://schemas.openxmlformats.org/drawingml/2006/main">
               <a:ext uri="{FF2B5EF4-FFF2-40B4-BE49-F238E27FC236}">
-                <a16:creationId xmlns:a16="http://schemas.microsoft.com/office/drawing/2014/main" id="{AB2BE5BA-79C0-4E36-BD60-9616ECF4ABB6}"/>
+                <a16:creationId xmlns:a16="http://schemas.microsoft.com/office/drawing/2014/main" id="{88328B99-A0D4-4973-A1A2-2E7C644F399B}"/>
               </a:ext>
             </a:extLst>
           </p:cNvPr>
@@ -6229,7 +9178,7 @@
           <p:cNvPr id="19" name="">
             <a:extLst xmlns:a="http://schemas.openxmlformats.org/drawingml/2006/main">
               <a:ext uri="{FF2B5EF4-FFF2-40B4-BE49-F238E27FC236}">
-                <a16:creationId xmlns:a16="http://schemas.microsoft.com/office/drawing/2014/main" id="{25CCE8EA-CE35-42A0-9C6D-0115CDBC6AAE}"/>
+                <a16:creationId xmlns:a16="http://schemas.microsoft.com/office/drawing/2014/main" id="{9D06EDD3-3943-4ADF-99E9-D27B00A4B46E}"/>
               </a:ext>
             </a:extLst>
           </p:cNvPr>
@@ -6279,7 +9228,7 @@
           <p:cNvPr id="20" name="">
             <a:extLst xmlns:a="http://schemas.openxmlformats.org/drawingml/2006/main">
               <a:ext uri="{FF2B5EF4-FFF2-40B4-BE49-F238E27FC236}">
-                <a16:creationId xmlns:a16="http://schemas.microsoft.com/office/drawing/2014/main" id="{941474C3-049C-4BA7-AF0F-E9D717D11828}"/>
+                <a16:creationId xmlns:a16="http://schemas.microsoft.com/office/drawing/2014/main" id="{2992B66F-22D6-4E62-8F2D-EC65E951FF8B}"/>
               </a:ext>
             </a:extLst>
           </p:cNvPr>
@@ -6310,7 +9259,7 @@
           <p:cNvPr id="21" name="">
             <a:extLst xmlns:a="http://schemas.openxmlformats.org/drawingml/2006/main">
               <a:ext uri="{FF2B5EF4-FFF2-40B4-BE49-F238E27FC236}">
-                <a16:creationId xmlns:a16="http://schemas.microsoft.com/office/drawing/2014/main" id="{E42A0478-B6DF-42F7-B747-A5CF7EE52CCA}"/>
+                <a16:creationId xmlns:a16="http://schemas.microsoft.com/office/drawing/2014/main" id="{B0A57169-0B98-42EC-B805-39988D0154CC}"/>
               </a:ext>
             </a:extLst>
           </p:cNvPr>
@@ -6360,7 +9309,7 @@
           <p:cNvPr id="22" name="">
             <a:extLst xmlns:a="http://schemas.openxmlformats.org/drawingml/2006/main">
               <a:ext uri="{FF2B5EF4-FFF2-40B4-BE49-F238E27FC236}">
-                <a16:creationId xmlns:a16="http://schemas.microsoft.com/office/drawing/2014/main" id="{6ADB618A-8CF4-4D90-AA80-0E1A8A6491D2}"/>
+                <a16:creationId xmlns:a16="http://schemas.microsoft.com/office/drawing/2014/main" id="{0367FE2E-3109-49D2-B732-6BA880E4E282}"/>
               </a:ext>
             </a:extLst>
           </p:cNvPr>
@@ -6391,7 +9340,7 @@
           <p:cNvPr id="23" name="">
             <a:extLst xmlns:a="http://schemas.openxmlformats.org/drawingml/2006/main">
               <a:ext uri="{FF2B5EF4-FFF2-40B4-BE49-F238E27FC236}">
-                <a16:creationId xmlns:a16="http://schemas.microsoft.com/office/drawing/2014/main" id="{B2DA6E1C-6486-4E1A-84F4-C885BD4B28CD}"/>
+                <a16:creationId xmlns:a16="http://schemas.microsoft.com/office/drawing/2014/main" id="{FDE63C90-6CFF-447B-ABA0-1597606B19F7}"/>
               </a:ext>
             </a:extLst>
           </p:cNvPr>
@@ -6441,7 +9390,7 @@
           <p:cNvPr id="24" name="">
             <a:extLst xmlns:a="http://schemas.openxmlformats.org/drawingml/2006/main">
               <a:ext uri="{FF2B5EF4-FFF2-40B4-BE49-F238E27FC236}">
-                <a16:creationId xmlns:a16="http://schemas.microsoft.com/office/drawing/2014/main" id="{02ED9FB2-28EC-4120-85BB-E03CAF67BA54}"/>
+                <a16:creationId xmlns:a16="http://schemas.microsoft.com/office/drawing/2014/main" id="{83FD460C-7163-425D-B61A-9092E693EFBD}"/>
               </a:ext>
             </a:extLst>
           </p:cNvPr>
@@ -6476,7 +9425,7 @@
           <p:cNvPr id="25" name="">
             <a:extLst xmlns:a="http://schemas.openxmlformats.org/drawingml/2006/main">
               <a:ext uri="{FF2B5EF4-FFF2-40B4-BE49-F238E27FC236}">
-                <a16:creationId xmlns:a16="http://schemas.microsoft.com/office/drawing/2014/main" id="{2F3B08E7-5C27-4936-8D6A-669BFCEB4ABE}"/>
+                <a16:creationId xmlns:a16="http://schemas.microsoft.com/office/drawing/2014/main" id="{A64B0DAB-50A1-4597-B47D-E18071333834}"/>
               </a:ext>
             </a:extLst>
           </p:cNvPr>
@@ -6526,7 +9475,7 @@
           <p:cNvPr id="26" name="">
             <a:extLst xmlns:a="http://schemas.openxmlformats.org/drawingml/2006/main">
               <a:ext uri="{FF2B5EF4-FFF2-40B4-BE49-F238E27FC236}">
-                <a16:creationId xmlns:a16="http://schemas.microsoft.com/office/drawing/2014/main" id="{292436E6-F374-4C65-8EEF-EEB455AE096E}"/>
+                <a16:creationId xmlns:a16="http://schemas.microsoft.com/office/drawing/2014/main" id="{81C412B8-EB74-4A78-AB4B-0C19578DD944}"/>
               </a:ext>
             </a:extLst>
           </p:cNvPr>
@@ -6557,7 +9506,7 @@
           <p:cNvPr id="27" name="">
             <a:extLst xmlns:a="http://schemas.openxmlformats.org/drawingml/2006/main">
               <a:ext uri="{FF2B5EF4-FFF2-40B4-BE49-F238E27FC236}">
-                <a16:creationId xmlns:a16="http://schemas.microsoft.com/office/drawing/2014/main" id="{82D74C28-DAF9-4B92-9A65-65E91B3E814F}"/>
+                <a16:creationId xmlns:a16="http://schemas.microsoft.com/office/drawing/2014/main" id="{1E7A64A5-F2B0-46D1-9F3A-91F7DAA05572}"/>
               </a:ext>
             </a:extLst>
           </p:cNvPr>
@@ -6607,7 +9556,7 @@
           <p:cNvPr id="28" name="">
             <a:extLst xmlns:a="http://schemas.openxmlformats.org/drawingml/2006/main">
               <a:ext uri="{FF2B5EF4-FFF2-40B4-BE49-F238E27FC236}">
-                <a16:creationId xmlns:a16="http://schemas.microsoft.com/office/drawing/2014/main" id="{97E31E10-E21A-4829-AF07-DD1E7ADFA9C8}"/>
+                <a16:creationId xmlns:a16="http://schemas.microsoft.com/office/drawing/2014/main" id="{54BC4305-DA21-482E-BA3A-AD92FCA5A8FA}"/>
               </a:ext>
             </a:extLst>
           </p:cNvPr>
@@ -6638,7 +9587,7 @@
           <p:cNvPr id="29" name="">
             <a:extLst xmlns:a="http://schemas.openxmlformats.org/drawingml/2006/main">
               <a:ext uri="{FF2B5EF4-FFF2-40B4-BE49-F238E27FC236}">
-                <a16:creationId xmlns:a16="http://schemas.microsoft.com/office/drawing/2014/main" id="{823B1313-7112-44C8-AA3F-EAB7FCF8C66C}"/>
+                <a16:creationId xmlns:a16="http://schemas.microsoft.com/office/drawing/2014/main" id="{B26AC21E-9303-4B7E-BBB1-17D0E831DA17}"/>
               </a:ext>
             </a:extLst>
           </p:cNvPr>
@@ -6688,7 +9637,7 @@
           <p:cNvPr id="30" name="">
             <a:extLst xmlns:a="http://schemas.openxmlformats.org/drawingml/2006/main">
               <a:ext uri="{FF2B5EF4-FFF2-40B4-BE49-F238E27FC236}">
-                <a16:creationId xmlns:a16="http://schemas.microsoft.com/office/drawing/2014/main" id="{0F2D323E-01B7-44FC-B354-C1A58E2F3BE2}"/>
+                <a16:creationId xmlns:a16="http://schemas.microsoft.com/office/drawing/2014/main" id="{629978CC-66A6-4858-8C0E-D1731A086524}"/>
               </a:ext>
             </a:extLst>
           </p:cNvPr>
@@ -6719,7 +9668,7 @@
           <p:cNvPr id="31" name="">
             <a:extLst xmlns:a="http://schemas.openxmlformats.org/drawingml/2006/main">
               <a:ext uri="{FF2B5EF4-FFF2-40B4-BE49-F238E27FC236}">
-                <a16:creationId xmlns:a16="http://schemas.microsoft.com/office/drawing/2014/main" id="{6A2FA2E4-C756-41F3-873D-00FFD1C3D6CD}"/>
+                <a16:creationId xmlns:a16="http://schemas.microsoft.com/office/drawing/2014/main" id="{7FF8F6ED-DBA3-42B3-A5D1-FEDF775A9CC0}"/>
               </a:ext>
             </a:extLst>
           </p:cNvPr>
@@ -6769,7 +9718,7 @@
           <p:cNvPr id="32" name="">
             <a:extLst xmlns:a="http://schemas.openxmlformats.org/drawingml/2006/main">
               <a:ext uri="{FF2B5EF4-FFF2-40B4-BE49-F238E27FC236}">
-                <a16:creationId xmlns:a16="http://schemas.microsoft.com/office/drawing/2014/main" id="{CF4C7076-6529-4FCE-A758-0BBADEB5286B}"/>
+                <a16:creationId xmlns:a16="http://schemas.microsoft.com/office/drawing/2014/main" id="{AFEF79DA-FA80-4901-9639-F84E0BE3B1A7}"/>
               </a:ext>
             </a:extLst>
           </p:cNvPr>
@@ -6800,7 +9749,7 @@
           <p:cNvPr id="33" name="">
             <a:extLst xmlns:a="http://schemas.openxmlformats.org/drawingml/2006/main">
               <a:ext uri="{FF2B5EF4-FFF2-40B4-BE49-F238E27FC236}">
-                <a16:creationId xmlns:a16="http://schemas.microsoft.com/office/drawing/2014/main" id="{D0A103EA-58BE-4369-B397-3274EBF38BAB}"/>
+                <a16:creationId xmlns:a16="http://schemas.microsoft.com/office/drawing/2014/main" id="{A58CDB32-E6EC-48F8-9C0B-6ADB2BBF6AEE}"/>
               </a:ext>
             </a:extLst>
           </p:cNvPr>
@@ -6850,7 +9799,7 @@
           <p:cNvPr id="34" name="">
             <a:extLst xmlns:a="http://schemas.openxmlformats.org/drawingml/2006/main">
               <a:ext uri="{FF2B5EF4-FFF2-40B4-BE49-F238E27FC236}">
-                <a16:creationId xmlns:a16="http://schemas.microsoft.com/office/drawing/2014/main" id="{ACA90780-FDE2-4D73-A917-A30BBFC92532}"/>
+                <a16:creationId xmlns:a16="http://schemas.microsoft.com/office/drawing/2014/main" id="{E180D554-77EC-4DFD-B443-4507B8E5CBD1}"/>
               </a:ext>
             </a:extLst>
           </p:cNvPr>
@@ -6885,7 +9834,7 @@
           <p:cNvPr id="35" name="">
             <a:extLst xmlns:a="http://schemas.openxmlformats.org/drawingml/2006/main">
               <a:ext uri="{FF2B5EF4-FFF2-40B4-BE49-F238E27FC236}">
-                <a16:creationId xmlns:a16="http://schemas.microsoft.com/office/drawing/2014/main" id="{669E0B81-EACC-44F0-8E07-7BF023B6BC1A}"/>
+                <a16:creationId xmlns:a16="http://schemas.microsoft.com/office/drawing/2014/main" id="{4BB1AB8B-F3F8-48C3-A6A6-74605F888791}"/>
               </a:ext>
             </a:extLst>
           </p:cNvPr>
@@ -6935,7 +9884,7 @@
           <p:cNvPr id="36" name="">
             <a:extLst xmlns:a="http://schemas.openxmlformats.org/drawingml/2006/main">
               <a:ext uri="{FF2B5EF4-FFF2-40B4-BE49-F238E27FC236}">
-                <a16:creationId xmlns:a16="http://schemas.microsoft.com/office/drawing/2014/main" id="{42250177-7DC4-43BD-BF38-2539897766B6}"/>
+                <a16:creationId xmlns:a16="http://schemas.microsoft.com/office/drawing/2014/main" id="{999D0240-2780-45B9-830B-5A429C17673A}"/>
               </a:ext>
             </a:extLst>
           </p:cNvPr>
@@ -6966,7 +9915,7 @@
           <p:cNvPr id="37" name="">
             <a:extLst xmlns:a="http://schemas.openxmlformats.org/drawingml/2006/main">
               <a:ext uri="{FF2B5EF4-FFF2-40B4-BE49-F238E27FC236}">
-                <a16:creationId xmlns:a16="http://schemas.microsoft.com/office/drawing/2014/main" id="{EB809749-0370-4795-8018-CCEC75022CF9}"/>
+                <a16:creationId xmlns:a16="http://schemas.microsoft.com/office/drawing/2014/main" id="{FFFBFAF0-52B6-4D3C-BD0F-82241EA6C351}"/>
               </a:ext>
             </a:extLst>
           </p:cNvPr>
@@ -7016,7 +9965,7 @@
           <p:cNvPr id="38" name="">
             <a:extLst xmlns:a="http://schemas.openxmlformats.org/drawingml/2006/main">
               <a:ext uri="{FF2B5EF4-FFF2-40B4-BE49-F238E27FC236}">
-                <a16:creationId xmlns:a16="http://schemas.microsoft.com/office/drawing/2014/main" id="{3E05986E-652A-49A9-9968-197E1B2FE922}"/>
+                <a16:creationId xmlns:a16="http://schemas.microsoft.com/office/drawing/2014/main" id="{35677099-F116-43B0-AD51-1E179C831C27}"/>
               </a:ext>
             </a:extLst>
           </p:cNvPr>
@@ -7047,7 +9996,7 @@
           <p:cNvPr id="39" name="">
             <a:extLst xmlns:a="http://schemas.openxmlformats.org/drawingml/2006/main">
               <a:ext uri="{FF2B5EF4-FFF2-40B4-BE49-F238E27FC236}">
-                <a16:creationId xmlns:a16="http://schemas.microsoft.com/office/drawing/2014/main" id="{8D58CC91-AF4B-4809-A0F6-37C12ECA4B88}"/>
+                <a16:creationId xmlns:a16="http://schemas.microsoft.com/office/drawing/2014/main" id="{50B47728-B64B-45C9-B801-FE2DFD548239}"/>
               </a:ext>
             </a:extLst>
           </p:cNvPr>
@@ -7097,7 +10046,7 @@
           <p:cNvPr id="40" name="">
             <a:extLst xmlns:a="http://schemas.openxmlformats.org/drawingml/2006/main">
               <a:ext uri="{FF2B5EF4-FFF2-40B4-BE49-F238E27FC236}">
-                <a16:creationId xmlns:a16="http://schemas.microsoft.com/office/drawing/2014/main" id="{7C29C235-4EC7-4A2A-9142-8F2653DB943B}"/>
+                <a16:creationId xmlns:a16="http://schemas.microsoft.com/office/drawing/2014/main" id="{7459A0AB-16A3-428D-B523-3E3B1DB7C67B}"/>
               </a:ext>
             </a:extLst>
           </p:cNvPr>
@@ -7128,7 +10077,7 @@
           <p:cNvPr id="41" name="">
             <a:extLst xmlns:a="http://schemas.openxmlformats.org/drawingml/2006/main">
               <a:ext uri="{FF2B5EF4-FFF2-40B4-BE49-F238E27FC236}">
-                <a16:creationId xmlns:a16="http://schemas.microsoft.com/office/drawing/2014/main" id="{52A26C57-CA36-4ADF-82D7-67EE2BAAE819}"/>
+                <a16:creationId xmlns:a16="http://schemas.microsoft.com/office/drawing/2014/main" id="{1E295C43-B9D9-467C-B4B8-1DF91FF65C6E}"/>
               </a:ext>
             </a:extLst>
           </p:cNvPr>
@@ -7178,7 +10127,7 @@
           <p:cNvPr id="42" name="">
             <a:extLst xmlns:a="http://schemas.openxmlformats.org/drawingml/2006/main">
               <a:ext uri="{FF2B5EF4-FFF2-40B4-BE49-F238E27FC236}">
-                <a16:creationId xmlns:a16="http://schemas.microsoft.com/office/drawing/2014/main" id="{7893B418-BEC6-4A1D-8D53-8CAF1E3D8900}"/>
+                <a16:creationId xmlns:a16="http://schemas.microsoft.com/office/drawing/2014/main" id="{36AA5F9B-29FF-4639-9933-0428E1EC048E}"/>
               </a:ext>
             </a:extLst>
           </p:cNvPr>
@@ -7209,7 +10158,7 @@
           <p:cNvPr id="43" name="">
             <a:extLst xmlns:a="http://schemas.openxmlformats.org/drawingml/2006/main">
               <a:ext uri="{FF2B5EF4-FFF2-40B4-BE49-F238E27FC236}">
-                <a16:creationId xmlns:a16="http://schemas.microsoft.com/office/drawing/2014/main" id="{6ACA1FEB-FD69-47AA-AD53-EDCBBB5795C5}"/>
+                <a16:creationId xmlns:a16="http://schemas.microsoft.com/office/drawing/2014/main" id="{5194972A-891C-4AED-B5B5-681228FAF003}"/>
               </a:ext>
             </a:extLst>
           </p:cNvPr>
@@ -7259,7 +10208,7 @@
           <p:cNvPr id="44" name="">
             <a:extLst xmlns:a="http://schemas.openxmlformats.org/drawingml/2006/main">
               <a:ext uri="{FF2B5EF4-FFF2-40B4-BE49-F238E27FC236}">
-                <a16:creationId xmlns:a16="http://schemas.microsoft.com/office/drawing/2014/main" id="{4BC40F52-31DA-42F0-B536-3A441368113D}"/>
+                <a16:creationId xmlns:a16="http://schemas.microsoft.com/office/drawing/2014/main" id="{CEC407D1-67AF-4A6A-A24F-3117419E8D1B}"/>
               </a:ext>
             </a:extLst>
           </p:cNvPr>
@@ -7307,7 +10256,7 @@
     </p:spTree>
     <p:extLst>
       <p:ext uri="{BB962C8B-B14F-4D97-AF65-F5344CB8AC3E}">
-        <p14:creationId xmlns:p14="http://schemas.microsoft.com/office/powerpoint/2010/main" val="833482016"/>
+        <p14:creationId xmlns:p14="http://schemas.microsoft.com/office/powerpoint/2010/main" val="483779356"/>
       </p:ext>
     </p:extLst>
   </p:cSld>
@@ -7338,7 +10287,7 @@
           <p:cNvPr id="1" name="">
             <a:extLst xmlns:a="http://schemas.openxmlformats.org/drawingml/2006/main">
               <a:ext uri="{FF2B5EF4-FFF2-40B4-BE49-F238E27FC236}">
-                <a16:creationId xmlns:a16="http://schemas.microsoft.com/office/drawing/2014/main" id="{D0CD4D1D-03AA-4663-9DF8-B0B8AE096B44}"/>
+                <a16:creationId xmlns:a16="http://schemas.microsoft.com/office/drawing/2014/main" id="{426A956C-4E27-4AD1-9576-0EBD8A44844B}"/>
               </a:ext>
             </a:extLst>
           </p:cNvPr>
@@ -7388,7 +10337,7 @@
           <p:cNvPr id="2" name="">
             <a:extLst xmlns:a="http://schemas.openxmlformats.org/drawingml/2006/main">
               <a:ext uri="{FF2B5EF4-FFF2-40B4-BE49-F238E27FC236}">
-                <a16:creationId xmlns:a16="http://schemas.microsoft.com/office/drawing/2014/main" id="{FF5485CA-7DB3-426D-8283-007E72211D7B}"/>
+                <a16:creationId xmlns:a16="http://schemas.microsoft.com/office/drawing/2014/main" id="{D2F26F6E-CC1F-47C5-AD54-D74FBF8C6BDA}"/>
               </a:ext>
             </a:extLst>
           </p:cNvPr>
@@ -7438,7 +10387,7 @@
           <p:cNvPr id="3" name="">
             <a:extLst xmlns:a="http://schemas.openxmlformats.org/drawingml/2006/main">
               <a:ext uri="{FF2B5EF4-FFF2-40B4-BE49-F238E27FC236}">
-                <a16:creationId xmlns:a16="http://schemas.microsoft.com/office/drawing/2014/main" id="{BAD76897-E523-4973-A38F-3E9D99FC6202}"/>
+                <a16:creationId xmlns:a16="http://schemas.microsoft.com/office/drawing/2014/main" id="{D12E49DA-FD9A-4924-809A-D10C1A00F55E}"/>
               </a:ext>
             </a:extLst>
           </p:cNvPr>
@@ -7471,7 +10420,7 @@
           <p:cNvPr id="4" name="">
             <a:extLst xmlns:a="http://schemas.openxmlformats.org/drawingml/2006/main">
               <a:ext uri="{FF2B5EF4-FFF2-40B4-BE49-F238E27FC236}">
-                <a16:creationId xmlns:a16="http://schemas.microsoft.com/office/drawing/2014/main" id="{06068611-D2B3-4C77-964A-DD0E03B0F999}"/>
+                <a16:creationId xmlns:a16="http://schemas.microsoft.com/office/drawing/2014/main" id="{72DDFE06-2867-4D16-B214-7A0AC662D13C}"/>
               </a:ext>
             </a:extLst>
           </p:cNvPr>
@@ -7506,7 +10455,7 @@
           <p:cNvPr id="5" name="">
             <a:extLst xmlns:a="http://schemas.openxmlformats.org/drawingml/2006/main">
               <a:ext uri="{FF2B5EF4-FFF2-40B4-BE49-F238E27FC236}">
-                <a16:creationId xmlns:a16="http://schemas.microsoft.com/office/drawing/2014/main" id="{A970FE27-90C1-4CE9-AC34-D3DE6107FE98}"/>
+                <a16:creationId xmlns:a16="http://schemas.microsoft.com/office/drawing/2014/main" id="{5A23349B-5DF6-46F3-A8CF-FB44EE45A9F4}"/>
               </a:ext>
             </a:extLst>
           </p:cNvPr>
@@ -7541,7 +10490,7 @@
           <p:cNvPr id="6" name="">
             <a:extLst xmlns:a="http://schemas.openxmlformats.org/drawingml/2006/main">
               <a:ext uri="{FF2B5EF4-FFF2-40B4-BE49-F238E27FC236}">
-                <a16:creationId xmlns:a16="http://schemas.microsoft.com/office/drawing/2014/main" id="{2084FC0F-8C7E-4630-B0E3-C87E6A5BCDBE}"/>
+                <a16:creationId xmlns:a16="http://schemas.microsoft.com/office/drawing/2014/main" id="{9CB499FF-AB35-42FB-9FB5-20AD51239BDB}"/>
               </a:ext>
             </a:extLst>
           </p:cNvPr>
@@ -7591,7 +10540,7 @@
           <p:cNvPr id="7" name="">
             <a:extLst xmlns:a="http://schemas.openxmlformats.org/drawingml/2006/main">
               <a:ext uri="{FF2B5EF4-FFF2-40B4-BE49-F238E27FC236}">
-                <a16:creationId xmlns:a16="http://schemas.microsoft.com/office/drawing/2014/main" id="{DA86F69A-313C-44DC-9569-C6D40BE31E66}"/>
+                <a16:creationId xmlns:a16="http://schemas.microsoft.com/office/drawing/2014/main" id="{6847BE81-E7AA-48A6-B870-6C15B0AED325}"/>
               </a:ext>
             </a:extLst>
           </p:cNvPr>
@@ -7622,7 +10571,7 @@
           <p:cNvPr id="8" name="">
             <a:extLst xmlns:a="http://schemas.openxmlformats.org/drawingml/2006/main">
               <a:ext uri="{FF2B5EF4-FFF2-40B4-BE49-F238E27FC236}">
-                <a16:creationId xmlns:a16="http://schemas.microsoft.com/office/drawing/2014/main" id="{0DD52A69-6D5B-4F0A-AABC-B4C60FD4E018}"/>
+                <a16:creationId xmlns:a16="http://schemas.microsoft.com/office/drawing/2014/main" id="{11057EFC-7D8F-4368-8F06-F97111A0F739}"/>
               </a:ext>
             </a:extLst>
           </p:cNvPr>
@@ -7672,7 +10621,7 @@
           <p:cNvPr id="9" name="">
             <a:extLst xmlns:a="http://schemas.openxmlformats.org/drawingml/2006/main">
               <a:ext uri="{FF2B5EF4-FFF2-40B4-BE49-F238E27FC236}">
-                <a16:creationId xmlns:a16="http://schemas.microsoft.com/office/drawing/2014/main" id="{5E6F7325-0E5A-43CA-9450-CB36ED1ACA18}"/>
+                <a16:creationId xmlns:a16="http://schemas.microsoft.com/office/drawing/2014/main" id="{40AA5754-166C-4E66-ACC9-666B48E23333}"/>
               </a:ext>
             </a:extLst>
           </p:cNvPr>
@@ -7703,7 +10652,7 @@
           <p:cNvPr id="10" name="">
             <a:extLst xmlns:a="http://schemas.openxmlformats.org/drawingml/2006/main">
               <a:ext uri="{FF2B5EF4-FFF2-40B4-BE49-F238E27FC236}">
-                <a16:creationId xmlns:a16="http://schemas.microsoft.com/office/drawing/2014/main" id="{7BF990B8-D136-4286-BB4A-C8B3B8178949}"/>
+                <a16:creationId xmlns:a16="http://schemas.microsoft.com/office/drawing/2014/main" id="{836D618F-7983-491B-85E2-270E178B28BD}"/>
               </a:ext>
             </a:extLst>
           </p:cNvPr>
@@ -7753,7 +10702,7 @@
           <p:cNvPr id="11" name="">
             <a:extLst xmlns:a="http://schemas.openxmlformats.org/drawingml/2006/main">
               <a:ext uri="{FF2B5EF4-FFF2-40B4-BE49-F238E27FC236}">
-                <a16:creationId xmlns:a16="http://schemas.microsoft.com/office/drawing/2014/main" id="{9B1779E9-162A-44BD-BC5D-53933CD9408D}"/>
+                <a16:creationId xmlns:a16="http://schemas.microsoft.com/office/drawing/2014/main" id="{1F972EDB-D6ED-41B1-A38B-0F1D291688F1}"/>
               </a:ext>
             </a:extLst>
           </p:cNvPr>
@@ -7784,7 +10733,7 @@
           <p:cNvPr id="12" name="">
             <a:extLst xmlns:a="http://schemas.openxmlformats.org/drawingml/2006/main">
               <a:ext uri="{FF2B5EF4-FFF2-40B4-BE49-F238E27FC236}">
-                <a16:creationId xmlns:a16="http://schemas.microsoft.com/office/drawing/2014/main" id="{4CDFE46E-3E6F-468D-A12C-CDD19A06532A}"/>
+                <a16:creationId xmlns:a16="http://schemas.microsoft.com/office/drawing/2014/main" id="{10DF9544-D978-41D7-B0DE-5B3D30DA5F5B}"/>
               </a:ext>
             </a:extLst>
           </p:cNvPr>
@@ -7834,7 +10783,7 @@
           <p:cNvPr id="13" name="">
             <a:extLst xmlns:a="http://schemas.openxmlformats.org/drawingml/2006/main">
               <a:ext uri="{FF2B5EF4-FFF2-40B4-BE49-F238E27FC236}">
-                <a16:creationId xmlns:a16="http://schemas.microsoft.com/office/drawing/2014/main" id="{7070537C-49C3-45B1-BD38-B07AB2C5A509}"/>
+                <a16:creationId xmlns:a16="http://schemas.microsoft.com/office/drawing/2014/main" id="{B37AA124-7991-4002-BEB0-ACBABE3BFC4A}"/>
               </a:ext>
             </a:extLst>
           </p:cNvPr>
@@ -7865,7 +10814,7 @@
           <p:cNvPr id="14" name="">
             <a:extLst xmlns:a="http://schemas.openxmlformats.org/drawingml/2006/main">
               <a:ext uri="{FF2B5EF4-FFF2-40B4-BE49-F238E27FC236}">
-                <a16:creationId xmlns:a16="http://schemas.microsoft.com/office/drawing/2014/main" id="{B7141405-8B1A-4B3F-8F16-63B3337094B7}"/>
+                <a16:creationId xmlns:a16="http://schemas.microsoft.com/office/drawing/2014/main" id="{7AFE5E4A-8568-4372-BCAD-3860EBDF5E9D}"/>
               </a:ext>
             </a:extLst>
           </p:cNvPr>
@@ -7915,7 +10864,7 @@
           <p:cNvPr id="15" name="">
             <a:extLst xmlns:a="http://schemas.openxmlformats.org/drawingml/2006/main">
               <a:ext uri="{FF2B5EF4-FFF2-40B4-BE49-F238E27FC236}">
-                <a16:creationId xmlns:a16="http://schemas.microsoft.com/office/drawing/2014/main" id="{78775E77-EB16-41A1-93E3-507F3F3C3917}"/>
+                <a16:creationId xmlns:a16="http://schemas.microsoft.com/office/drawing/2014/main" id="{31A5EFC7-A4B4-4973-A1DE-8FC123220B74}"/>
               </a:ext>
             </a:extLst>
           </p:cNvPr>
@@ -7946,7 +10895,7 @@
           <p:cNvPr id="16" name="">
             <a:extLst xmlns:a="http://schemas.openxmlformats.org/drawingml/2006/main">
               <a:ext uri="{FF2B5EF4-FFF2-40B4-BE49-F238E27FC236}">
-                <a16:creationId xmlns:a16="http://schemas.microsoft.com/office/drawing/2014/main" id="{6C4F0CEC-24EA-44EA-A206-A7BF8B8EEC6B}"/>
+                <a16:creationId xmlns:a16="http://schemas.microsoft.com/office/drawing/2014/main" id="{EDEB1705-5B33-4A5D-B074-7D89D5DC9EC0}"/>
               </a:ext>
             </a:extLst>
           </p:cNvPr>
@@ -7996,7 +10945,7 @@
           <p:cNvPr id="17" name="">
             <a:extLst xmlns:a="http://schemas.openxmlformats.org/drawingml/2006/main">
               <a:ext uri="{FF2B5EF4-FFF2-40B4-BE49-F238E27FC236}">
-                <a16:creationId xmlns:a16="http://schemas.microsoft.com/office/drawing/2014/main" id="{A044F030-52BE-4B6C-8D65-2F3756185A49}"/>
+                <a16:creationId xmlns:a16="http://schemas.microsoft.com/office/drawing/2014/main" id="{D312FF90-713C-4833-96BE-50FA47340DA2}"/>
               </a:ext>
             </a:extLst>
           </p:cNvPr>
@@ -8046,7 +10995,7 @@
           <p:cNvPr id="18" name="">
             <a:extLst xmlns:a="http://schemas.openxmlformats.org/drawingml/2006/main">
               <a:ext uri="{FF2B5EF4-FFF2-40B4-BE49-F238E27FC236}">
-                <a16:creationId xmlns:a16="http://schemas.microsoft.com/office/drawing/2014/main" id="{727480D5-D6AD-465D-8F5C-3A8A565474FE}"/>
+                <a16:creationId xmlns:a16="http://schemas.microsoft.com/office/drawing/2014/main" id="{86014AC8-554C-4C32-BBFB-B6C24D092D53}"/>
               </a:ext>
             </a:extLst>
           </p:cNvPr>
@@ -8077,7 +11026,7 @@
           <p:cNvPr id="19" name="">
             <a:extLst xmlns:a="http://schemas.openxmlformats.org/drawingml/2006/main">
               <a:ext uri="{FF2B5EF4-FFF2-40B4-BE49-F238E27FC236}">
-                <a16:creationId xmlns:a16="http://schemas.microsoft.com/office/drawing/2014/main" id="{A8172C9C-A02A-440D-A2A6-E27D533A94EA}"/>
+                <a16:creationId xmlns:a16="http://schemas.microsoft.com/office/drawing/2014/main" id="{F6DEB681-4F75-4633-B7E1-3382109EB04C}"/>
               </a:ext>
             </a:extLst>
           </p:cNvPr>
@@ -8127,7 +11076,7 @@
           <p:cNvPr id="20" name="">
             <a:extLst xmlns:a="http://schemas.openxmlformats.org/drawingml/2006/main">
               <a:ext uri="{FF2B5EF4-FFF2-40B4-BE49-F238E27FC236}">
-                <a16:creationId xmlns:a16="http://schemas.microsoft.com/office/drawing/2014/main" id="{7D4EFE5C-3485-4EE7-B8F0-FB95176E4E6E}"/>
+                <a16:creationId xmlns:a16="http://schemas.microsoft.com/office/drawing/2014/main" id="{C37CFAF3-B2D7-42DE-81A5-FFD4F83656B2}"/>
               </a:ext>
             </a:extLst>
           </p:cNvPr>
@@ -8158,7 +11107,7 @@
           <p:cNvPr id="21" name="">
             <a:extLst xmlns:a="http://schemas.openxmlformats.org/drawingml/2006/main">
               <a:ext uri="{FF2B5EF4-FFF2-40B4-BE49-F238E27FC236}">
-                <a16:creationId xmlns:a16="http://schemas.microsoft.com/office/drawing/2014/main" id="{562E8D8D-A05F-4CCF-94B3-2D7DD9FA0E1D}"/>
+                <a16:creationId xmlns:a16="http://schemas.microsoft.com/office/drawing/2014/main" id="{7CD4B05A-0A9B-49A4-8946-C5AA0C27AF30}"/>
               </a:ext>
             </a:extLst>
           </p:cNvPr>
@@ -8208,7 +11157,7 @@
           <p:cNvPr id="22" name="">
             <a:extLst xmlns:a="http://schemas.openxmlformats.org/drawingml/2006/main">
               <a:ext uri="{FF2B5EF4-FFF2-40B4-BE49-F238E27FC236}">
-                <a16:creationId xmlns:a16="http://schemas.microsoft.com/office/drawing/2014/main" id="{5F6B446E-571E-435A-9E82-0823B69CD16B}"/>
+                <a16:creationId xmlns:a16="http://schemas.microsoft.com/office/drawing/2014/main" id="{32E3D37B-11D0-4702-9789-D0D0C6A3DE96}"/>
               </a:ext>
             </a:extLst>
           </p:cNvPr>
@@ -8239,7 +11188,7 @@
           <p:cNvPr id="23" name="">
             <a:extLst xmlns:a="http://schemas.openxmlformats.org/drawingml/2006/main">
               <a:ext uri="{FF2B5EF4-FFF2-40B4-BE49-F238E27FC236}">
-                <a16:creationId xmlns:a16="http://schemas.microsoft.com/office/drawing/2014/main" id="{CAD70CF1-0703-49A1-BDC6-A75E7EC0DB6C}"/>
+                <a16:creationId xmlns:a16="http://schemas.microsoft.com/office/drawing/2014/main" id="{D40D0D79-A11A-4940-BEC6-CF728A6FA9DC}"/>
               </a:ext>
             </a:extLst>
           </p:cNvPr>
@@ -8289,7 +11238,7 @@
           <p:cNvPr id="24" name="">
             <a:extLst xmlns:a="http://schemas.openxmlformats.org/drawingml/2006/main">
               <a:ext uri="{FF2B5EF4-FFF2-40B4-BE49-F238E27FC236}">
-                <a16:creationId xmlns:a16="http://schemas.microsoft.com/office/drawing/2014/main" id="{18797125-7ABE-4BF3-B0BC-A69BCE9F9D4C}"/>
+                <a16:creationId xmlns:a16="http://schemas.microsoft.com/office/drawing/2014/main" id="{CA4A5C98-5D4C-4040-853D-8893620171EC}"/>
               </a:ext>
             </a:extLst>
           </p:cNvPr>
@@ -8320,7 +11269,7 @@
           <p:cNvPr id="25" name="">
             <a:extLst xmlns:a="http://schemas.openxmlformats.org/drawingml/2006/main">
               <a:ext uri="{FF2B5EF4-FFF2-40B4-BE49-F238E27FC236}">
-                <a16:creationId xmlns:a16="http://schemas.microsoft.com/office/drawing/2014/main" id="{0B70231A-EC74-4AAE-B92C-2CE84FC6ECD0}"/>
+                <a16:creationId xmlns:a16="http://schemas.microsoft.com/office/drawing/2014/main" id="{04AD8E6A-20B4-4E12-A8A0-C7B81E448B7A}"/>
               </a:ext>
             </a:extLst>
           </p:cNvPr>
@@ -8370,7 +11319,7 @@
           <p:cNvPr id="26" name="">
             <a:extLst xmlns:a="http://schemas.openxmlformats.org/drawingml/2006/main">
               <a:ext uri="{FF2B5EF4-FFF2-40B4-BE49-F238E27FC236}">
-                <a16:creationId xmlns:a16="http://schemas.microsoft.com/office/drawing/2014/main" id="{072B13AF-B30E-4BFC-A498-3E3ECC74F831}"/>
+                <a16:creationId xmlns:a16="http://schemas.microsoft.com/office/drawing/2014/main" id="{FB8C8295-3C64-48FA-BDC1-F40BDACD566C}"/>
               </a:ext>
             </a:extLst>
           </p:cNvPr>
@@ -8401,7 +11350,7 @@
           <p:cNvPr id="27" name="">
             <a:extLst xmlns:a="http://schemas.openxmlformats.org/drawingml/2006/main">
               <a:ext uri="{FF2B5EF4-FFF2-40B4-BE49-F238E27FC236}">
-                <a16:creationId xmlns:a16="http://schemas.microsoft.com/office/drawing/2014/main" id="{4191BCAE-0D6A-4384-8F42-86C83D14AAE0}"/>
+                <a16:creationId xmlns:a16="http://schemas.microsoft.com/office/drawing/2014/main" id="{A190BC24-CF7A-46B6-ADF8-3D24FE063B75}"/>
               </a:ext>
             </a:extLst>
           </p:cNvPr>
@@ -8449,7 +11398,7 @@
     </p:spTree>
     <p:extLst>
       <p:ext uri="{BB962C8B-B14F-4D97-AF65-F5344CB8AC3E}">
-        <p14:creationId xmlns:p14="http://schemas.microsoft.com/office/powerpoint/2010/main" val="635840943"/>
+        <p14:creationId xmlns:p14="http://schemas.microsoft.com/office/powerpoint/2010/main" val="1222737422"/>
       </p:ext>
     </p:extLst>
   </p:cSld>
@@ -8480,7 +11429,7 @@
           <p:cNvPr id="1" name="">
             <a:extLst xmlns:a="http://schemas.openxmlformats.org/drawingml/2006/main">
               <a:ext uri="{FF2B5EF4-FFF2-40B4-BE49-F238E27FC236}">
-                <a16:creationId xmlns:a16="http://schemas.microsoft.com/office/drawing/2014/main" id="{2D53863B-00FD-4F33-B1C0-988F87EE49D9}"/>
+                <a16:creationId xmlns:a16="http://schemas.microsoft.com/office/drawing/2014/main" id="{443739F3-E4E2-4386-8C6F-C1A92E027867}"/>
               </a:ext>
             </a:extLst>
           </p:cNvPr>
@@ -8530,7 +11479,7 @@
           <p:cNvPr id="2" name="">
             <a:extLst xmlns:a="http://schemas.openxmlformats.org/drawingml/2006/main">
               <a:ext uri="{FF2B5EF4-FFF2-40B4-BE49-F238E27FC236}">
-                <a16:creationId xmlns:a16="http://schemas.microsoft.com/office/drawing/2014/main" id="{766217F2-478D-4904-82AD-5C5368A6307B}"/>
+                <a16:creationId xmlns:a16="http://schemas.microsoft.com/office/drawing/2014/main" id="{5B25765E-ED48-4188-906A-96F05F7791A9}"/>
               </a:ext>
             </a:extLst>
           </p:cNvPr>
@@ -8580,7 +11529,7 @@
           <p:cNvPr id="3" name="">
             <a:extLst xmlns:a="http://schemas.openxmlformats.org/drawingml/2006/main">
               <a:ext uri="{FF2B5EF4-FFF2-40B4-BE49-F238E27FC236}">
-                <a16:creationId xmlns:a16="http://schemas.microsoft.com/office/drawing/2014/main" id="{CB0CA937-6FD6-480A-BB4E-499B2C9CB3D2}"/>
+                <a16:creationId xmlns:a16="http://schemas.microsoft.com/office/drawing/2014/main" id="{7E201075-0734-4C0C-92D7-94F23300D0E7}"/>
               </a:ext>
             </a:extLst>
           </p:cNvPr>
@@ -8613,7 +11562,7 @@
           <p:cNvPr id="4" name="">
             <a:extLst xmlns:a="http://schemas.openxmlformats.org/drawingml/2006/main">
               <a:ext uri="{FF2B5EF4-FFF2-40B4-BE49-F238E27FC236}">
-                <a16:creationId xmlns:a16="http://schemas.microsoft.com/office/drawing/2014/main" id="{91DF3392-ABC1-407D-A6C4-BD7202A11A39}"/>
+                <a16:creationId xmlns:a16="http://schemas.microsoft.com/office/drawing/2014/main" id="{59801B92-BF97-46F7-A832-90257EE21026}"/>
               </a:ext>
             </a:extLst>
           </p:cNvPr>
@@ -8648,7 +11597,7 @@
           <p:cNvPr id="5" name="">
             <a:extLst xmlns:a="http://schemas.openxmlformats.org/drawingml/2006/main">
               <a:ext uri="{FF2B5EF4-FFF2-40B4-BE49-F238E27FC236}">
-                <a16:creationId xmlns:a16="http://schemas.microsoft.com/office/drawing/2014/main" id="{1B2F4D32-1F9D-46B5-A5F1-1279D78A2FEF}"/>
+                <a16:creationId xmlns:a16="http://schemas.microsoft.com/office/drawing/2014/main" id="{B98A012F-BC1B-4241-B906-587C5DC430E9}"/>
               </a:ext>
             </a:extLst>
           </p:cNvPr>
@@ -8698,7 +11647,7 @@
           <p:cNvPr id="6" name="">
             <a:extLst xmlns:a="http://schemas.openxmlformats.org/drawingml/2006/main">
               <a:ext uri="{FF2B5EF4-FFF2-40B4-BE49-F238E27FC236}">
-                <a16:creationId xmlns:a16="http://schemas.microsoft.com/office/drawing/2014/main" id="{B1351248-F07A-4856-8FEA-182D31A9B719}"/>
+                <a16:creationId xmlns:a16="http://schemas.microsoft.com/office/drawing/2014/main" id="{29A3E5FD-C5D0-41E7-8733-62AA07F9B2A6}"/>
               </a:ext>
             </a:extLst>
           </p:cNvPr>
@@ -8729,7 +11678,7 @@
           <p:cNvPr id="7" name="">
             <a:extLst xmlns:a="http://schemas.openxmlformats.org/drawingml/2006/main">
               <a:ext uri="{FF2B5EF4-FFF2-40B4-BE49-F238E27FC236}">
-                <a16:creationId xmlns:a16="http://schemas.microsoft.com/office/drawing/2014/main" id="{9E221B55-3E41-411D-9E13-CEA97237FF4E}"/>
+                <a16:creationId xmlns:a16="http://schemas.microsoft.com/office/drawing/2014/main" id="{AB02C42D-0D22-418B-A7B6-9B8852C49BC6}"/>
               </a:ext>
             </a:extLst>
           </p:cNvPr>
@@ -8779,7 +11728,7 @@
           <p:cNvPr id="8" name="">
             <a:extLst xmlns:a="http://schemas.openxmlformats.org/drawingml/2006/main">
               <a:ext uri="{FF2B5EF4-FFF2-40B4-BE49-F238E27FC236}">
-                <a16:creationId xmlns:a16="http://schemas.microsoft.com/office/drawing/2014/main" id="{25004774-A442-497C-AAE4-BAE21C9A2167}"/>
+                <a16:creationId xmlns:a16="http://schemas.microsoft.com/office/drawing/2014/main" id="{90AC6970-9560-4BBE-8574-D411BCC11692}"/>
               </a:ext>
             </a:extLst>
           </p:cNvPr>
@@ -8810,7 +11759,7 @@
           <p:cNvPr id="9" name="">
             <a:extLst xmlns:a="http://schemas.openxmlformats.org/drawingml/2006/main">
               <a:ext uri="{FF2B5EF4-FFF2-40B4-BE49-F238E27FC236}">
-                <a16:creationId xmlns:a16="http://schemas.microsoft.com/office/drawing/2014/main" id="{70F5AB6C-2B5F-49CD-BCED-8CAAEAE181CF}"/>
+                <a16:creationId xmlns:a16="http://schemas.microsoft.com/office/drawing/2014/main" id="{02112D7D-EF2D-4744-8F38-31D66768A2DF}"/>
               </a:ext>
             </a:extLst>
           </p:cNvPr>
@@ -8860,7 +11809,7 @@
           <p:cNvPr id="10" name="">
             <a:extLst xmlns:a="http://schemas.openxmlformats.org/drawingml/2006/main">
               <a:ext uri="{FF2B5EF4-FFF2-40B4-BE49-F238E27FC236}">
-                <a16:creationId xmlns:a16="http://schemas.microsoft.com/office/drawing/2014/main" id="{607B7907-912A-479E-A1B1-54D130F86FAF}"/>
+                <a16:creationId xmlns:a16="http://schemas.microsoft.com/office/drawing/2014/main" id="{CB49A0E3-6224-4287-9D12-7E649166D382}"/>
               </a:ext>
             </a:extLst>
           </p:cNvPr>
@@ -8891,7 +11840,7 @@
           <p:cNvPr id="11" name="">
             <a:extLst xmlns:a="http://schemas.openxmlformats.org/drawingml/2006/main">
               <a:ext uri="{FF2B5EF4-FFF2-40B4-BE49-F238E27FC236}">
-                <a16:creationId xmlns:a16="http://schemas.microsoft.com/office/drawing/2014/main" id="{8348F3D9-1AAD-4FD1-BF9D-932BCA0C8A63}"/>
+                <a16:creationId xmlns:a16="http://schemas.microsoft.com/office/drawing/2014/main" id="{476B76B2-363D-4071-B575-52B747CCD983}"/>
               </a:ext>
             </a:extLst>
           </p:cNvPr>
@@ -8941,7 +11890,7 @@
           <p:cNvPr id="12" name="">
             <a:extLst xmlns:a="http://schemas.openxmlformats.org/drawingml/2006/main">
               <a:ext uri="{FF2B5EF4-FFF2-40B4-BE49-F238E27FC236}">
-                <a16:creationId xmlns:a16="http://schemas.microsoft.com/office/drawing/2014/main" id="{96A102BB-15F6-47AD-A1C4-B2DA90FDCA81}"/>
+                <a16:creationId xmlns:a16="http://schemas.microsoft.com/office/drawing/2014/main" id="{74C95184-7FCB-49D6-8979-1BEA7F86D791}"/>
               </a:ext>
             </a:extLst>
           </p:cNvPr>
@@ -8972,7 +11921,7 @@
           <p:cNvPr id="13" name="">
             <a:extLst xmlns:a="http://schemas.openxmlformats.org/drawingml/2006/main">
               <a:ext uri="{FF2B5EF4-FFF2-40B4-BE49-F238E27FC236}">
-                <a16:creationId xmlns:a16="http://schemas.microsoft.com/office/drawing/2014/main" id="{4326E059-8F9C-4948-AF2F-B7DA4FA65A3D}"/>
+                <a16:creationId xmlns:a16="http://schemas.microsoft.com/office/drawing/2014/main" id="{C4CFE570-02AD-4ED2-8A44-4277EE8AE748}"/>
               </a:ext>
             </a:extLst>
           </p:cNvPr>
@@ -9022,7 +11971,7 @@
           <p:cNvPr id="14" name="">
             <a:extLst xmlns:a="http://schemas.openxmlformats.org/drawingml/2006/main">
               <a:ext uri="{FF2B5EF4-FFF2-40B4-BE49-F238E27FC236}">
-                <a16:creationId xmlns:a16="http://schemas.microsoft.com/office/drawing/2014/main" id="{1EC9554C-EACD-4BBD-9FD4-52778684139B}"/>
+                <a16:creationId xmlns:a16="http://schemas.microsoft.com/office/drawing/2014/main" id="{A612F7D1-6FB2-4619-A386-B58A816C53FE}"/>
               </a:ext>
             </a:extLst>
           </p:cNvPr>
@@ -9053,7 +12002,7 @@
           <p:cNvPr id="15" name="">
             <a:extLst xmlns:a="http://schemas.openxmlformats.org/drawingml/2006/main">
               <a:ext uri="{FF2B5EF4-FFF2-40B4-BE49-F238E27FC236}">
-                <a16:creationId xmlns:a16="http://schemas.microsoft.com/office/drawing/2014/main" id="{0A17A06C-7148-448B-B593-8E0429096C67}"/>
+                <a16:creationId xmlns:a16="http://schemas.microsoft.com/office/drawing/2014/main" id="{0DA2D9F3-13C7-46B0-9DAA-91183F64659A}"/>
               </a:ext>
             </a:extLst>
           </p:cNvPr>
@@ -9103,7 +12052,7 @@
           <p:cNvPr id="16" name="">
             <a:extLst xmlns:a="http://schemas.openxmlformats.org/drawingml/2006/main">
               <a:ext uri="{FF2B5EF4-FFF2-40B4-BE49-F238E27FC236}">
-                <a16:creationId xmlns:a16="http://schemas.microsoft.com/office/drawing/2014/main" id="{C5F0BDC0-8CFF-4800-B280-80E5A5E94F48}"/>
+                <a16:creationId xmlns:a16="http://schemas.microsoft.com/office/drawing/2014/main" id="{4C9EF156-8836-4ED3-9E70-D95A3D2D64C3}"/>
               </a:ext>
             </a:extLst>
           </p:cNvPr>
@@ -9138,7 +12087,7 @@
           <p:cNvPr id="17" name="">
             <a:extLst xmlns:a="http://schemas.openxmlformats.org/drawingml/2006/main">
               <a:ext uri="{FF2B5EF4-FFF2-40B4-BE49-F238E27FC236}">
-                <a16:creationId xmlns:a16="http://schemas.microsoft.com/office/drawing/2014/main" id="{FFCC535B-525C-4880-AFC5-99E9C96D361A}"/>
+                <a16:creationId xmlns:a16="http://schemas.microsoft.com/office/drawing/2014/main" id="{DAA57325-C61F-4CC0-BEE5-E88185683898}"/>
               </a:ext>
             </a:extLst>
           </p:cNvPr>
@@ -9188,7 +12137,7 @@
           <p:cNvPr id="18" name="">
             <a:extLst xmlns:a="http://schemas.openxmlformats.org/drawingml/2006/main">
               <a:ext uri="{FF2B5EF4-FFF2-40B4-BE49-F238E27FC236}">
-                <a16:creationId xmlns:a16="http://schemas.microsoft.com/office/drawing/2014/main" id="{937D829F-74C3-432C-9768-525829A6CF2F}"/>
+                <a16:creationId xmlns:a16="http://schemas.microsoft.com/office/drawing/2014/main" id="{BB0FAF69-2690-49E8-AAC5-92561201468E}"/>
               </a:ext>
             </a:extLst>
           </p:cNvPr>
@@ -9219,7 +12168,7 @@
           <p:cNvPr id="19" name="">
             <a:extLst xmlns:a="http://schemas.openxmlformats.org/drawingml/2006/main">
               <a:ext uri="{FF2B5EF4-FFF2-40B4-BE49-F238E27FC236}">
-                <a16:creationId xmlns:a16="http://schemas.microsoft.com/office/drawing/2014/main" id="{AAD9D4C1-6643-4933-BA8F-2A86737873E8}"/>
+                <a16:creationId xmlns:a16="http://schemas.microsoft.com/office/drawing/2014/main" id="{846092FB-6AA2-4D5B-8093-EF4C05E00488}"/>
               </a:ext>
             </a:extLst>
           </p:cNvPr>
@@ -9269,7 +12218,7 @@
           <p:cNvPr id="20" name="">
             <a:extLst xmlns:a="http://schemas.openxmlformats.org/drawingml/2006/main">
               <a:ext uri="{FF2B5EF4-FFF2-40B4-BE49-F238E27FC236}">
-                <a16:creationId xmlns:a16="http://schemas.microsoft.com/office/drawing/2014/main" id="{9ECF8C7C-4DEC-4718-82AA-5F82390D53DE}"/>
+                <a16:creationId xmlns:a16="http://schemas.microsoft.com/office/drawing/2014/main" id="{E56BCAE5-30DC-4780-A94B-5431EFC9593F}"/>
               </a:ext>
             </a:extLst>
           </p:cNvPr>
@@ -9300,7 +12249,7 @@
           <p:cNvPr id="21" name="">
             <a:extLst xmlns:a="http://schemas.openxmlformats.org/drawingml/2006/main">
               <a:ext uri="{FF2B5EF4-FFF2-40B4-BE49-F238E27FC236}">
-                <a16:creationId xmlns:a16="http://schemas.microsoft.com/office/drawing/2014/main" id="{8A753F43-E765-4290-BD66-5D32CC8D6859}"/>
+                <a16:creationId xmlns:a16="http://schemas.microsoft.com/office/drawing/2014/main" id="{78BEFB06-8D1E-4515-8DE8-101CA3EC9EA9}"/>
               </a:ext>
             </a:extLst>
           </p:cNvPr>
@@ -9350,7 +12299,7 @@
           <p:cNvPr id="22" name="">
             <a:extLst xmlns:a="http://schemas.openxmlformats.org/drawingml/2006/main">
               <a:ext uri="{FF2B5EF4-FFF2-40B4-BE49-F238E27FC236}">
-                <a16:creationId xmlns:a16="http://schemas.microsoft.com/office/drawing/2014/main" id="{974A7E84-BCB3-4620-AA8F-D98C59A9AC84}"/>
+                <a16:creationId xmlns:a16="http://schemas.microsoft.com/office/drawing/2014/main" id="{987EAAA9-88D2-4F8B-BDFB-EF36AE0696CF}"/>
               </a:ext>
             </a:extLst>
           </p:cNvPr>
@@ -9381,7 +12330,7 @@
           <p:cNvPr id="23" name="">
             <a:extLst xmlns:a="http://schemas.openxmlformats.org/drawingml/2006/main">
               <a:ext uri="{FF2B5EF4-FFF2-40B4-BE49-F238E27FC236}">
-                <a16:creationId xmlns:a16="http://schemas.microsoft.com/office/drawing/2014/main" id="{1DAC7103-2291-4337-ABBE-E56F4DA8ACB3}"/>
+                <a16:creationId xmlns:a16="http://schemas.microsoft.com/office/drawing/2014/main" id="{3C72785F-F410-40A1-A386-FE50B8CB3FC2}"/>
               </a:ext>
             </a:extLst>
           </p:cNvPr>
@@ -9431,7 +12380,7 @@
           <p:cNvPr id="24" name="">
             <a:extLst xmlns:a="http://schemas.openxmlformats.org/drawingml/2006/main">
               <a:ext uri="{FF2B5EF4-FFF2-40B4-BE49-F238E27FC236}">
-                <a16:creationId xmlns:a16="http://schemas.microsoft.com/office/drawing/2014/main" id="{9666F099-6C2B-4D73-B7EF-08E687B4A03D}"/>
+                <a16:creationId xmlns:a16="http://schemas.microsoft.com/office/drawing/2014/main" id="{2AFACE8C-5DAB-4C97-84C1-7468A2947D5A}"/>
               </a:ext>
             </a:extLst>
           </p:cNvPr>
@@ -9462,7 +12411,7 @@
           <p:cNvPr id="25" name="">
             <a:extLst xmlns:a="http://schemas.openxmlformats.org/drawingml/2006/main">
               <a:ext uri="{FF2B5EF4-FFF2-40B4-BE49-F238E27FC236}">
-                <a16:creationId xmlns:a16="http://schemas.microsoft.com/office/drawing/2014/main" id="{13BAD1CA-0169-46EF-AAD3-2EBED6738D99}"/>
+                <a16:creationId xmlns:a16="http://schemas.microsoft.com/office/drawing/2014/main" id="{D20EAA42-F412-45DF-8A27-15A5C0D1564C}"/>
               </a:ext>
             </a:extLst>
           </p:cNvPr>
@@ -9512,7 +12461,7 @@
           <p:cNvPr id="26" name="">
             <a:extLst xmlns:a="http://schemas.openxmlformats.org/drawingml/2006/main">
               <a:ext uri="{FF2B5EF4-FFF2-40B4-BE49-F238E27FC236}">
-                <a16:creationId xmlns:a16="http://schemas.microsoft.com/office/drawing/2014/main" id="{06505205-A510-4D2C-B2BC-1895B71EA5EB}"/>
+                <a16:creationId xmlns:a16="http://schemas.microsoft.com/office/drawing/2014/main" id="{E17432BB-6AF3-4375-B4BE-A6672F82F283}"/>
               </a:ext>
             </a:extLst>
           </p:cNvPr>
@@ -9543,7 +12492,7 @@
           <p:cNvPr id="27" name="">
             <a:extLst xmlns:a="http://schemas.openxmlformats.org/drawingml/2006/main">
               <a:ext uri="{FF2B5EF4-FFF2-40B4-BE49-F238E27FC236}">
-                <a16:creationId xmlns:a16="http://schemas.microsoft.com/office/drawing/2014/main" id="{35F7665B-A9DE-49B9-9756-977C86ECA981}"/>
+                <a16:creationId xmlns:a16="http://schemas.microsoft.com/office/drawing/2014/main" id="{E751F110-620B-4A2D-84EA-03D7A77BAC3C}"/>
               </a:ext>
             </a:extLst>
           </p:cNvPr>
@@ -9591,7 +12540,7 @@
     </p:spTree>
     <p:extLst>
       <p:ext uri="{BB962C8B-B14F-4D97-AF65-F5344CB8AC3E}">
-        <p14:creationId xmlns:p14="http://schemas.microsoft.com/office/powerpoint/2010/main" val="375766020"/>
+        <p14:creationId xmlns:p14="http://schemas.microsoft.com/office/powerpoint/2010/main" val="139311800"/>
       </p:ext>
     </p:extLst>
   </p:cSld>
@@ -9622,7 +12571,7 @@
           <p:cNvPr id="1" name="">
             <a:extLst xmlns:a="http://schemas.openxmlformats.org/drawingml/2006/main">
               <a:ext uri="{FF2B5EF4-FFF2-40B4-BE49-F238E27FC236}">
-                <a16:creationId xmlns:a16="http://schemas.microsoft.com/office/drawing/2014/main" id="{C21F1DC0-5166-476F-8AA2-2D8FCBE72E2C}"/>
+                <a16:creationId xmlns:a16="http://schemas.microsoft.com/office/drawing/2014/main" id="{B2FCFE4B-ADFF-4A97-AC14-BFCBA9E7EED7}"/>
               </a:ext>
             </a:extLst>
           </p:cNvPr>
@@ -9672,7 +12621,7 @@
           <p:cNvPr id="2" name="">
             <a:extLst xmlns:a="http://schemas.openxmlformats.org/drawingml/2006/main">
               <a:ext uri="{FF2B5EF4-FFF2-40B4-BE49-F238E27FC236}">
-                <a16:creationId xmlns:a16="http://schemas.microsoft.com/office/drawing/2014/main" id="{54352E64-4C54-41B8-9DDB-B625284A4764}"/>
+                <a16:creationId xmlns:a16="http://schemas.microsoft.com/office/drawing/2014/main" id="{59779B16-C44F-4C19-9B9B-BB057B52FE3A}"/>
               </a:ext>
             </a:extLst>
           </p:cNvPr>
@@ -9722,7 +12671,7 @@
           <p:cNvPr id="3" name="">
             <a:extLst xmlns:a="http://schemas.openxmlformats.org/drawingml/2006/main">
               <a:ext uri="{FF2B5EF4-FFF2-40B4-BE49-F238E27FC236}">
-                <a16:creationId xmlns:a16="http://schemas.microsoft.com/office/drawing/2014/main" id="{698F6855-7EF6-48F9-95A3-9BEDBAD09C98}"/>
+                <a16:creationId xmlns:a16="http://schemas.microsoft.com/office/drawing/2014/main" id="{5EF2B354-683B-47E9-93C7-CC6C0BF54AC9}"/>
               </a:ext>
             </a:extLst>
           </p:cNvPr>
@@ -9755,7 +12704,7 @@
           <p:cNvPr id="4" name="">
             <a:extLst xmlns:a="http://schemas.openxmlformats.org/drawingml/2006/main">
               <a:ext uri="{FF2B5EF4-FFF2-40B4-BE49-F238E27FC236}">
-                <a16:creationId xmlns:a16="http://schemas.microsoft.com/office/drawing/2014/main" id="{73DAC494-DE83-408A-99CB-63AD861C8051}"/>
+                <a16:creationId xmlns:a16="http://schemas.microsoft.com/office/drawing/2014/main" id="{1F425E80-7B50-43B4-A713-F3FF703F4DB3}"/>
               </a:ext>
             </a:extLst>
           </p:cNvPr>
@@ -9790,7 +12739,7 @@
           <p:cNvPr id="5" name="">
             <a:extLst xmlns:a="http://schemas.openxmlformats.org/drawingml/2006/main">
               <a:ext uri="{FF2B5EF4-FFF2-40B4-BE49-F238E27FC236}">
-                <a16:creationId xmlns:a16="http://schemas.microsoft.com/office/drawing/2014/main" id="{70BF5479-AC19-4E67-9A61-B518C679AEC5}"/>
+                <a16:creationId xmlns:a16="http://schemas.microsoft.com/office/drawing/2014/main" id="{F9325BCF-2B76-4C40-B1C7-C3A39E2078FA}"/>
               </a:ext>
             </a:extLst>
           </p:cNvPr>
@@ -9840,7 +12789,7 @@
           <p:cNvPr id="6" name="">
             <a:extLst xmlns:a="http://schemas.openxmlformats.org/drawingml/2006/main">
               <a:ext uri="{FF2B5EF4-FFF2-40B4-BE49-F238E27FC236}">
-                <a16:creationId xmlns:a16="http://schemas.microsoft.com/office/drawing/2014/main" id="{5AC33AF2-A81A-4496-87A0-82701BB6F72F}"/>
+                <a16:creationId xmlns:a16="http://schemas.microsoft.com/office/drawing/2014/main" id="{67BF0B49-C6FF-4035-ABE1-96E99C62C653}"/>
               </a:ext>
             </a:extLst>
           </p:cNvPr>
@@ -9890,7 +12839,7 @@
           <p:cNvPr id="7" name="">
             <a:extLst xmlns:a="http://schemas.openxmlformats.org/drawingml/2006/main">
               <a:ext uri="{FF2B5EF4-FFF2-40B4-BE49-F238E27FC236}">
-                <a16:creationId xmlns:a16="http://schemas.microsoft.com/office/drawing/2014/main" id="{6DEA1A93-8811-4D9D-8EE3-5DF92BB318A0}"/>
+                <a16:creationId xmlns:a16="http://schemas.microsoft.com/office/drawing/2014/main" id="{0FCDED2C-6AAF-4CAA-813D-DE233C543599}"/>
               </a:ext>
             </a:extLst>
           </p:cNvPr>
@@ -9925,7 +12874,7 @@
           <p:cNvPr id="8" name="">
             <a:extLst xmlns:a="http://schemas.openxmlformats.org/drawingml/2006/main">
               <a:ext uri="{FF2B5EF4-FFF2-40B4-BE49-F238E27FC236}">
-                <a16:creationId xmlns:a16="http://schemas.microsoft.com/office/drawing/2014/main" id="{E9085633-7C48-44D9-B383-91EAE084A87E}"/>
+                <a16:creationId xmlns:a16="http://schemas.microsoft.com/office/drawing/2014/main" id="{1E4403BC-6D00-4688-A5C2-01DA5ABE4F2F}"/>
               </a:ext>
             </a:extLst>
           </p:cNvPr>
@@ -9975,7 +12924,7 @@
           <p:cNvPr id="9" name="">
             <a:extLst xmlns:a="http://schemas.openxmlformats.org/drawingml/2006/main">
               <a:ext uri="{FF2B5EF4-FFF2-40B4-BE49-F238E27FC236}">
-                <a16:creationId xmlns:a16="http://schemas.microsoft.com/office/drawing/2014/main" id="{7543C56B-3832-46A8-B22F-C5791487C653}"/>
+                <a16:creationId xmlns:a16="http://schemas.microsoft.com/office/drawing/2014/main" id="{BC1670DD-7F47-4655-B269-7D3CC9DC0FDB}"/>
               </a:ext>
             </a:extLst>
           </p:cNvPr>
@@ -10006,7 +12955,7 @@
           <p:cNvPr id="10" name="">
             <a:extLst xmlns:a="http://schemas.openxmlformats.org/drawingml/2006/main">
               <a:ext uri="{FF2B5EF4-FFF2-40B4-BE49-F238E27FC236}">
-                <a16:creationId xmlns:a16="http://schemas.microsoft.com/office/drawing/2014/main" id="{7FCEF72C-CF0F-47EC-A37B-E3BE5F7772F4}"/>
+                <a16:creationId xmlns:a16="http://schemas.microsoft.com/office/drawing/2014/main" id="{518416F0-3103-446E-A79E-29834758F0B7}"/>
               </a:ext>
             </a:extLst>
           </p:cNvPr>
@@ -10056,7 +13005,7 @@
           <p:cNvPr id="11" name="">
             <a:extLst xmlns:a="http://schemas.openxmlformats.org/drawingml/2006/main">
               <a:ext uri="{FF2B5EF4-FFF2-40B4-BE49-F238E27FC236}">
-                <a16:creationId xmlns:a16="http://schemas.microsoft.com/office/drawing/2014/main" id="{9486BEC5-DD0E-4949-A702-921F84F972B6}"/>
+                <a16:creationId xmlns:a16="http://schemas.microsoft.com/office/drawing/2014/main" id="{1ECC40C0-5A11-4EE8-903D-6640A28B57DE}"/>
               </a:ext>
             </a:extLst>
           </p:cNvPr>
@@ -10087,7 +13036,7 @@
           <p:cNvPr id="12" name="">
             <a:extLst xmlns:a="http://schemas.openxmlformats.org/drawingml/2006/main">
               <a:ext uri="{FF2B5EF4-FFF2-40B4-BE49-F238E27FC236}">
-                <a16:creationId xmlns:a16="http://schemas.microsoft.com/office/drawing/2014/main" id="{4F8BA426-5726-46E5-8C4C-CA41B70E1820}"/>
+                <a16:creationId xmlns:a16="http://schemas.microsoft.com/office/drawing/2014/main" id="{F2268646-A00A-4992-BD04-9E3645E84731}"/>
               </a:ext>
             </a:extLst>
           </p:cNvPr>
@@ -10137,7 +13086,7 @@
           <p:cNvPr id="13" name="">
             <a:extLst xmlns:a="http://schemas.openxmlformats.org/drawingml/2006/main">
               <a:ext uri="{FF2B5EF4-FFF2-40B4-BE49-F238E27FC236}">
-                <a16:creationId xmlns:a16="http://schemas.microsoft.com/office/drawing/2014/main" id="{DB9AF9CD-9A16-4158-86CA-12894FA56A59}"/>
+                <a16:creationId xmlns:a16="http://schemas.microsoft.com/office/drawing/2014/main" id="{C6A1DDCE-CBAC-42B7-A646-AC78CDFC7D77}"/>
               </a:ext>
             </a:extLst>
           </p:cNvPr>
@@ -10168,7 +13117,7 @@
           <p:cNvPr id="14" name="">
             <a:extLst xmlns:a="http://schemas.openxmlformats.org/drawingml/2006/main">
               <a:ext uri="{FF2B5EF4-FFF2-40B4-BE49-F238E27FC236}">
-                <a16:creationId xmlns:a16="http://schemas.microsoft.com/office/drawing/2014/main" id="{8C93D43A-6947-4061-8ECA-19A99AC9582C}"/>
+                <a16:creationId xmlns:a16="http://schemas.microsoft.com/office/drawing/2014/main" id="{80CD4DE7-9EF7-4DCD-AF5D-2B880AFD02C5}"/>
               </a:ext>
             </a:extLst>
           </p:cNvPr>
@@ -10218,7 +13167,7 @@
           <p:cNvPr id="15" name="">
             <a:extLst xmlns:a="http://schemas.openxmlformats.org/drawingml/2006/main">
               <a:ext uri="{FF2B5EF4-FFF2-40B4-BE49-F238E27FC236}">
-                <a16:creationId xmlns:a16="http://schemas.microsoft.com/office/drawing/2014/main" id="{853B3BF0-EA8C-49F7-80A4-EB6AFB42FB92}"/>
+                <a16:creationId xmlns:a16="http://schemas.microsoft.com/office/drawing/2014/main" id="{39B6AF1F-3798-41BC-9ED3-D715D81BD9F9}"/>
               </a:ext>
             </a:extLst>
           </p:cNvPr>
@@ -10249,7 +13198,7 @@
           <p:cNvPr id="16" name="">
             <a:extLst xmlns:a="http://schemas.openxmlformats.org/drawingml/2006/main">
               <a:ext uri="{FF2B5EF4-FFF2-40B4-BE49-F238E27FC236}">
-                <a16:creationId xmlns:a16="http://schemas.microsoft.com/office/drawing/2014/main" id="{18C67C4E-3707-417B-9F6A-801A7862E26E}"/>
+                <a16:creationId xmlns:a16="http://schemas.microsoft.com/office/drawing/2014/main" id="{1A620B9E-4068-4BE7-A32A-0280D0FAE5E0}"/>
               </a:ext>
             </a:extLst>
           </p:cNvPr>
@@ -10299,7 +13248,7 @@
           <p:cNvPr id="17" name="">
             <a:extLst xmlns:a="http://schemas.openxmlformats.org/drawingml/2006/main">
               <a:ext uri="{FF2B5EF4-FFF2-40B4-BE49-F238E27FC236}">
-                <a16:creationId xmlns:a16="http://schemas.microsoft.com/office/drawing/2014/main" id="{DCFED356-48FB-4F2D-B6A7-74ABAED81F28}"/>
+                <a16:creationId xmlns:a16="http://schemas.microsoft.com/office/drawing/2014/main" id="{6D3FE26B-8FC4-4988-B039-08DF9F63AD23}"/>
               </a:ext>
             </a:extLst>
           </p:cNvPr>
@@ -10347,7 +13296,7 @@
     </p:spTree>
     <p:extLst>
       <p:ext uri="{BB962C8B-B14F-4D97-AF65-F5344CB8AC3E}">
-        <p14:creationId xmlns:p14="http://schemas.microsoft.com/office/powerpoint/2010/main" val="2029024405"/>
+        <p14:creationId xmlns:p14="http://schemas.microsoft.com/office/powerpoint/2010/main" val="249256092"/>
       </p:ext>
     </p:extLst>
   </p:cSld>

</xml_diff>

<commit_message>
Add Gen5.3 representative timing tapes
</commit_message>
<xml_diff>
--- a/presentations/gen5_3_bull_momentum_specialist_plan.pptx
+++ b/presentations/gen5_3_bull_momentum_specialist_plan.pptx
@@ -2,25 +2,26 @@
 <file path=ppt/presentation.xml><?xml version="1.0" encoding="utf-8"?>
 <p:presentation xmlns:p="http://schemas.openxmlformats.org/presentationml/2006/main">
   <p:sldMasterIdLst>
-    <p:sldMasterId xmlns:r="http://schemas.openxmlformats.org/officeDocument/2006/relationships" id="2147483648" r:id="Rffc1a028262e4739"/>
+    <p:sldMasterId xmlns:r="http://schemas.openxmlformats.org/officeDocument/2006/relationships" id="2147483648" r:id="Raa45211ec0ff4887"/>
   </p:sldMasterIdLst>
   <p:notesMasterIdLst>
-    <p:notesMasterId xmlns:r="http://schemas.openxmlformats.org/officeDocument/2006/relationships" r:id="Re5715b932fd345ed"/>
+    <p:notesMasterId xmlns:r="http://schemas.openxmlformats.org/officeDocument/2006/relationships" r:id="Reef466d9dcfa4e89"/>
   </p:notesMasterIdLst>
   <p:sldIdLst>
-    <p:sldId xmlns:r="http://schemas.openxmlformats.org/officeDocument/2006/relationships" id="256" r:id="Rf1bb3d7fb46c447c"/>
-    <p:sldId xmlns:r="http://schemas.openxmlformats.org/officeDocument/2006/relationships" id="257" r:id="R88a8ef7417ba4719"/>
-    <p:sldId xmlns:r="http://schemas.openxmlformats.org/officeDocument/2006/relationships" id="258" r:id="R6f6780d49d6f4419"/>
-    <p:sldId xmlns:r="http://schemas.openxmlformats.org/officeDocument/2006/relationships" id="259" r:id="R93af5d5a86d24e96"/>
-    <p:sldId xmlns:r="http://schemas.openxmlformats.org/officeDocument/2006/relationships" id="260" r:id="R684b6c2954884bc8"/>
-    <p:sldId xmlns:r="http://schemas.openxmlformats.org/officeDocument/2006/relationships" id="261" r:id="R8a05b78f19694027"/>
-    <p:sldId xmlns:r="http://schemas.openxmlformats.org/officeDocument/2006/relationships" id="262" r:id="R8073d5dd73ab41b8"/>
-    <p:sldId xmlns:r="http://schemas.openxmlformats.org/officeDocument/2006/relationships" id="263" r:id="R1491b24603014c2b"/>
-    <p:sldId xmlns:r="http://schemas.openxmlformats.org/officeDocument/2006/relationships" id="264" r:id="R16b1a4373991483b"/>
-    <p:sldId xmlns:r="http://schemas.openxmlformats.org/officeDocument/2006/relationships" id="265" r:id="Ra7d3c940f4d6418d"/>
-    <p:sldId xmlns:r="http://schemas.openxmlformats.org/officeDocument/2006/relationships" id="266" r:id="R319079a09bab4c78"/>
-    <p:sldId xmlns:r="http://schemas.openxmlformats.org/officeDocument/2006/relationships" id="267" r:id="R14ac2b761943420d"/>
-    <p:sldId xmlns:r="http://schemas.openxmlformats.org/officeDocument/2006/relationships" id="268" r:id="R38acd66fbbad4d66"/>
+    <p:sldId xmlns:r="http://schemas.openxmlformats.org/officeDocument/2006/relationships" id="256" r:id="Rb3c30fb8852c4220"/>
+    <p:sldId xmlns:r="http://schemas.openxmlformats.org/officeDocument/2006/relationships" id="257" r:id="Rc706546d613c48a2"/>
+    <p:sldId xmlns:r="http://schemas.openxmlformats.org/officeDocument/2006/relationships" id="258" r:id="R74eb1b3da3984f7a"/>
+    <p:sldId xmlns:r="http://schemas.openxmlformats.org/officeDocument/2006/relationships" id="259" r:id="R05e1e9f00d1940c2"/>
+    <p:sldId xmlns:r="http://schemas.openxmlformats.org/officeDocument/2006/relationships" id="260" r:id="R2b29d76b352e42b3"/>
+    <p:sldId xmlns:r="http://schemas.openxmlformats.org/officeDocument/2006/relationships" id="261" r:id="Rbc4a5ad60a984fb0"/>
+    <p:sldId xmlns:r="http://schemas.openxmlformats.org/officeDocument/2006/relationships" id="262" r:id="Rd74302f855894819"/>
+    <p:sldId xmlns:r="http://schemas.openxmlformats.org/officeDocument/2006/relationships" id="263" r:id="R61570a3bb4194786"/>
+    <p:sldId xmlns:r="http://schemas.openxmlformats.org/officeDocument/2006/relationships" id="264" r:id="Rd48d3ce50e4f4b52"/>
+    <p:sldId xmlns:r="http://schemas.openxmlformats.org/officeDocument/2006/relationships" id="265" r:id="R0d3e502721fb46f5"/>
+    <p:sldId xmlns:r="http://schemas.openxmlformats.org/officeDocument/2006/relationships" id="266" r:id="R5bfe041ab62f409b"/>
+    <p:sldId xmlns:r="http://schemas.openxmlformats.org/officeDocument/2006/relationships" id="267" r:id="R2b782f655cc94610"/>
+    <p:sldId xmlns:r="http://schemas.openxmlformats.org/officeDocument/2006/relationships" id="268" r:id="Rd4617074c7834014"/>
+    <p:sldId xmlns:r="http://schemas.openxmlformats.org/officeDocument/2006/relationships" id="269" r:id="R60b5437a28c24c45"/>
   </p:sldIdLst>
   <p:sldSz cx="12192000" cy="6858000"/>
   <p:notesSz cx="6858000" cy="9144000"/>
@@ -839,6 +840,72 @@
 </p:notes>
 </file>
 
+<file path=ppt/notesSlides/notesSlide14.xml><?xml version="1.0" encoding="utf-8"?>
+<p:notes xmlns:p="http://schemas.openxmlformats.org/presentationml/2006/main">
+  <p:cSld>
+    <p:spTree>
+      <p:nvGrpSpPr>
+        <p:cNvPr id="1" name=""/>
+        <p:cNvGrpSpPr/>
+        <p:nvPr/>
+      </p:nvGrpSpPr>
+      <p:grpSpPr>
+        <a:xfrm xmlns:a="http://schemas.openxmlformats.org/drawingml/2006/main"/>
+      </p:grpSpPr>
+      <p:sp>
+        <p:nvSpPr>
+          <p:cNvPr id="2" name="Slide Image Placeholder 1"/>
+          <p:cNvSpPr>
+            <a:spLocks xmlns:a="http://schemas.openxmlformats.org/drawingml/2006/main" noGrp="1"/>
+          </p:cNvSpPr>
+          <p:nvPr>
+            <p:ph type="sldImg" idx="0"/>
+          </p:nvPr>
+        </p:nvSpPr>
+        <p:spPr/>
+      </p:sp>
+      <p:sp>
+        <p:nvSpPr>
+          <p:cNvPr id="3" name="Notes Placeholder 2"/>
+          <p:cNvSpPr>
+            <a:spLocks xmlns:a="http://schemas.openxmlformats.org/drawingml/2006/main" noGrp="1"/>
+          </p:cNvSpPr>
+          <p:nvPr>
+            <p:ph type="body" idx="1"/>
+          </p:nvPr>
+        </p:nvSpPr>
+        <p:spPr/>
+        <p:txBody>
+          <a:bodyPr xmlns:a="http://schemas.openxmlformats.org/drawingml/2006/main"/>
+          <a:lstStyle xmlns:a="http://schemas.openxmlformats.org/drawingml/2006/main"/>
+          <a:p xmlns:a="http://schemas.openxmlformats.org/drawingml/2006/main"/>
+        </p:txBody>
+      </p:sp>
+      <p:sp>
+        <p:nvSpPr>
+          <p:cNvPr id="4" name="Slide Number Placeholder 3"/>
+          <p:cNvSpPr>
+            <a:spLocks xmlns:a="http://schemas.openxmlformats.org/drawingml/2006/main" noGrp="1"/>
+          </p:cNvSpPr>
+          <p:nvPr>
+            <p:ph type="sldNum" idx="5"/>
+          </p:nvPr>
+        </p:nvSpPr>
+        <p:spPr/>
+        <p:txBody>
+          <a:bodyPr xmlns:a="http://schemas.openxmlformats.org/drawingml/2006/main"/>
+          <a:lstStyle xmlns:a="http://schemas.openxmlformats.org/drawingml/2006/main"/>
+          <a:p xmlns:a="http://schemas.openxmlformats.org/drawingml/2006/main"/>
+        </p:txBody>
+      </p:sp>
+    </p:spTree>
+  </p:cSld>
+  <p:clrMapOvr>
+    <a:masterClrMapping xmlns:a="http://schemas.openxmlformats.org/drawingml/2006/main"/>
+  </p:clrMapOvr>
+</p:notes>
+</file>
+
 <file path=ppt/notesSlides/notesSlide2.xml><?xml version="1.0" encoding="utf-8"?>
 <p:notes xmlns:p="http://schemas.openxmlformats.org/presentationml/2006/main">
   <p:cSld>
@@ -1405,7 +1472,7 @@
   </p:cSld>
   <p:clrMap bg1="lt1" tx1="dk1" bg2="lt2" tx2="dk2" accent1="accent1" accent2="accent2" accent3="accent3" accent4="accent4" accent5="accent5" accent6="accent6" hlink="hlink" folHlink="folHlink"/>
   <p:sldLayoutIdLst>
-    <p:sldLayoutId xmlns:r="http://schemas.openxmlformats.org/officeDocument/2006/relationships" id="2147483649" r:id="R240ed903c0b34d75"/>
+    <p:sldLayoutId xmlns:r="http://schemas.openxmlformats.org/officeDocument/2006/relationships" id="2147483649" r:id="R667a5a0485454720"/>
   </p:sldLayoutIdLst>
   <p:txStyles>
     <p:titleStyle>
@@ -1956,7 +2023,7 @@
           <p:cNvPr id="1" name="">
             <a:extLst xmlns:a="http://schemas.openxmlformats.org/drawingml/2006/main">
               <a:ext uri="{FF2B5EF4-FFF2-40B4-BE49-F238E27FC236}">
-                <a16:creationId xmlns:a16="http://schemas.microsoft.com/office/drawing/2014/main" id="{2BFEAC4A-957D-4A47-95DB-6A56AC60EAAF}"/>
+                <a16:creationId xmlns:a16="http://schemas.microsoft.com/office/drawing/2014/main" id="{657000B1-E6FC-4252-A977-DC7F313FA1C1}"/>
               </a:ext>
             </a:extLst>
           </p:cNvPr>
@@ -2006,7 +2073,7 @@
           <p:cNvPr id="2" name="">
             <a:extLst xmlns:a="http://schemas.openxmlformats.org/drawingml/2006/main">
               <a:ext uri="{FF2B5EF4-FFF2-40B4-BE49-F238E27FC236}">
-                <a16:creationId xmlns:a16="http://schemas.microsoft.com/office/drawing/2014/main" id="{92F76554-9CF5-46F4-B0B1-F6945E83BBFE}"/>
+                <a16:creationId xmlns:a16="http://schemas.microsoft.com/office/drawing/2014/main" id="{59D99581-2A1C-4D0C-8672-C961667688C0}"/>
               </a:ext>
             </a:extLst>
           </p:cNvPr>
@@ -2056,7 +2123,7 @@
           <p:cNvPr id="3" name="">
             <a:extLst xmlns:a="http://schemas.openxmlformats.org/drawingml/2006/main">
               <a:ext uri="{FF2B5EF4-FFF2-40B4-BE49-F238E27FC236}">
-                <a16:creationId xmlns:a16="http://schemas.microsoft.com/office/drawing/2014/main" id="{ED232ACF-A13F-4192-9AD8-C30CE7E378EC}"/>
+                <a16:creationId xmlns:a16="http://schemas.microsoft.com/office/drawing/2014/main" id="{D038FDC5-C479-49A3-8117-0EA5AC58C002}"/>
               </a:ext>
             </a:extLst>
           </p:cNvPr>
@@ -2106,7 +2173,7 @@
           <p:cNvPr id="4" name="">
             <a:extLst xmlns:a="http://schemas.openxmlformats.org/drawingml/2006/main">
               <a:ext uri="{FF2B5EF4-FFF2-40B4-BE49-F238E27FC236}">
-                <a16:creationId xmlns:a16="http://schemas.microsoft.com/office/drawing/2014/main" id="{B2B9F2DA-D573-4559-9FFF-47C11C7D0AA4}"/>
+                <a16:creationId xmlns:a16="http://schemas.microsoft.com/office/drawing/2014/main" id="{FD4403A8-37E3-4075-B560-E67617793979}"/>
               </a:ext>
             </a:extLst>
           </p:cNvPr>
@@ -2141,7 +2208,7 @@
           <p:cNvPr id="5" name="">
             <a:extLst xmlns:a="http://schemas.openxmlformats.org/drawingml/2006/main">
               <a:ext uri="{FF2B5EF4-FFF2-40B4-BE49-F238E27FC236}">
-                <a16:creationId xmlns:a16="http://schemas.microsoft.com/office/drawing/2014/main" id="{376A605F-C51F-4C6C-B7F6-97CD7934731B}"/>
+                <a16:creationId xmlns:a16="http://schemas.microsoft.com/office/drawing/2014/main" id="{BEB18E2C-609A-485D-8693-32FD01A06CB9}"/>
               </a:ext>
             </a:extLst>
           </p:cNvPr>
@@ -2191,7 +2258,7 @@
           <p:cNvPr id="6" name="">
             <a:extLst xmlns:a="http://schemas.openxmlformats.org/drawingml/2006/main">
               <a:ext uri="{FF2B5EF4-FFF2-40B4-BE49-F238E27FC236}">
-                <a16:creationId xmlns:a16="http://schemas.microsoft.com/office/drawing/2014/main" id="{3FD3B4CB-0407-4782-8CAE-FDFCF65373BD}"/>
+                <a16:creationId xmlns:a16="http://schemas.microsoft.com/office/drawing/2014/main" id="{CB59A9B9-23AF-4332-AA42-E764F10ADBC5}"/>
               </a:ext>
             </a:extLst>
           </p:cNvPr>
@@ -2241,7 +2308,7 @@
           <p:cNvPr id="7" name="">
             <a:extLst xmlns:a="http://schemas.openxmlformats.org/drawingml/2006/main">
               <a:ext uri="{FF2B5EF4-FFF2-40B4-BE49-F238E27FC236}">
-                <a16:creationId xmlns:a16="http://schemas.microsoft.com/office/drawing/2014/main" id="{A3BAA75E-F23C-4F30-B972-C2A1265B5C1B}"/>
+                <a16:creationId xmlns:a16="http://schemas.microsoft.com/office/drawing/2014/main" id="{E3C6C031-6524-428F-822B-BF3AEDA203DE}"/>
               </a:ext>
             </a:extLst>
           </p:cNvPr>
@@ -2289,7 +2356,7 @@
     </p:spTree>
     <p:extLst>
       <p:ext uri="{BB962C8B-B14F-4D97-AF65-F5344CB8AC3E}">
-        <p14:creationId xmlns:p14="http://schemas.microsoft.com/office/powerpoint/2010/main" val="563850745"/>
+        <p14:creationId xmlns:p14="http://schemas.microsoft.com/office/powerpoint/2010/main" val="355922960"/>
       </p:ext>
     </p:extLst>
   </p:cSld>
@@ -2320,7 +2387,7 @@
           <p:cNvPr id="1" name="">
             <a:extLst xmlns:a="http://schemas.openxmlformats.org/drawingml/2006/main">
               <a:ext uri="{FF2B5EF4-FFF2-40B4-BE49-F238E27FC236}">
-                <a16:creationId xmlns:a16="http://schemas.microsoft.com/office/drawing/2014/main" id="{23FC7A45-F790-4641-956E-1021CB3C1B51}"/>
+                <a16:creationId xmlns:a16="http://schemas.microsoft.com/office/drawing/2014/main" id="{D0F9134A-B2C0-4660-8A56-79B3ACB4A704}"/>
               </a:ext>
             </a:extLst>
           </p:cNvPr>
@@ -2370,7 +2437,7 @@
           <p:cNvPr id="2" name="">
             <a:extLst xmlns:a="http://schemas.openxmlformats.org/drawingml/2006/main">
               <a:ext uri="{FF2B5EF4-FFF2-40B4-BE49-F238E27FC236}">
-                <a16:creationId xmlns:a16="http://schemas.microsoft.com/office/drawing/2014/main" id="{29A9BC32-4796-4D97-AE25-5A65F73F16C3}"/>
+                <a16:creationId xmlns:a16="http://schemas.microsoft.com/office/drawing/2014/main" id="{CAB2261E-2117-442A-AB03-1E7B2F6BE58B}"/>
               </a:ext>
             </a:extLst>
           </p:cNvPr>
@@ -2420,7 +2487,7 @@
           <p:cNvPr id="3" name="">
             <a:extLst xmlns:a="http://schemas.openxmlformats.org/drawingml/2006/main">
               <a:ext uri="{FF2B5EF4-FFF2-40B4-BE49-F238E27FC236}">
-                <a16:creationId xmlns:a16="http://schemas.microsoft.com/office/drawing/2014/main" id="{E24DE787-D63A-4D71-8268-0A833CBE4F2B}"/>
+                <a16:creationId xmlns:a16="http://schemas.microsoft.com/office/drawing/2014/main" id="{2B693E31-E2D4-4A38-83B0-B6CC1242AA6B}"/>
               </a:ext>
             </a:extLst>
           </p:cNvPr>
@@ -2453,7 +2520,7 @@
           <p:cNvPr id="4" name="">
             <a:extLst xmlns:a="http://schemas.openxmlformats.org/drawingml/2006/main">
               <a:ext uri="{FF2B5EF4-FFF2-40B4-BE49-F238E27FC236}">
-                <a16:creationId xmlns:a16="http://schemas.microsoft.com/office/drawing/2014/main" id="{88341BA6-A0C7-4389-A348-0EDE8444AF55}"/>
+                <a16:creationId xmlns:a16="http://schemas.microsoft.com/office/drawing/2014/main" id="{21144CBD-EC85-47A2-A2DA-BFC5B46649F4}"/>
               </a:ext>
             </a:extLst>
           </p:cNvPr>
@@ -2488,7 +2555,7 @@
           <p:cNvPr id="5" name="">
             <a:extLst xmlns:a="http://schemas.openxmlformats.org/drawingml/2006/main">
               <a:ext uri="{FF2B5EF4-FFF2-40B4-BE49-F238E27FC236}">
-                <a16:creationId xmlns:a16="http://schemas.microsoft.com/office/drawing/2014/main" id="{946ECB9C-7386-4FAC-8147-EE10B7234CF0}"/>
+                <a16:creationId xmlns:a16="http://schemas.microsoft.com/office/drawing/2014/main" id="{F595C2AB-622C-46DA-92E0-E4824F8BA3E4}"/>
               </a:ext>
             </a:extLst>
           </p:cNvPr>
@@ -2538,7 +2605,7 @@
           <p:cNvPr id="6" name="">
             <a:extLst xmlns:a="http://schemas.openxmlformats.org/drawingml/2006/main">
               <a:ext uri="{FF2B5EF4-FFF2-40B4-BE49-F238E27FC236}">
-                <a16:creationId xmlns:a16="http://schemas.microsoft.com/office/drawing/2014/main" id="{C48F1386-E841-49EF-A08F-F88963D64767}"/>
+                <a16:creationId xmlns:a16="http://schemas.microsoft.com/office/drawing/2014/main" id="{C1B67922-11D4-457B-8C19-6152474089B2}"/>
               </a:ext>
             </a:extLst>
           </p:cNvPr>
@@ -2569,7 +2636,7 @@
           <p:cNvPr id="7" name="">
             <a:extLst xmlns:a="http://schemas.openxmlformats.org/drawingml/2006/main">
               <a:ext uri="{FF2B5EF4-FFF2-40B4-BE49-F238E27FC236}">
-                <a16:creationId xmlns:a16="http://schemas.microsoft.com/office/drawing/2014/main" id="{CEF94EC5-F88D-419C-8787-27A92ECAA2B2}"/>
+                <a16:creationId xmlns:a16="http://schemas.microsoft.com/office/drawing/2014/main" id="{04441526-D86A-4809-9451-5CD076450C1E}"/>
               </a:ext>
             </a:extLst>
           </p:cNvPr>
@@ -2619,7 +2686,7 @@
           <p:cNvPr id="8" name="">
             <a:extLst xmlns:a="http://schemas.openxmlformats.org/drawingml/2006/main">
               <a:ext uri="{FF2B5EF4-FFF2-40B4-BE49-F238E27FC236}">
-                <a16:creationId xmlns:a16="http://schemas.microsoft.com/office/drawing/2014/main" id="{D3ABC21C-1006-4A43-B782-46DF7D13F5E6}"/>
+                <a16:creationId xmlns:a16="http://schemas.microsoft.com/office/drawing/2014/main" id="{03134629-D0A3-4212-A7E2-CF785CA47556}"/>
               </a:ext>
             </a:extLst>
           </p:cNvPr>
@@ -2650,7 +2717,7 @@
           <p:cNvPr id="9" name="">
             <a:extLst xmlns:a="http://schemas.openxmlformats.org/drawingml/2006/main">
               <a:ext uri="{FF2B5EF4-FFF2-40B4-BE49-F238E27FC236}">
-                <a16:creationId xmlns:a16="http://schemas.microsoft.com/office/drawing/2014/main" id="{226EE91E-4877-4D4A-A319-37CFDBA3F934}"/>
+                <a16:creationId xmlns:a16="http://schemas.microsoft.com/office/drawing/2014/main" id="{312F420F-C7D7-4706-83C8-19BB37C00EE1}"/>
               </a:ext>
             </a:extLst>
           </p:cNvPr>
@@ -2700,7 +2767,7 @@
           <p:cNvPr id="10" name="">
             <a:extLst xmlns:a="http://schemas.openxmlformats.org/drawingml/2006/main">
               <a:ext uri="{FF2B5EF4-FFF2-40B4-BE49-F238E27FC236}">
-                <a16:creationId xmlns:a16="http://schemas.microsoft.com/office/drawing/2014/main" id="{AB940544-8A0A-4C1A-A2D3-56112916A610}"/>
+                <a16:creationId xmlns:a16="http://schemas.microsoft.com/office/drawing/2014/main" id="{F7C8F83F-E7A5-429A-BD1F-91A8A04286ED}"/>
               </a:ext>
             </a:extLst>
           </p:cNvPr>
@@ -2731,7 +2798,7 @@
           <p:cNvPr id="11" name="">
             <a:extLst xmlns:a="http://schemas.openxmlformats.org/drawingml/2006/main">
               <a:ext uri="{FF2B5EF4-FFF2-40B4-BE49-F238E27FC236}">
-                <a16:creationId xmlns:a16="http://schemas.microsoft.com/office/drawing/2014/main" id="{86CA11B9-23ED-4EA7-A27E-52D9F1B4D7B0}"/>
+                <a16:creationId xmlns:a16="http://schemas.microsoft.com/office/drawing/2014/main" id="{B10F79D4-6C0B-4F0A-A538-6D3A15CD359D}"/>
               </a:ext>
             </a:extLst>
           </p:cNvPr>
@@ -2781,7 +2848,7 @@
           <p:cNvPr id="12" name="">
             <a:extLst xmlns:a="http://schemas.openxmlformats.org/drawingml/2006/main">
               <a:ext uri="{FF2B5EF4-FFF2-40B4-BE49-F238E27FC236}">
-                <a16:creationId xmlns:a16="http://schemas.microsoft.com/office/drawing/2014/main" id="{618126D9-1435-48C4-99F2-63BC7F47CB9D}"/>
+                <a16:creationId xmlns:a16="http://schemas.microsoft.com/office/drawing/2014/main" id="{EBB49F8B-0263-490F-9D44-C6335DF435D3}"/>
               </a:ext>
             </a:extLst>
           </p:cNvPr>
@@ -2812,7 +2879,7 @@
           <p:cNvPr id="13" name="">
             <a:extLst xmlns:a="http://schemas.openxmlformats.org/drawingml/2006/main">
               <a:ext uri="{FF2B5EF4-FFF2-40B4-BE49-F238E27FC236}">
-                <a16:creationId xmlns:a16="http://schemas.microsoft.com/office/drawing/2014/main" id="{3AEBBC96-9B67-4488-8414-423F59D7463D}"/>
+                <a16:creationId xmlns:a16="http://schemas.microsoft.com/office/drawing/2014/main" id="{3ED7936D-AA14-42E4-B363-8217A4AE3BE0}"/>
               </a:ext>
             </a:extLst>
           </p:cNvPr>
@@ -2862,7 +2929,7 @@
           <p:cNvPr id="14" name="">
             <a:extLst xmlns:a="http://schemas.openxmlformats.org/drawingml/2006/main">
               <a:ext uri="{FF2B5EF4-FFF2-40B4-BE49-F238E27FC236}">
-                <a16:creationId xmlns:a16="http://schemas.microsoft.com/office/drawing/2014/main" id="{6F48D719-5AF5-42F6-8F17-11DA2E7ED6B8}"/>
+                <a16:creationId xmlns:a16="http://schemas.microsoft.com/office/drawing/2014/main" id="{BA0AC52F-13E8-4CBF-BA34-5B912240680A}"/>
               </a:ext>
             </a:extLst>
           </p:cNvPr>
@@ -2893,7 +2960,7 @@
           <p:cNvPr id="15" name="">
             <a:extLst xmlns:a="http://schemas.openxmlformats.org/drawingml/2006/main">
               <a:ext uri="{FF2B5EF4-FFF2-40B4-BE49-F238E27FC236}">
-                <a16:creationId xmlns:a16="http://schemas.microsoft.com/office/drawing/2014/main" id="{6EF81309-8F0C-412D-8A67-C6DB5089B12E}"/>
+                <a16:creationId xmlns:a16="http://schemas.microsoft.com/office/drawing/2014/main" id="{2DE07A93-3118-4255-ACD3-4166B8A118A1}"/>
               </a:ext>
             </a:extLst>
           </p:cNvPr>
@@ -2943,7 +3010,7 @@
           <p:cNvPr id="16" name="">
             <a:extLst xmlns:a="http://schemas.openxmlformats.org/drawingml/2006/main">
               <a:ext uri="{FF2B5EF4-FFF2-40B4-BE49-F238E27FC236}">
-                <a16:creationId xmlns:a16="http://schemas.microsoft.com/office/drawing/2014/main" id="{79B06206-3877-438C-B4D1-926C5A9916CA}"/>
+                <a16:creationId xmlns:a16="http://schemas.microsoft.com/office/drawing/2014/main" id="{73B03C8B-C1AE-4FC6-8724-20B9C7B7F543}"/>
               </a:ext>
             </a:extLst>
           </p:cNvPr>
@@ -2978,7 +3045,7 @@
           <p:cNvPr id="17" name="">
             <a:extLst xmlns:a="http://schemas.openxmlformats.org/drawingml/2006/main">
               <a:ext uri="{FF2B5EF4-FFF2-40B4-BE49-F238E27FC236}">
-                <a16:creationId xmlns:a16="http://schemas.microsoft.com/office/drawing/2014/main" id="{D4666629-F56D-4D53-AB7E-44ECB1F297AD}"/>
+                <a16:creationId xmlns:a16="http://schemas.microsoft.com/office/drawing/2014/main" id="{AC296602-EB28-49F0-9F0C-B3975742C4AE}"/>
               </a:ext>
             </a:extLst>
           </p:cNvPr>
@@ -3028,7 +3095,7 @@
           <p:cNvPr id="18" name="">
             <a:extLst xmlns:a="http://schemas.openxmlformats.org/drawingml/2006/main">
               <a:ext uri="{FF2B5EF4-FFF2-40B4-BE49-F238E27FC236}">
-                <a16:creationId xmlns:a16="http://schemas.microsoft.com/office/drawing/2014/main" id="{E20C6ADF-34D4-49F1-BCDF-3AFCDD95D209}"/>
+                <a16:creationId xmlns:a16="http://schemas.microsoft.com/office/drawing/2014/main" id="{A403CE8B-F00B-42EF-AABB-910B047ADE61}"/>
               </a:ext>
             </a:extLst>
           </p:cNvPr>
@@ -3059,7 +3126,7 @@
           <p:cNvPr id="19" name="">
             <a:extLst xmlns:a="http://schemas.openxmlformats.org/drawingml/2006/main">
               <a:ext uri="{FF2B5EF4-FFF2-40B4-BE49-F238E27FC236}">
-                <a16:creationId xmlns:a16="http://schemas.microsoft.com/office/drawing/2014/main" id="{7CC1659A-0079-400B-9CDD-D13683EE02CA}"/>
+                <a16:creationId xmlns:a16="http://schemas.microsoft.com/office/drawing/2014/main" id="{919247C3-DD73-4B51-A8C3-7094ADA2EE79}"/>
               </a:ext>
             </a:extLst>
           </p:cNvPr>
@@ -3109,7 +3176,7 @@
           <p:cNvPr id="20" name="">
             <a:extLst xmlns:a="http://schemas.openxmlformats.org/drawingml/2006/main">
               <a:ext uri="{FF2B5EF4-FFF2-40B4-BE49-F238E27FC236}">
-                <a16:creationId xmlns:a16="http://schemas.microsoft.com/office/drawing/2014/main" id="{6F37CB97-20AC-400D-AF2D-3AB96B633B85}"/>
+                <a16:creationId xmlns:a16="http://schemas.microsoft.com/office/drawing/2014/main" id="{1C7AFD57-0124-480C-B50D-A772EF90194A}"/>
               </a:ext>
             </a:extLst>
           </p:cNvPr>
@@ -3140,7 +3207,7 @@
           <p:cNvPr id="21" name="">
             <a:extLst xmlns:a="http://schemas.openxmlformats.org/drawingml/2006/main">
               <a:ext uri="{FF2B5EF4-FFF2-40B4-BE49-F238E27FC236}">
-                <a16:creationId xmlns:a16="http://schemas.microsoft.com/office/drawing/2014/main" id="{16BF09B5-2693-4564-B5CF-03A4D31DE5B2}"/>
+                <a16:creationId xmlns:a16="http://schemas.microsoft.com/office/drawing/2014/main" id="{F8FE5E65-0542-4DF5-809C-691E9EEAEB1A}"/>
               </a:ext>
             </a:extLst>
           </p:cNvPr>
@@ -3190,7 +3257,7 @@
           <p:cNvPr id="22" name="">
             <a:extLst xmlns:a="http://schemas.openxmlformats.org/drawingml/2006/main">
               <a:ext uri="{FF2B5EF4-FFF2-40B4-BE49-F238E27FC236}">
-                <a16:creationId xmlns:a16="http://schemas.microsoft.com/office/drawing/2014/main" id="{B92E38F8-E3EA-44F9-96D0-EE718C4C21F0}"/>
+                <a16:creationId xmlns:a16="http://schemas.microsoft.com/office/drawing/2014/main" id="{6329E18C-F325-4AAE-8C03-A5C32CB4C1A2}"/>
               </a:ext>
             </a:extLst>
           </p:cNvPr>
@@ -3221,7 +3288,7 @@
           <p:cNvPr id="23" name="">
             <a:extLst xmlns:a="http://schemas.openxmlformats.org/drawingml/2006/main">
               <a:ext uri="{FF2B5EF4-FFF2-40B4-BE49-F238E27FC236}">
-                <a16:creationId xmlns:a16="http://schemas.microsoft.com/office/drawing/2014/main" id="{E15FA4CF-E644-41F2-8418-05E4495488F2}"/>
+                <a16:creationId xmlns:a16="http://schemas.microsoft.com/office/drawing/2014/main" id="{20036279-6843-40A5-8BBE-E80C5687C76E}"/>
               </a:ext>
             </a:extLst>
           </p:cNvPr>
@@ -3271,7 +3338,7 @@
           <p:cNvPr id="24" name="">
             <a:extLst xmlns:a="http://schemas.openxmlformats.org/drawingml/2006/main">
               <a:ext uri="{FF2B5EF4-FFF2-40B4-BE49-F238E27FC236}">
-                <a16:creationId xmlns:a16="http://schemas.microsoft.com/office/drawing/2014/main" id="{977B37E7-8306-433D-B7C3-5E95DCFA8B8F}"/>
+                <a16:creationId xmlns:a16="http://schemas.microsoft.com/office/drawing/2014/main" id="{27A94E94-122B-428D-9750-10C59BA62880}"/>
               </a:ext>
             </a:extLst>
           </p:cNvPr>
@@ -3302,7 +3369,7 @@
           <p:cNvPr id="25" name="">
             <a:extLst xmlns:a="http://schemas.openxmlformats.org/drawingml/2006/main">
               <a:ext uri="{FF2B5EF4-FFF2-40B4-BE49-F238E27FC236}">
-                <a16:creationId xmlns:a16="http://schemas.microsoft.com/office/drawing/2014/main" id="{6C877C2E-399A-4358-91A6-A325F9805CE5}"/>
+                <a16:creationId xmlns:a16="http://schemas.microsoft.com/office/drawing/2014/main" id="{5A44AA0E-A1F1-4A0C-A3A1-B87CD2260468}"/>
               </a:ext>
             </a:extLst>
           </p:cNvPr>
@@ -3350,7 +3417,7 @@
     </p:spTree>
     <p:extLst>
       <p:ext uri="{BB962C8B-B14F-4D97-AF65-F5344CB8AC3E}">
-        <p14:creationId xmlns:p14="http://schemas.microsoft.com/office/powerpoint/2010/main" val="1282990229"/>
+        <p14:creationId xmlns:p14="http://schemas.microsoft.com/office/powerpoint/2010/main" val="1396399350"/>
       </p:ext>
     </p:extLst>
   </p:cSld>
@@ -3381,7 +3448,7 @@
           <p:cNvPr id="1" name="">
             <a:extLst xmlns:a="http://schemas.openxmlformats.org/drawingml/2006/main">
               <a:ext uri="{FF2B5EF4-FFF2-40B4-BE49-F238E27FC236}">
-                <a16:creationId xmlns:a16="http://schemas.microsoft.com/office/drawing/2014/main" id="{70CD79F7-CC52-4B5B-9E87-16A329432F58}"/>
+                <a16:creationId xmlns:a16="http://schemas.microsoft.com/office/drawing/2014/main" id="{249F7537-583E-4CDE-80E2-8B33C29FC1AD}"/>
               </a:ext>
             </a:extLst>
           </p:cNvPr>
@@ -3431,7 +3498,7 @@
           <p:cNvPr id="2" name="">
             <a:extLst xmlns:a="http://schemas.openxmlformats.org/drawingml/2006/main">
               <a:ext uri="{FF2B5EF4-FFF2-40B4-BE49-F238E27FC236}">
-                <a16:creationId xmlns:a16="http://schemas.microsoft.com/office/drawing/2014/main" id="{84C4786C-A965-468D-98B5-1E1DC94F5841}"/>
+                <a16:creationId xmlns:a16="http://schemas.microsoft.com/office/drawing/2014/main" id="{E6D2230D-2AF8-44DC-AE47-C9E67A7D6610}"/>
               </a:ext>
             </a:extLst>
           </p:cNvPr>
@@ -3481,7 +3548,7 @@
           <p:cNvPr id="3" name="">
             <a:extLst xmlns:a="http://schemas.openxmlformats.org/drawingml/2006/main">
               <a:ext uri="{FF2B5EF4-FFF2-40B4-BE49-F238E27FC236}">
-                <a16:creationId xmlns:a16="http://schemas.microsoft.com/office/drawing/2014/main" id="{14F1C752-0696-46AC-A71B-53B41F53F791}"/>
+                <a16:creationId xmlns:a16="http://schemas.microsoft.com/office/drawing/2014/main" id="{B437C5AE-8CC7-466A-9A5F-019174F60E37}"/>
               </a:ext>
             </a:extLst>
           </p:cNvPr>
@@ -3514,7 +3581,7 @@
           <p:cNvPr id="4" name="">
             <a:extLst xmlns:a="http://schemas.openxmlformats.org/drawingml/2006/main">
               <a:ext uri="{FF2B5EF4-FFF2-40B4-BE49-F238E27FC236}">
-                <a16:creationId xmlns:a16="http://schemas.microsoft.com/office/drawing/2014/main" id="{68EE189A-3DFF-4A5E-B1DE-9358766A46DA}"/>
+                <a16:creationId xmlns:a16="http://schemas.microsoft.com/office/drawing/2014/main" id="{D967A81E-87DB-467D-BD99-B4C8875E13CE}"/>
               </a:ext>
             </a:extLst>
           </p:cNvPr>
@@ -3549,7 +3616,7 @@
           <p:cNvPr id="5" name="">
             <a:extLst xmlns:a="http://schemas.openxmlformats.org/drawingml/2006/main">
               <a:ext uri="{FF2B5EF4-FFF2-40B4-BE49-F238E27FC236}">
-                <a16:creationId xmlns:a16="http://schemas.microsoft.com/office/drawing/2014/main" id="{5D4838EE-EB96-4EEC-832C-583C99B959FF}"/>
+                <a16:creationId xmlns:a16="http://schemas.microsoft.com/office/drawing/2014/main" id="{EFF8B982-3B6C-409D-9108-92612075EAC0}"/>
               </a:ext>
             </a:extLst>
           </p:cNvPr>
@@ -3599,7 +3666,7 @@
           <p:cNvPr id="6" name="">
             <a:extLst xmlns:a="http://schemas.openxmlformats.org/drawingml/2006/main">
               <a:ext uri="{FF2B5EF4-FFF2-40B4-BE49-F238E27FC236}">
-                <a16:creationId xmlns:a16="http://schemas.microsoft.com/office/drawing/2014/main" id="{C41DBB9B-A087-47E9-B5A0-840B923BE7AE}"/>
+                <a16:creationId xmlns:a16="http://schemas.microsoft.com/office/drawing/2014/main" id="{29337049-1753-4E42-8858-C251CD0EBB27}"/>
               </a:ext>
             </a:extLst>
           </p:cNvPr>
@@ -3649,7 +3716,7 @@
           <p:cNvPr id="7" name="">
             <a:extLst xmlns:a="http://schemas.openxmlformats.org/drawingml/2006/main">
               <a:ext uri="{FF2B5EF4-FFF2-40B4-BE49-F238E27FC236}">
-                <a16:creationId xmlns:a16="http://schemas.microsoft.com/office/drawing/2014/main" id="{97F24DF0-767F-4E4F-ABF6-110329071EF9}"/>
+                <a16:creationId xmlns:a16="http://schemas.microsoft.com/office/drawing/2014/main" id="{8742C28A-98AF-406F-B8EF-E9109F1309AF}"/>
               </a:ext>
             </a:extLst>
           </p:cNvPr>
@@ -3684,7 +3751,7 @@
           <p:cNvPr id="8" name="">
             <a:extLst xmlns:a="http://schemas.openxmlformats.org/drawingml/2006/main">
               <a:ext uri="{FF2B5EF4-FFF2-40B4-BE49-F238E27FC236}">
-                <a16:creationId xmlns:a16="http://schemas.microsoft.com/office/drawing/2014/main" id="{6AC8CE07-F207-43E9-B447-C4675B480F28}"/>
+                <a16:creationId xmlns:a16="http://schemas.microsoft.com/office/drawing/2014/main" id="{6DEBF121-9DC3-45DD-BBEF-73683C84EFF6}"/>
               </a:ext>
             </a:extLst>
           </p:cNvPr>
@@ -3734,7 +3801,7 @@
           <p:cNvPr id="9" name="">
             <a:extLst xmlns:a="http://schemas.openxmlformats.org/drawingml/2006/main">
               <a:ext uri="{FF2B5EF4-FFF2-40B4-BE49-F238E27FC236}">
-                <a16:creationId xmlns:a16="http://schemas.microsoft.com/office/drawing/2014/main" id="{49A7CF44-E324-476F-B66F-A92273B710CC}"/>
+                <a16:creationId xmlns:a16="http://schemas.microsoft.com/office/drawing/2014/main" id="{90027C1D-F24C-49B7-B2F3-C1966ECE8949}"/>
               </a:ext>
             </a:extLst>
           </p:cNvPr>
@@ -3784,7 +3851,7 @@
           <p:cNvPr id="10" name="">
             <a:extLst xmlns:a="http://schemas.openxmlformats.org/drawingml/2006/main">
               <a:ext uri="{FF2B5EF4-FFF2-40B4-BE49-F238E27FC236}">
-                <a16:creationId xmlns:a16="http://schemas.microsoft.com/office/drawing/2014/main" id="{E50BBEF9-5B1D-4F04-862D-80266BD1D07F}"/>
+                <a16:creationId xmlns:a16="http://schemas.microsoft.com/office/drawing/2014/main" id="{77F4463B-7216-4906-9F65-EEC1047BA9F9}"/>
               </a:ext>
             </a:extLst>
           </p:cNvPr>
@@ -3819,7 +3886,7 @@
           <p:cNvPr id="11" name="">
             <a:extLst xmlns:a="http://schemas.openxmlformats.org/drawingml/2006/main">
               <a:ext uri="{FF2B5EF4-FFF2-40B4-BE49-F238E27FC236}">
-                <a16:creationId xmlns:a16="http://schemas.microsoft.com/office/drawing/2014/main" id="{62F08763-2A0D-4849-9048-B4E69D45C0A8}"/>
+                <a16:creationId xmlns:a16="http://schemas.microsoft.com/office/drawing/2014/main" id="{ACFDE75D-5577-43C0-AAFE-3C51CBDEF3F7}"/>
               </a:ext>
             </a:extLst>
           </p:cNvPr>
@@ -3869,7 +3936,7 @@
           <p:cNvPr id="12" name="">
             <a:extLst xmlns:a="http://schemas.openxmlformats.org/drawingml/2006/main">
               <a:ext uri="{FF2B5EF4-FFF2-40B4-BE49-F238E27FC236}">
-                <a16:creationId xmlns:a16="http://schemas.microsoft.com/office/drawing/2014/main" id="{DDD8C620-B4FD-4BE9-996B-09E6C1796601}"/>
+                <a16:creationId xmlns:a16="http://schemas.microsoft.com/office/drawing/2014/main" id="{D48D45ED-25A2-4A04-9CE6-E845AB67E81B}"/>
               </a:ext>
             </a:extLst>
           </p:cNvPr>
@@ -3919,7 +3986,7 @@
           <p:cNvPr id="13" name="">
             <a:extLst xmlns:a="http://schemas.openxmlformats.org/drawingml/2006/main">
               <a:ext uri="{FF2B5EF4-FFF2-40B4-BE49-F238E27FC236}">
-                <a16:creationId xmlns:a16="http://schemas.microsoft.com/office/drawing/2014/main" id="{315AA798-8273-420D-953D-0C81C2AC7EB6}"/>
+                <a16:creationId xmlns:a16="http://schemas.microsoft.com/office/drawing/2014/main" id="{B596AF4E-E30D-4A71-9D76-945AB50C484B}"/>
               </a:ext>
             </a:extLst>
           </p:cNvPr>
@@ -3954,7 +4021,7 @@
           <p:cNvPr id="14" name="">
             <a:extLst xmlns:a="http://schemas.openxmlformats.org/drawingml/2006/main">
               <a:ext uri="{FF2B5EF4-FFF2-40B4-BE49-F238E27FC236}">
-                <a16:creationId xmlns:a16="http://schemas.microsoft.com/office/drawing/2014/main" id="{EBBE8E46-A404-4138-A0C0-323D2D4C38B5}"/>
+                <a16:creationId xmlns:a16="http://schemas.microsoft.com/office/drawing/2014/main" id="{A813CF60-63DA-4664-BF1F-0CA2A4CAFED5}"/>
               </a:ext>
             </a:extLst>
           </p:cNvPr>
@@ -4004,7 +4071,7 @@
           <p:cNvPr id="15" name="">
             <a:extLst xmlns:a="http://schemas.openxmlformats.org/drawingml/2006/main">
               <a:ext uri="{FF2B5EF4-FFF2-40B4-BE49-F238E27FC236}">
-                <a16:creationId xmlns:a16="http://schemas.microsoft.com/office/drawing/2014/main" id="{96F826CE-F39B-4959-BD8C-4B72E8A4DDBC}"/>
+                <a16:creationId xmlns:a16="http://schemas.microsoft.com/office/drawing/2014/main" id="{0FB1046F-2141-4944-A1F8-18AD9AD5F24F}"/>
               </a:ext>
             </a:extLst>
           </p:cNvPr>
@@ -4058,7 +4125,7 @@
           <p:nvPr/>
         </p:nvPicPr>
         <p:blipFill>
-          <a:blip xmlns:r="http://schemas.openxmlformats.org/officeDocument/2006/relationships" xmlns:a="http://schemas.openxmlformats.org/drawingml/2006/main" r:embed="R278f100491ba4b25"/>
+          <a:blip xmlns:r="http://schemas.openxmlformats.org/officeDocument/2006/relationships" xmlns:a="http://schemas.openxmlformats.org/drawingml/2006/main" r:embed="R00fde917fbcb4c62"/>
           <a:stretch xmlns:a="http://schemas.openxmlformats.org/drawingml/2006/main"/>
         </p:blipFill>
         <p:spPr>
@@ -4076,7 +4143,7 @@
           <p:cNvPr id="17" name="">
             <a:extLst xmlns:a="http://schemas.openxmlformats.org/drawingml/2006/main">
               <a:ext uri="{FF2B5EF4-FFF2-40B4-BE49-F238E27FC236}">
-                <a16:creationId xmlns:a16="http://schemas.microsoft.com/office/drawing/2014/main" id="{B6220455-213F-4FC2-A029-0A0A975BCF7D}"/>
+                <a16:creationId xmlns:a16="http://schemas.microsoft.com/office/drawing/2014/main" id="{B0A16371-B82E-4848-BDCE-4B76AD1EAD4E}"/>
               </a:ext>
             </a:extLst>
           </p:cNvPr>
@@ -4124,7 +4191,7 @@
     </p:spTree>
     <p:extLst>
       <p:ext uri="{BB962C8B-B14F-4D97-AF65-F5344CB8AC3E}">
-        <p14:creationId xmlns:p14="http://schemas.microsoft.com/office/powerpoint/2010/main" val="1358957094"/>
+        <p14:creationId xmlns:p14="http://schemas.microsoft.com/office/powerpoint/2010/main" val="1448227414"/>
       </p:ext>
     </p:extLst>
   </p:cSld>
@@ -4155,7 +4222,7 @@
           <p:cNvPr id="1" name="">
             <a:extLst xmlns:a="http://schemas.openxmlformats.org/drawingml/2006/main">
               <a:ext uri="{FF2B5EF4-FFF2-40B4-BE49-F238E27FC236}">
-                <a16:creationId xmlns:a16="http://schemas.microsoft.com/office/drawing/2014/main" id="{509C3F20-768F-423E-9B77-847C66881538}"/>
+                <a16:creationId xmlns:a16="http://schemas.microsoft.com/office/drawing/2014/main" id="{131E2AA2-27C8-43C7-8269-8728E6D51DE8}"/>
               </a:ext>
             </a:extLst>
           </p:cNvPr>
@@ -4205,7 +4272,7 @@
           <p:cNvPr id="2" name="">
             <a:extLst xmlns:a="http://schemas.openxmlformats.org/drawingml/2006/main">
               <a:ext uri="{FF2B5EF4-FFF2-40B4-BE49-F238E27FC236}">
-                <a16:creationId xmlns:a16="http://schemas.microsoft.com/office/drawing/2014/main" id="{2D13A5C7-EB63-489A-9AFC-4F47C39D9345}"/>
+                <a16:creationId xmlns:a16="http://schemas.microsoft.com/office/drawing/2014/main" id="{E1F25699-8E57-49C3-8705-F465473B8955}"/>
               </a:ext>
             </a:extLst>
           </p:cNvPr>
@@ -4255,7 +4322,7 @@
           <p:cNvPr id="3" name="">
             <a:extLst xmlns:a="http://schemas.openxmlformats.org/drawingml/2006/main">
               <a:ext uri="{FF2B5EF4-FFF2-40B4-BE49-F238E27FC236}">
-                <a16:creationId xmlns:a16="http://schemas.microsoft.com/office/drawing/2014/main" id="{F6FF025A-78A2-42A2-8D0B-FB7AA17B2A2A}"/>
+                <a16:creationId xmlns:a16="http://schemas.microsoft.com/office/drawing/2014/main" id="{CE311341-B0D5-4011-8E66-EC0B8E9B88E3}"/>
               </a:ext>
             </a:extLst>
           </p:cNvPr>
@@ -4292,7 +4359,7 @@
           <p:nvPr/>
         </p:nvPicPr>
         <p:blipFill>
-          <a:blip xmlns:r="http://schemas.openxmlformats.org/officeDocument/2006/relationships" xmlns:a="http://schemas.openxmlformats.org/drawingml/2006/main" r:embed="R79cdf432fdbc4868"/>
+          <a:blip xmlns:r="http://schemas.openxmlformats.org/officeDocument/2006/relationships" xmlns:a="http://schemas.openxmlformats.org/drawingml/2006/main" r:embed="Rc0afda9ebc1b4c29"/>
           <a:stretch xmlns:a="http://schemas.openxmlformats.org/drawingml/2006/main"/>
         </p:blipFill>
         <p:spPr>
@@ -4314,7 +4381,7 @@
           <p:nvPr/>
         </p:nvPicPr>
         <p:blipFill>
-          <a:blip xmlns:r="http://schemas.openxmlformats.org/officeDocument/2006/relationships" xmlns:a="http://schemas.openxmlformats.org/drawingml/2006/main" r:embed="R62952b35a6db4f65"/>
+          <a:blip xmlns:r="http://schemas.openxmlformats.org/officeDocument/2006/relationships" xmlns:a="http://schemas.openxmlformats.org/drawingml/2006/main" r:embed="R4e64226368784307"/>
           <a:stretch xmlns:a="http://schemas.openxmlformats.org/drawingml/2006/main"/>
         </p:blipFill>
         <p:spPr>
@@ -4332,7 +4399,7 @@
           <p:cNvPr id="6" name="">
             <a:extLst xmlns:a="http://schemas.openxmlformats.org/drawingml/2006/main">
               <a:ext uri="{FF2B5EF4-FFF2-40B4-BE49-F238E27FC236}">
-                <a16:creationId xmlns:a16="http://schemas.microsoft.com/office/drawing/2014/main" id="{C4AA4F32-5D3E-48CE-BE03-D089C827E0A2}"/>
+                <a16:creationId xmlns:a16="http://schemas.microsoft.com/office/drawing/2014/main" id="{3767862E-9659-48BE-82BA-6113549A717E}"/>
               </a:ext>
             </a:extLst>
           </p:cNvPr>
@@ -4380,7 +4447,7 @@
     </p:spTree>
     <p:extLst>
       <p:ext uri="{BB962C8B-B14F-4D97-AF65-F5344CB8AC3E}">
-        <p14:creationId xmlns:p14="http://schemas.microsoft.com/office/powerpoint/2010/main" val="766357857"/>
+        <p14:creationId xmlns:p14="http://schemas.microsoft.com/office/powerpoint/2010/main" val="2034478583"/>
       </p:ext>
     </p:extLst>
   </p:cSld>
@@ -4411,7 +4478,7 @@
           <p:cNvPr id="1" name="">
             <a:extLst xmlns:a="http://schemas.openxmlformats.org/drawingml/2006/main">
               <a:ext uri="{FF2B5EF4-FFF2-40B4-BE49-F238E27FC236}">
-                <a16:creationId xmlns:a16="http://schemas.microsoft.com/office/drawing/2014/main" id="{3A32EB45-078B-4261-8835-BB19AD1FEBA3}"/>
+                <a16:creationId xmlns:a16="http://schemas.microsoft.com/office/drawing/2014/main" id="{2E49CE19-4708-4CCB-9256-165C27CFEB2F}"/>
               </a:ext>
             </a:extLst>
           </p:cNvPr>
@@ -4461,7 +4528,7 @@
           <p:cNvPr id="2" name="">
             <a:extLst xmlns:a="http://schemas.openxmlformats.org/drawingml/2006/main">
               <a:ext uri="{FF2B5EF4-FFF2-40B4-BE49-F238E27FC236}">
-                <a16:creationId xmlns:a16="http://schemas.microsoft.com/office/drawing/2014/main" id="{1E237E4E-DC9D-4D4B-A15C-37818A57564F}"/>
+                <a16:creationId xmlns:a16="http://schemas.microsoft.com/office/drawing/2014/main" id="{9637C673-C2A4-4F73-9425-60168B86A4AD}"/>
               </a:ext>
             </a:extLst>
           </p:cNvPr>
@@ -4501,7 +4568,7 @@
                   <a:srgbClr val="111827"/>
                 </a:solidFill>
               </a:rPr>
-              <a:t>Next Gen5.3 slice: diagnose why bullish participation is still late</a:t>
+              <a:t>Representative trade tapes show the system joined the move but did not stay with enough of it</a:t>
             </a:r>
           </a:p>
         </p:txBody>
@@ -4511,7 +4578,7 @@
           <p:cNvPr id="3" name="">
             <a:extLst xmlns:a="http://schemas.openxmlformats.org/drawingml/2006/main">
               <a:ext uri="{FF2B5EF4-FFF2-40B4-BE49-F238E27FC236}">
-                <a16:creationId xmlns:a16="http://schemas.microsoft.com/office/drawing/2014/main" id="{AFC7B80E-D94E-41C7-A38A-5530914D5ABD}"/>
+                <a16:creationId xmlns:a16="http://schemas.microsoft.com/office/drawing/2014/main" id="{8E60BA35-98BB-48A4-B1AD-092AC13939A7}"/>
               </a:ext>
             </a:extLst>
           </p:cNvPr>
@@ -4539,12 +4606,655 @@
           </a:ln>
         </p:spPr>
       </p:sp>
+      <p:pic>
+        <p:nvPicPr>
+          <p:cNvPr id="19" name=""/>
+          <p:cNvPicPr>
+            <a:picLocks xmlns:a="http://schemas.openxmlformats.org/drawingml/2006/main" noChangeAspect="1"/>
+          </p:cNvPicPr>
+          <p:nvPr/>
+        </p:nvPicPr>
+        <p:blipFill>
+          <a:blip xmlns:r="http://schemas.openxmlformats.org/officeDocument/2006/relationships" xmlns:a="http://schemas.openxmlformats.org/drawingml/2006/main" r:embed="R1e78d08c35044ac2"/>
+          <a:stretch xmlns:a="http://schemas.openxmlformats.org/drawingml/2006/main"/>
+        </p:blipFill>
+        <p:spPr>
+          <a:xfrm xmlns:a="http://schemas.openxmlformats.org/drawingml/2006/main">
+            <a:off x="1225717" y="1695450"/>
+            <a:ext cx="5930566" cy="4333875"/>
+          </a:xfrm>
+          <a:prstGeom xmlns:a="http://schemas.openxmlformats.org/drawingml/2006/main" prst="rect">
+            <a:avLst/>
+          </a:prstGeom>
+        </p:spPr>
+      </p:pic>
+      <p:sp>
+        <p:nvSpPr>
+          <p:cNvPr id="5" name="">
+            <a:extLst xmlns:a="http://schemas.openxmlformats.org/drawingml/2006/main">
+              <a:ext uri="{FF2B5EF4-FFF2-40B4-BE49-F238E27FC236}">
+                <a16:creationId xmlns:a16="http://schemas.microsoft.com/office/drawing/2014/main" id="{CDC7019C-E289-4BCC-A149-EEF64D8D6327}"/>
+              </a:ext>
+            </a:extLst>
+          </p:cNvPr>
+          <p:cNvSpPr>
+            <a:spLocks xmlns:a="http://schemas.openxmlformats.org/drawingml/2006/main" noGrp="1"/>
+          </p:cNvSpPr>
+          <p:nvPr/>
+        </p:nvSpPr>
+        <p:spPr>
+          <a:xfrm xmlns:a="http://schemas.openxmlformats.org/drawingml/2006/main">
+            <a:off x="8229600" y="1962150"/>
+            <a:ext cx="3048000" cy="3219450"/>
+          </a:xfrm>
+          <a:prstGeom xmlns:a="http://schemas.openxmlformats.org/drawingml/2006/main" prst="roundRect">
+            <a:avLst>
+              <a:gd name="adj" fmla="val 2500"/>
+            </a:avLst>
+          </a:prstGeom>
+          <a:solidFill xmlns:a="http://schemas.openxmlformats.org/drawingml/2006/main">
+            <a:srgbClr val="F8FAFC"/>
+          </a:solidFill>
+          <a:ln xmlns:a="http://schemas.openxmlformats.org/drawingml/2006/main" w="9525">
+            <a:solidFill>
+              <a:srgbClr val="D7DEE8"/>
+            </a:solidFill>
+            <a:prstDash val="solid"/>
+          </a:ln>
+        </p:spPr>
+      </p:sp>
+      <p:sp>
+        <p:nvSpPr>
+          <p:cNvPr id="6" name="">
+            <a:extLst xmlns:a="http://schemas.openxmlformats.org/drawingml/2006/main">
+              <a:ext uri="{FF2B5EF4-FFF2-40B4-BE49-F238E27FC236}">
+                <a16:creationId xmlns:a16="http://schemas.microsoft.com/office/drawing/2014/main" id="{220AB060-612F-47B2-81A0-AFBD6C5321CF}"/>
+              </a:ext>
+            </a:extLst>
+          </p:cNvPr>
+          <p:cNvSpPr>
+            <a:spLocks xmlns:a="http://schemas.openxmlformats.org/drawingml/2006/main" noGrp="1"/>
+          </p:cNvSpPr>
+          <p:nvPr/>
+        </p:nvSpPr>
+        <p:spPr>
+          <a:xfrm xmlns:a="http://schemas.openxmlformats.org/drawingml/2006/main">
+            <a:off x="8515350" y="2247900"/>
+            <a:ext cx="2381250" cy="285750"/>
+          </a:xfrm>
+          <a:prstGeom xmlns:a="http://schemas.openxmlformats.org/drawingml/2006/main" prst="rect">
+            <a:avLst/>
+          </a:prstGeom>
+          <a:noFill xmlns:a="http://schemas.openxmlformats.org/drawingml/2006/main"/>
+          <a:ln xmlns:a="http://schemas.openxmlformats.org/drawingml/2006/main" w="0">
+            <a:noFill/>
+            <a:prstDash val="solid"/>
+          </a:ln>
+        </p:spPr>
+        <p:txBody>
+          <a:bodyPr xmlns:a="http://schemas.openxmlformats.org/drawingml/2006/main"/>
+          <a:lstStyle xmlns:a="http://schemas.openxmlformats.org/drawingml/2006/main"/>
+          <a:p xmlns:a="http://schemas.openxmlformats.org/drawingml/2006/main">
+            <a:pPr>
+              <a:defRPr sz="1875" b="1">
+                <a:solidFill>
+                  <a:srgbClr val="111827"/>
+                </a:solidFill>
+              </a:defRPr>
+            </a:pPr>
+            <a:r>
+              <a:rPr sz="1875" b="1">
+                <a:solidFill>
+                  <a:srgbClr val="111827"/>
+                </a:solidFill>
+              </a:rPr>
+              <a:t>What to look for</a:t>
+            </a:r>
+          </a:p>
+        </p:txBody>
+      </p:sp>
+      <p:sp>
+        <p:nvSpPr>
+          <p:cNvPr id="7" name="">
+            <a:extLst xmlns:a="http://schemas.openxmlformats.org/drawingml/2006/main">
+              <a:ext uri="{FF2B5EF4-FFF2-40B4-BE49-F238E27FC236}">
+                <a16:creationId xmlns:a16="http://schemas.microsoft.com/office/drawing/2014/main" id="{76027923-78BB-48AE-9339-92859393047A}"/>
+              </a:ext>
+            </a:extLst>
+          </p:cNvPr>
+          <p:cNvSpPr>
+            <a:spLocks xmlns:a="http://schemas.openxmlformats.org/drawingml/2006/main" noGrp="1"/>
+          </p:cNvSpPr>
+          <p:nvPr/>
+        </p:nvSpPr>
+        <p:spPr>
+          <a:xfrm xmlns:a="http://schemas.openxmlformats.org/drawingml/2006/main">
+            <a:off x="8534400" y="2905125"/>
+            <a:ext cx="76200" cy="76200"/>
+          </a:xfrm>
+          <a:prstGeom xmlns:a="http://schemas.openxmlformats.org/drawingml/2006/main" prst="ellipse">
+            <a:avLst/>
+          </a:prstGeom>
+          <a:solidFill xmlns:a="http://schemas.openxmlformats.org/drawingml/2006/main">
+            <a:srgbClr val="D97706"/>
+          </a:solidFill>
+          <a:ln xmlns:a="http://schemas.openxmlformats.org/drawingml/2006/main" w="0">
+            <a:noFill/>
+            <a:prstDash val="solid"/>
+          </a:ln>
+        </p:spPr>
+      </p:sp>
+      <p:sp>
+        <p:nvSpPr>
+          <p:cNvPr id="8" name="">
+            <a:extLst xmlns:a="http://schemas.openxmlformats.org/drawingml/2006/main">
+              <a:ext uri="{FF2B5EF4-FFF2-40B4-BE49-F238E27FC236}">
+                <a16:creationId xmlns:a16="http://schemas.microsoft.com/office/drawing/2014/main" id="{5AADE182-F029-433F-A645-126896DFFDFD}"/>
+              </a:ext>
+            </a:extLst>
+          </p:cNvPr>
+          <p:cNvSpPr>
+            <a:spLocks xmlns:a="http://schemas.openxmlformats.org/drawingml/2006/main" noGrp="1"/>
+          </p:cNvSpPr>
+          <p:nvPr/>
+        </p:nvSpPr>
+        <p:spPr>
+          <a:xfrm xmlns:a="http://schemas.openxmlformats.org/drawingml/2006/main">
+            <a:off x="8743950" y="2819400"/>
+            <a:ext cx="2152650" cy="533400"/>
+          </a:xfrm>
+          <a:prstGeom xmlns:a="http://schemas.openxmlformats.org/drawingml/2006/main" prst="rect">
+            <a:avLst/>
+          </a:prstGeom>
+          <a:noFill xmlns:a="http://schemas.openxmlformats.org/drawingml/2006/main"/>
+          <a:ln xmlns:a="http://schemas.openxmlformats.org/drawingml/2006/main" w="0">
+            <a:noFill/>
+            <a:prstDash val="solid"/>
+          </a:ln>
+        </p:spPr>
+        <p:txBody>
+          <a:bodyPr xmlns:a="http://schemas.openxmlformats.org/drawingml/2006/main"/>
+          <a:lstStyle xmlns:a="http://schemas.openxmlformats.org/drawingml/2006/main"/>
+          <a:p xmlns:a="http://schemas.openxmlformats.org/drawingml/2006/main">
+            <a:pPr>
+              <a:defRPr sz="1125" b="0">
+                <a:solidFill>
+                  <a:srgbClr val="111827"/>
+                </a:solidFill>
+              </a:defRPr>
+            </a:pPr>
+            <a:r>
+              <a:rPr sz="1125" b="0">
+                <a:solidFill>
+                  <a:srgbClr val="111827"/>
+                </a:solidFill>
+              </a:rPr>
+              <a:t>Blue markers are entries; yellow markers are exits.</a:t>
+            </a:r>
+          </a:p>
+        </p:txBody>
+      </p:sp>
+      <p:sp>
+        <p:nvSpPr>
+          <p:cNvPr id="9" name="">
+            <a:extLst xmlns:a="http://schemas.openxmlformats.org/drawingml/2006/main">
+              <a:ext uri="{FF2B5EF4-FFF2-40B4-BE49-F238E27FC236}">
+                <a16:creationId xmlns:a16="http://schemas.microsoft.com/office/drawing/2014/main" id="{E2F121F3-A0E9-4F50-9C4C-E3136732FE8F}"/>
+              </a:ext>
+            </a:extLst>
+          </p:cNvPr>
+          <p:cNvSpPr>
+            <a:spLocks xmlns:a="http://schemas.openxmlformats.org/drawingml/2006/main" noGrp="1"/>
+          </p:cNvSpPr>
+          <p:nvPr/>
+        </p:nvSpPr>
+        <p:spPr>
+          <a:xfrm xmlns:a="http://schemas.openxmlformats.org/drawingml/2006/main">
+            <a:off x="8534400" y="3400425"/>
+            <a:ext cx="76200" cy="76200"/>
+          </a:xfrm>
+          <a:prstGeom xmlns:a="http://schemas.openxmlformats.org/drawingml/2006/main" prst="ellipse">
+            <a:avLst/>
+          </a:prstGeom>
+          <a:solidFill xmlns:a="http://schemas.openxmlformats.org/drawingml/2006/main">
+            <a:srgbClr val="D97706"/>
+          </a:solidFill>
+          <a:ln xmlns:a="http://schemas.openxmlformats.org/drawingml/2006/main" w="0">
+            <a:noFill/>
+            <a:prstDash val="solid"/>
+          </a:ln>
+        </p:spPr>
+      </p:sp>
+      <p:sp>
+        <p:nvSpPr>
+          <p:cNvPr id="10" name="">
+            <a:extLst xmlns:a="http://schemas.openxmlformats.org/drawingml/2006/main">
+              <a:ext uri="{FF2B5EF4-FFF2-40B4-BE49-F238E27FC236}">
+                <a16:creationId xmlns:a16="http://schemas.microsoft.com/office/drawing/2014/main" id="{1EA18AB2-A17F-42E3-8199-678CCBE02E13}"/>
+              </a:ext>
+            </a:extLst>
+          </p:cNvPr>
+          <p:cNvSpPr>
+            <a:spLocks xmlns:a="http://schemas.openxmlformats.org/drawingml/2006/main" noGrp="1"/>
+          </p:cNvSpPr>
+          <p:nvPr/>
+        </p:nvSpPr>
+        <p:spPr>
+          <a:xfrm xmlns:a="http://schemas.openxmlformats.org/drawingml/2006/main">
+            <a:off x="8743950" y="3314700"/>
+            <a:ext cx="2152650" cy="533400"/>
+          </a:xfrm>
+          <a:prstGeom xmlns:a="http://schemas.openxmlformats.org/drawingml/2006/main" prst="rect">
+            <a:avLst/>
+          </a:prstGeom>
+          <a:noFill xmlns:a="http://schemas.openxmlformats.org/drawingml/2006/main"/>
+          <a:ln xmlns:a="http://schemas.openxmlformats.org/drawingml/2006/main" w="0">
+            <a:noFill/>
+            <a:prstDash val="solid"/>
+          </a:ln>
+        </p:spPr>
+        <p:txBody>
+          <a:bodyPr xmlns:a="http://schemas.openxmlformats.org/drawingml/2006/main"/>
+          <a:lstStyle xmlns:a="http://schemas.openxmlformats.org/drawingml/2006/main"/>
+          <a:p xmlns:a="http://schemas.openxmlformats.org/drawingml/2006/main">
+            <a:pPr>
+              <a:defRPr sz="1125" b="0">
+                <a:solidFill>
+                  <a:srgbClr val="111827"/>
+                </a:solidFill>
+              </a:defRPr>
+            </a:pPr>
+            <a:r>
+              <a:rPr sz="1125" b="0">
+                <a:solidFill>
+                  <a:srgbClr val="111827"/>
+                </a:solidFill>
+              </a:rPr>
+              <a:t>Dashed lines trace completed or open trades.</a:t>
+            </a:r>
+          </a:p>
+        </p:txBody>
+      </p:sp>
+      <p:sp>
+        <p:nvSpPr>
+          <p:cNvPr id="11" name="">
+            <a:extLst xmlns:a="http://schemas.openxmlformats.org/drawingml/2006/main">
+              <a:ext uri="{FF2B5EF4-FFF2-40B4-BE49-F238E27FC236}">
+                <a16:creationId xmlns:a16="http://schemas.microsoft.com/office/drawing/2014/main" id="{5AA48097-B65D-4190-A1FF-66D0BAA83209}"/>
+              </a:ext>
+            </a:extLst>
+          </p:cNvPr>
+          <p:cNvSpPr>
+            <a:spLocks xmlns:a="http://schemas.openxmlformats.org/drawingml/2006/main" noGrp="1"/>
+          </p:cNvSpPr>
+          <p:nvPr/>
+        </p:nvSpPr>
+        <p:spPr>
+          <a:xfrm xmlns:a="http://schemas.openxmlformats.org/drawingml/2006/main">
+            <a:off x="8534400" y="3895725"/>
+            <a:ext cx="76200" cy="76200"/>
+          </a:xfrm>
+          <a:prstGeom xmlns:a="http://schemas.openxmlformats.org/drawingml/2006/main" prst="ellipse">
+            <a:avLst/>
+          </a:prstGeom>
+          <a:solidFill xmlns:a="http://schemas.openxmlformats.org/drawingml/2006/main">
+            <a:srgbClr val="D97706"/>
+          </a:solidFill>
+          <a:ln xmlns:a="http://schemas.openxmlformats.org/drawingml/2006/main" w="0">
+            <a:noFill/>
+            <a:prstDash val="solid"/>
+          </a:ln>
+        </p:spPr>
+      </p:sp>
+      <p:sp>
+        <p:nvSpPr>
+          <p:cNvPr id="12" name="">
+            <a:extLst xmlns:a="http://schemas.openxmlformats.org/drawingml/2006/main">
+              <a:ext uri="{FF2B5EF4-FFF2-40B4-BE49-F238E27FC236}">
+                <a16:creationId xmlns:a16="http://schemas.microsoft.com/office/drawing/2014/main" id="{8808AEC8-3A93-4578-97B3-AEFD798C2CAF}"/>
+              </a:ext>
+            </a:extLst>
+          </p:cNvPr>
+          <p:cNvSpPr>
+            <a:spLocks xmlns:a="http://schemas.openxmlformats.org/drawingml/2006/main" noGrp="1"/>
+          </p:cNvSpPr>
+          <p:nvPr/>
+        </p:nvSpPr>
+        <p:spPr>
+          <a:xfrm xmlns:a="http://schemas.openxmlformats.org/drawingml/2006/main">
+            <a:off x="8743950" y="3810000"/>
+            <a:ext cx="2152650" cy="533400"/>
+          </a:xfrm>
+          <a:prstGeom xmlns:a="http://schemas.openxmlformats.org/drawingml/2006/main" prst="rect">
+            <a:avLst/>
+          </a:prstGeom>
+          <a:noFill xmlns:a="http://schemas.openxmlformats.org/drawingml/2006/main"/>
+          <a:ln xmlns:a="http://schemas.openxmlformats.org/drawingml/2006/main" w="0">
+            <a:noFill/>
+            <a:prstDash val="solid"/>
+          </a:ln>
+        </p:spPr>
+        <p:txBody>
+          <a:bodyPr xmlns:a="http://schemas.openxmlformats.org/drawingml/2006/main"/>
+          <a:lstStyle xmlns:a="http://schemas.openxmlformats.org/drawingml/2006/main"/>
+          <a:p xmlns:a="http://schemas.openxmlformats.org/drawingml/2006/main">
+            <a:pPr>
+              <a:defRPr sz="1125" b="0">
+                <a:solidFill>
+                  <a:srgbClr val="111827"/>
+                </a:solidFill>
+              </a:defRPr>
+            </a:pPr>
+            <a:r>
+              <a:rPr sz="1125" b="0">
+                <a:solidFill>
+                  <a:srgbClr val="111827"/>
+                </a:solidFill>
+              </a:rPr>
+              <a:t>State bands often change after the trend is underway.</a:t>
+            </a:r>
+          </a:p>
+        </p:txBody>
+      </p:sp>
+      <p:sp>
+        <p:nvSpPr>
+          <p:cNvPr id="13" name="">
+            <a:extLst xmlns:a="http://schemas.openxmlformats.org/drawingml/2006/main">
+              <a:ext uri="{FF2B5EF4-FFF2-40B4-BE49-F238E27FC236}">
+                <a16:creationId xmlns:a16="http://schemas.microsoft.com/office/drawing/2014/main" id="{BAFD8EAD-356B-46D5-9303-840C642D623B}"/>
+              </a:ext>
+            </a:extLst>
+          </p:cNvPr>
+          <p:cNvSpPr>
+            <a:spLocks xmlns:a="http://schemas.openxmlformats.org/drawingml/2006/main" noGrp="1"/>
+          </p:cNvSpPr>
+          <p:nvPr/>
+        </p:nvSpPr>
+        <p:spPr>
+          <a:xfrm xmlns:a="http://schemas.openxmlformats.org/drawingml/2006/main">
+            <a:off x="8534400" y="4391025"/>
+            <a:ext cx="76200" cy="76200"/>
+          </a:xfrm>
+          <a:prstGeom xmlns:a="http://schemas.openxmlformats.org/drawingml/2006/main" prst="ellipse">
+            <a:avLst/>
+          </a:prstGeom>
+          <a:solidFill xmlns:a="http://schemas.openxmlformats.org/drawingml/2006/main">
+            <a:srgbClr val="D97706"/>
+          </a:solidFill>
+          <a:ln xmlns:a="http://schemas.openxmlformats.org/drawingml/2006/main" w="0">
+            <a:noFill/>
+            <a:prstDash val="solid"/>
+          </a:ln>
+        </p:spPr>
+      </p:sp>
+      <p:sp>
+        <p:nvSpPr>
+          <p:cNvPr id="14" name="">
+            <a:extLst xmlns:a="http://schemas.openxmlformats.org/drawingml/2006/main">
+              <a:ext uri="{FF2B5EF4-FFF2-40B4-BE49-F238E27FC236}">
+                <a16:creationId xmlns:a16="http://schemas.microsoft.com/office/drawing/2014/main" id="{66B06686-B98F-42CD-A7E4-0DF90FE4DE7D}"/>
+              </a:ext>
+            </a:extLst>
+          </p:cNvPr>
+          <p:cNvSpPr>
+            <a:spLocks xmlns:a="http://schemas.openxmlformats.org/drawingml/2006/main" noGrp="1"/>
+          </p:cNvSpPr>
+          <p:nvPr/>
+        </p:nvSpPr>
+        <p:spPr>
+          <a:xfrm xmlns:a="http://schemas.openxmlformats.org/drawingml/2006/main">
+            <a:off x="8743950" y="4305300"/>
+            <a:ext cx="2152650" cy="533400"/>
+          </a:xfrm>
+          <a:prstGeom xmlns:a="http://schemas.openxmlformats.org/drawingml/2006/main" prst="rect">
+            <a:avLst/>
+          </a:prstGeom>
+          <a:noFill xmlns:a="http://schemas.openxmlformats.org/drawingml/2006/main"/>
+          <a:ln xmlns:a="http://schemas.openxmlformats.org/drawingml/2006/main" w="0">
+            <a:noFill/>
+            <a:prstDash val="solid"/>
+          </a:ln>
+        </p:spPr>
+        <p:txBody>
+          <a:bodyPr xmlns:a="http://schemas.openxmlformats.org/drawingml/2006/main"/>
+          <a:lstStyle xmlns:a="http://schemas.openxmlformats.org/drawingml/2006/main"/>
+          <a:p xmlns:a="http://schemas.openxmlformats.org/drawingml/2006/main">
+            <a:pPr>
+              <a:defRPr sz="1125" b="0">
+                <a:solidFill>
+                  <a:srgbClr val="111827"/>
+                </a:solidFill>
+              </a:defRPr>
+            </a:pPr>
+            <a:r>
+              <a:rPr sz="1125" b="0">
+                <a:solidFill>
+                  <a:srgbClr val="111827"/>
+                </a:solidFill>
+              </a:rPr>
+              <a:t>Continuation helps, but it still misses part of the move.</a:t>
+            </a:r>
+          </a:p>
+        </p:txBody>
+      </p:sp>
+      <p:sp>
+        <p:nvSpPr>
+          <p:cNvPr id="15" name="">
+            <a:extLst xmlns:a="http://schemas.openxmlformats.org/drawingml/2006/main">
+              <a:ext uri="{FF2B5EF4-FFF2-40B4-BE49-F238E27FC236}">
+                <a16:creationId xmlns:a16="http://schemas.microsoft.com/office/drawing/2014/main" id="{6DD43B7F-4896-47BD-A452-F2C9CE6E0324}"/>
+              </a:ext>
+            </a:extLst>
+          </p:cNvPr>
+          <p:cNvSpPr>
+            <a:spLocks xmlns:a="http://schemas.openxmlformats.org/drawingml/2006/main" noGrp="1"/>
+          </p:cNvSpPr>
+          <p:nvPr/>
+        </p:nvSpPr>
+        <p:spPr>
+          <a:xfrm xmlns:a="http://schemas.openxmlformats.org/drawingml/2006/main">
+            <a:off x="1123950" y="6172200"/>
+            <a:ext cx="9334500" cy="285750"/>
+          </a:xfrm>
+          <a:prstGeom xmlns:a="http://schemas.openxmlformats.org/drawingml/2006/main" prst="rect">
+            <a:avLst/>
+          </a:prstGeom>
+          <a:noFill xmlns:a="http://schemas.openxmlformats.org/drawingml/2006/main"/>
+          <a:ln xmlns:a="http://schemas.openxmlformats.org/drawingml/2006/main" w="0">
+            <a:noFill/>
+            <a:prstDash val="solid"/>
+          </a:ln>
+        </p:spPr>
+        <p:txBody>
+          <a:bodyPr xmlns:a="http://schemas.openxmlformats.org/drawingml/2006/main"/>
+          <a:lstStyle xmlns:a="http://schemas.openxmlformats.org/drawingml/2006/main"/>
+          <a:p xmlns:a="http://schemas.openxmlformats.org/drawingml/2006/main">
+            <a:pPr algn="ctr">
+              <a:defRPr sz="1350" b="1">
+                <a:solidFill>
+                  <a:srgbClr val="111827"/>
+                </a:solidFill>
+              </a:defRPr>
+            </a:pPr>
+            <a:r>
+              <a:rPr sz="1350" b="1">
+                <a:solidFill>
+                  <a:srgbClr val="111827"/>
+                </a:solidFill>
+              </a:rPr>
+              <a:t>For exploratory POCs, include representative trade tapes whenever timing, participation, or state behavior is central.</a:t>
+            </a:r>
+          </a:p>
+        </p:txBody>
+      </p:sp>
+    </p:spTree>
+    <p:extLst>
+      <p:ext uri="{BB962C8B-B14F-4D97-AF65-F5344CB8AC3E}">
+        <p14:creationId xmlns:p14="http://schemas.microsoft.com/office/powerpoint/2010/main" val="1650519962"/>
+      </p:ext>
+    </p:extLst>
+  </p:cSld>
+</p:sld>
+</file>
+
+<file path=ppt/slides/slide14.xml><?xml version="1.0" encoding="utf-8"?>
+<p:sld xmlns:p="http://schemas.openxmlformats.org/presentationml/2006/main">
+  <p:cSld>
+    <p:bg>
+      <p:bgPr>
+        <a:solidFill xmlns:a="http://schemas.openxmlformats.org/drawingml/2006/main">
+          <a:srgbClr val="FFFFFF"/>
+        </a:solidFill>
+      </p:bgPr>
+    </p:bg>
+    <p:spTree>
+      <p:nvGrpSpPr>
+        <p:cNvPr id="1" name=""/>
+        <p:cNvGrpSpPr/>
+        <p:nvPr/>
+      </p:nvGrpSpPr>
+      <p:grpSpPr>
+        <a:xfrm xmlns:a="http://schemas.openxmlformats.org/drawingml/2006/main"/>
+      </p:grpSpPr>
+      <p:sp>
+        <p:nvSpPr>
+          <p:cNvPr id="1" name="">
+            <a:extLst xmlns:a="http://schemas.openxmlformats.org/drawingml/2006/main">
+              <a:ext uri="{FF2B5EF4-FFF2-40B4-BE49-F238E27FC236}">
+                <a16:creationId xmlns:a16="http://schemas.microsoft.com/office/drawing/2014/main" id="{E9D326F1-D9B4-4207-863E-76E2C37C77DE}"/>
+              </a:ext>
+            </a:extLst>
+          </p:cNvPr>
+          <p:cNvSpPr>
+            <a:spLocks xmlns:a="http://schemas.openxmlformats.org/drawingml/2006/main" noGrp="1"/>
+          </p:cNvSpPr>
+          <p:nvPr/>
+        </p:nvSpPr>
+        <p:spPr>
+          <a:xfrm xmlns:a="http://schemas.openxmlformats.org/drawingml/2006/main">
+            <a:off x="609600" y="304800"/>
+            <a:ext cx="5334000" cy="209550"/>
+          </a:xfrm>
+          <a:prstGeom xmlns:a="http://schemas.openxmlformats.org/drawingml/2006/main" prst="rect">
+            <a:avLst/>
+          </a:prstGeom>
+          <a:noFill xmlns:a="http://schemas.openxmlformats.org/drawingml/2006/main"/>
+          <a:ln xmlns:a="http://schemas.openxmlformats.org/drawingml/2006/main" w="0">
+            <a:noFill/>
+            <a:prstDash val="solid"/>
+          </a:ln>
+        </p:spPr>
+        <p:txBody>
+          <a:bodyPr xmlns:a="http://schemas.openxmlformats.org/drawingml/2006/main"/>
+          <a:lstStyle xmlns:a="http://schemas.openxmlformats.org/drawingml/2006/main"/>
+          <a:p xmlns:a="http://schemas.openxmlformats.org/drawingml/2006/main">
+            <a:pPr>
+              <a:defRPr sz="975" b="1">
+                <a:solidFill>
+                  <a:srgbClr val="2563EB"/>
+                </a:solidFill>
+              </a:defRPr>
+            </a:pPr>
+            <a:r>
+              <a:rPr sz="975" b="1">
+                <a:solidFill>
+                  <a:srgbClr val="2563EB"/>
+                </a:solidFill>
+              </a:rPr>
+              <a:t>GEN5.3 PCA RESEARCH PIVOT</a:t>
+            </a:r>
+          </a:p>
+        </p:txBody>
+      </p:sp>
+      <p:sp>
+        <p:nvSpPr>
+          <p:cNvPr id="2" name="">
+            <a:extLst xmlns:a="http://schemas.openxmlformats.org/drawingml/2006/main">
+              <a:ext uri="{FF2B5EF4-FFF2-40B4-BE49-F238E27FC236}">
+                <a16:creationId xmlns:a16="http://schemas.microsoft.com/office/drawing/2014/main" id="{E586E8DD-493E-4A39-8FF3-35A16863F5FE}"/>
+              </a:ext>
+            </a:extLst>
+          </p:cNvPr>
+          <p:cNvSpPr>
+            <a:spLocks xmlns:a="http://schemas.openxmlformats.org/drawingml/2006/main" noGrp="1"/>
+          </p:cNvSpPr>
+          <p:nvPr/>
+        </p:nvSpPr>
+        <p:spPr>
+          <a:xfrm xmlns:a="http://schemas.openxmlformats.org/drawingml/2006/main">
+            <a:off x="609600" y="647700"/>
+            <a:ext cx="9334500" cy="876300"/>
+          </a:xfrm>
+          <a:prstGeom xmlns:a="http://schemas.openxmlformats.org/drawingml/2006/main" prst="rect">
+            <a:avLst/>
+          </a:prstGeom>
+          <a:noFill xmlns:a="http://schemas.openxmlformats.org/drawingml/2006/main"/>
+          <a:ln xmlns:a="http://schemas.openxmlformats.org/drawingml/2006/main" w="0">
+            <a:noFill/>
+            <a:prstDash val="solid"/>
+          </a:ln>
+        </p:spPr>
+        <p:txBody>
+          <a:bodyPr xmlns:a="http://schemas.openxmlformats.org/drawingml/2006/main"/>
+          <a:lstStyle xmlns:a="http://schemas.openxmlformats.org/drawingml/2006/main"/>
+          <a:p xmlns:a="http://schemas.openxmlformats.org/drawingml/2006/main">
+            <a:pPr>
+              <a:defRPr sz="2775" b="1">
+                <a:solidFill>
+                  <a:srgbClr val="111827"/>
+                </a:solidFill>
+              </a:defRPr>
+            </a:pPr>
+            <a:r>
+              <a:rPr sz="2775" b="1">
+                <a:solidFill>
+                  <a:srgbClr val="111827"/>
+                </a:solidFill>
+              </a:rPr>
+              <a:t>Next Gen5.3 slice: diagnose why bullish participation is still late</a:t>
+            </a:r>
+          </a:p>
+        </p:txBody>
+      </p:sp>
+      <p:sp>
+        <p:nvSpPr>
+          <p:cNvPr id="3" name="">
+            <a:extLst xmlns:a="http://schemas.openxmlformats.org/drawingml/2006/main">
+              <a:ext uri="{FF2B5EF4-FFF2-40B4-BE49-F238E27FC236}">
+                <a16:creationId xmlns:a16="http://schemas.microsoft.com/office/drawing/2014/main" id="{BDE6A1F6-684A-4614-8BB0-BB35FAB66D31}"/>
+              </a:ext>
+            </a:extLst>
+          </p:cNvPr>
+          <p:cNvSpPr>
+            <a:spLocks xmlns:a="http://schemas.openxmlformats.org/drawingml/2006/main" noGrp="1"/>
+          </p:cNvSpPr>
+          <p:nvPr/>
+        </p:nvSpPr>
+        <p:spPr>
+          <a:xfrm xmlns:a="http://schemas.openxmlformats.org/drawingml/2006/main">
+            <a:off x="609600" y="1485900"/>
+            <a:ext cx="10572750" cy="9525"/>
+          </a:xfrm>
+          <a:prstGeom xmlns:a="http://schemas.openxmlformats.org/drawingml/2006/main" prst="rect">
+            <a:avLst/>
+          </a:prstGeom>
+          <a:solidFill xmlns:a="http://schemas.openxmlformats.org/drawingml/2006/main">
+            <a:srgbClr val="CBD3DD"/>
+          </a:solidFill>
+          <a:ln xmlns:a="http://schemas.openxmlformats.org/drawingml/2006/main" w="0">
+            <a:solidFill>
+              <a:srgbClr val="CBD3DD"/>
+            </a:solidFill>
+            <a:prstDash val="solid"/>
+          </a:ln>
+        </p:spPr>
+      </p:sp>
       <p:sp>
         <p:nvSpPr>
           <p:cNvPr id="4" name="">
             <a:extLst xmlns:a="http://schemas.openxmlformats.org/drawingml/2006/main">
               <a:ext uri="{FF2B5EF4-FFF2-40B4-BE49-F238E27FC236}">
-                <a16:creationId xmlns:a16="http://schemas.microsoft.com/office/drawing/2014/main" id="{A8D9F19F-1B92-46A0-BCC1-5C44691BFE29}"/>
+                <a16:creationId xmlns:a16="http://schemas.microsoft.com/office/drawing/2014/main" id="{57B8F3AF-64F1-46D3-A0CA-3FD974AB7344}"/>
               </a:ext>
             </a:extLst>
           </p:cNvPr>
@@ -4579,7 +5289,7 @@
           <p:cNvPr id="5" name="">
             <a:extLst xmlns:a="http://schemas.openxmlformats.org/drawingml/2006/main">
               <a:ext uri="{FF2B5EF4-FFF2-40B4-BE49-F238E27FC236}">
-                <a16:creationId xmlns:a16="http://schemas.microsoft.com/office/drawing/2014/main" id="{CE98FB16-782F-4777-BBDE-1BFA4DFBC24D}"/>
+                <a16:creationId xmlns:a16="http://schemas.microsoft.com/office/drawing/2014/main" id="{317C030A-04F8-408F-95EF-82ED9D7E500D}"/>
               </a:ext>
             </a:extLst>
           </p:cNvPr>
@@ -4629,7 +5339,7 @@
           <p:cNvPr id="6" name="">
             <a:extLst xmlns:a="http://schemas.openxmlformats.org/drawingml/2006/main">
               <a:ext uri="{FF2B5EF4-FFF2-40B4-BE49-F238E27FC236}">
-                <a16:creationId xmlns:a16="http://schemas.microsoft.com/office/drawing/2014/main" id="{338F9BD9-D933-4A2C-AC6A-0D194C2185C1}"/>
+                <a16:creationId xmlns:a16="http://schemas.microsoft.com/office/drawing/2014/main" id="{ECF7FC39-3F15-44B2-BCB2-FE01A3B6A889}"/>
               </a:ext>
             </a:extLst>
           </p:cNvPr>
@@ -4679,7 +5389,7 @@
           <p:cNvPr id="7" name="">
             <a:extLst xmlns:a="http://schemas.openxmlformats.org/drawingml/2006/main">
               <a:ext uri="{FF2B5EF4-FFF2-40B4-BE49-F238E27FC236}">
-                <a16:creationId xmlns:a16="http://schemas.microsoft.com/office/drawing/2014/main" id="{B3F5F196-1666-49A7-BCD6-EC81AD2B63F7}"/>
+                <a16:creationId xmlns:a16="http://schemas.microsoft.com/office/drawing/2014/main" id="{5C8E5DA0-6873-4B17-A0BF-90BB939B6F5A}"/>
               </a:ext>
             </a:extLst>
           </p:cNvPr>
@@ -4710,7 +5420,7 @@
           <p:cNvPr id="8" name="">
             <a:extLst xmlns:a="http://schemas.openxmlformats.org/drawingml/2006/main">
               <a:ext uri="{FF2B5EF4-FFF2-40B4-BE49-F238E27FC236}">
-                <a16:creationId xmlns:a16="http://schemas.microsoft.com/office/drawing/2014/main" id="{0D8FAC86-95B7-4BF9-91F0-0ECA9CB447E0}"/>
+                <a16:creationId xmlns:a16="http://schemas.microsoft.com/office/drawing/2014/main" id="{B37FD213-C355-4854-A17A-A5C78F4DA9DB}"/>
               </a:ext>
             </a:extLst>
           </p:cNvPr>
@@ -4760,7 +5470,7 @@
           <p:cNvPr id="9" name="">
             <a:extLst xmlns:a="http://schemas.openxmlformats.org/drawingml/2006/main">
               <a:ext uri="{FF2B5EF4-FFF2-40B4-BE49-F238E27FC236}">
-                <a16:creationId xmlns:a16="http://schemas.microsoft.com/office/drawing/2014/main" id="{1FA72D4A-C5A1-4A50-AF2D-A8DE6D0C144F}"/>
+                <a16:creationId xmlns:a16="http://schemas.microsoft.com/office/drawing/2014/main" id="{E4577EBD-2667-4D29-B856-7E5E5BAA003D}"/>
               </a:ext>
             </a:extLst>
           </p:cNvPr>
@@ -4791,7 +5501,7 @@
           <p:cNvPr id="10" name="">
             <a:extLst xmlns:a="http://schemas.openxmlformats.org/drawingml/2006/main">
               <a:ext uri="{FF2B5EF4-FFF2-40B4-BE49-F238E27FC236}">
-                <a16:creationId xmlns:a16="http://schemas.microsoft.com/office/drawing/2014/main" id="{91FDB32A-5FF4-4F4A-BF49-5D777F7159A3}"/>
+                <a16:creationId xmlns:a16="http://schemas.microsoft.com/office/drawing/2014/main" id="{6CC0C929-6633-4EFC-B8C9-DF9F3A52FDBA}"/>
               </a:ext>
             </a:extLst>
           </p:cNvPr>
@@ -4841,7 +5551,7 @@
           <p:cNvPr id="11" name="">
             <a:extLst xmlns:a="http://schemas.openxmlformats.org/drawingml/2006/main">
               <a:ext uri="{FF2B5EF4-FFF2-40B4-BE49-F238E27FC236}">
-                <a16:creationId xmlns:a16="http://schemas.microsoft.com/office/drawing/2014/main" id="{A400D0AA-86EE-4B9A-B254-0571CF439806}"/>
+                <a16:creationId xmlns:a16="http://schemas.microsoft.com/office/drawing/2014/main" id="{219500A9-8E13-4A10-BBE6-CFD3075DF204}"/>
               </a:ext>
             </a:extLst>
           </p:cNvPr>
@@ -4872,7 +5582,7 @@
           <p:cNvPr id="12" name="">
             <a:extLst xmlns:a="http://schemas.openxmlformats.org/drawingml/2006/main">
               <a:ext uri="{FF2B5EF4-FFF2-40B4-BE49-F238E27FC236}">
-                <a16:creationId xmlns:a16="http://schemas.microsoft.com/office/drawing/2014/main" id="{7DD09877-F53F-465F-98E0-F2F73361D395}"/>
+                <a16:creationId xmlns:a16="http://schemas.microsoft.com/office/drawing/2014/main" id="{8E387EF0-2676-4A3B-A928-10F85ECDCE96}"/>
               </a:ext>
             </a:extLst>
           </p:cNvPr>
@@ -4922,7 +5632,7 @@
           <p:cNvPr id="13" name="">
             <a:extLst xmlns:a="http://schemas.openxmlformats.org/drawingml/2006/main">
               <a:ext uri="{FF2B5EF4-FFF2-40B4-BE49-F238E27FC236}">
-                <a16:creationId xmlns:a16="http://schemas.microsoft.com/office/drawing/2014/main" id="{FADED8C5-8ECF-41C7-B5AA-37414E0C5A75}"/>
+                <a16:creationId xmlns:a16="http://schemas.microsoft.com/office/drawing/2014/main" id="{396D3758-C954-4F19-8CF1-5186036AA24D}"/>
               </a:ext>
             </a:extLst>
           </p:cNvPr>
@@ -4970,7 +5680,7 @@
     </p:spTree>
     <p:extLst>
       <p:ext uri="{BB962C8B-B14F-4D97-AF65-F5344CB8AC3E}">
-        <p14:creationId xmlns:p14="http://schemas.microsoft.com/office/powerpoint/2010/main" val="71963633"/>
+        <p14:creationId xmlns:p14="http://schemas.microsoft.com/office/powerpoint/2010/main" val="1263480480"/>
       </p:ext>
     </p:extLst>
   </p:cSld>
@@ -5001,7 +5711,7 @@
           <p:cNvPr id="1" name="">
             <a:extLst xmlns:a="http://schemas.openxmlformats.org/drawingml/2006/main">
               <a:ext uri="{FF2B5EF4-FFF2-40B4-BE49-F238E27FC236}">
-                <a16:creationId xmlns:a16="http://schemas.microsoft.com/office/drawing/2014/main" id="{56FF4BE9-853A-4D90-A041-E3F808DCD5BB}"/>
+                <a16:creationId xmlns:a16="http://schemas.microsoft.com/office/drawing/2014/main" id="{59E0DA4E-2A5A-4143-864B-B03F49131AB2}"/>
               </a:ext>
             </a:extLst>
           </p:cNvPr>
@@ -5051,7 +5761,7 @@
           <p:cNvPr id="2" name="">
             <a:extLst xmlns:a="http://schemas.openxmlformats.org/drawingml/2006/main">
               <a:ext uri="{FF2B5EF4-FFF2-40B4-BE49-F238E27FC236}">
-                <a16:creationId xmlns:a16="http://schemas.microsoft.com/office/drawing/2014/main" id="{50871AA7-C3BB-47BE-97AD-DC12E6757797}"/>
+                <a16:creationId xmlns:a16="http://schemas.microsoft.com/office/drawing/2014/main" id="{2016C719-33F5-4D52-AC8F-C6944F85301E}"/>
               </a:ext>
             </a:extLst>
           </p:cNvPr>
@@ -5101,7 +5811,7 @@
           <p:cNvPr id="3" name="">
             <a:extLst xmlns:a="http://schemas.openxmlformats.org/drawingml/2006/main">
               <a:ext uri="{FF2B5EF4-FFF2-40B4-BE49-F238E27FC236}">
-                <a16:creationId xmlns:a16="http://schemas.microsoft.com/office/drawing/2014/main" id="{C824441C-47DF-4A3B-AC0A-3894885AD635}"/>
+                <a16:creationId xmlns:a16="http://schemas.microsoft.com/office/drawing/2014/main" id="{E2890007-8DFB-425F-9AD4-6388B895E510}"/>
               </a:ext>
             </a:extLst>
           </p:cNvPr>
@@ -5134,7 +5844,7 @@
           <p:cNvPr id="4" name="">
             <a:extLst xmlns:a="http://schemas.openxmlformats.org/drawingml/2006/main">
               <a:ext uri="{FF2B5EF4-FFF2-40B4-BE49-F238E27FC236}">
-                <a16:creationId xmlns:a16="http://schemas.microsoft.com/office/drawing/2014/main" id="{D76A394C-50C7-471B-8C22-9BB1A25041B4}"/>
+                <a16:creationId xmlns:a16="http://schemas.microsoft.com/office/drawing/2014/main" id="{5ABA1610-68D6-4C50-9EF4-C88C358A56DE}"/>
               </a:ext>
             </a:extLst>
           </p:cNvPr>
@@ -5169,7 +5879,7 @@
           <p:cNvPr id="5" name="">
             <a:extLst xmlns:a="http://schemas.openxmlformats.org/drawingml/2006/main">
               <a:ext uri="{FF2B5EF4-FFF2-40B4-BE49-F238E27FC236}">
-                <a16:creationId xmlns:a16="http://schemas.microsoft.com/office/drawing/2014/main" id="{608CFF40-39F5-4437-8BAE-B814631A1455}"/>
+                <a16:creationId xmlns:a16="http://schemas.microsoft.com/office/drawing/2014/main" id="{0EEA3DCB-A856-4051-A366-AAA135A0628F}"/>
               </a:ext>
             </a:extLst>
           </p:cNvPr>
@@ -5219,7 +5929,7 @@
           <p:cNvPr id="6" name="">
             <a:extLst xmlns:a="http://schemas.openxmlformats.org/drawingml/2006/main">
               <a:ext uri="{FF2B5EF4-FFF2-40B4-BE49-F238E27FC236}">
-                <a16:creationId xmlns:a16="http://schemas.microsoft.com/office/drawing/2014/main" id="{3AD0750A-7CB9-41D9-8EBE-A8D10DFAFBD9}"/>
+                <a16:creationId xmlns:a16="http://schemas.microsoft.com/office/drawing/2014/main" id="{C93D0F24-3378-4D19-B9AE-719315278D4C}"/>
               </a:ext>
             </a:extLst>
           </p:cNvPr>
@@ -5250,7 +5960,7 @@
           <p:cNvPr id="7" name="">
             <a:extLst xmlns:a="http://schemas.openxmlformats.org/drawingml/2006/main">
               <a:ext uri="{FF2B5EF4-FFF2-40B4-BE49-F238E27FC236}">
-                <a16:creationId xmlns:a16="http://schemas.microsoft.com/office/drawing/2014/main" id="{EE174954-FBEC-483B-B138-85AE35B0101A}"/>
+                <a16:creationId xmlns:a16="http://schemas.microsoft.com/office/drawing/2014/main" id="{EFE09788-8B43-45DA-9447-E84EFA2BAA81}"/>
               </a:ext>
             </a:extLst>
           </p:cNvPr>
@@ -5300,7 +6010,7 @@
           <p:cNvPr id="8" name="">
             <a:extLst xmlns:a="http://schemas.openxmlformats.org/drawingml/2006/main">
               <a:ext uri="{FF2B5EF4-FFF2-40B4-BE49-F238E27FC236}">
-                <a16:creationId xmlns:a16="http://schemas.microsoft.com/office/drawing/2014/main" id="{457A7F49-5706-4F19-BC04-E3D740ECE589}"/>
+                <a16:creationId xmlns:a16="http://schemas.microsoft.com/office/drawing/2014/main" id="{B1AC6FB2-956C-4731-9471-12E60065B91E}"/>
               </a:ext>
             </a:extLst>
           </p:cNvPr>
@@ -5331,7 +6041,7 @@
           <p:cNvPr id="9" name="">
             <a:extLst xmlns:a="http://schemas.openxmlformats.org/drawingml/2006/main">
               <a:ext uri="{FF2B5EF4-FFF2-40B4-BE49-F238E27FC236}">
-                <a16:creationId xmlns:a16="http://schemas.microsoft.com/office/drawing/2014/main" id="{B6A857AC-5EA5-4446-A0A2-5ECCBB2732D4}"/>
+                <a16:creationId xmlns:a16="http://schemas.microsoft.com/office/drawing/2014/main" id="{7D828120-AF67-4780-A9AF-A7E11FC0999A}"/>
               </a:ext>
             </a:extLst>
           </p:cNvPr>
@@ -5381,7 +6091,7 @@
           <p:cNvPr id="10" name="">
             <a:extLst xmlns:a="http://schemas.openxmlformats.org/drawingml/2006/main">
               <a:ext uri="{FF2B5EF4-FFF2-40B4-BE49-F238E27FC236}">
-                <a16:creationId xmlns:a16="http://schemas.microsoft.com/office/drawing/2014/main" id="{65F7332E-78CF-4343-A53B-277E98DDDD9A}"/>
+                <a16:creationId xmlns:a16="http://schemas.microsoft.com/office/drawing/2014/main" id="{A56DA876-E51D-4279-8969-A49082AFF13E}"/>
               </a:ext>
             </a:extLst>
           </p:cNvPr>
@@ -5412,7 +6122,7 @@
           <p:cNvPr id="11" name="">
             <a:extLst xmlns:a="http://schemas.openxmlformats.org/drawingml/2006/main">
               <a:ext uri="{FF2B5EF4-FFF2-40B4-BE49-F238E27FC236}">
-                <a16:creationId xmlns:a16="http://schemas.microsoft.com/office/drawing/2014/main" id="{0EBE3D20-2538-47DD-B072-F2823878FEA2}"/>
+                <a16:creationId xmlns:a16="http://schemas.microsoft.com/office/drawing/2014/main" id="{4F59F405-447C-4137-A4F6-40F6FAC939FE}"/>
               </a:ext>
             </a:extLst>
           </p:cNvPr>
@@ -5462,7 +6172,7 @@
           <p:cNvPr id="12" name="">
             <a:extLst xmlns:a="http://schemas.openxmlformats.org/drawingml/2006/main">
               <a:ext uri="{FF2B5EF4-FFF2-40B4-BE49-F238E27FC236}">
-                <a16:creationId xmlns:a16="http://schemas.microsoft.com/office/drawing/2014/main" id="{037E0167-547C-482F-B78E-A5EF1D1F4FEF}"/>
+                <a16:creationId xmlns:a16="http://schemas.microsoft.com/office/drawing/2014/main" id="{13D0AB8F-742D-4654-967C-B4620E0654D5}"/>
               </a:ext>
             </a:extLst>
           </p:cNvPr>
@@ -5493,7 +6203,7 @@
           <p:cNvPr id="13" name="">
             <a:extLst xmlns:a="http://schemas.openxmlformats.org/drawingml/2006/main">
               <a:ext uri="{FF2B5EF4-FFF2-40B4-BE49-F238E27FC236}">
-                <a16:creationId xmlns:a16="http://schemas.microsoft.com/office/drawing/2014/main" id="{E0CCF127-389E-47ED-B0B2-617D692BA24D}"/>
+                <a16:creationId xmlns:a16="http://schemas.microsoft.com/office/drawing/2014/main" id="{DDCD89D2-AD27-416D-A2B3-3A6A7FA8C79B}"/>
               </a:ext>
             </a:extLst>
           </p:cNvPr>
@@ -5543,7 +6253,7 @@
           <p:cNvPr id="14" name="">
             <a:extLst xmlns:a="http://schemas.openxmlformats.org/drawingml/2006/main">
               <a:ext uri="{FF2B5EF4-FFF2-40B4-BE49-F238E27FC236}">
-                <a16:creationId xmlns:a16="http://schemas.microsoft.com/office/drawing/2014/main" id="{3E5793A2-C081-45B1-834A-9E5E8E5160BB}"/>
+                <a16:creationId xmlns:a16="http://schemas.microsoft.com/office/drawing/2014/main" id="{9C4922AE-E2D4-4938-9335-1F5BCAE26AC8}"/>
               </a:ext>
             </a:extLst>
           </p:cNvPr>
@@ -5574,7 +6284,7 @@
           <p:cNvPr id="15" name="">
             <a:extLst xmlns:a="http://schemas.openxmlformats.org/drawingml/2006/main">
               <a:ext uri="{FF2B5EF4-FFF2-40B4-BE49-F238E27FC236}">
-                <a16:creationId xmlns:a16="http://schemas.microsoft.com/office/drawing/2014/main" id="{3FCA4997-78B9-46B7-A02C-264EB4FE7D83}"/>
+                <a16:creationId xmlns:a16="http://schemas.microsoft.com/office/drawing/2014/main" id="{A1541E48-17B3-4FF5-92B1-761A069F099B}"/>
               </a:ext>
             </a:extLst>
           </p:cNvPr>
@@ -5624,7 +6334,7 @@
           <p:cNvPr id="16" name="">
             <a:extLst xmlns:a="http://schemas.openxmlformats.org/drawingml/2006/main">
               <a:ext uri="{FF2B5EF4-FFF2-40B4-BE49-F238E27FC236}">
-                <a16:creationId xmlns:a16="http://schemas.microsoft.com/office/drawing/2014/main" id="{41E06B2A-C501-41BB-B677-F2FCDE45D13F}"/>
+                <a16:creationId xmlns:a16="http://schemas.microsoft.com/office/drawing/2014/main" id="{D646A760-138C-4EF3-8895-26483272AB30}"/>
               </a:ext>
             </a:extLst>
           </p:cNvPr>
@@ -5659,7 +6369,7 @@
           <p:cNvPr id="17" name="">
             <a:extLst xmlns:a="http://schemas.openxmlformats.org/drawingml/2006/main">
               <a:ext uri="{FF2B5EF4-FFF2-40B4-BE49-F238E27FC236}">
-                <a16:creationId xmlns:a16="http://schemas.microsoft.com/office/drawing/2014/main" id="{F20FF216-BA8B-4AC5-A13F-D0D6254D84FF}"/>
+                <a16:creationId xmlns:a16="http://schemas.microsoft.com/office/drawing/2014/main" id="{1CEAA359-9E00-4943-93DF-E4C38F3A51B9}"/>
               </a:ext>
             </a:extLst>
           </p:cNvPr>
@@ -5709,7 +6419,7 @@
           <p:cNvPr id="18" name="">
             <a:extLst xmlns:a="http://schemas.openxmlformats.org/drawingml/2006/main">
               <a:ext uri="{FF2B5EF4-FFF2-40B4-BE49-F238E27FC236}">
-                <a16:creationId xmlns:a16="http://schemas.microsoft.com/office/drawing/2014/main" id="{AFF661A5-A840-4B6A-8BA7-638C73AA082C}"/>
+                <a16:creationId xmlns:a16="http://schemas.microsoft.com/office/drawing/2014/main" id="{22CF6CA0-327E-4846-9924-D5A71EC4241A}"/>
               </a:ext>
             </a:extLst>
           </p:cNvPr>
@@ -5740,7 +6450,7 @@
           <p:cNvPr id="19" name="">
             <a:extLst xmlns:a="http://schemas.openxmlformats.org/drawingml/2006/main">
               <a:ext uri="{FF2B5EF4-FFF2-40B4-BE49-F238E27FC236}">
-                <a16:creationId xmlns:a16="http://schemas.microsoft.com/office/drawing/2014/main" id="{C05BBF29-7D38-4E93-93E9-3ADC9664037F}"/>
+                <a16:creationId xmlns:a16="http://schemas.microsoft.com/office/drawing/2014/main" id="{8E2BE86C-5F0D-48F9-8CFB-EC43AD8DEE05}"/>
               </a:ext>
             </a:extLst>
           </p:cNvPr>
@@ -5790,7 +6500,7 @@
           <p:cNvPr id="20" name="">
             <a:extLst xmlns:a="http://schemas.openxmlformats.org/drawingml/2006/main">
               <a:ext uri="{FF2B5EF4-FFF2-40B4-BE49-F238E27FC236}">
-                <a16:creationId xmlns:a16="http://schemas.microsoft.com/office/drawing/2014/main" id="{9A00D305-4ED3-4D1B-8944-3C78885C40EF}"/>
+                <a16:creationId xmlns:a16="http://schemas.microsoft.com/office/drawing/2014/main" id="{8610215F-9D9D-4B1E-9A31-02F79C350529}"/>
               </a:ext>
             </a:extLst>
           </p:cNvPr>
@@ -5821,7 +6531,7 @@
           <p:cNvPr id="21" name="">
             <a:extLst xmlns:a="http://schemas.openxmlformats.org/drawingml/2006/main">
               <a:ext uri="{FF2B5EF4-FFF2-40B4-BE49-F238E27FC236}">
-                <a16:creationId xmlns:a16="http://schemas.microsoft.com/office/drawing/2014/main" id="{BCCE2957-721F-4D22-A5FB-A802DD76829D}"/>
+                <a16:creationId xmlns:a16="http://schemas.microsoft.com/office/drawing/2014/main" id="{85F6C6AE-7FD6-4FC4-B525-A42CDCB7779A}"/>
               </a:ext>
             </a:extLst>
           </p:cNvPr>
@@ -5871,7 +6581,7 @@
           <p:cNvPr id="22" name="">
             <a:extLst xmlns:a="http://schemas.openxmlformats.org/drawingml/2006/main">
               <a:ext uri="{FF2B5EF4-FFF2-40B4-BE49-F238E27FC236}">
-                <a16:creationId xmlns:a16="http://schemas.microsoft.com/office/drawing/2014/main" id="{51FFA570-664A-4441-8CFB-96881B24F52E}"/>
+                <a16:creationId xmlns:a16="http://schemas.microsoft.com/office/drawing/2014/main" id="{F4354BC0-B30E-4725-B0B7-DAF51E709E37}"/>
               </a:ext>
             </a:extLst>
           </p:cNvPr>
@@ -5902,7 +6612,7 @@
           <p:cNvPr id="23" name="">
             <a:extLst xmlns:a="http://schemas.openxmlformats.org/drawingml/2006/main">
               <a:ext uri="{FF2B5EF4-FFF2-40B4-BE49-F238E27FC236}">
-                <a16:creationId xmlns:a16="http://schemas.microsoft.com/office/drawing/2014/main" id="{65633EE2-0DFF-496C-A049-875D671FDBEB}"/>
+                <a16:creationId xmlns:a16="http://schemas.microsoft.com/office/drawing/2014/main" id="{E754C1C3-853F-4158-A650-89296055152F}"/>
               </a:ext>
             </a:extLst>
           </p:cNvPr>
@@ -5952,7 +6662,7 @@
           <p:cNvPr id="24" name="">
             <a:extLst xmlns:a="http://schemas.openxmlformats.org/drawingml/2006/main">
               <a:ext uri="{FF2B5EF4-FFF2-40B4-BE49-F238E27FC236}">
-                <a16:creationId xmlns:a16="http://schemas.microsoft.com/office/drawing/2014/main" id="{15DA309B-B513-421F-8D24-38B1F029B44F}"/>
+                <a16:creationId xmlns:a16="http://schemas.microsoft.com/office/drawing/2014/main" id="{0E266711-0298-411C-B716-76852D663B74}"/>
               </a:ext>
             </a:extLst>
           </p:cNvPr>
@@ -5983,7 +6693,7 @@
           <p:cNvPr id="25" name="">
             <a:extLst xmlns:a="http://schemas.openxmlformats.org/drawingml/2006/main">
               <a:ext uri="{FF2B5EF4-FFF2-40B4-BE49-F238E27FC236}">
-                <a16:creationId xmlns:a16="http://schemas.microsoft.com/office/drawing/2014/main" id="{717F9C7C-B1B2-43C9-8A0B-283A4F6F0802}"/>
+                <a16:creationId xmlns:a16="http://schemas.microsoft.com/office/drawing/2014/main" id="{24FBF112-BB6F-4504-B029-C11E37F49354}"/>
               </a:ext>
             </a:extLst>
           </p:cNvPr>
@@ -6033,7 +6743,7 @@
           <p:cNvPr id="26" name="">
             <a:extLst xmlns:a="http://schemas.openxmlformats.org/drawingml/2006/main">
               <a:ext uri="{FF2B5EF4-FFF2-40B4-BE49-F238E27FC236}">
-                <a16:creationId xmlns:a16="http://schemas.microsoft.com/office/drawing/2014/main" id="{97BF6F11-E197-4588-953A-FA82B478A557}"/>
+                <a16:creationId xmlns:a16="http://schemas.microsoft.com/office/drawing/2014/main" id="{AEF493FF-C33C-44B8-B27B-332AD176F358}"/>
               </a:ext>
             </a:extLst>
           </p:cNvPr>
@@ -6081,7 +6791,7 @@
     </p:spTree>
     <p:extLst>
       <p:ext uri="{BB962C8B-B14F-4D97-AF65-F5344CB8AC3E}">
-        <p14:creationId xmlns:p14="http://schemas.microsoft.com/office/powerpoint/2010/main" val="138071836"/>
+        <p14:creationId xmlns:p14="http://schemas.microsoft.com/office/powerpoint/2010/main" val="1695962986"/>
       </p:ext>
     </p:extLst>
   </p:cSld>
@@ -6112,7 +6822,7 @@
           <p:cNvPr id="1" name="">
             <a:extLst xmlns:a="http://schemas.openxmlformats.org/drawingml/2006/main">
               <a:ext uri="{FF2B5EF4-FFF2-40B4-BE49-F238E27FC236}">
-                <a16:creationId xmlns:a16="http://schemas.microsoft.com/office/drawing/2014/main" id="{BF4DB844-203E-4B76-83AC-ABF7E1D7DD1F}"/>
+                <a16:creationId xmlns:a16="http://schemas.microsoft.com/office/drawing/2014/main" id="{6A840E08-C67F-4D29-8350-C5800C17C5B4}"/>
               </a:ext>
             </a:extLst>
           </p:cNvPr>
@@ -6162,7 +6872,7 @@
           <p:cNvPr id="2" name="">
             <a:extLst xmlns:a="http://schemas.openxmlformats.org/drawingml/2006/main">
               <a:ext uri="{FF2B5EF4-FFF2-40B4-BE49-F238E27FC236}">
-                <a16:creationId xmlns:a16="http://schemas.microsoft.com/office/drawing/2014/main" id="{F657AF1B-EE97-466D-8235-14881E0B5A7C}"/>
+                <a16:creationId xmlns:a16="http://schemas.microsoft.com/office/drawing/2014/main" id="{D9C3AFFA-8663-49B0-8D80-D36BFC030491}"/>
               </a:ext>
             </a:extLst>
           </p:cNvPr>
@@ -6212,7 +6922,7 @@
           <p:cNvPr id="3" name="">
             <a:extLst xmlns:a="http://schemas.openxmlformats.org/drawingml/2006/main">
               <a:ext uri="{FF2B5EF4-FFF2-40B4-BE49-F238E27FC236}">
-                <a16:creationId xmlns:a16="http://schemas.microsoft.com/office/drawing/2014/main" id="{2C5CC106-91BA-4226-BFDA-3324D764B0A9}"/>
+                <a16:creationId xmlns:a16="http://schemas.microsoft.com/office/drawing/2014/main" id="{56C854DF-8FDD-4D3D-AFC2-1A3279B4ED8C}"/>
               </a:ext>
             </a:extLst>
           </p:cNvPr>
@@ -6245,7 +6955,7 @@
           <p:cNvPr id="4" name="">
             <a:extLst xmlns:a="http://schemas.openxmlformats.org/drawingml/2006/main">
               <a:ext uri="{FF2B5EF4-FFF2-40B4-BE49-F238E27FC236}">
-                <a16:creationId xmlns:a16="http://schemas.microsoft.com/office/drawing/2014/main" id="{7BB18FA5-5856-4786-A876-9F78BF416430}"/>
+                <a16:creationId xmlns:a16="http://schemas.microsoft.com/office/drawing/2014/main" id="{DF113309-8E05-416C-9D15-7D5D7A2D0151}"/>
               </a:ext>
             </a:extLst>
           </p:cNvPr>
@@ -6280,7 +6990,7 @@
           <p:cNvPr id="5" name="">
             <a:extLst xmlns:a="http://schemas.openxmlformats.org/drawingml/2006/main">
               <a:ext uri="{FF2B5EF4-FFF2-40B4-BE49-F238E27FC236}">
-                <a16:creationId xmlns:a16="http://schemas.microsoft.com/office/drawing/2014/main" id="{642B28B0-2934-4492-A20C-5EF2575250BB}"/>
+                <a16:creationId xmlns:a16="http://schemas.microsoft.com/office/drawing/2014/main" id="{DE08D470-1FE3-4826-973D-C51D593E3371}"/>
               </a:ext>
             </a:extLst>
           </p:cNvPr>
@@ -6330,7 +7040,7 @@
           <p:cNvPr id="6" name="">
             <a:extLst xmlns:a="http://schemas.openxmlformats.org/drawingml/2006/main">
               <a:ext uri="{FF2B5EF4-FFF2-40B4-BE49-F238E27FC236}">
-                <a16:creationId xmlns:a16="http://schemas.microsoft.com/office/drawing/2014/main" id="{1F451813-8BE4-47EB-91D4-75EC29674B67}"/>
+                <a16:creationId xmlns:a16="http://schemas.microsoft.com/office/drawing/2014/main" id="{3D42E8E7-D448-4DB1-BD79-FE89822E2E01}"/>
               </a:ext>
             </a:extLst>
           </p:cNvPr>
@@ -6361,7 +7071,7 @@
           <p:cNvPr id="7" name="">
             <a:extLst xmlns:a="http://schemas.openxmlformats.org/drawingml/2006/main">
               <a:ext uri="{FF2B5EF4-FFF2-40B4-BE49-F238E27FC236}">
-                <a16:creationId xmlns:a16="http://schemas.microsoft.com/office/drawing/2014/main" id="{207D013A-30B6-489A-B37B-91F09E4D80A6}"/>
+                <a16:creationId xmlns:a16="http://schemas.microsoft.com/office/drawing/2014/main" id="{C6AA491D-B115-443C-A18B-3F1BE83A2AB4}"/>
               </a:ext>
             </a:extLst>
           </p:cNvPr>
@@ -6396,7 +7106,7 @@
           <p:cNvPr id="8" name="">
             <a:extLst xmlns:a="http://schemas.openxmlformats.org/drawingml/2006/main">
               <a:ext uri="{FF2B5EF4-FFF2-40B4-BE49-F238E27FC236}">
-                <a16:creationId xmlns:a16="http://schemas.microsoft.com/office/drawing/2014/main" id="{B9635D39-9F8C-4517-A239-A2E47C4A55CE}"/>
+                <a16:creationId xmlns:a16="http://schemas.microsoft.com/office/drawing/2014/main" id="{EA322CF6-CAE4-4F04-A1BD-363184007EF1}"/>
               </a:ext>
             </a:extLst>
           </p:cNvPr>
@@ -6446,7 +7156,7 @@
           <p:cNvPr id="9" name="">
             <a:extLst xmlns:a="http://schemas.openxmlformats.org/drawingml/2006/main">
               <a:ext uri="{FF2B5EF4-FFF2-40B4-BE49-F238E27FC236}">
-                <a16:creationId xmlns:a16="http://schemas.microsoft.com/office/drawing/2014/main" id="{D7AF7FE6-F5B8-4B8F-8C4D-47A2BB986536}"/>
+                <a16:creationId xmlns:a16="http://schemas.microsoft.com/office/drawing/2014/main" id="{1A4117E9-093C-4F57-B62C-CC8CF2114CE0}"/>
               </a:ext>
             </a:extLst>
           </p:cNvPr>
@@ -6477,7 +7187,7 @@
           <p:cNvPr id="10" name="">
             <a:extLst xmlns:a="http://schemas.openxmlformats.org/drawingml/2006/main">
               <a:ext uri="{FF2B5EF4-FFF2-40B4-BE49-F238E27FC236}">
-                <a16:creationId xmlns:a16="http://schemas.microsoft.com/office/drawing/2014/main" id="{E67FF066-BF73-4D6D-861B-D7D9D8F052BA}"/>
+                <a16:creationId xmlns:a16="http://schemas.microsoft.com/office/drawing/2014/main" id="{1C713534-0B45-4277-A66F-3BE47ADB0EE6}"/>
               </a:ext>
             </a:extLst>
           </p:cNvPr>
@@ -6512,7 +7222,7 @@
           <p:cNvPr id="11" name="">
             <a:extLst xmlns:a="http://schemas.openxmlformats.org/drawingml/2006/main">
               <a:ext uri="{FF2B5EF4-FFF2-40B4-BE49-F238E27FC236}">
-                <a16:creationId xmlns:a16="http://schemas.microsoft.com/office/drawing/2014/main" id="{BE47F05B-960C-47AA-9ADF-8D066C83732C}"/>
+                <a16:creationId xmlns:a16="http://schemas.microsoft.com/office/drawing/2014/main" id="{527A480E-7668-4B98-A75D-D16A6FF6115C}"/>
               </a:ext>
             </a:extLst>
           </p:cNvPr>
@@ -6562,7 +7272,7 @@
           <p:cNvPr id="12" name="">
             <a:extLst xmlns:a="http://schemas.openxmlformats.org/drawingml/2006/main">
               <a:ext uri="{FF2B5EF4-FFF2-40B4-BE49-F238E27FC236}">
-                <a16:creationId xmlns:a16="http://schemas.microsoft.com/office/drawing/2014/main" id="{F0460358-2E2C-44A0-9338-C2967EAAB0A4}"/>
+                <a16:creationId xmlns:a16="http://schemas.microsoft.com/office/drawing/2014/main" id="{72D7D8CB-C828-4DBD-8B87-9165170D53E9}"/>
               </a:ext>
             </a:extLst>
           </p:cNvPr>
@@ -6593,7 +7303,7 @@
           <p:cNvPr id="13" name="">
             <a:extLst xmlns:a="http://schemas.openxmlformats.org/drawingml/2006/main">
               <a:ext uri="{FF2B5EF4-FFF2-40B4-BE49-F238E27FC236}">
-                <a16:creationId xmlns:a16="http://schemas.microsoft.com/office/drawing/2014/main" id="{1092F0FD-3477-40A5-9136-AB936622F2B7}"/>
+                <a16:creationId xmlns:a16="http://schemas.microsoft.com/office/drawing/2014/main" id="{973FBD33-D260-430E-9EF0-B939D200C336}"/>
               </a:ext>
             </a:extLst>
           </p:cNvPr>
@@ -6628,7 +7338,7 @@
           <p:cNvPr id="14" name="">
             <a:extLst xmlns:a="http://schemas.openxmlformats.org/drawingml/2006/main">
               <a:ext uri="{FF2B5EF4-FFF2-40B4-BE49-F238E27FC236}">
-                <a16:creationId xmlns:a16="http://schemas.microsoft.com/office/drawing/2014/main" id="{AFD92E67-1725-44B3-810C-FBE6CAEF0F1B}"/>
+                <a16:creationId xmlns:a16="http://schemas.microsoft.com/office/drawing/2014/main" id="{0C5389FB-8945-4D51-BD00-F9C56689973E}"/>
               </a:ext>
             </a:extLst>
           </p:cNvPr>
@@ -6678,7 +7388,7 @@
           <p:cNvPr id="15" name="">
             <a:extLst xmlns:a="http://schemas.openxmlformats.org/drawingml/2006/main">
               <a:ext uri="{FF2B5EF4-FFF2-40B4-BE49-F238E27FC236}">
-                <a16:creationId xmlns:a16="http://schemas.microsoft.com/office/drawing/2014/main" id="{A0654890-1D3B-43A3-91AC-51560F022E39}"/>
+                <a16:creationId xmlns:a16="http://schemas.microsoft.com/office/drawing/2014/main" id="{40DE107D-F137-4AFA-9318-E221DDA4B78D}"/>
               </a:ext>
             </a:extLst>
           </p:cNvPr>
@@ -6713,7 +7423,7 @@
           <p:cNvPr id="16" name="">
             <a:extLst xmlns:a="http://schemas.openxmlformats.org/drawingml/2006/main">
               <a:ext uri="{FF2B5EF4-FFF2-40B4-BE49-F238E27FC236}">
-                <a16:creationId xmlns:a16="http://schemas.microsoft.com/office/drawing/2014/main" id="{615048F9-EB4E-4077-92CD-ECE171728AAB}"/>
+                <a16:creationId xmlns:a16="http://schemas.microsoft.com/office/drawing/2014/main" id="{3568DB2C-935C-44EF-B56A-2843D527C75C}"/>
               </a:ext>
             </a:extLst>
           </p:cNvPr>
@@ -6763,7 +7473,7 @@
           <p:cNvPr id="17" name="">
             <a:extLst xmlns:a="http://schemas.openxmlformats.org/drawingml/2006/main">
               <a:ext uri="{FF2B5EF4-FFF2-40B4-BE49-F238E27FC236}">
-                <a16:creationId xmlns:a16="http://schemas.microsoft.com/office/drawing/2014/main" id="{AD9AF367-4D20-436E-BC2C-CBC8F24DD3E5}"/>
+                <a16:creationId xmlns:a16="http://schemas.microsoft.com/office/drawing/2014/main" id="{A0B88127-D66C-4CAA-BCAF-3B77643C01AA}"/>
               </a:ext>
             </a:extLst>
           </p:cNvPr>
@@ -6811,7 +7521,7 @@
     </p:spTree>
     <p:extLst>
       <p:ext uri="{BB962C8B-B14F-4D97-AF65-F5344CB8AC3E}">
-        <p14:creationId xmlns:p14="http://schemas.microsoft.com/office/powerpoint/2010/main" val="2002627261"/>
+        <p14:creationId xmlns:p14="http://schemas.microsoft.com/office/powerpoint/2010/main" val="1727269420"/>
       </p:ext>
     </p:extLst>
   </p:cSld>
@@ -6842,7 +7552,7 @@
           <p:cNvPr id="1" name="">
             <a:extLst xmlns:a="http://schemas.openxmlformats.org/drawingml/2006/main">
               <a:ext uri="{FF2B5EF4-FFF2-40B4-BE49-F238E27FC236}">
-                <a16:creationId xmlns:a16="http://schemas.microsoft.com/office/drawing/2014/main" id="{CE5F6DBB-CC7D-4EBD-BB07-D6F9D329AB2E}"/>
+                <a16:creationId xmlns:a16="http://schemas.microsoft.com/office/drawing/2014/main" id="{E423FE18-49C8-4C39-B352-7D4F101C4898}"/>
               </a:ext>
             </a:extLst>
           </p:cNvPr>
@@ -6892,7 +7602,7 @@
           <p:cNvPr id="2" name="">
             <a:extLst xmlns:a="http://schemas.openxmlformats.org/drawingml/2006/main">
               <a:ext uri="{FF2B5EF4-FFF2-40B4-BE49-F238E27FC236}">
-                <a16:creationId xmlns:a16="http://schemas.microsoft.com/office/drawing/2014/main" id="{E5F98F62-C008-4FB2-AF3F-86DBBD2484CC}"/>
+                <a16:creationId xmlns:a16="http://schemas.microsoft.com/office/drawing/2014/main" id="{2DF759A4-99E1-4FA2-9073-157D5C9D0190}"/>
               </a:ext>
             </a:extLst>
           </p:cNvPr>
@@ -6942,7 +7652,7 @@
           <p:cNvPr id="3" name="">
             <a:extLst xmlns:a="http://schemas.openxmlformats.org/drawingml/2006/main">
               <a:ext uri="{FF2B5EF4-FFF2-40B4-BE49-F238E27FC236}">
-                <a16:creationId xmlns:a16="http://schemas.microsoft.com/office/drawing/2014/main" id="{61093D7C-3021-4458-869D-820E63CA7550}"/>
+                <a16:creationId xmlns:a16="http://schemas.microsoft.com/office/drawing/2014/main" id="{A01F0FF0-4E95-429D-AE04-E913F6C0C504}"/>
               </a:ext>
             </a:extLst>
           </p:cNvPr>
@@ -6975,7 +7685,7 @@
           <p:cNvPr id="4" name="">
             <a:extLst xmlns:a="http://schemas.openxmlformats.org/drawingml/2006/main">
               <a:ext uri="{FF2B5EF4-FFF2-40B4-BE49-F238E27FC236}">
-                <a16:creationId xmlns:a16="http://schemas.microsoft.com/office/drawing/2014/main" id="{AE96D7ED-87FC-43DC-B44D-B10033550293}"/>
+                <a16:creationId xmlns:a16="http://schemas.microsoft.com/office/drawing/2014/main" id="{D63798DA-C16A-4CAB-9AFA-9877F6058EF4}"/>
               </a:ext>
             </a:extLst>
           </p:cNvPr>
@@ -7010,7 +7720,7 @@
           <p:cNvPr id="5" name="">
             <a:extLst xmlns:a="http://schemas.openxmlformats.org/drawingml/2006/main">
               <a:ext uri="{FF2B5EF4-FFF2-40B4-BE49-F238E27FC236}">
-                <a16:creationId xmlns:a16="http://schemas.microsoft.com/office/drawing/2014/main" id="{853B821C-60FA-434F-8BF2-95762B98A7F2}"/>
+                <a16:creationId xmlns:a16="http://schemas.microsoft.com/office/drawing/2014/main" id="{B576E540-1FC4-4C5E-89FB-4192A43686E7}"/>
               </a:ext>
             </a:extLst>
           </p:cNvPr>
@@ -7045,7 +7755,7 @@
           <p:cNvPr id="6" name="">
             <a:extLst xmlns:a="http://schemas.openxmlformats.org/drawingml/2006/main">
               <a:ext uri="{FF2B5EF4-FFF2-40B4-BE49-F238E27FC236}">
-                <a16:creationId xmlns:a16="http://schemas.microsoft.com/office/drawing/2014/main" id="{A8A24997-3FDD-4164-AA8E-037211CB1AC1}"/>
+                <a16:creationId xmlns:a16="http://schemas.microsoft.com/office/drawing/2014/main" id="{3C0F001A-AE11-4725-9D49-0E223B769962}"/>
               </a:ext>
             </a:extLst>
           </p:cNvPr>
@@ -7095,7 +7805,7 @@
           <p:cNvPr id="7" name="">
             <a:extLst xmlns:a="http://schemas.openxmlformats.org/drawingml/2006/main">
               <a:ext uri="{FF2B5EF4-FFF2-40B4-BE49-F238E27FC236}">
-                <a16:creationId xmlns:a16="http://schemas.microsoft.com/office/drawing/2014/main" id="{E6C50622-B418-45EF-8803-5B302920C30D}"/>
+                <a16:creationId xmlns:a16="http://schemas.microsoft.com/office/drawing/2014/main" id="{FA68A66F-1BF8-4F9D-B0A9-AA6818D1B91F}"/>
               </a:ext>
             </a:extLst>
           </p:cNvPr>
@@ -7145,7 +7855,7 @@
           <p:cNvPr id="8" name="">
             <a:extLst xmlns:a="http://schemas.openxmlformats.org/drawingml/2006/main">
               <a:ext uri="{FF2B5EF4-FFF2-40B4-BE49-F238E27FC236}">
-                <a16:creationId xmlns:a16="http://schemas.microsoft.com/office/drawing/2014/main" id="{13AB00C2-7B08-42F7-AED8-7DC001D94F14}"/>
+                <a16:creationId xmlns:a16="http://schemas.microsoft.com/office/drawing/2014/main" id="{F9D6F89E-CC2D-4294-902C-59375AE807BD}"/>
               </a:ext>
             </a:extLst>
           </p:cNvPr>
@@ -7176,7 +7886,7 @@
           <p:cNvPr id="9" name="">
             <a:extLst xmlns:a="http://schemas.openxmlformats.org/drawingml/2006/main">
               <a:ext uri="{FF2B5EF4-FFF2-40B4-BE49-F238E27FC236}">
-                <a16:creationId xmlns:a16="http://schemas.microsoft.com/office/drawing/2014/main" id="{4658822D-511A-4F2A-A409-7FF15DC9227A}"/>
+                <a16:creationId xmlns:a16="http://schemas.microsoft.com/office/drawing/2014/main" id="{D2A8682C-66A7-4F59-8827-160A800EA7E3}"/>
               </a:ext>
             </a:extLst>
           </p:cNvPr>
@@ -7226,7 +7936,7 @@
           <p:cNvPr id="10" name="">
             <a:extLst xmlns:a="http://schemas.openxmlformats.org/drawingml/2006/main">
               <a:ext uri="{FF2B5EF4-FFF2-40B4-BE49-F238E27FC236}">
-                <a16:creationId xmlns:a16="http://schemas.microsoft.com/office/drawing/2014/main" id="{DF441EA0-F8CE-4C7C-A62B-9AB7DF5FB977}"/>
+                <a16:creationId xmlns:a16="http://schemas.microsoft.com/office/drawing/2014/main" id="{7A9F803A-D8B8-421C-B260-918EAEEA114D}"/>
               </a:ext>
             </a:extLst>
           </p:cNvPr>
@@ -7257,7 +7967,7 @@
           <p:cNvPr id="11" name="">
             <a:extLst xmlns:a="http://schemas.openxmlformats.org/drawingml/2006/main">
               <a:ext uri="{FF2B5EF4-FFF2-40B4-BE49-F238E27FC236}">
-                <a16:creationId xmlns:a16="http://schemas.microsoft.com/office/drawing/2014/main" id="{A448222B-6AD0-4123-BA27-84902E663F56}"/>
+                <a16:creationId xmlns:a16="http://schemas.microsoft.com/office/drawing/2014/main" id="{6B5B968B-BBC9-4B63-883F-E0FBFF4FA70C}"/>
               </a:ext>
             </a:extLst>
           </p:cNvPr>
@@ -7307,7 +8017,7 @@
           <p:cNvPr id="12" name="">
             <a:extLst xmlns:a="http://schemas.openxmlformats.org/drawingml/2006/main">
               <a:ext uri="{FF2B5EF4-FFF2-40B4-BE49-F238E27FC236}">
-                <a16:creationId xmlns:a16="http://schemas.microsoft.com/office/drawing/2014/main" id="{A4573205-E61D-49BD-9F21-B36235632CEE}"/>
+                <a16:creationId xmlns:a16="http://schemas.microsoft.com/office/drawing/2014/main" id="{DFB4318D-1616-4699-8420-CA743EA51CFF}"/>
               </a:ext>
             </a:extLst>
           </p:cNvPr>
@@ -7338,7 +8048,7 @@
           <p:cNvPr id="13" name="">
             <a:extLst xmlns:a="http://schemas.openxmlformats.org/drawingml/2006/main">
               <a:ext uri="{FF2B5EF4-FFF2-40B4-BE49-F238E27FC236}">
-                <a16:creationId xmlns:a16="http://schemas.microsoft.com/office/drawing/2014/main" id="{67AFEFA9-3421-4F34-A284-682E5C90A116}"/>
+                <a16:creationId xmlns:a16="http://schemas.microsoft.com/office/drawing/2014/main" id="{3218905C-B2A5-4C05-9D82-E80F0BC8F46C}"/>
               </a:ext>
             </a:extLst>
           </p:cNvPr>
@@ -7388,7 +8098,7 @@
           <p:cNvPr id="14" name="">
             <a:extLst xmlns:a="http://schemas.openxmlformats.org/drawingml/2006/main">
               <a:ext uri="{FF2B5EF4-FFF2-40B4-BE49-F238E27FC236}">
-                <a16:creationId xmlns:a16="http://schemas.microsoft.com/office/drawing/2014/main" id="{D7329E7A-5070-4C70-9144-E8AB1B07995B}"/>
+                <a16:creationId xmlns:a16="http://schemas.microsoft.com/office/drawing/2014/main" id="{40DDF0C6-F60A-493C-AB55-3A3742C710F3}"/>
               </a:ext>
             </a:extLst>
           </p:cNvPr>
@@ -7419,7 +8129,7 @@
           <p:cNvPr id="15" name="">
             <a:extLst xmlns:a="http://schemas.openxmlformats.org/drawingml/2006/main">
               <a:ext uri="{FF2B5EF4-FFF2-40B4-BE49-F238E27FC236}">
-                <a16:creationId xmlns:a16="http://schemas.microsoft.com/office/drawing/2014/main" id="{5A403A76-4BAC-407C-8E15-08F56F72A358}"/>
+                <a16:creationId xmlns:a16="http://schemas.microsoft.com/office/drawing/2014/main" id="{8C227A99-73E3-4C78-AF48-50AEF3E808D9}"/>
               </a:ext>
             </a:extLst>
           </p:cNvPr>
@@ -7469,7 +8179,7 @@
           <p:cNvPr id="16" name="">
             <a:extLst xmlns:a="http://schemas.openxmlformats.org/drawingml/2006/main">
               <a:ext uri="{FF2B5EF4-FFF2-40B4-BE49-F238E27FC236}">
-                <a16:creationId xmlns:a16="http://schemas.microsoft.com/office/drawing/2014/main" id="{EBDF9DF3-5E29-46C2-814E-A67B44E6604D}"/>
+                <a16:creationId xmlns:a16="http://schemas.microsoft.com/office/drawing/2014/main" id="{B689206B-6294-434D-B049-EDEABA365E84}"/>
               </a:ext>
             </a:extLst>
           </p:cNvPr>
@@ -7500,7 +8210,7 @@
           <p:cNvPr id="17" name="">
             <a:extLst xmlns:a="http://schemas.openxmlformats.org/drawingml/2006/main">
               <a:ext uri="{FF2B5EF4-FFF2-40B4-BE49-F238E27FC236}">
-                <a16:creationId xmlns:a16="http://schemas.microsoft.com/office/drawing/2014/main" id="{D9ED026A-4174-4406-9F8F-23102F79DD1F}"/>
+                <a16:creationId xmlns:a16="http://schemas.microsoft.com/office/drawing/2014/main" id="{EAB62372-87D4-43E6-840A-731D9B2B640E}"/>
               </a:ext>
             </a:extLst>
           </p:cNvPr>
@@ -7550,7 +8260,7 @@
           <p:cNvPr id="18" name="">
             <a:extLst xmlns:a="http://schemas.openxmlformats.org/drawingml/2006/main">
               <a:ext uri="{FF2B5EF4-FFF2-40B4-BE49-F238E27FC236}">
-                <a16:creationId xmlns:a16="http://schemas.microsoft.com/office/drawing/2014/main" id="{5092516C-0586-45E5-9D88-A97853DAB758}"/>
+                <a16:creationId xmlns:a16="http://schemas.microsoft.com/office/drawing/2014/main" id="{D0CD1280-FD28-48B2-BF63-42D448393601}"/>
               </a:ext>
             </a:extLst>
           </p:cNvPr>
@@ -7581,7 +8291,7 @@
           <p:cNvPr id="19" name="">
             <a:extLst xmlns:a="http://schemas.openxmlformats.org/drawingml/2006/main">
               <a:ext uri="{FF2B5EF4-FFF2-40B4-BE49-F238E27FC236}">
-                <a16:creationId xmlns:a16="http://schemas.microsoft.com/office/drawing/2014/main" id="{7B2C9635-1D94-4F5E-AA03-7F1A1295531F}"/>
+                <a16:creationId xmlns:a16="http://schemas.microsoft.com/office/drawing/2014/main" id="{465DE92B-61F7-48B3-BDAB-FEA46F3912D4}"/>
               </a:ext>
             </a:extLst>
           </p:cNvPr>
@@ -7631,7 +8341,7 @@
           <p:cNvPr id="20" name="">
             <a:extLst xmlns:a="http://schemas.openxmlformats.org/drawingml/2006/main">
               <a:ext uri="{FF2B5EF4-FFF2-40B4-BE49-F238E27FC236}">
-                <a16:creationId xmlns:a16="http://schemas.microsoft.com/office/drawing/2014/main" id="{392E08F9-CB24-45BC-802F-626AC9917505}"/>
+                <a16:creationId xmlns:a16="http://schemas.microsoft.com/office/drawing/2014/main" id="{02133AA9-684F-4D66-9B33-B8509A1B73FB}"/>
               </a:ext>
             </a:extLst>
           </p:cNvPr>
@@ -7662,7 +8372,7 @@
           <p:cNvPr id="21" name="">
             <a:extLst xmlns:a="http://schemas.openxmlformats.org/drawingml/2006/main">
               <a:ext uri="{FF2B5EF4-FFF2-40B4-BE49-F238E27FC236}">
-                <a16:creationId xmlns:a16="http://schemas.microsoft.com/office/drawing/2014/main" id="{E440289E-6001-4106-86D5-EF4122F7B3C6}"/>
+                <a16:creationId xmlns:a16="http://schemas.microsoft.com/office/drawing/2014/main" id="{6DFA0F5D-EC87-4188-89A6-F95D966AB9E9}"/>
               </a:ext>
             </a:extLst>
           </p:cNvPr>
@@ -7712,7 +8422,7 @@
           <p:cNvPr id="22" name="">
             <a:extLst xmlns:a="http://schemas.openxmlformats.org/drawingml/2006/main">
               <a:ext uri="{FF2B5EF4-FFF2-40B4-BE49-F238E27FC236}">
-                <a16:creationId xmlns:a16="http://schemas.microsoft.com/office/drawing/2014/main" id="{624AAC33-05FA-474B-A984-920B8C39015F}"/>
+                <a16:creationId xmlns:a16="http://schemas.microsoft.com/office/drawing/2014/main" id="{15FF4E0D-D2AC-42AA-8731-24D9C7418620}"/>
               </a:ext>
             </a:extLst>
           </p:cNvPr>
@@ -7743,7 +8453,7 @@
           <p:cNvPr id="23" name="">
             <a:extLst xmlns:a="http://schemas.openxmlformats.org/drawingml/2006/main">
               <a:ext uri="{FF2B5EF4-FFF2-40B4-BE49-F238E27FC236}">
-                <a16:creationId xmlns:a16="http://schemas.microsoft.com/office/drawing/2014/main" id="{F11FA9B6-BAFF-4E61-97E0-F01A283E6866}"/>
+                <a16:creationId xmlns:a16="http://schemas.microsoft.com/office/drawing/2014/main" id="{043426F0-B7B7-45A3-A468-DB0D524F2EB5}"/>
               </a:ext>
             </a:extLst>
           </p:cNvPr>
@@ -7791,7 +8501,7 @@
     </p:spTree>
     <p:extLst>
       <p:ext uri="{BB962C8B-B14F-4D97-AF65-F5344CB8AC3E}">
-        <p14:creationId xmlns:p14="http://schemas.microsoft.com/office/powerpoint/2010/main" val="1094014076"/>
+        <p14:creationId xmlns:p14="http://schemas.microsoft.com/office/powerpoint/2010/main" val="2008708327"/>
       </p:ext>
     </p:extLst>
   </p:cSld>
@@ -7822,7 +8532,7 @@
           <p:cNvPr id="1" name="">
             <a:extLst xmlns:a="http://schemas.openxmlformats.org/drawingml/2006/main">
               <a:ext uri="{FF2B5EF4-FFF2-40B4-BE49-F238E27FC236}">
-                <a16:creationId xmlns:a16="http://schemas.microsoft.com/office/drawing/2014/main" id="{4957E6DF-8D33-48F0-BFD5-07A2B86B989D}"/>
+                <a16:creationId xmlns:a16="http://schemas.microsoft.com/office/drawing/2014/main" id="{524AA359-3563-444C-B55E-F58792039F13}"/>
               </a:ext>
             </a:extLst>
           </p:cNvPr>
@@ -7872,7 +8582,7 @@
           <p:cNvPr id="2" name="">
             <a:extLst xmlns:a="http://schemas.openxmlformats.org/drawingml/2006/main">
               <a:ext uri="{FF2B5EF4-FFF2-40B4-BE49-F238E27FC236}">
-                <a16:creationId xmlns:a16="http://schemas.microsoft.com/office/drawing/2014/main" id="{F0823E1B-4541-469A-A946-29C0C8BC124A}"/>
+                <a16:creationId xmlns:a16="http://schemas.microsoft.com/office/drawing/2014/main" id="{845A48C0-BC00-4C88-A764-A3203DB77200}"/>
               </a:ext>
             </a:extLst>
           </p:cNvPr>
@@ -7922,7 +8632,7 @@
           <p:cNvPr id="3" name="">
             <a:extLst xmlns:a="http://schemas.openxmlformats.org/drawingml/2006/main">
               <a:ext uri="{FF2B5EF4-FFF2-40B4-BE49-F238E27FC236}">
-                <a16:creationId xmlns:a16="http://schemas.microsoft.com/office/drawing/2014/main" id="{25121B9D-0B0E-4783-BFBA-6390CE346164}"/>
+                <a16:creationId xmlns:a16="http://schemas.microsoft.com/office/drawing/2014/main" id="{0D30E0CA-8ABC-4EAC-B0C2-12C615A0127C}"/>
               </a:ext>
             </a:extLst>
           </p:cNvPr>
@@ -7955,7 +8665,7 @@
           <p:cNvPr id="4" name="">
             <a:extLst xmlns:a="http://schemas.openxmlformats.org/drawingml/2006/main">
               <a:ext uri="{FF2B5EF4-FFF2-40B4-BE49-F238E27FC236}">
-                <a16:creationId xmlns:a16="http://schemas.microsoft.com/office/drawing/2014/main" id="{554F84EB-DE9D-4180-9A77-9F795A621564}"/>
+                <a16:creationId xmlns:a16="http://schemas.microsoft.com/office/drawing/2014/main" id="{2153A0FD-A358-4229-B1B3-1FCB56FC2B4A}"/>
               </a:ext>
             </a:extLst>
           </p:cNvPr>
@@ -7990,7 +8700,7 @@
           <p:cNvPr id="5" name="">
             <a:extLst xmlns:a="http://schemas.openxmlformats.org/drawingml/2006/main">
               <a:ext uri="{FF2B5EF4-FFF2-40B4-BE49-F238E27FC236}">
-                <a16:creationId xmlns:a16="http://schemas.microsoft.com/office/drawing/2014/main" id="{D1310A29-0109-4B97-8D1C-B275B98E177B}"/>
+                <a16:creationId xmlns:a16="http://schemas.microsoft.com/office/drawing/2014/main" id="{34CCEA44-D6BB-4DE6-A92B-9BFC2CC331AD}"/>
               </a:ext>
             </a:extLst>
           </p:cNvPr>
@@ -8025,7 +8735,7 @@
           <p:cNvPr id="6" name="">
             <a:extLst xmlns:a="http://schemas.openxmlformats.org/drawingml/2006/main">
               <a:ext uri="{FF2B5EF4-FFF2-40B4-BE49-F238E27FC236}">
-                <a16:creationId xmlns:a16="http://schemas.microsoft.com/office/drawing/2014/main" id="{E38230A1-5BA5-4702-A822-DDA122EAAB33}"/>
+                <a16:creationId xmlns:a16="http://schemas.microsoft.com/office/drawing/2014/main" id="{FF89AAF8-AB11-40BC-8208-A580F89F9AE4}"/>
               </a:ext>
             </a:extLst>
           </p:cNvPr>
@@ -8060,7 +8770,7 @@
           <p:cNvPr id="7" name="">
             <a:extLst xmlns:a="http://schemas.openxmlformats.org/drawingml/2006/main">
               <a:ext uri="{FF2B5EF4-FFF2-40B4-BE49-F238E27FC236}">
-                <a16:creationId xmlns:a16="http://schemas.microsoft.com/office/drawing/2014/main" id="{F31348D2-EDE4-4EC3-B216-3F53FA0CD19E}"/>
+                <a16:creationId xmlns:a16="http://schemas.microsoft.com/office/drawing/2014/main" id="{60137C13-C84F-4646-B25F-969BC134799E}"/>
               </a:ext>
             </a:extLst>
           </p:cNvPr>
@@ -8110,7 +8820,7 @@
           <p:cNvPr id="8" name="">
             <a:extLst xmlns:a="http://schemas.openxmlformats.org/drawingml/2006/main">
               <a:ext uri="{FF2B5EF4-FFF2-40B4-BE49-F238E27FC236}">
-                <a16:creationId xmlns:a16="http://schemas.microsoft.com/office/drawing/2014/main" id="{3C00BD6A-EEE3-432D-B9D2-59957176FF5E}"/>
+                <a16:creationId xmlns:a16="http://schemas.microsoft.com/office/drawing/2014/main" id="{8F180A79-F8B2-4BF8-AA4A-C5A0E534CC81}"/>
               </a:ext>
             </a:extLst>
           </p:cNvPr>
@@ -8160,7 +8870,7 @@
           <p:cNvPr id="9" name="">
             <a:extLst xmlns:a="http://schemas.openxmlformats.org/drawingml/2006/main">
               <a:ext uri="{FF2B5EF4-FFF2-40B4-BE49-F238E27FC236}">
-                <a16:creationId xmlns:a16="http://schemas.microsoft.com/office/drawing/2014/main" id="{DE49B5CF-AA58-4B4A-9247-E6CB868B8EFC}"/>
+                <a16:creationId xmlns:a16="http://schemas.microsoft.com/office/drawing/2014/main" id="{8C76D08E-5A54-468A-B9BE-30CA0375F966}"/>
               </a:ext>
             </a:extLst>
           </p:cNvPr>
@@ -8210,7 +8920,7 @@
           <p:cNvPr id="10" name="">
             <a:extLst xmlns:a="http://schemas.openxmlformats.org/drawingml/2006/main">
               <a:ext uri="{FF2B5EF4-FFF2-40B4-BE49-F238E27FC236}">
-                <a16:creationId xmlns:a16="http://schemas.microsoft.com/office/drawing/2014/main" id="{C849A663-6CAF-438F-8021-2908343EC0B9}"/>
+                <a16:creationId xmlns:a16="http://schemas.microsoft.com/office/drawing/2014/main" id="{14178E92-587B-4B1E-AB38-6A874BB8CE7E}"/>
               </a:ext>
             </a:extLst>
           </p:cNvPr>
@@ -8260,7 +8970,7 @@
           <p:cNvPr id="11" name="">
             <a:extLst xmlns:a="http://schemas.openxmlformats.org/drawingml/2006/main">
               <a:ext uri="{FF2B5EF4-FFF2-40B4-BE49-F238E27FC236}">
-                <a16:creationId xmlns:a16="http://schemas.microsoft.com/office/drawing/2014/main" id="{FA6BAE1E-D37E-468E-8CAA-5FF9A7D1F73F}"/>
+                <a16:creationId xmlns:a16="http://schemas.microsoft.com/office/drawing/2014/main" id="{6E902757-D6D2-45B0-AFB4-8363A3C740E4}"/>
               </a:ext>
             </a:extLst>
           </p:cNvPr>
@@ -8310,7 +9020,7 @@
           <p:cNvPr id="12" name="">
             <a:extLst xmlns:a="http://schemas.openxmlformats.org/drawingml/2006/main">
               <a:ext uri="{FF2B5EF4-FFF2-40B4-BE49-F238E27FC236}">
-                <a16:creationId xmlns:a16="http://schemas.microsoft.com/office/drawing/2014/main" id="{10E2EEA2-35B6-4345-8C7C-574EA0B41DFD}"/>
+                <a16:creationId xmlns:a16="http://schemas.microsoft.com/office/drawing/2014/main" id="{3E5F805B-057C-486A-9310-26D86E45C562}"/>
               </a:ext>
             </a:extLst>
           </p:cNvPr>
@@ -8360,7 +9070,7 @@
           <p:cNvPr id="13" name="">
             <a:extLst xmlns:a="http://schemas.openxmlformats.org/drawingml/2006/main">
               <a:ext uri="{FF2B5EF4-FFF2-40B4-BE49-F238E27FC236}">
-                <a16:creationId xmlns:a16="http://schemas.microsoft.com/office/drawing/2014/main" id="{32F08A7D-6002-4052-8683-7943D1C98359}"/>
+                <a16:creationId xmlns:a16="http://schemas.microsoft.com/office/drawing/2014/main" id="{866F7B0D-E5A9-4EC5-B872-5D9CCD8360EA}"/>
               </a:ext>
             </a:extLst>
           </p:cNvPr>
@@ -8408,7 +9118,7 @@
     </p:spTree>
     <p:extLst>
       <p:ext uri="{BB962C8B-B14F-4D97-AF65-F5344CB8AC3E}">
-        <p14:creationId xmlns:p14="http://schemas.microsoft.com/office/powerpoint/2010/main" val="1404789962"/>
+        <p14:creationId xmlns:p14="http://schemas.microsoft.com/office/powerpoint/2010/main" val="359685640"/>
       </p:ext>
     </p:extLst>
   </p:cSld>
@@ -8439,7 +9149,7 @@
           <p:cNvPr id="1" name="">
             <a:extLst xmlns:a="http://schemas.openxmlformats.org/drawingml/2006/main">
               <a:ext uri="{FF2B5EF4-FFF2-40B4-BE49-F238E27FC236}">
-                <a16:creationId xmlns:a16="http://schemas.microsoft.com/office/drawing/2014/main" id="{B1F4F06C-685D-4FB0-A1F7-77EADF5397A2}"/>
+                <a16:creationId xmlns:a16="http://schemas.microsoft.com/office/drawing/2014/main" id="{D732A811-E5AB-48FB-A9B0-3B57C9921FAB}"/>
               </a:ext>
             </a:extLst>
           </p:cNvPr>
@@ -8489,7 +9199,7 @@
           <p:cNvPr id="2" name="">
             <a:extLst xmlns:a="http://schemas.openxmlformats.org/drawingml/2006/main">
               <a:ext uri="{FF2B5EF4-FFF2-40B4-BE49-F238E27FC236}">
-                <a16:creationId xmlns:a16="http://schemas.microsoft.com/office/drawing/2014/main" id="{A6444397-8ED2-4192-81AF-FB1BC2C53825}"/>
+                <a16:creationId xmlns:a16="http://schemas.microsoft.com/office/drawing/2014/main" id="{50492119-5453-4296-8DA9-919803DA6344}"/>
               </a:ext>
             </a:extLst>
           </p:cNvPr>
@@ -8539,7 +9249,7 @@
           <p:cNvPr id="3" name="">
             <a:extLst xmlns:a="http://schemas.openxmlformats.org/drawingml/2006/main">
               <a:ext uri="{FF2B5EF4-FFF2-40B4-BE49-F238E27FC236}">
-                <a16:creationId xmlns:a16="http://schemas.microsoft.com/office/drawing/2014/main" id="{E8562D3F-9004-49CC-93EF-FC14EFD2E659}"/>
+                <a16:creationId xmlns:a16="http://schemas.microsoft.com/office/drawing/2014/main" id="{F0E7F188-08E8-40EE-B871-048AAE84B257}"/>
               </a:ext>
             </a:extLst>
           </p:cNvPr>
@@ -8572,7 +9282,7 @@
           <p:cNvPr id="4" name="">
             <a:extLst xmlns:a="http://schemas.openxmlformats.org/drawingml/2006/main">
               <a:ext uri="{FF2B5EF4-FFF2-40B4-BE49-F238E27FC236}">
-                <a16:creationId xmlns:a16="http://schemas.microsoft.com/office/drawing/2014/main" id="{88C4C8D9-CBEE-4149-A7DA-F9EA53CD9A7D}"/>
+                <a16:creationId xmlns:a16="http://schemas.microsoft.com/office/drawing/2014/main" id="{C2E41CB6-9DD8-4E90-B352-66283FB50EB5}"/>
               </a:ext>
             </a:extLst>
           </p:cNvPr>
@@ -8607,7 +9317,7 @@
           <p:cNvPr id="5" name="">
             <a:extLst xmlns:a="http://schemas.openxmlformats.org/drawingml/2006/main">
               <a:ext uri="{FF2B5EF4-FFF2-40B4-BE49-F238E27FC236}">
-                <a16:creationId xmlns:a16="http://schemas.microsoft.com/office/drawing/2014/main" id="{91B6BC0E-3A56-4921-85FD-F766A57817E0}"/>
+                <a16:creationId xmlns:a16="http://schemas.microsoft.com/office/drawing/2014/main" id="{0B25E74B-C24B-41F8-AC30-39A5C94777D5}"/>
               </a:ext>
             </a:extLst>
           </p:cNvPr>
@@ -8657,7 +9367,7 @@
           <p:cNvPr id="6" name="">
             <a:extLst xmlns:a="http://schemas.openxmlformats.org/drawingml/2006/main">
               <a:ext uri="{FF2B5EF4-FFF2-40B4-BE49-F238E27FC236}">
-                <a16:creationId xmlns:a16="http://schemas.microsoft.com/office/drawing/2014/main" id="{6D485949-F335-4448-8DF2-7A1C1895E7CF}"/>
+                <a16:creationId xmlns:a16="http://schemas.microsoft.com/office/drawing/2014/main" id="{AC51FD01-9301-4BD9-A835-EED4782EA348}"/>
               </a:ext>
             </a:extLst>
           </p:cNvPr>
@@ -8688,7 +9398,7 @@
           <p:cNvPr id="7" name="">
             <a:extLst xmlns:a="http://schemas.openxmlformats.org/drawingml/2006/main">
               <a:ext uri="{FF2B5EF4-FFF2-40B4-BE49-F238E27FC236}">
-                <a16:creationId xmlns:a16="http://schemas.microsoft.com/office/drawing/2014/main" id="{80554F95-8511-4FC9-8B43-DB13C12F421A}"/>
+                <a16:creationId xmlns:a16="http://schemas.microsoft.com/office/drawing/2014/main" id="{77C15502-0682-43F1-86BD-ADAEC4795C48}"/>
               </a:ext>
             </a:extLst>
           </p:cNvPr>
@@ -8738,7 +9448,7 @@
           <p:cNvPr id="8" name="">
             <a:extLst xmlns:a="http://schemas.openxmlformats.org/drawingml/2006/main">
               <a:ext uri="{FF2B5EF4-FFF2-40B4-BE49-F238E27FC236}">
-                <a16:creationId xmlns:a16="http://schemas.microsoft.com/office/drawing/2014/main" id="{D272D281-7496-4142-8A75-842F52FCDB90}"/>
+                <a16:creationId xmlns:a16="http://schemas.microsoft.com/office/drawing/2014/main" id="{9ABB4E3E-1DAF-4446-B9F7-CB82F1DEF121}"/>
               </a:ext>
             </a:extLst>
           </p:cNvPr>
@@ -8769,7 +9479,7 @@
           <p:cNvPr id="9" name="">
             <a:extLst xmlns:a="http://schemas.openxmlformats.org/drawingml/2006/main">
               <a:ext uri="{FF2B5EF4-FFF2-40B4-BE49-F238E27FC236}">
-                <a16:creationId xmlns:a16="http://schemas.microsoft.com/office/drawing/2014/main" id="{14F19489-3C17-47C3-987B-13F433A28DDD}"/>
+                <a16:creationId xmlns:a16="http://schemas.microsoft.com/office/drawing/2014/main" id="{71D9B4C9-E1B8-414C-B5F4-80F15E2FB16F}"/>
               </a:ext>
             </a:extLst>
           </p:cNvPr>
@@ -8819,7 +9529,7 @@
           <p:cNvPr id="10" name="">
             <a:extLst xmlns:a="http://schemas.openxmlformats.org/drawingml/2006/main">
               <a:ext uri="{FF2B5EF4-FFF2-40B4-BE49-F238E27FC236}">
-                <a16:creationId xmlns:a16="http://schemas.microsoft.com/office/drawing/2014/main" id="{D5980CA1-48DA-4A19-ADF3-1CEB47FE0ACC}"/>
+                <a16:creationId xmlns:a16="http://schemas.microsoft.com/office/drawing/2014/main" id="{8F0DA46C-ECDC-48EF-82E9-A154D85139B8}"/>
               </a:ext>
             </a:extLst>
           </p:cNvPr>
@@ -8850,7 +9560,7 @@
           <p:cNvPr id="11" name="">
             <a:extLst xmlns:a="http://schemas.openxmlformats.org/drawingml/2006/main">
               <a:ext uri="{FF2B5EF4-FFF2-40B4-BE49-F238E27FC236}">
-                <a16:creationId xmlns:a16="http://schemas.microsoft.com/office/drawing/2014/main" id="{EF03EFB7-D871-43AB-A38B-66F2D9603F0D}"/>
+                <a16:creationId xmlns:a16="http://schemas.microsoft.com/office/drawing/2014/main" id="{FEE0F941-3587-4E2C-9BF5-37EFFB5B875C}"/>
               </a:ext>
             </a:extLst>
           </p:cNvPr>
@@ -8900,7 +9610,7 @@
           <p:cNvPr id="12" name="">
             <a:extLst xmlns:a="http://schemas.openxmlformats.org/drawingml/2006/main">
               <a:ext uri="{FF2B5EF4-FFF2-40B4-BE49-F238E27FC236}">
-                <a16:creationId xmlns:a16="http://schemas.microsoft.com/office/drawing/2014/main" id="{E87BE44E-CE9B-4CFA-BC12-0121E77024B1}"/>
+                <a16:creationId xmlns:a16="http://schemas.microsoft.com/office/drawing/2014/main" id="{E4220817-FDFA-45FF-8A20-B956BFD1E5D9}"/>
               </a:ext>
             </a:extLst>
           </p:cNvPr>
@@ -8931,7 +9641,7 @@
           <p:cNvPr id="13" name="">
             <a:extLst xmlns:a="http://schemas.openxmlformats.org/drawingml/2006/main">
               <a:ext uri="{FF2B5EF4-FFF2-40B4-BE49-F238E27FC236}">
-                <a16:creationId xmlns:a16="http://schemas.microsoft.com/office/drawing/2014/main" id="{9B0988AF-C765-41B1-A38A-5C77F29F40AD}"/>
+                <a16:creationId xmlns:a16="http://schemas.microsoft.com/office/drawing/2014/main" id="{0BAB0FFB-8111-468C-A51A-8BBB54112276}"/>
               </a:ext>
             </a:extLst>
           </p:cNvPr>
@@ -8981,7 +9691,7 @@
           <p:cNvPr id="14" name="">
             <a:extLst xmlns:a="http://schemas.openxmlformats.org/drawingml/2006/main">
               <a:ext uri="{FF2B5EF4-FFF2-40B4-BE49-F238E27FC236}">
-                <a16:creationId xmlns:a16="http://schemas.microsoft.com/office/drawing/2014/main" id="{E0091A29-20C3-4098-97ED-B1C41F108921}"/>
+                <a16:creationId xmlns:a16="http://schemas.microsoft.com/office/drawing/2014/main" id="{9AEE69CA-526F-4846-824E-23B781A9DE0B}"/>
               </a:ext>
             </a:extLst>
           </p:cNvPr>
@@ -9016,7 +9726,7 @@
           <p:cNvPr id="15" name="">
             <a:extLst xmlns:a="http://schemas.openxmlformats.org/drawingml/2006/main">
               <a:ext uri="{FF2B5EF4-FFF2-40B4-BE49-F238E27FC236}">
-                <a16:creationId xmlns:a16="http://schemas.microsoft.com/office/drawing/2014/main" id="{D37B2C7D-2A68-45CC-95AC-DFAB12FD79A1}"/>
+                <a16:creationId xmlns:a16="http://schemas.microsoft.com/office/drawing/2014/main" id="{15E47B87-E538-4C97-9D58-74E1AF29FEFB}"/>
               </a:ext>
             </a:extLst>
           </p:cNvPr>
@@ -9066,7 +9776,7 @@
           <p:cNvPr id="16" name="">
             <a:extLst xmlns:a="http://schemas.openxmlformats.org/drawingml/2006/main">
               <a:ext uri="{FF2B5EF4-FFF2-40B4-BE49-F238E27FC236}">
-                <a16:creationId xmlns:a16="http://schemas.microsoft.com/office/drawing/2014/main" id="{2546B165-BB8A-4DC0-8742-DD490817F4E9}"/>
+                <a16:creationId xmlns:a16="http://schemas.microsoft.com/office/drawing/2014/main" id="{EE534865-3C49-4652-81B3-4C9535F9B15B}"/>
               </a:ext>
             </a:extLst>
           </p:cNvPr>
@@ -9097,7 +9807,7 @@
           <p:cNvPr id="17" name="">
             <a:extLst xmlns:a="http://schemas.openxmlformats.org/drawingml/2006/main">
               <a:ext uri="{FF2B5EF4-FFF2-40B4-BE49-F238E27FC236}">
-                <a16:creationId xmlns:a16="http://schemas.microsoft.com/office/drawing/2014/main" id="{A01493C1-0437-44E4-B728-561519AE8D18}"/>
+                <a16:creationId xmlns:a16="http://schemas.microsoft.com/office/drawing/2014/main" id="{6950AE5E-8D41-4D48-986E-4CA4BC570AA5}"/>
               </a:ext>
             </a:extLst>
           </p:cNvPr>
@@ -9147,7 +9857,7 @@
           <p:cNvPr id="18" name="">
             <a:extLst xmlns:a="http://schemas.openxmlformats.org/drawingml/2006/main">
               <a:ext uri="{FF2B5EF4-FFF2-40B4-BE49-F238E27FC236}">
-                <a16:creationId xmlns:a16="http://schemas.microsoft.com/office/drawing/2014/main" id="{88328B99-A0D4-4973-A1A2-2E7C644F399B}"/>
+                <a16:creationId xmlns:a16="http://schemas.microsoft.com/office/drawing/2014/main" id="{FD607EB2-FDDE-4B7C-BDA6-5326DE6D60FB}"/>
               </a:ext>
             </a:extLst>
           </p:cNvPr>
@@ -9178,7 +9888,7 @@
           <p:cNvPr id="19" name="">
             <a:extLst xmlns:a="http://schemas.openxmlformats.org/drawingml/2006/main">
               <a:ext uri="{FF2B5EF4-FFF2-40B4-BE49-F238E27FC236}">
-                <a16:creationId xmlns:a16="http://schemas.microsoft.com/office/drawing/2014/main" id="{9D06EDD3-3943-4ADF-99E9-D27B00A4B46E}"/>
+                <a16:creationId xmlns:a16="http://schemas.microsoft.com/office/drawing/2014/main" id="{17069432-DA0A-4182-AC1A-CFA2CB5EB0F9}"/>
               </a:ext>
             </a:extLst>
           </p:cNvPr>
@@ -9228,7 +9938,7 @@
           <p:cNvPr id="20" name="">
             <a:extLst xmlns:a="http://schemas.openxmlformats.org/drawingml/2006/main">
               <a:ext uri="{FF2B5EF4-FFF2-40B4-BE49-F238E27FC236}">
-                <a16:creationId xmlns:a16="http://schemas.microsoft.com/office/drawing/2014/main" id="{2992B66F-22D6-4E62-8F2D-EC65E951FF8B}"/>
+                <a16:creationId xmlns:a16="http://schemas.microsoft.com/office/drawing/2014/main" id="{DBFBD00D-5B60-48CF-B48B-E6A5596305BF}"/>
               </a:ext>
             </a:extLst>
           </p:cNvPr>
@@ -9259,7 +9969,7 @@
           <p:cNvPr id="21" name="">
             <a:extLst xmlns:a="http://schemas.openxmlformats.org/drawingml/2006/main">
               <a:ext uri="{FF2B5EF4-FFF2-40B4-BE49-F238E27FC236}">
-                <a16:creationId xmlns:a16="http://schemas.microsoft.com/office/drawing/2014/main" id="{B0A57169-0B98-42EC-B805-39988D0154CC}"/>
+                <a16:creationId xmlns:a16="http://schemas.microsoft.com/office/drawing/2014/main" id="{5DAA6431-963A-4C08-B232-29FE23E8BFE5}"/>
               </a:ext>
             </a:extLst>
           </p:cNvPr>
@@ -9309,7 +10019,7 @@
           <p:cNvPr id="22" name="">
             <a:extLst xmlns:a="http://schemas.openxmlformats.org/drawingml/2006/main">
               <a:ext uri="{FF2B5EF4-FFF2-40B4-BE49-F238E27FC236}">
-                <a16:creationId xmlns:a16="http://schemas.microsoft.com/office/drawing/2014/main" id="{0367FE2E-3109-49D2-B732-6BA880E4E282}"/>
+                <a16:creationId xmlns:a16="http://schemas.microsoft.com/office/drawing/2014/main" id="{4F881C80-47E8-463D-8D74-362CCB0B045C}"/>
               </a:ext>
             </a:extLst>
           </p:cNvPr>
@@ -9340,7 +10050,7 @@
           <p:cNvPr id="23" name="">
             <a:extLst xmlns:a="http://schemas.openxmlformats.org/drawingml/2006/main">
               <a:ext uri="{FF2B5EF4-FFF2-40B4-BE49-F238E27FC236}">
-                <a16:creationId xmlns:a16="http://schemas.microsoft.com/office/drawing/2014/main" id="{FDE63C90-6CFF-447B-ABA0-1597606B19F7}"/>
+                <a16:creationId xmlns:a16="http://schemas.microsoft.com/office/drawing/2014/main" id="{BB4CF5A3-9FBE-46BF-9A5F-9BDE45DC041F}"/>
               </a:ext>
             </a:extLst>
           </p:cNvPr>
@@ -9390,7 +10100,7 @@
           <p:cNvPr id="24" name="">
             <a:extLst xmlns:a="http://schemas.openxmlformats.org/drawingml/2006/main">
               <a:ext uri="{FF2B5EF4-FFF2-40B4-BE49-F238E27FC236}">
-                <a16:creationId xmlns:a16="http://schemas.microsoft.com/office/drawing/2014/main" id="{83FD460C-7163-425D-B61A-9092E693EFBD}"/>
+                <a16:creationId xmlns:a16="http://schemas.microsoft.com/office/drawing/2014/main" id="{A990D80C-4506-40A7-9ED3-4B963CE8E820}"/>
               </a:ext>
             </a:extLst>
           </p:cNvPr>
@@ -9425,7 +10135,7 @@
           <p:cNvPr id="25" name="">
             <a:extLst xmlns:a="http://schemas.openxmlformats.org/drawingml/2006/main">
               <a:ext uri="{FF2B5EF4-FFF2-40B4-BE49-F238E27FC236}">
-                <a16:creationId xmlns:a16="http://schemas.microsoft.com/office/drawing/2014/main" id="{A64B0DAB-50A1-4597-B47D-E18071333834}"/>
+                <a16:creationId xmlns:a16="http://schemas.microsoft.com/office/drawing/2014/main" id="{8187C020-EDF9-481F-B4C0-B9999F7D080C}"/>
               </a:ext>
             </a:extLst>
           </p:cNvPr>
@@ -9475,7 +10185,7 @@
           <p:cNvPr id="26" name="">
             <a:extLst xmlns:a="http://schemas.openxmlformats.org/drawingml/2006/main">
               <a:ext uri="{FF2B5EF4-FFF2-40B4-BE49-F238E27FC236}">
-                <a16:creationId xmlns:a16="http://schemas.microsoft.com/office/drawing/2014/main" id="{81C412B8-EB74-4A78-AB4B-0C19578DD944}"/>
+                <a16:creationId xmlns:a16="http://schemas.microsoft.com/office/drawing/2014/main" id="{1D732429-724E-452F-A562-5994D5FE0727}"/>
               </a:ext>
             </a:extLst>
           </p:cNvPr>
@@ -9506,7 +10216,7 @@
           <p:cNvPr id="27" name="">
             <a:extLst xmlns:a="http://schemas.openxmlformats.org/drawingml/2006/main">
               <a:ext uri="{FF2B5EF4-FFF2-40B4-BE49-F238E27FC236}">
-                <a16:creationId xmlns:a16="http://schemas.microsoft.com/office/drawing/2014/main" id="{1E7A64A5-F2B0-46D1-9F3A-91F7DAA05572}"/>
+                <a16:creationId xmlns:a16="http://schemas.microsoft.com/office/drawing/2014/main" id="{2183682C-48BB-4008-BE7D-F243C3CFB57C}"/>
               </a:ext>
             </a:extLst>
           </p:cNvPr>
@@ -9556,7 +10266,7 @@
           <p:cNvPr id="28" name="">
             <a:extLst xmlns:a="http://schemas.openxmlformats.org/drawingml/2006/main">
               <a:ext uri="{FF2B5EF4-FFF2-40B4-BE49-F238E27FC236}">
-                <a16:creationId xmlns:a16="http://schemas.microsoft.com/office/drawing/2014/main" id="{54BC4305-DA21-482E-BA3A-AD92FCA5A8FA}"/>
+                <a16:creationId xmlns:a16="http://schemas.microsoft.com/office/drawing/2014/main" id="{38886314-B04A-4F9F-85BB-E3B007C78E49}"/>
               </a:ext>
             </a:extLst>
           </p:cNvPr>
@@ -9587,7 +10297,7 @@
           <p:cNvPr id="29" name="">
             <a:extLst xmlns:a="http://schemas.openxmlformats.org/drawingml/2006/main">
               <a:ext uri="{FF2B5EF4-FFF2-40B4-BE49-F238E27FC236}">
-                <a16:creationId xmlns:a16="http://schemas.microsoft.com/office/drawing/2014/main" id="{B26AC21E-9303-4B7E-BBB1-17D0E831DA17}"/>
+                <a16:creationId xmlns:a16="http://schemas.microsoft.com/office/drawing/2014/main" id="{0004A199-189B-4B6C-AEFE-FB91DF907ADD}"/>
               </a:ext>
             </a:extLst>
           </p:cNvPr>
@@ -9637,7 +10347,7 @@
           <p:cNvPr id="30" name="">
             <a:extLst xmlns:a="http://schemas.openxmlformats.org/drawingml/2006/main">
               <a:ext uri="{FF2B5EF4-FFF2-40B4-BE49-F238E27FC236}">
-                <a16:creationId xmlns:a16="http://schemas.microsoft.com/office/drawing/2014/main" id="{629978CC-66A6-4858-8C0E-D1731A086524}"/>
+                <a16:creationId xmlns:a16="http://schemas.microsoft.com/office/drawing/2014/main" id="{D082C4B0-4458-440A-9539-929788004E69}"/>
               </a:ext>
             </a:extLst>
           </p:cNvPr>
@@ -9668,7 +10378,7 @@
           <p:cNvPr id="31" name="">
             <a:extLst xmlns:a="http://schemas.openxmlformats.org/drawingml/2006/main">
               <a:ext uri="{FF2B5EF4-FFF2-40B4-BE49-F238E27FC236}">
-                <a16:creationId xmlns:a16="http://schemas.microsoft.com/office/drawing/2014/main" id="{7FF8F6ED-DBA3-42B3-A5D1-FEDF775A9CC0}"/>
+                <a16:creationId xmlns:a16="http://schemas.microsoft.com/office/drawing/2014/main" id="{527287B8-22DC-42D1-A29B-48A10D2A440E}"/>
               </a:ext>
             </a:extLst>
           </p:cNvPr>
@@ -9718,7 +10428,7 @@
           <p:cNvPr id="32" name="">
             <a:extLst xmlns:a="http://schemas.openxmlformats.org/drawingml/2006/main">
               <a:ext uri="{FF2B5EF4-FFF2-40B4-BE49-F238E27FC236}">
-                <a16:creationId xmlns:a16="http://schemas.microsoft.com/office/drawing/2014/main" id="{AFEF79DA-FA80-4901-9639-F84E0BE3B1A7}"/>
+                <a16:creationId xmlns:a16="http://schemas.microsoft.com/office/drawing/2014/main" id="{2F6124E0-4F4F-492F-9224-BA76E5513742}"/>
               </a:ext>
             </a:extLst>
           </p:cNvPr>
@@ -9749,7 +10459,7 @@
           <p:cNvPr id="33" name="">
             <a:extLst xmlns:a="http://schemas.openxmlformats.org/drawingml/2006/main">
               <a:ext uri="{FF2B5EF4-FFF2-40B4-BE49-F238E27FC236}">
-                <a16:creationId xmlns:a16="http://schemas.microsoft.com/office/drawing/2014/main" id="{A58CDB32-E6EC-48F8-9C0B-6ADB2BBF6AEE}"/>
+                <a16:creationId xmlns:a16="http://schemas.microsoft.com/office/drawing/2014/main" id="{62DB92D5-96F0-40CB-BAAB-CF4192D658DD}"/>
               </a:ext>
             </a:extLst>
           </p:cNvPr>
@@ -9799,7 +10509,7 @@
           <p:cNvPr id="34" name="">
             <a:extLst xmlns:a="http://schemas.openxmlformats.org/drawingml/2006/main">
               <a:ext uri="{FF2B5EF4-FFF2-40B4-BE49-F238E27FC236}">
-                <a16:creationId xmlns:a16="http://schemas.microsoft.com/office/drawing/2014/main" id="{E180D554-77EC-4DFD-B443-4507B8E5CBD1}"/>
+                <a16:creationId xmlns:a16="http://schemas.microsoft.com/office/drawing/2014/main" id="{CDC05822-ACFC-4834-8F18-FFC55B0505A4}"/>
               </a:ext>
             </a:extLst>
           </p:cNvPr>
@@ -9834,7 +10544,7 @@
           <p:cNvPr id="35" name="">
             <a:extLst xmlns:a="http://schemas.openxmlformats.org/drawingml/2006/main">
               <a:ext uri="{FF2B5EF4-FFF2-40B4-BE49-F238E27FC236}">
-                <a16:creationId xmlns:a16="http://schemas.microsoft.com/office/drawing/2014/main" id="{4BB1AB8B-F3F8-48C3-A6A6-74605F888791}"/>
+                <a16:creationId xmlns:a16="http://schemas.microsoft.com/office/drawing/2014/main" id="{DD7F5512-7731-4592-9666-F0FAD833B2A4}"/>
               </a:ext>
             </a:extLst>
           </p:cNvPr>
@@ -9884,7 +10594,7 @@
           <p:cNvPr id="36" name="">
             <a:extLst xmlns:a="http://schemas.openxmlformats.org/drawingml/2006/main">
               <a:ext uri="{FF2B5EF4-FFF2-40B4-BE49-F238E27FC236}">
-                <a16:creationId xmlns:a16="http://schemas.microsoft.com/office/drawing/2014/main" id="{999D0240-2780-45B9-830B-5A429C17673A}"/>
+                <a16:creationId xmlns:a16="http://schemas.microsoft.com/office/drawing/2014/main" id="{9F4CEE3A-EA28-42FF-9333-9AC72DAD86EA}"/>
               </a:ext>
             </a:extLst>
           </p:cNvPr>
@@ -9915,7 +10625,7 @@
           <p:cNvPr id="37" name="">
             <a:extLst xmlns:a="http://schemas.openxmlformats.org/drawingml/2006/main">
               <a:ext uri="{FF2B5EF4-FFF2-40B4-BE49-F238E27FC236}">
-                <a16:creationId xmlns:a16="http://schemas.microsoft.com/office/drawing/2014/main" id="{FFFBFAF0-52B6-4D3C-BD0F-82241EA6C351}"/>
+                <a16:creationId xmlns:a16="http://schemas.microsoft.com/office/drawing/2014/main" id="{9C170797-9D27-42E2-8C07-DC7F14FCF2D1}"/>
               </a:ext>
             </a:extLst>
           </p:cNvPr>
@@ -9965,7 +10675,7 @@
           <p:cNvPr id="38" name="">
             <a:extLst xmlns:a="http://schemas.openxmlformats.org/drawingml/2006/main">
               <a:ext uri="{FF2B5EF4-FFF2-40B4-BE49-F238E27FC236}">
-                <a16:creationId xmlns:a16="http://schemas.microsoft.com/office/drawing/2014/main" id="{35677099-F116-43B0-AD51-1E179C831C27}"/>
+                <a16:creationId xmlns:a16="http://schemas.microsoft.com/office/drawing/2014/main" id="{328A2FDA-0B25-4AE3-BFA6-37758FD01551}"/>
               </a:ext>
             </a:extLst>
           </p:cNvPr>
@@ -9996,7 +10706,7 @@
           <p:cNvPr id="39" name="">
             <a:extLst xmlns:a="http://schemas.openxmlformats.org/drawingml/2006/main">
               <a:ext uri="{FF2B5EF4-FFF2-40B4-BE49-F238E27FC236}">
-                <a16:creationId xmlns:a16="http://schemas.microsoft.com/office/drawing/2014/main" id="{50B47728-B64B-45C9-B801-FE2DFD548239}"/>
+                <a16:creationId xmlns:a16="http://schemas.microsoft.com/office/drawing/2014/main" id="{C4C508D1-4AC3-42AD-8969-95D8E3437625}"/>
               </a:ext>
             </a:extLst>
           </p:cNvPr>
@@ -10046,7 +10756,7 @@
           <p:cNvPr id="40" name="">
             <a:extLst xmlns:a="http://schemas.openxmlformats.org/drawingml/2006/main">
               <a:ext uri="{FF2B5EF4-FFF2-40B4-BE49-F238E27FC236}">
-                <a16:creationId xmlns:a16="http://schemas.microsoft.com/office/drawing/2014/main" id="{7459A0AB-16A3-428D-B523-3E3B1DB7C67B}"/>
+                <a16:creationId xmlns:a16="http://schemas.microsoft.com/office/drawing/2014/main" id="{04A2E119-649A-46BF-8451-62B74CF77B03}"/>
               </a:ext>
             </a:extLst>
           </p:cNvPr>
@@ -10077,7 +10787,7 @@
           <p:cNvPr id="41" name="">
             <a:extLst xmlns:a="http://schemas.openxmlformats.org/drawingml/2006/main">
               <a:ext uri="{FF2B5EF4-FFF2-40B4-BE49-F238E27FC236}">
-                <a16:creationId xmlns:a16="http://schemas.microsoft.com/office/drawing/2014/main" id="{1E295C43-B9D9-467C-B4B8-1DF91FF65C6E}"/>
+                <a16:creationId xmlns:a16="http://schemas.microsoft.com/office/drawing/2014/main" id="{9CF58C8D-90EE-4946-A843-70B4848B6FF0}"/>
               </a:ext>
             </a:extLst>
           </p:cNvPr>
@@ -10127,7 +10837,7 @@
           <p:cNvPr id="42" name="">
             <a:extLst xmlns:a="http://schemas.openxmlformats.org/drawingml/2006/main">
               <a:ext uri="{FF2B5EF4-FFF2-40B4-BE49-F238E27FC236}">
-                <a16:creationId xmlns:a16="http://schemas.microsoft.com/office/drawing/2014/main" id="{36AA5F9B-29FF-4639-9933-0428E1EC048E}"/>
+                <a16:creationId xmlns:a16="http://schemas.microsoft.com/office/drawing/2014/main" id="{427B678F-F936-43AD-AF2D-0AF4D88B0C00}"/>
               </a:ext>
             </a:extLst>
           </p:cNvPr>
@@ -10158,7 +10868,7 @@
           <p:cNvPr id="43" name="">
             <a:extLst xmlns:a="http://schemas.openxmlformats.org/drawingml/2006/main">
               <a:ext uri="{FF2B5EF4-FFF2-40B4-BE49-F238E27FC236}">
-                <a16:creationId xmlns:a16="http://schemas.microsoft.com/office/drawing/2014/main" id="{5194972A-891C-4AED-B5B5-681228FAF003}"/>
+                <a16:creationId xmlns:a16="http://schemas.microsoft.com/office/drawing/2014/main" id="{FC25954F-5279-414E-BA72-F01298331608}"/>
               </a:ext>
             </a:extLst>
           </p:cNvPr>
@@ -10208,7 +10918,7 @@
           <p:cNvPr id="44" name="">
             <a:extLst xmlns:a="http://schemas.openxmlformats.org/drawingml/2006/main">
               <a:ext uri="{FF2B5EF4-FFF2-40B4-BE49-F238E27FC236}">
-                <a16:creationId xmlns:a16="http://schemas.microsoft.com/office/drawing/2014/main" id="{CEC407D1-67AF-4A6A-A24F-3117419E8D1B}"/>
+                <a16:creationId xmlns:a16="http://schemas.microsoft.com/office/drawing/2014/main" id="{1C4DEDC6-04D7-4B99-B6D9-6ABAEDE88668}"/>
               </a:ext>
             </a:extLst>
           </p:cNvPr>
@@ -10256,7 +10966,7 @@
     </p:spTree>
     <p:extLst>
       <p:ext uri="{BB962C8B-B14F-4D97-AF65-F5344CB8AC3E}">
-        <p14:creationId xmlns:p14="http://schemas.microsoft.com/office/powerpoint/2010/main" val="483779356"/>
+        <p14:creationId xmlns:p14="http://schemas.microsoft.com/office/powerpoint/2010/main" val="1229254742"/>
       </p:ext>
     </p:extLst>
   </p:cSld>
@@ -10287,7 +10997,7 @@
           <p:cNvPr id="1" name="">
             <a:extLst xmlns:a="http://schemas.openxmlformats.org/drawingml/2006/main">
               <a:ext uri="{FF2B5EF4-FFF2-40B4-BE49-F238E27FC236}">
-                <a16:creationId xmlns:a16="http://schemas.microsoft.com/office/drawing/2014/main" id="{426A956C-4E27-4AD1-9576-0EBD8A44844B}"/>
+                <a16:creationId xmlns:a16="http://schemas.microsoft.com/office/drawing/2014/main" id="{046ED6DA-3467-4AFB-A7A8-0A1D6574AF1C}"/>
               </a:ext>
             </a:extLst>
           </p:cNvPr>
@@ -10337,7 +11047,7 @@
           <p:cNvPr id="2" name="">
             <a:extLst xmlns:a="http://schemas.openxmlformats.org/drawingml/2006/main">
               <a:ext uri="{FF2B5EF4-FFF2-40B4-BE49-F238E27FC236}">
-                <a16:creationId xmlns:a16="http://schemas.microsoft.com/office/drawing/2014/main" id="{D2F26F6E-CC1F-47C5-AD54-D74FBF8C6BDA}"/>
+                <a16:creationId xmlns:a16="http://schemas.microsoft.com/office/drawing/2014/main" id="{0CF87ED3-7CE4-4391-8BE3-E7B07A5C5F94}"/>
               </a:ext>
             </a:extLst>
           </p:cNvPr>
@@ -10387,7 +11097,7 @@
           <p:cNvPr id="3" name="">
             <a:extLst xmlns:a="http://schemas.openxmlformats.org/drawingml/2006/main">
               <a:ext uri="{FF2B5EF4-FFF2-40B4-BE49-F238E27FC236}">
-                <a16:creationId xmlns:a16="http://schemas.microsoft.com/office/drawing/2014/main" id="{D12E49DA-FD9A-4924-809A-D10C1A00F55E}"/>
+                <a16:creationId xmlns:a16="http://schemas.microsoft.com/office/drawing/2014/main" id="{046AD400-C4BA-439F-BA92-8D086063E4A0}"/>
               </a:ext>
             </a:extLst>
           </p:cNvPr>
@@ -10420,7 +11130,7 @@
           <p:cNvPr id="4" name="">
             <a:extLst xmlns:a="http://schemas.openxmlformats.org/drawingml/2006/main">
               <a:ext uri="{FF2B5EF4-FFF2-40B4-BE49-F238E27FC236}">
-                <a16:creationId xmlns:a16="http://schemas.microsoft.com/office/drawing/2014/main" id="{72DDFE06-2867-4D16-B214-7A0AC662D13C}"/>
+                <a16:creationId xmlns:a16="http://schemas.microsoft.com/office/drawing/2014/main" id="{166293B7-8928-4756-8C88-60525265EA01}"/>
               </a:ext>
             </a:extLst>
           </p:cNvPr>
@@ -10455,7 +11165,7 @@
           <p:cNvPr id="5" name="">
             <a:extLst xmlns:a="http://schemas.openxmlformats.org/drawingml/2006/main">
               <a:ext uri="{FF2B5EF4-FFF2-40B4-BE49-F238E27FC236}">
-                <a16:creationId xmlns:a16="http://schemas.microsoft.com/office/drawing/2014/main" id="{5A23349B-5DF6-46F3-A8CF-FB44EE45A9F4}"/>
+                <a16:creationId xmlns:a16="http://schemas.microsoft.com/office/drawing/2014/main" id="{9E284E98-5CD9-4AA7-B902-EC9A739368E1}"/>
               </a:ext>
             </a:extLst>
           </p:cNvPr>
@@ -10490,7 +11200,7 @@
           <p:cNvPr id="6" name="">
             <a:extLst xmlns:a="http://schemas.openxmlformats.org/drawingml/2006/main">
               <a:ext uri="{FF2B5EF4-FFF2-40B4-BE49-F238E27FC236}">
-                <a16:creationId xmlns:a16="http://schemas.microsoft.com/office/drawing/2014/main" id="{9CB499FF-AB35-42FB-9FB5-20AD51239BDB}"/>
+                <a16:creationId xmlns:a16="http://schemas.microsoft.com/office/drawing/2014/main" id="{165358F0-CFAF-4E55-BB65-5A23E27F7159}"/>
               </a:ext>
             </a:extLst>
           </p:cNvPr>
@@ -10540,7 +11250,7 @@
           <p:cNvPr id="7" name="">
             <a:extLst xmlns:a="http://schemas.openxmlformats.org/drawingml/2006/main">
               <a:ext uri="{FF2B5EF4-FFF2-40B4-BE49-F238E27FC236}">
-                <a16:creationId xmlns:a16="http://schemas.microsoft.com/office/drawing/2014/main" id="{6847BE81-E7AA-48A6-B870-6C15B0AED325}"/>
+                <a16:creationId xmlns:a16="http://schemas.microsoft.com/office/drawing/2014/main" id="{E23C1646-905F-481C-AB9E-42F83EF422F5}"/>
               </a:ext>
             </a:extLst>
           </p:cNvPr>
@@ -10571,7 +11281,7 @@
           <p:cNvPr id="8" name="">
             <a:extLst xmlns:a="http://schemas.openxmlformats.org/drawingml/2006/main">
               <a:ext uri="{FF2B5EF4-FFF2-40B4-BE49-F238E27FC236}">
-                <a16:creationId xmlns:a16="http://schemas.microsoft.com/office/drawing/2014/main" id="{11057EFC-7D8F-4368-8F06-F97111A0F739}"/>
+                <a16:creationId xmlns:a16="http://schemas.microsoft.com/office/drawing/2014/main" id="{ACCC915C-F0CA-42E5-9EDF-8130756507EC}"/>
               </a:ext>
             </a:extLst>
           </p:cNvPr>
@@ -10621,7 +11331,7 @@
           <p:cNvPr id="9" name="">
             <a:extLst xmlns:a="http://schemas.openxmlformats.org/drawingml/2006/main">
               <a:ext uri="{FF2B5EF4-FFF2-40B4-BE49-F238E27FC236}">
-                <a16:creationId xmlns:a16="http://schemas.microsoft.com/office/drawing/2014/main" id="{40AA5754-166C-4E66-ACC9-666B48E23333}"/>
+                <a16:creationId xmlns:a16="http://schemas.microsoft.com/office/drawing/2014/main" id="{005FEF6D-34CE-44D1-BD3A-2198BEEF0B7B}"/>
               </a:ext>
             </a:extLst>
           </p:cNvPr>
@@ -10652,7 +11362,7 @@
           <p:cNvPr id="10" name="">
             <a:extLst xmlns:a="http://schemas.openxmlformats.org/drawingml/2006/main">
               <a:ext uri="{FF2B5EF4-FFF2-40B4-BE49-F238E27FC236}">
-                <a16:creationId xmlns:a16="http://schemas.microsoft.com/office/drawing/2014/main" id="{836D618F-7983-491B-85E2-270E178B28BD}"/>
+                <a16:creationId xmlns:a16="http://schemas.microsoft.com/office/drawing/2014/main" id="{11632DC8-09F4-4CE5-9B42-F1EDA0185DDB}"/>
               </a:ext>
             </a:extLst>
           </p:cNvPr>
@@ -10702,7 +11412,7 @@
           <p:cNvPr id="11" name="">
             <a:extLst xmlns:a="http://schemas.openxmlformats.org/drawingml/2006/main">
               <a:ext uri="{FF2B5EF4-FFF2-40B4-BE49-F238E27FC236}">
-                <a16:creationId xmlns:a16="http://schemas.microsoft.com/office/drawing/2014/main" id="{1F972EDB-D6ED-41B1-A38B-0F1D291688F1}"/>
+                <a16:creationId xmlns:a16="http://schemas.microsoft.com/office/drawing/2014/main" id="{3DC25FD8-14B6-430C-9395-D08E7AB94365}"/>
               </a:ext>
             </a:extLst>
           </p:cNvPr>
@@ -10733,7 +11443,7 @@
           <p:cNvPr id="12" name="">
             <a:extLst xmlns:a="http://schemas.openxmlformats.org/drawingml/2006/main">
               <a:ext uri="{FF2B5EF4-FFF2-40B4-BE49-F238E27FC236}">
-                <a16:creationId xmlns:a16="http://schemas.microsoft.com/office/drawing/2014/main" id="{10DF9544-D978-41D7-B0DE-5B3D30DA5F5B}"/>
+                <a16:creationId xmlns:a16="http://schemas.microsoft.com/office/drawing/2014/main" id="{F847E951-FB66-4D15-B040-CE9A26C81763}"/>
               </a:ext>
             </a:extLst>
           </p:cNvPr>
@@ -10783,7 +11493,7 @@
           <p:cNvPr id="13" name="">
             <a:extLst xmlns:a="http://schemas.openxmlformats.org/drawingml/2006/main">
               <a:ext uri="{FF2B5EF4-FFF2-40B4-BE49-F238E27FC236}">
-                <a16:creationId xmlns:a16="http://schemas.microsoft.com/office/drawing/2014/main" id="{B37AA124-7991-4002-BEB0-ACBABE3BFC4A}"/>
+                <a16:creationId xmlns:a16="http://schemas.microsoft.com/office/drawing/2014/main" id="{B6C368A6-0748-4A92-B7C7-ACCEBDE029EF}"/>
               </a:ext>
             </a:extLst>
           </p:cNvPr>
@@ -10814,7 +11524,7 @@
           <p:cNvPr id="14" name="">
             <a:extLst xmlns:a="http://schemas.openxmlformats.org/drawingml/2006/main">
               <a:ext uri="{FF2B5EF4-FFF2-40B4-BE49-F238E27FC236}">
-                <a16:creationId xmlns:a16="http://schemas.microsoft.com/office/drawing/2014/main" id="{7AFE5E4A-8568-4372-BCAD-3860EBDF5E9D}"/>
+                <a16:creationId xmlns:a16="http://schemas.microsoft.com/office/drawing/2014/main" id="{D7A99D9B-F06B-4802-88B4-A26291DC447D}"/>
               </a:ext>
             </a:extLst>
           </p:cNvPr>
@@ -10864,7 +11574,7 @@
           <p:cNvPr id="15" name="">
             <a:extLst xmlns:a="http://schemas.openxmlformats.org/drawingml/2006/main">
               <a:ext uri="{FF2B5EF4-FFF2-40B4-BE49-F238E27FC236}">
-                <a16:creationId xmlns:a16="http://schemas.microsoft.com/office/drawing/2014/main" id="{31A5EFC7-A4B4-4973-A1DE-8FC123220B74}"/>
+                <a16:creationId xmlns:a16="http://schemas.microsoft.com/office/drawing/2014/main" id="{B356F06F-3886-485D-A64E-796C945C7067}"/>
               </a:ext>
             </a:extLst>
           </p:cNvPr>
@@ -10895,7 +11605,7 @@
           <p:cNvPr id="16" name="">
             <a:extLst xmlns:a="http://schemas.openxmlformats.org/drawingml/2006/main">
               <a:ext uri="{FF2B5EF4-FFF2-40B4-BE49-F238E27FC236}">
-                <a16:creationId xmlns:a16="http://schemas.microsoft.com/office/drawing/2014/main" id="{EDEB1705-5B33-4A5D-B074-7D89D5DC9EC0}"/>
+                <a16:creationId xmlns:a16="http://schemas.microsoft.com/office/drawing/2014/main" id="{59DAA904-5F24-425E-BBE7-DA8DE5FF11B4}"/>
               </a:ext>
             </a:extLst>
           </p:cNvPr>
@@ -10945,7 +11655,7 @@
           <p:cNvPr id="17" name="">
             <a:extLst xmlns:a="http://schemas.openxmlformats.org/drawingml/2006/main">
               <a:ext uri="{FF2B5EF4-FFF2-40B4-BE49-F238E27FC236}">
-                <a16:creationId xmlns:a16="http://schemas.microsoft.com/office/drawing/2014/main" id="{D312FF90-713C-4833-96BE-50FA47340DA2}"/>
+                <a16:creationId xmlns:a16="http://schemas.microsoft.com/office/drawing/2014/main" id="{D403FB37-5B51-4460-8B47-D52A021DBE5A}"/>
               </a:ext>
             </a:extLst>
           </p:cNvPr>
@@ -10995,7 +11705,7 @@
           <p:cNvPr id="18" name="">
             <a:extLst xmlns:a="http://schemas.openxmlformats.org/drawingml/2006/main">
               <a:ext uri="{FF2B5EF4-FFF2-40B4-BE49-F238E27FC236}">
-                <a16:creationId xmlns:a16="http://schemas.microsoft.com/office/drawing/2014/main" id="{86014AC8-554C-4C32-BBFB-B6C24D092D53}"/>
+                <a16:creationId xmlns:a16="http://schemas.microsoft.com/office/drawing/2014/main" id="{5BC5BE08-A79D-44DF-AD94-04F0D18FF1C1}"/>
               </a:ext>
             </a:extLst>
           </p:cNvPr>
@@ -11026,7 +11736,7 @@
           <p:cNvPr id="19" name="">
             <a:extLst xmlns:a="http://schemas.openxmlformats.org/drawingml/2006/main">
               <a:ext uri="{FF2B5EF4-FFF2-40B4-BE49-F238E27FC236}">
-                <a16:creationId xmlns:a16="http://schemas.microsoft.com/office/drawing/2014/main" id="{F6DEB681-4F75-4633-B7E1-3382109EB04C}"/>
+                <a16:creationId xmlns:a16="http://schemas.microsoft.com/office/drawing/2014/main" id="{CC1B8650-0CA2-489B-BB9B-23C59E032886}"/>
               </a:ext>
             </a:extLst>
           </p:cNvPr>
@@ -11076,7 +11786,7 @@
           <p:cNvPr id="20" name="">
             <a:extLst xmlns:a="http://schemas.openxmlformats.org/drawingml/2006/main">
               <a:ext uri="{FF2B5EF4-FFF2-40B4-BE49-F238E27FC236}">
-                <a16:creationId xmlns:a16="http://schemas.microsoft.com/office/drawing/2014/main" id="{C37CFAF3-B2D7-42DE-81A5-FFD4F83656B2}"/>
+                <a16:creationId xmlns:a16="http://schemas.microsoft.com/office/drawing/2014/main" id="{0F42FB7F-77EC-4FFF-AEB4-82AFEDD73C95}"/>
               </a:ext>
             </a:extLst>
           </p:cNvPr>
@@ -11107,7 +11817,7 @@
           <p:cNvPr id="21" name="">
             <a:extLst xmlns:a="http://schemas.openxmlformats.org/drawingml/2006/main">
               <a:ext uri="{FF2B5EF4-FFF2-40B4-BE49-F238E27FC236}">
-                <a16:creationId xmlns:a16="http://schemas.microsoft.com/office/drawing/2014/main" id="{7CD4B05A-0A9B-49A4-8946-C5AA0C27AF30}"/>
+                <a16:creationId xmlns:a16="http://schemas.microsoft.com/office/drawing/2014/main" id="{136E9EF0-F4FD-4BF8-A55A-4E2447108CC8}"/>
               </a:ext>
             </a:extLst>
           </p:cNvPr>
@@ -11157,7 +11867,7 @@
           <p:cNvPr id="22" name="">
             <a:extLst xmlns:a="http://schemas.openxmlformats.org/drawingml/2006/main">
               <a:ext uri="{FF2B5EF4-FFF2-40B4-BE49-F238E27FC236}">
-                <a16:creationId xmlns:a16="http://schemas.microsoft.com/office/drawing/2014/main" id="{32E3D37B-11D0-4702-9789-D0D0C6A3DE96}"/>
+                <a16:creationId xmlns:a16="http://schemas.microsoft.com/office/drawing/2014/main" id="{B3C8774F-B4AC-4E5F-A9DE-15AA47C29E02}"/>
               </a:ext>
             </a:extLst>
           </p:cNvPr>
@@ -11188,7 +11898,7 @@
           <p:cNvPr id="23" name="">
             <a:extLst xmlns:a="http://schemas.openxmlformats.org/drawingml/2006/main">
               <a:ext uri="{FF2B5EF4-FFF2-40B4-BE49-F238E27FC236}">
-                <a16:creationId xmlns:a16="http://schemas.microsoft.com/office/drawing/2014/main" id="{D40D0D79-A11A-4940-BEC6-CF728A6FA9DC}"/>
+                <a16:creationId xmlns:a16="http://schemas.microsoft.com/office/drawing/2014/main" id="{389E3284-BF96-4D99-A225-A8AF3570337D}"/>
               </a:ext>
             </a:extLst>
           </p:cNvPr>
@@ -11238,7 +11948,7 @@
           <p:cNvPr id="24" name="">
             <a:extLst xmlns:a="http://schemas.openxmlformats.org/drawingml/2006/main">
               <a:ext uri="{FF2B5EF4-FFF2-40B4-BE49-F238E27FC236}">
-                <a16:creationId xmlns:a16="http://schemas.microsoft.com/office/drawing/2014/main" id="{CA4A5C98-5D4C-4040-853D-8893620171EC}"/>
+                <a16:creationId xmlns:a16="http://schemas.microsoft.com/office/drawing/2014/main" id="{409059DA-A156-4932-9EB7-47D2D9269F27}"/>
               </a:ext>
             </a:extLst>
           </p:cNvPr>
@@ -11269,7 +11979,7 @@
           <p:cNvPr id="25" name="">
             <a:extLst xmlns:a="http://schemas.openxmlformats.org/drawingml/2006/main">
               <a:ext uri="{FF2B5EF4-FFF2-40B4-BE49-F238E27FC236}">
-                <a16:creationId xmlns:a16="http://schemas.microsoft.com/office/drawing/2014/main" id="{04AD8E6A-20B4-4E12-A8A0-C7B81E448B7A}"/>
+                <a16:creationId xmlns:a16="http://schemas.microsoft.com/office/drawing/2014/main" id="{36FD26D6-7E64-4A79-BA59-2C22549219AC}"/>
               </a:ext>
             </a:extLst>
           </p:cNvPr>
@@ -11319,7 +12029,7 @@
           <p:cNvPr id="26" name="">
             <a:extLst xmlns:a="http://schemas.openxmlformats.org/drawingml/2006/main">
               <a:ext uri="{FF2B5EF4-FFF2-40B4-BE49-F238E27FC236}">
-                <a16:creationId xmlns:a16="http://schemas.microsoft.com/office/drawing/2014/main" id="{FB8C8295-3C64-48FA-BDC1-F40BDACD566C}"/>
+                <a16:creationId xmlns:a16="http://schemas.microsoft.com/office/drawing/2014/main" id="{4C521710-D3DF-4235-841D-9103BA9C6046}"/>
               </a:ext>
             </a:extLst>
           </p:cNvPr>
@@ -11350,7 +12060,7 @@
           <p:cNvPr id="27" name="">
             <a:extLst xmlns:a="http://schemas.openxmlformats.org/drawingml/2006/main">
               <a:ext uri="{FF2B5EF4-FFF2-40B4-BE49-F238E27FC236}">
-                <a16:creationId xmlns:a16="http://schemas.microsoft.com/office/drawing/2014/main" id="{A190BC24-CF7A-46B6-ADF8-3D24FE063B75}"/>
+                <a16:creationId xmlns:a16="http://schemas.microsoft.com/office/drawing/2014/main" id="{1E3B1D21-59A4-445E-B3AC-8F14A3695935}"/>
               </a:ext>
             </a:extLst>
           </p:cNvPr>
@@ -11398,7 +12108,7 @@
     </p:spTree>
     <p:extLst>
       <p:ext uri="{BB962C8B-B14F-4D97-AF65-F5344CB8AC3E}">
-        <p14:creationId xmlns:p14="http://schemas.microsoft.com/office/powerpoint/2010/main" val="1222737422"/>
+        <p14:creationId xmlns:p14="http://schemas.microsoft.com/office/powerpoint/2010/main" val="1291274272"/>
       </p:ext>
     </p:extLst>
   </p:cSld>
@@ -11429,7 +12139,7 @@
           <p:cNvPr id="1" name="">
             <a:extLst xmlns:a="http://schemas.openxmlformats.org/drawingml/2006/main">
               <a:ext uri="{FF2B5EF4-FFF2-40B4-BE49-F238E27FC236}">
-                <a16:creationId xmlns:a16="http://schemas.microsoft.com/office/drawing/2014/main" id="{443739F3-E4E2-4386-8C6F-C1A92E027867}"/>
+                <a16:creationId xmlns:a16="http://schemas.microsoft.com/office/drawing/2014/main" id="{816CDB7C-284E-401B-8C56-E56DA74BBD7C}"/>
               </a:ext>
             </a:extLst>
           </p:cNvPr>
@@ -11479,7 +12189,7 @@
           <p:cNvPr id="2" name="">
             <a:extLst xmlns:a="http://schemas.openxmlformats.org/drawingml/2006/main">
               <a:ext uri="{FF2B5EF4-FFF2-40B4-BE49-F238E27FC236}">
-                <a16:creationId xmlns:a16="http://schemas.microsoft.com/office/drawing/2014/main" id="{5B25765E-ED48-4188-906A-96F05F7791A9}"/>
+                <a16:creationId xmlns:a16="http://schemas.microsoft.com/office/drawing/2014/main" id="{46AEDAC2-5D05-4181-978C-AF922CC10BDF}"/>
               </a:ext>
             </a:extLst>
           </p:cNvPr>
@@ -11529,7 +12239,7 @@
           <p:cNvPr id="3" name="">
             <a:extLst xmlns:a="http://schemas.openxmlformats.org/drawingml/2006/main">
               <a:ext uri="{FF2B5EF4-FFF2-40B4-BE49-F238E27FC236}">
-                <a16:creationId xmlns:a16="http://schemas.microsoft.com/office/drawing/2014/main" id="{7E201075-0734-4C0C-92D7-94F23300D0E7}"/>
+                <a16:creationId xmlns:a16="http://schemas.microsoft.com/office/drawing/2014/main" id="{E666DFF6-EEBD-418B-BD5D-5D93F69F3D1E}"/>
               </a:ext>
             </a:extLst>
           </p:cNvPr>
@@ -11562,7 +12272,7 @@
           <p:cNvPr id="4" name="">
             <a:extLst xmlns:a="http://schemas.openxmlformats.org/drawingml/2006/main">
               <a:ext uri="{FF2B5EF4-FFF2-40B4-BE49-F238E27FC236}">
-                <a16:creationId xmlns:a16="http://schemas.microsoft.com/office/drawing/2014/main" id="{59801B92-BF97-46F7-A832-90257EE21026}"/>
+                <a16:creationId xmlns:a16="http://schemas.microsoft.com/office/drawing/2014/main" id="{F1A84ABF-41CF-4766-86EA-05F83527D7C1}"/>
               </a:ext>
             </a:extLst>
           </p:cNvPr>
@@ -11597,7 +12307,7 @@
           <p:cNvPr id="5" name="">
             <a:extLst xmlns:a="http://schemas.openxmlformats.org/drawingml/2006/main">
               <a:ext uri="{FF2B5EF4-FFF2-40B4-BE49-F238E27FC236}">
-                <a16:creationId xmlns:a16="http://schemas.microsoft.com/office/drawing/2014/main" id="{B98A012F-BC1B-4241-B906-587C5DC430E9}"/>
+                <a16:creationId xmlns:a16="http://schemas.microsoft.com/office/drawing/2014/main" id="{57A23CD1-1CA0-474B-875D-A6750957388F}"/>
               </a:ext>
             </a:extLst>
           </p:cNvPr>
@@ -11647,7 +12357,7 @@
           <p:cNvPr id="6" name="">
             <a:extLst xmlns:a="http://schemas.openxmlformats.org/drawingml/2006/main">
               <a:ext uri="{FF2B5EF4-FFF2-40B4-BE49-F238E27FC236}">
-                <a16:creationId xmlns:a16="http://schemas.microsoft.com/office/drawing/2014/main" id="{29A3E5FD-C5D0-41E7-8733-62AA07F9B2A6}"/>
+                <a16:creationId xmlns:a16="http://schemas.microsoft.com/office/drawing/2014/main" id="{174E92A9-9509-419A-A9BC-84605253F077}"/>
               </a:ext>
             </a:extLst>
           </p:cNvPr>
@@ -11678,7 +12388,7 @@
           <p:cNvPr id="7" name="">
             <a:extLst xmlns:a="http://schemas.openxmlformats.org/drawingml/2006/main">
               <a:ext uri="{FF2B5EF4-FFF2-40B4-BE49-F238E27FC236}">
-                <a16:creationId xmlns:a16="http://schemas.microsoft.com/office/drawing/2014/main" id="{AB02C42D-0D22-418B-A7B6-9B8852C49BC6}"/>
+                <a16:creationId xmlns:a16="http://schemas.microsoft.com/office/drawing/2014/main" id="{F9A61E31-F741-4E02-8899-827FD1AC2C50}"/>
               </a:ext>
             </a:extLst>
           </p:cNvPr>
@@ -11728,7 +12438,7 @@
           <p:cNvPr id="8" name="">
             <a:extLst xmlns:a="http://schemas.openxmlformats.org/drawingml/2006/main">
               <a:ext uri="{FF2B5EF4-FFF2-40B4-BE49-F238E27FC236}">
-                <a16:creationId xmlns:a16="http://schemas.microsoft.com/office/drawing/2014/main" id="{90AC6970-9560-4BBE-8574-D411BCC11692}"/>
+                <a16:creationId xmlns:a16="http://schemas.microsoft.com/office/drawing/2014/main" id="{6EA51F5B-6088-44ED-9A07-08C586F2DD0A}"/>
               </a:ext>
             </a:extLst>
           </p:cNvPr>
@@ -11759,7 +12469,7 @@
           <p:cNvPr id="9" name="">
             <a:extLst xmlns:a="http://schemas.openxmlformats.org/drawingml/2006/main">
               <a:ext uri="{FF2B5EF4-FFF2-40B4-BE49-F238E27FC236}">
-                <a16:creationId xmlns:a16="http://schemas.microsoft.com/office/drawing/2014/main" id="{02112D7D-EF2D-4744-8F38-31D66768A2DF}"/>
+                <a16:creationId xmlns:a16="http://schemas.microsoft.com/office/drawing/2014/main" id="{CDD74DC5-58C2-4001-BC56-392828B71D06}"/>
               </a:ext>
             </a:extLst>
           </p:cNvPr>
@@ -11809,7 +12519,7 @@
           <p:cNvPr id="10" name="">
             <a:extLst xmlns:a="http://schemas.openxmlformats.org/drawingml/2006/main">
               <a:ext uri="{FF2B5EF4-FFF2-40B4-BE49-F238E27FC236}">
-                <a16:creationId xmlns:a16="http://schemas.microsoft.com/office/drawing/2014/main" id="{CB49A0E3-6224-4287-9D12-7E649166D382}"/>
+                <a16:creationId xmlns:a16="http://schemas.microsoft.com/office/drawing/2014/main" id="{F29CE372-017A-4DCF-BF78-709820F71493}"/>
               </a:ext>
             </a:extLst>
           </p:cNvPr>
@@ -11840,7 +12550,7 @@
           <p:cNvPr id="11" name="">
             <a:extLst xmlns:a="http://schemas.openxmlformats.org/drawingml/2006/main">
               <a:ext uri="{FF2B5EF4-FFF2-40B4-BE49-F238E27FC236}">
-                <a16:creationId xmlns:a16="http://schemas.microsoft.com/office/drawing/2014/main" id="{476B76B2-363D-4071-B575-52B747CCD983}"/>
+                <a16:creationId xmlns:a16="http://schemas.microsoft.com/office/drawing/2014/main" id="{1E3DFC1C-B0B2-442D-BDAB-B18FE038CB9F}"/>
               </a:ext>
             </a:extLst>
           </p:cNvPr>
@@ -11890,7 +12600,7 @@
           <p:cNvPr id="12" name="">
             <a:extLst xmlns:a="http://schemas.openxmlformats.org/drawingml/2006/main">
               <a:ext uri="{FF2B5EF4-FFF2-40B4-BE49-F238E27FC236}">
-                <a16:creationId xmlns:a16="http://schemas.microsoft.com/office/drawing/2014/main" id="{74C95184-7FCB-49D6-8979-1BEA7F86D791}"/>
+                <a16:creationId xmlns:a16="http://schemas.microsoft.com/office/drawing/2014/main" id="{12D2EF3D-7CB2-42B8-AEEE-707C8267910E}"/>
               </a:ext>
             </a:extLst>
           </p:cNvPr>
@@ -11921,7 +12631,7 @@
           <p:cNvPr id="13" name="">
             <a:extLst xmlns:a="http://schemas.openxmlformats.org/drawingml/2006/main">
               <a:ext uri="{FF2B5EF4-FFF2-40B4-BE49-F238E27FC236}">
-                <a16:creationId xmlns:a16="http://schemas.microsoft.com/office/drawing/2014/main" id="{C4CFE570-02AD-4ED2-8A44-4277EE8AE748}"/>
+                <a16:creationId xmlns:a16="http://schemas.microsoft.com/office/drawing/2014/main" id="{0045F10E-1165-4E54-9391-7999225B1E17}"/>
               </a:ext>
             </a:extLst>
           </p:cNvPr>
@@ -11971,7 +12681,7 @@
           <p:cNvPr id="14" name="">
             <a:extLst xmlns:a="http://schemas.openxmlformats.org/drawingml/2006/main">
               <a:ext uri="{FF2B5EF4-FFF2-40B4-BE49-F238E27FC236}">
-                <a16:creationId xmlns:a16="http://schemas.microsoft.com/office/drawing/2014/main" id="{A612F7D1-6FB2-4619-A386-B58A816C53FE}"/>
+                <a16:creationId xmlns:a16="http://schemas.microsoft.com/office/drawing/2014/main" id="{81ABA04B-F1E7-4405-BA7E-4CF6A232CE22}"/>
               </a:ext>
             </a:extLst>
           </p:cNvPr>
@@ -12002,7 +12712,7 @@
           <p:cNvPr id="15" name="">
             <a:extLst xmlns:a="http://schemas.openxmlformats.org/drawingml/2006/main">
               <a:ext uri="{FF2B5EF4-FFF2-40B4-BE49-F238E27FC236}">
-                <a16:creationId xmlns:a16="http://schemas.microsoft.com/office/drawing/2014/main" id="{0DA2D9F3-13C7-46B0-9DAA-91183F64659A}"/>
+                <a16:creationId xmlns:a16="http://schemas.microsoft.com/office/drawing/2014/main" id="{C4E7DE7B-5E79-43AB-97B0-0FFC3A78DF02}"/>
               </a:ext>
             </a:extLst>
           </p:cNvPr>
@@ -12052,7 +12762,7 @@
           <p:cNvPr id="16" name="">
             <a:extLst xmlns:a="http://schemas.openxmlformats.org/drawingml/2006/main">
               <a:ext uri="{FF2B5EF4-FFF2-40B4-BE49-F238E27FC236}">
-                <a16:creationId xmlns:a16="http://schemas.microsoft.com/office/drawing/2014/main" id="{4C9EF156-8836-4ED3-9E70-D95A3D2D64C3}"/>
+                <a16:creationId xmlns:a16="http://schemas.microsoft.com/office/drawing/2014/main" id="{D2A837EB-E01D-45B4-A768-D56E0258DA2C}"/>
               </a:ext>
             </a:extLst>
           </p:cNvPr>
@@ -12087,7 +12797,7 @@
           <p:cNvPr id="17" name="">
             <a:extLst xmlns:a="http://schemas.openxmlformats.org/drawingml/2006/main">
               <a:ext uri="{FF2B5EF4-FFF2-40B4-BE49-F238E27FC236}">
-                <a16:creationId xmlns:a16="http://schemas.microsoft.com/office/drawing/2014/main" id="{DAA57325-C61F-4CC0-BEE5-E88185683898}"/>
+                <a16:creationId xmlns:a16="http://schemas.microsoft.com/office/drawing/2014/main" id="{C293FC30-BE95-4CED-A2CC-FEA218966E44}"/>
               </a:ext>
             </a:extLst>
           </p:cNvPr>
@@ -12137,7 +12847,7 @@
           <p:cNvPr id="18" name="">
             <a:extLst xmlns:a="http://schemas.openxmlformats.org/drawingml/2006/main">
               <a:ext uri="{FF2B5EF4-FFF2-40B4-BE49-F238E27FC236}">
-                <a16:creationId xmlns:a16="http://schemas.microsoft.com/office/drawing/2014/main" id="{BB0FAF69-2690-49E8-AAC5-92561201468E}"/>
+                <a16:creationId xmlns:a16="http://schemas.microsoft.com/office/drawing/2014/main" id="{1E086AAD-35B9-4711-8864-497BCF8D8214}"/>
               </a:ext>
             </a:extLst>
           </p:cNvPr>
@@ -12168,7 +12878,7 @@
           <p:cNvPr id="19" name="">
             <a:extLst xmlns:a="http://schemas.openxmlformats.org/drawingml/2006/main">
               <a:ext uri="{FF2B5EF4-FFF2-40B4-BE49-F238E27FC236}">
-                <a16:creationId xmlns:a16="http://schemas.microsoft.com/office/drawing/2014/main" id="{846092FB-6AA2-4D5B-8093-EF4C05E00488}"/>
+                <a16:creationId xmlns:a16="http://schemas.microsoft.com/office/drawing/2014/main" id="{F04FECEE-2678-4D8C-B334-7D41C104F312}"/>
               </a:ext>
             </a:extLst>
           </p:cNvPr>
@@ -12218,7 +12928,7 @@
           <p:cNvPr id="20" name="">
             <a:extLst xmlns:a="http://schemas.openxmlformats.org/drawingml/2006/main">
               <a:ext uri="{FF2B5EF4-FFF2-40B4-BE49-F238E27FC236}">
-                <a16:creationId xmlns:a16="http://schemas.microsoft.com/office/drawing/2014/main" id="{E56BCAE5-30DC-4780-A94B-5431EFC9593F}"/>
+                <a16:creationId xmlns:a16="http://schemas.microsoft.com/office/drawing/2014/main" id="{B939450C-CC7B-4C1F-B21F-B06A6DDAAF6D}"/>
               </a:ext>
             </a:extLst>
           </p:cNvPr>
@@ -12249,7 +12959,7 @@
           <p:cNvPr id="21" name="">
             <a:extLst xmlns:a="http://schemas.openxmlformats.org/drawingml/2006/main">
               <a:ext uri="{FF2B5EF4-FFF2-40B4-BE49-F238E27FC236}">
-                <a16:creationId xmlns:a16="http://schemas.microsoft.com/office/drawing/2014/main" id="{78BEFB06-8D1E-4515-8DE8-101CA3EC9EA9}"/>
+                <a16:creationId xmlns:a16="http://schemas.microsoft.com/office/drawing/2014/main" id="{7A51CC34-4BFD-4B51-AB17-713AB578FB43}"/>
               </a:ext>
             </a:extLst>
           </p:cNvPr>
@@ -12299,7 +13009,7 @@
           <p:cNvPr id="22" name="">
             <a:extLst xmlns:a="http://schemas.openxmlformats.org/drawingml/2006/main">
               <a:ext uri="{FF2B5EF4-FFF2-40B4-BE49-F238E27FC236}">
-                <a16:creationId xmlns:a16="http://schemas.microsoft.com/office/drawing/2014/main" id="{987EAAA9-88D2-4F8B-BDFB-EF36AE0696CF}"/>
+                <a16:creationId xmlns:a16="http://schemas.microsoft.com/office/drawing/2014/main" id="{457A66DA-163D-40D3-A266-89A44E9AFCB7}"/>
               </a:ext>
             </a:extLst>
           </p:cNvPr>
@@ -12330,7 +13040,7 @@
           <p:cNvPr id="23" name="">
             <a:extLst xmlns:a="http://schemas.openxmlformats.org/drawingml/2006/main">
               <a:ext uri="{FF2B5EF4-FFF2-40B4-BE49-F238E27FC236}">
-                <a16:creationId xmlns:a16="http://schemas.microsoft.com/office/drawing/2014/main" id="{3C72785F-F410-40A1-A386-FE50B8CB3FC2}"/>
+                <a16:creationId xmlns:a16="http://schemas.microsoft.com/office/drawing/2014/main" id="{E9429C3A-BC11-4736-8338-AE1443CA367A}"/>
               </a:ext>
             </a:extLst>
           </p:cNvPr>
@@ -12380,7 +13090,7 @@
           <p:cNvPr id="24" name="">
             <a:extLst xmlns:a="http://schemas.openxmlformats.org/drawingml/2006/main">
               <a:ext uri="{FF2B5EF4-FFF2-40B4-BE49-F238E27FC236}">
-                <a16:creationId xmlns:a16="http://schemas.microsoft.com/office/drawing/2014/main" id="{2AFACE8C-5DAB-4C97-84C1-7468A2947D5A}"/>
+                <a16:creationId xmlns:a16="http://schemas.microsoft.com/office/drawing/2014/main" id="{98B8CACE-6433-4AC1-BCF9-ED562935DC5A}"/>
               </a:ext>
             </a:extLst>
           </p:cNvPr>
@@ -12411,7 +13121,7 @@
           <p:cNvPr id="25" name="">
             <a:extLst xmlns:a="http://schemas.openxmlformats.org/drawingml/2006/main">
               <a:ext uri="{FF2B5EF4-FFF2-40B4-BE49-F238E27FC236}">
-                <a16:creationId xmlns:a16="http://schemas.microsoft.com/office/drawing/2014/main" id="{D20EAA42-F412-45DF-8A27-15A5C0D1564C}"/>
+                <a16:creationId xmlns:a16="http://schemas.microsoft.com/office/drawing/2014/main" id="{195177CE-5831-48A2-816C-67F70ED29ED0}"/>
               </a:ext>
             </a:extLst>
           </p:cNvPr>
@@ -12461,7 +13171,7 @@
           <p:cNvPr id="26" name="">
             <a:extLst xmlns:a="http://schemas.openxmlformats.org/drawingml/2006/main">
               <a:ext uri="{FF2B5EF4-FFF2-40B4-BE49-F238E27FC236}">
-                <a16:creationId xmlns:a16="http://schemas.microsoft.com/office/drawing/2014/main" id="{E17432BB-6AF3-4375-B4BE-A6672F82F283}"/>
+                <a16:creationId xmlns:a16="http://schemas.microsoft.com/office/drawing/2014/main" id="{CC920F93-20A2-4070-92CC-1C758FE084E5}"/>
               </a:ext>
             </a:extLst>
           </p:cNvPr>
@@ -12492,7 +13202,7 @@
           <p:cNvPr id="27" name="">
             <a:extLst xmlns:a="http://schemas.openxmlformats.org/drawingml/2006/main">
               <a:ext uri="{FF2B5EF4-FFF2-40B4-BE49-F238E27FC236}">
-                <a16:creationId xmlns:a16="http://schemas.microsoft.com/office/drawing/2014/main" id="{E751F110-620B-4A2D-84EA-03D7A77BAC3C}"/>
+                <a16:creationId xmlns:a16="http://schemas.microsoft.com/office/drawing/2014/main" id="{172EEA85-A27E-4719-9E32-EF451E9DC06C}"/>
               </a:ext>
             </a:extLst>
           </p:cNvPr>
@@ -12540,7 +13250,7 @@
     </p:spTree>
     <p:extLst>
       <p:ext uri="{BB962C8B-B14F-4D97-AF65-F5344CB8AC3E}">
-        <p14:creationId xmlns:p14="http://schemas.microsoft.com/office/powerpoint/2010/main" val="139311800"/>
+        <p14:creationId xmlns:p14="http://schemas.microsoft.com/office/powerpoint/2010/main" val="108289799"/>
       </p:ext>
     </p:extLst>
   </p:cSld>
@@ -12571,7 +13281,7 @@
           <p:cNvPr id="1" name="">
             <a:extLst xmlns:a="http://schemas.openxmlformats.org/drawingml/2006/main">
               <a:ext uri="{FF2B5EF4-FFF2-40B4-BE49-F238E27FC236}">
-                <a16:creationId xmlns:a16="http://schemas.microsoft.com/office/drawing/2014/main" id="{B2FCFE4B-ADFF-4A97-AC14-BFCBA9E7EED7}"/>
+                <a16:creationId xmlns:a16="http://schemas.microsoft.com/office/drawing/2014/main" id="{B3ACF61B-1944-477E-8A75-9EF9F207ECBE}"/>
               </a:ext>
             </a:extLst>
           </p:cNvPr>
@@ -12621,7 +13331,7 @@
           <p:cNvPr id="2" name="">
             <a:extLst xmlns:a="http://schemas.openxmlformats.org/drawingml/2006/main">
               <a:ext uri="{FF2B5EF4-FFF2-40B4-BE49-F238E27FC236}">
-                <a16:creationId xmlns:a16="http://schemas.microsoft.com/office/drawing/2014/main" id="{59779B16-C44F-4C19-9B9B-BB057B52FE3A}"/>
+                <a16:creationId xmlns:a16="http://schemas.microsoft.com/office/drawing/2014/main" id="{33520278-EF78-4BB3-965C-02351F79E0A5}"/>
               </a:ext>
             </a:extLst>
           </p:cNvPr>
@@ -12671,7 +13381,7 @@
           <p:cNvPr id="3" name="">
             <a:extLst xmlns:a="http://schemas.openxmlformats.org/drawingml/2006/main">
               <a:ext uri="{FF2B5EF4-FFF2-40B4-BE49-F238E27FC236}">
-                <a16:creationId xmlns:a16="http://schemas.microsoft.com/office/drawing/2014/main" id="{5EF2B354-683B-47E9-93C7-CC6C0BF54AC9}"/>
+                <a16:creationId xmlns:a16="http://schemas.microsoft.com/office/drawing/2014/main" id="{855157BD-15DB-42E2-AD1D-61A7FEBC3670}"/>
               </a:ext>
             </a:extLst>
           </p:cNvPr>
@@ -12704,7 +13414,7 @@
           <p:cNvPr id="4" name="">
             <a:extLst xmlns:a="http://schemas.openxmlformats.org/drawingml/2006/main">
               <a:ext uri="{FF2B5EF4-FFF2-40B4-BE49-F238E27FC236}">
-                <a16:creationId xmlns:a16="http://schemas.microsoft.com/office/drawing/2014/main" id="{1F425E80-7B50-43B4-A713-F3FF703F4DB3}"/>
+                <a16:creationId xmlns:a16="http://schemas.microsoft.com/office/drawing/2014/main" id="{3DA90ED0-E2F4-44B2-9ADF-26C9C17F931F}"/>
               </a:ext>
             </a:extLst>
           </p:cNvPr>
@@ -12739,7 +13449,7 @@
           <p:cNvPr id="5" name="">
             <a:extLst xmlns:a="http://schemas.openxmlformats.org/drawingml/2006/main">
               <a:ext uri="{FF2B5EF4-FFF2-40B4-BE49-F238E27FC236}">
-                <a16:creationId xmlns:a16="http://schemas.microsoft.com/office/drawing/2014/main" id="{F9325BCF-2B76-4C40-B1C7-C3A39E2078FA}"/>
+                <a16:creationId xmlns:a16="http://schemas.microsoft.com/office/drawing/2014/main" id="{637C685F-7D37-4580-BDDF-F387356FC9FA}"/>
               </a:ext>
             </a:extLst>
           </p:cNvPr>
@@ -12789,7 +13499,7 @@
           <p:cNvPr id="6" name="">
             <a:extLst xmlns:a="http://schemas.openxmlformats.org/drawingml/2006/main">
               <a:ext uri="{FF2B5EF4-FFF2-40B4-BE49-F238E27FC236}">
-                <a16:creationId xmlns:a16="http://schemas.microsoft.com/office/drawing/2014/main" id="{67BF0B49-C6FF-4035-ABE1-96E99C62C653}"/>
+                <a16:creationId xmlns:a16="http://schemas.microsoft.com/office/drawing/2014/main" id="{960F78CC-11BB-4C7F-999E-45A6E326060B}"/>
               </a:ext>
             </a:extLst>
           </p:cNvPr>
@@ -12839,7 +13549,7 @@
           <p:cNvPr id="7" name="">
             <a:extLst xmlns:a="http://schemas.openxmlformats.org/drawingml/2006/main">
               <a:ext uri="{FF2B5EF4-FFF2-40B4-BE49-F238E27FC236}">
-                <a16:creationId xmlns:a16="http://schemas.microsoft.com/office/drawing/2014/main" id="{0FCDED2C-6AAF-4CAA-813D-DE233C543599}"/>
+                <a16:creationId xmlns:a16="http://schemas.microsoft.com/office/drawing/2014/main" id="{CFD8887B-EF82-4194-B819-840D01C4FBCD}"/>
               </a:ext>
             </a:extLst>
           </p:cNvPr>
@@ -12874,7 +13584,7 @@
           <p:cNvPr id="8" name="">
             <a:extLst xmlns:a="http://schemas.openxmlformats.org/drawingml/2006/main">
               <a:ext uri="{FF2B5EF4-FFF2-40B4-BE49-F238E27FC236}">
-                <a16:creationId xmlns:a16="http://schemas.microsoft.com/office/drawing/2014/main" id="{1E4403BC-6D00-4688-A5C2-01DA5ABE4F2F}"/>
+                <a16:creationId xmlns:a16="http://schemas.microsoft.com/office/drawing/2014/main" id="{C0325001-D29A-4731-B5C3-50603041BF26}"/>
               </a:ext>
             </a:extLst>
           </p:cNvPr>
@@ -12924,7 +13634,7 @@
           <p:cNvPr id="9" name="">
             <a:extLst xmlns:a="http://schemas.openxmlformats.org/drawingml/2006/main">
               <a:ext uri="{FF2B5EF4-FFF2-40B4-BE49-F238E27FC236}">
-                <a16:creationId xmlns:a16="http://schemas.microsoft.com/office/drawing/2014/main" id="{BC1670DD-7F47-4655-B269-7D3CC9DC0FDB}"/>
+                <a16:creationId xmlns:a16="http://schemas.microsoft.com/office/drawing/2014/main" id="{3A1D0133-C76C-4A84-A275-4904F6655185}"/>
               </a:ext>
             </a:extLst>
           </p:cNvPr>
@@ -12955,7 +13665,7 @@
           <p:cNvPr id="10" name="">
             <a:extLst xmlns:a="http://schemas.openxmlformats.org/drawingml/2006/main">
               <a:ext uri="{FF2B5EF4-FFF2-40B4-BE49-F238E27FC236}">
-                <a16:creationId xmlns:a16="http://schemas.microsoft.com/office/drawing/2014/main" id="{518416F0-3103-446E-A79E-29834758F0B7}"/>
+                <a16:creationId xmlns:a16="http://schemas.microsoft.com/office/drawing/2014/main" id="{60C4F95D-F0D2-435C-B7E2-236852B9AEF1}"/>
               </a:ext>
             </a:extLst>
           </p:cNvPr>
@@ -13005,7 +13715,7 @@
           <p:cNvPr id="11" name="">
             <a:extLst xmlns:a="http://schemas.openxmlformats.org/drawingml/2006/main">
               <a:ext uri="{FF2B5EF4-FFF2-40B4-BE49-F238E27FC236}">
-                <a16:creationId xmlns:a16="http://schemas.microsoft.com/office/drawing/2014/main" id="{1ECC40C0-5A11-4EE8-903D-6640A28B57DE}"/>
+                <a16:creationId xmlns:a16="http://schemas.microsoft.com/office/drawing/2014/main" id="{85324FCE-6EE4-4082-B235-2959D6077100}"/>
               </a:ext>
             </a:extLst>
           </p:cNvPr>
@@ -13036,7 +13746,7 @@
           <p:cNvPr id="12" name="">
             <a:extLst xmlns:a="http://schemas.openxmlformats.org/drawingml/2006/main">
               <a:ext uri="{FF2B5EF4-FFF2-40B4-BE49-F238E27FC236}">
-                <a16:creationId xmlns:a16="http://schemas.microsoft.com/office/drawing/2014/main" id="{F2268646-A00A-4992-BD04-9E3645E84731}"/>
+                <a16:creationId xmlns:a16="http://schemas.microsoft.com/office/drawing/2014/main" id="{734AB775-DC68-450B-872E-4EB8A7DD66A7}"/>
               </a:ext>
             </a:extLst>
           </p:cNvPr>
@@ -13086,7 +13796,7 @@
           <p:cNvPr id="13" name="">
             <a:extLst xmlns:a="http://schemas.openxmlformats.org/drawingml/2006/main">
               <a:ext uri="{FF2B5EF4-FFF2-40B4-BE49-F238E27FC236}">
-                <a16:creationId xmlns:a16="http://schemas.microsoft.com/office/drawing/2014/main" id="{C6A1DDCE-CBAC-42B7-A646-AC78CDFC7D77}"/>
+                <a16:creationId xmlns:a16="http://schemas.microsoft.com/office/drawing/2014/main" id="{AB5799D0-986F-448F-9E5C-8D472C246D71}"/>
               </a:ext>
             </a:extLst>
           </p:cNvPr>
@@ -13117,7 +13827,7 @@
           <p:cNvPr id="14" name="">
             <a:extLst xmlns:a="http://schemas.openxmlformats.org/drawingml/2006/main">
               <a:ext uri="{FF2B5EF4-FFF2-40B4-BE49-F238E27FC236}">
-                <a16:creationId xmlns:a16="http://schemas.microsoft.com/office/drawing/2014/main" id="{80CD4DE7-9EF7-4DCD-AF5D-2B880AFD02C5}"/>
+                <a16:creationId xmlns:a16="http://schemas.microsoft.com/office/drawing/2014/main" id="{3B61B5C4-D339-4C33-AC80-1DFF70911952}"/>
               </a:ext>
             </a:extLst>
           </p:cNvPr>
@@ -13167,7 +13877,7 @@
           <p:cNvPr id="15" name="">
             <a:extLst xmlns:a="http://schemas.openxmlformats.org/drawingml/2006/main">
               <a:ext uri="{FF2B5EF4-FFF2-40B4-BE49-F238E27FC236}">
-                <a16:creationId xmlns:a16="http://schemas.microsoft.com/office/drawing/2014/main" id="{39B6AF1F-3798-41BC-9ED3-D715D81BD9F9}"/>
+                <a16:creationId xmlns:a16="http://schemas.microsoft.com/office/drawing/2014/main" id="{2DD34907-9886-47BA-B036-B991DE6141D8}"/>
               </a:ext>
             </a:extLst>
           </p:cNvPr>
@@ -13198,7 +13908,7 @@
           <p:cNvPr id="16" name="">
             <a:extLst xmlns:a="http://schemas.openxmlformats.org/drawingml/2006/main">
               <a:ext uri="{FF2B5EF4-FFF2-40B4-BE49-F238E27FC236}">
-                <a16:creationId xmlns:a16="http://schemas.microsoft.com/office/drawing/2014/main" id="{1A620B9E-4068-4BE7-A32A-0280D0FAE5E0}"/>
+                <a16:creationId xmlns:a16="http://schemas.microsoft.com/office/drawing/2014/main" id="{70C10A4C-4073-4F96-AA8A-02E3A71EEA46}"/>
               </a:ext>
             </a:extLst>
           </p:cNvPr>
@@ -13248,7 +13958,7 @@
           <p:cNvPr id="17" name="">
             <a:extLst xmlns:a="http://schemas.openxmlformats.org/drawingml/2006/main">
               <a:ext uri="{FF2B5EF4-FFF2-40B4-BE49-F238E27FC236}">
-                <a16:creationId xmlns:a16="http://schemas.microsoft.com/office/drawing/2014/main" id="{6D3FE26B-8FC4-4988-B039-08DF9F63AD23}"/>
+                <a16:creationId xmlns:a16="http://schemas.microsoft.com/office/drawing/2014/main" id="{A93B9574-D93A-4E2E-98E5-2A7430291AC2}"/>
               </a:ext>
             </a:extLst>
           </p:cNvPr>
@@ -13296,7 +14006,7 @@
     </p:spTree>
     <p:extLst>
       <p:ext uri="{BB962C8B-B14F-4D97-AF65-F5344CB8AC3E}">
-        <p14:creationId xmlns:p14="http://schemas.microsoft.com/office/powerpoint/2010/main" val="249256092"/>
+        <p14:creationId xmlns:p14="http://schemas.microsoft.com/office/powerpoint/2010/main" val="787680712"/>
       </p:ext>
     </p:extLst>
   </p:cSld>

</xml_diff>